<commit_message>
Pitch : courbe Steam depuis le lancement, données prioritaires expliquées, causes A/B explicites, slide Décision retirée
Co-Authored-By: Claude Opus 5.5 <noreply@anthropic.com>
Claude-Session: https://claude.ai/code/session_012kyLDzFB57v6JCyVf6ygKi
</commit_message>
<xml_diff>
--- a/docs/presentation/pitch_marvel_rivals_netease.pptx
+++ b/docs/presentation/pitch_marvel_rivals_netease.pptx
@@ -14,10 +14,9 @@
     <p:sldId id="262" r:id="rId8"/>
     <p:sldId id="263" r:id="rId9"/>
     <p:sldId id="264" r:id="rId10"/>
-    <p:sldId id="265" r:id="rId11"/>
   </p:sldIdLst>
   <p:notesMasterIdLst>
-    <p:notesMasterId r:id="rId12"/>
+    <p:notesMasterId r:id="rId11"/>
   </p:notesMasterIdLst>
   <p:sldSz cx="9144000" cy="5143500"/>
   <p:notesSz cx="5143500" cy="9144000"/>
@@ -226,9 +225,9 @@
           </c:marker>
           <c:cat>
             <c:multiLvlStrRef>
-              <c:f>Sheet1!$A$2:$A$16</c:f>
+              <c:f>Sheet1!$A$2:$A$23</c:f>
               <c:multiLvlStrCache>
-                <c:ptCount val="15"/>
+                <c:ptCount val="22"/>
                 <c:lvl>
                   <c:pt idx="0">
                     <c:v>Déc. 24</c:v>
@@ -275,16 +274,37 @@
                   <c:pt idx="14">
                     <c:v>Févr.</c:v>
                   </c:pt>
+                  <c:pt idx="15">
+                    <c:v>Mars</c:v>
+                  </c:pt>
+                  <c:pt idx="16">
+                    <c:v>Avr.</c:v>
+                  </c:pt>
+                  <c:pt idx="17">
+                    <c:v>Mai</c:v>
+                  </c:pt>
+                  <c:pt idx="18">
+                    <c:v>Juin</c:v>
+                  </c:pt>
+                  <c:pt idx="19">
+                    <c:v>Juil.</c:v>
+                  </c:pt>
+                  <c:pt idx="20">
+                    <c:v>Août</c:v>
+                  </c:pt>
+                  <c:pt idx="21">
+                    <c:v>Sept.*</c:v>
+                  </c:pt>
                 </c:lvl>
               </c:multiLvlStrCache>
             </c:multiLvlStrRef>
           </c:cat>
           <c:val>
             <c:numRef>
-              <c:f>Sheet1!$B$2:$B$16</c:f>
+              <c:f>Sheet1!$B$2:$B$23</c:f>
               <c:numCache>
                 <c:formatCode>General</c:formatCode>
-                <c:ptCount val="15"/>
+                <c:ptCount val="22"/>
                 <c:pt idx="0">
                   <c:v>279</c:v>
                 </c:pt>
@@ -329,6 +349,27 @@
                 </c:pt>
                 <c:pt idx="14">
                   <c:v>81</c:v>
+                </c:pt>
+                <c:pt idx="15">
+                  <c:v>65</c:v>
+                </c:pt>
+                <c:pt idx="16">
+                  <c:v>70</c:v>
+                </c:pt>
+                <c:pt idx="17">
+                  <c:v>68</c:v>
+                </c:pt>
+                <c:pt idx="18">
+                  <c:v>70</c:v>
+                </c:pt>
+                <c:pt idx="19">
+                  <c:v>84</c:v>
+                </c:pt>
+                <c:pt idx="20">
+                  <c:v>80</c:v>
+                </c:pt>
+                <c:pt idx="21">
+                  <c:v>68</c:v>
                 </c:pt>
               </c:numCache>
             </c:numRef>
@@ -389,7 +430,7 @@
           <a:lstStyle/>
           <a:p>
             <a:pPr>
-              <a:defRPr sz="900" b="0" i="0" u="none" strike="noStrike">
+              <a:defRPr sz="800" b="0" i="0" u="none" strike="noStrike">
                 <a:solidFill>
                   <a:srgbClr val="5E6378"/>
                 </a:solidFill>
@@ -1322,94 +1363,6 @@
 </p:notes>
 </file>
 
-<file path=ppt/notesSlides/notesSlide10.xml><?xml version="1.0" encoding="utf-8"?>
-<p:notes xmlns:a="http://schemas.openxmlformats.org/drawingml/2006/main" xmlns:r="http://schemas.openxmlformats.org/officeDocument/2006/relationships" xmlns:p="http://schemas.openxmlformats.org/presentationml/2006/main">
-  <p:cSld>
-    <p:spTree>
-      <p:nvGrpSpPr>
-        <p:cNvPr id="1" name=""/>
-        <p:cNvGrpSpPr/>
-        <p:nvPr/>
-      </p:nvGrpSpPr>
-      <p:grpSpPr>
-        <a:xfrm>
-          <a:off x="0" y="0"/>
-          <a:ext cx="0" cy="0"/>
-          <a:chOff x="0" y="0"/>
-          <a:chExt cx="0" cy="0"/>
-        </a:xfrm>
-      </p:grpSpPr>
-      <p:sp>
-        <p:nvSpPr>
-          <p:cNvPr id="2" name="Slide Image Placeholder 1"/>
-          <p:cNvSpPr>
-            <a:spLocks noGrp="1" noRot="1" noChangeAspect="1"/>
-          </p:cNvSpPr>
-          <p:nvPr>
-            <p:ph type="sldImg"/>
-          </p:nvPr>
-        </p:nvSpPr>
-        <p:spPr/>
-      </p:sp>
-      <p:sp>
-        <p:nvSpPr>
-          <p:cNvPr id="3" name="Notes Placeholder 2"/>
-          <p:cNvSpPr>
-            <a:spLocks noGrp="1"/>
-          </p:cNvSpPr>
-          <p:nvPr>
-            <p:ph type="body" idx="1"/>
-          </p:nvPr>
-        </p:nvSpPr>
-        <p:spPr/>
-        <p:txBody>
-          <a:bodyPr/>
-          <a:lstStyle/>
-          <a:p>
-            <a:r>
-              <a:rPr lang="en-US" dirty="0"/>
-              <a:t>Annexe, à montrer seulement si on vous demande une source.</a:t>
-            </a:r>
-            <a:endParaRPr lang="en-US" dirty="0"/>
-          </a:p>
-        </p:txBody>
-      </p:sp>
-      <p:sp>
-        <p:nvSpPr>
-          <p:cNvPr id="4" name="Slide Number Placeholder 3"/>
-          <p:cNvSpPr>
-            <a:spLocks noGrp="1"/>
-          </p:cNvSpPr>
-          <p:nvPr>
-            <p:ph type="sldNum" sz="quarter" idx="10"/>
-          </p:nvPr>
-        </p:nvSpPr>
-        <p:spPr/>
-        <p:txBody>
-          <a:bodyPr/>
-          <a:lstStyle/>
-          <a:p>
-            <a:fld id="{F7021451-1387-4CA6-816F-3879F97B5CBC}" type="slidenum">
-              <a:rPr lang="en-US"/>
-              <a:t>10</a:t>
-            </a:fld>
-            <a:endParaRPr lang="en-US"/>
-          </a:p>
-        </p:txBody>
-      </p:sp>
-    </p:spTree>
-    <p:extLst>
-      <p:ext uri="{BB962C8B-B14F-4D97-AF65-F5344CB8AC3E}">
-        <p14:creationId xmlns:p14="http://schemas.microsoft.com/office/powerpoint/2010/main" val="1024086991"/>
-      </p:ext>
-    </p:extLst>
-  </p:cSld>
-  <p:clrMapOvr>
-    <a:masterClrMapping/>
-  </p:clrMapOvr>
-</p:notes>
-</file>
-
 <file path=ppt/notesSlides/notesSlide2.xml><?xml version="1.0" encoding="utf-8"?>
 <p:notes xmlns:a="http://schemas.openxmlformats.org/drawingml/2006/main" xmlns:r="http://schemas.openxmlformats.org/officeDocument/2006/relationships" xmlns:p="http://schemas.openxmlformats.org/presentationml/2006/main">
   <p:cSld>
@@ -1456,7 +1409,7 @@
           <a:p>
             <a:r>
               <a:rPr lang="en-US" dirty="0"/>
-              <a:t>30 secondes. Sur Steam, la fréquentation moyenne a perdu 77 % en dix mois, puis plafonne sous 90 000. Pourtant 40 millions de joueurs sont venus en trois mois. Le jeu sait attirer ; il ne sait pas garder. Attention : Steam, c'est le PC seulement.</a:t>
+              <a:t>30 secondes. Depuis le lancement, la fréquentation moyenne sur Steam a perdu 76 %. Après un sommet en janvier 2025 (306 000), elle chute pendant neuf mois, puis stagne entre 64 000 et 89 000 depuis un an : les nouvelles saisons font des rebonds, pas une remontée. Pourtant 40 millions de joueurs sont venus en trois mois. Le jeu sait attirer ; il ne sait pas garder. Attention : Steam, c'est le PC seulement.</a:t>
             </a:r>
             <a:endParaRPr lang="en-US" dirty="0"/>
           </a:p>
@@ -1720,7 +1673,7 @@
           <a:p>
             <a:r>
               <a:rPr lang="en-US" dirty="0"/>
-              <a:t>Recommandation, première partie. Un objectif qui mesure exactement la trace de H5 : si perdre au début fait partir, les nouveaux perdants partent plus que les autres. Cible : un ratio de 1,2 au 31 mars 2027. Pour le mesurer et trouver la cause, 12 données prioritaires, notées ICE. Toutes existent déjà dans votre télémétrie : pas de nouvelle collecte, pas de nouvel outil. Et l'objectif peut dire non : si le ratio est déjà sous 1,2, on n'investit pas dans le matchmaking.</a:t>
+              <a:t>Recommandation, première partie : d'abord mesurer. L'objectif traduit notre hypothèse en chiffre : si perdre au début fait partir, les nouveaux qui perdent partent plus que les autres. On vise un écart d'au plus 1,2 fois au 31 mars 2027. Cinq données d'abord. Un : les résultats des dix premiers matchs et le départ à sept jours, c'est la mesure même de l'objectif. Deux : dans quel mode et sur quelle plateforme jouent les nouveaux, pour savoir quoi corriger en premier. Trois et quatre : chacune teste une des deux causes possibles. Cinq : NetEase a déjà changé le placement en classé à la saison 5 ; comparer avant et après, c'est une expérience gratuite. Tout existe déjà dans vos serveurs : pas de nouvelle collecte. Et si l'écart est déjà sous 1,2, on n'investit pas dans le matchmaking.</a:t>
             </a:r>
             <a:endParaRPr lang="en-US" dirty="0"/>
           </a:p>
@@ -1808,7 +1761,7 @@
           <a:p>
             <a:r>
               <a:rPr lang="en-US" dirty="0"/>
-              <a:t>Recommandation, deuxième partie. On ne teste que si l'audit confirme H5, et on teste le levier qui correspond à la cause. Cause A : un MMR de départ plus prudent et une convergence plus rapide, qui freine aussi les smurfs sans sanction. Cause B : resserrer la fourchette aux heures creuses, avec un seuil d'arrêt si l'attente dépasse 5 minutes. Dans les deux cas, une file débutants jusqu'au niveau 15 et l'isolement des groupes. Nous écartons les garde-fous de rôles : la liberté de composition fait partie de l'identité du jeu.</a:t>
+              <a:t>Recommandation, deuxième partie. Deux causes peuvent expliquer que les nouveaux perdent trop. Cause A, le démarrage à froid : le jeu ne sait rien d'un nouveau compte, il lui donne un niveau par défaut et le place mal pendant ses premiers matchs. Cause B, le manque de joueurs : quand la file est vide, le jeu accepte des écarts de niveau plus grands pour lancer la partie ; NetEase l'a lui-même expliqué en août 2025. Les données les distinguent : A, l'écart est fort sur les premiers matchs à toute heure ; B, il grandit quand la file se vide. On ne teste que le levier de la cause trouvée, avec un groupe témoin. Nous écartons les rôles imposés : la liberté de composition fait partie de l'identité du jeu.</a:t>
             </a:r>
             <a:endParaRPr lang="en-US" dirty="0"/>
           </a:p>
@@ -1984,7 +1937,7 @@
           <a:p>
             <a:r>
               <a:rPr lang="en-US" dirty="0"/>
-              <a:t>30 secondes sur les garde-fous. Chaque KPI a un seuil qui déclenche une décision : 1,2 pour lancer les tests, 5 minutes d'attente pour les arrêter, 50 % pour choisir le mode visé. Côté risques : accord de sous-traitance et pseudonymisation, aucun profilage individuel, et jamais de bots cachés.</a:t>
+              <a:t>30 secondes sur les garde-fous. Chaque KPI a un seuil qui déclenche une décision : 1,2 pour lancer les tests, 5 minutes d'attente pour les arrêter, 50 % pour choisir le mode visé. Côté risques : accord de sous-traitance et pseudonymisation, aucun profilage individuel, et jamais de bots cachés. Pour démarrer, nous vous demandons deux choses : signer l'accord de sous-traitance et lancer l'audit de 30 jours, environ 33 jours-homme. Si l'hypothèse est confirmée, vous tenez votre levier de rétention ; sinon, vous évitez d'investir au mauvais endroit. Merci, je prends vos questions.</a:t>
             </a:r>
             <a:endParaRPr lang="en-US" dirty="0"/>
           </a:p>
@@ -2072,7 +2025,7 @@
           <a:p>
             <a:r>
               <a:rPr lang="en-US" dirty="0"/>
-              <a:t>Conclusion. Deux décisions aujourd'hui : signer l'accord de sous-traitance et lancer l'audit, environ 33 jours-homme plafonnés. Dans les deux issues, vous gagnez : soit un levier de rétention prouvé, soit un investissement évité. Merci, je prends vos questions.</a:t>
+              <a:t>Annexe, à montrer seulement si on vous demande une source.</a:t>
             </a:r>
             <a:endParaRPr lang="en-US" dirty="0"/>
           </a:p>
@@ -2619,513 +2572,6 @@
 </p:sld>
 </file>
 
-<file path=ppt/slides/slide10.xml><?xml version="1.0" encoding="utf-8"?>
-<p:sld xmlns:a="http://schemas.openxmlformats.org/drawingml/2006/main" xmlns:r="http://schemas.openxmlformats.org/officeDocument/2006/relationships" xmlns:p="http://schemas.openxmlformats.org/presentationml/2006/main">
-  <p:cSld name="Slide 10">
-    <p:bg>
-      <p:bgPr>
-        <a:solidFill>
-          <a:srgbClr val="FFFFFF"/>
-        </a:solidFill>
-      </p:bgPr>
-    </p:bg>
-    <p:spTree>
-      <p:nvGrpSpPr>
-        <p:cNvPr id="1" name=""/>
-        <p:cNvGrpSpPr/>
-        <p:nvPr/>
-      </p:nvGrpSpPr>
-      <p:grpSpPr>
-        <a:xfrm>
-          <a:off x="0" y="0"/>
-          <a:ext cx="0" cy="0"/>
-          <a:chOff x="0" y="0"/>
-          <a:chExt cx="0" cy="0"/>
-        </a:xfrm>
-      </p:grpSpPr>
-      <p:sp>
-        <p:nvSpPr>
-          <p:cNvPr id="2" name="Text 0"/>
-          <p:cNvSpPr txBox="1"/>
-          <p:nvPr/>
-        </p:nvSpPr>
-        <p:spPr>
-          <a:xfrm>
-            <a:off x="457200" y="274320"/>
-            <a:ext cx="8229600" cy="548640"/>
-          </a:xfrm>
-          <a:prstGeom prst="rect">
-            <a:avLst/>
-          </a:prstGeom>
-          <a:noFill/>
-          <a:ln/>
-        </p:spPr>
-        <p:txBody>
-          <a:bodyPr wrap="square" lIns="0" tIns="0" rIns="0" bIns="0" rtlCol="0" anchor="ctr"/>
-          <a:lstStyle/>
-          <a:p>
-            <a:pPr indent="0" marL="0">
-              <a:buNone/>
-            </a:pPr>
-            <a:r>
-              <a:rPr lang="en-US" sz="2800" b="1" dirty="0">
-                <a:solidFill>
-                  <a:srgbClr val="1F2233"/>
-                </a:solidFill>
-                <a:latin typeface="Arial" pitchFamily="34" charset="0"/>
-                <a:ea typeface="Arial" pitchFamily="34" charset="-122"/>
-                <a:cs typeface="Arial" pitchFamily="34" charset="-120"/>
-              </a:rPr>
-              <a:t>Sources</a:t>
-            </a:r>
-            <a:endParaRPr lang="en-US" sz="2800" dirty="0"/>
-          </a:p>
-        </p:txBody>
-      </p:sp>
-      <p:sp>
-        <p:nvSpPr>
-          <p:cNvPr id="3" name="Text 1"/>
-          <p:cNvSpPr txBox="1"/>
-          <p:nvPr/>
-        </p:nvSpPr>
-        <p:spPr>
-          <a:xfrm>
-            <a:off x="457200" y="804672"/>
-            <a:ext cx="8229600" cy="320040"/>
-          </a:xfrm>
-          <a:prstGeom prst="rect">
-            <a:avLst/>
-          </a:prstGeom>
-          <a:noFill/>
-          <a:ln/>
-        </p:spPr>
-        <p:txBody>
-          <a:bodyPr wrap="square" lIns="0" tIns="0" rIns="0" bIns="0" rtlCol="0" anchor="ctr"/>
-          <a:lstStyle/>
-          <a:p>
-            <a:pPr indent="0" marL="0">
-              <a:buNone/>
-            </a:pPr>
-            <a:r>
-              <a:rPr lang="en-US" sz="1300" dirty="0">
-                <a:solidFill>
-                  <a:srgbClr val="5E6378"/>
-                </a:solidFill>
-                <a:latin typeface="Calibri" pitchFamily="34" charset="0"/>
-                <a:ea typeface="Calibri" pitchFamily="34" charset="-122"/>
-                <a:cs typeface="Calibri" pitchFamily="34" charset="-120"/>
-              </a:rPr>
-              <a:t>Annexe · consultées les 29 et 30/09/2026 · liens cliquables</a:t>
-            </a:r>
-            <a:endParaRPr lang="en-US" sz="1300" dirty="0"/>
-          </a:p>
-        </p:txBody>
-      </p:sp>
-      <p:sp>
-        <p:nvSpPr>
-          <p:cNvPr id="4" name="Text 2"/>
-          <p:cNvSpPr txBox="1"/>
-          <p:nvPr/>
-        </p:nvSpPr>
-        <p:spPr>
-          <a:xfrm>
-            <a:off x="457200" y="1234440"/>
-            <a:ext cx="8229600" cy="3474720"/>
-          </a:xfrm>
-          <a:prstGeom prst="rect">
-            <a:avLst/>
-          </a:prstGeom>
-          <a:noFill/>
-          <a:ln/>
-        </p:spPr>
-        <p:txBody>
-          <a:bodyPr wrap="square" rtlCol="0" anchor="t"/>
-          <a:lstStyle/>
-          <a:p>
-            <a:pPr marL="342900" indent="-342900">
-              <a:spcAft>
-                <a:spcPts val="400"/>
-              </a:spcAft>
-              <a:buSzPct val="100000"/>
-              <a:buChar char="•"/>
-            </a:pPr>
-            <a:r>
-              <a:rPr lang="en-US" sz="1200" u="sng" dirty="0">
-                <a:solidFill>
-                  <a:srgbClr val="2F3C7E"/>
-                </a:solidFill>
-                <a:latin typeface="Calibri" pitchFamily="34" charset="0"/>
-                <a:ea typeface="Calibri" pitchFamily="34" charset="-122"/>
-                <a:cs typeface="Calibri" pitchFamily="34" charset="-120"/>
-                <a:hlinkClick r:id="rId1" invalidUrl="" action="" tgtFrame="" tooltip="" history="1" highlightClick="0" endSnd="0">
-                  <a:extLst>
-                    <a:ext uri="{A12FA001-AC4F-418D-AE19-62706E023703}">
-                      <ahyp:hlinkClr xmlns:ahyp="http://schemas.microsoft.com/office/drawing/2018/hyperlinkcolor" val="tx"/>
-                    </a:ext>
-                  </a:extLst>
-                </a:hlinkClick>
-              </a:rPr>
-              <a:t>Steam Charts, moyennes mensuelles (PC)</a:t>
-            </a:r>
-            <a:endParaRPr lang="en-US" sz="1200" dirty="0"/>
-          </a:p>
-          <a:p>
-            <a:pPr marL="342900" indent="-342900">
-              <a:spcAft>
-                <a:spcPts val="400"/>
-              </a:spcAft>
-              <a:buSzPct val="100000"/>
-              <a:buChar char="•"/>
-            </a:pPr>
-            <a:r>
-              <a:rPr lang="en-US" sz="1200" u="sng" dirty="0">
-                <a:solidFill>
-                  <a:srgbClr val="2F3C7E"/>
-                </a:solidFill>
-                <a:latin typeface="Calibri" pitchFamily="34" charset="0"/>
-                <a:ea typeface="Calibri" pitchFamily="34" charset="-122"/>
-                <a:cs typeface="Calibri" pitchFamily="34" charset="-120"/>
-                <a:hlinkClick r:id="rId2" invalidUrl="" action="" tgtFrame="" tooltip="" history="1" highlightClick="0" endSnd="0">
-                  <a:extLst>
-                    <a:ext uri="{A12FA001-AC4F-418D-AE19-62706E023703}">
-                      <ahyp:hlinkClr xmlns:ahyp="http://schemas.microsoft.com/office/drawing/2018/hyperlinkcolor" val="tx"/>
-                    </a:ext>
-                  </a:extLst>
-                </a:hlinkClick>
-              </a:rPr>
-              <a:t>40 millions de joueurs, rapport NetEase (Game World Observer)</a:t>
-            </a:r>
-            <a:endParaRPr lang="en-US" sz="1200" dirty="0"/>
-          </a:p>
-          <a:p>
-            <a:pPr marL="342900" indent="-342900">
-              <a:spcAft>
-                <a:spcPts val="400"/>
-              </a:spcAft>
-              <a:buSzPct val="100000"/>
-              <a:buChar char="•"/>
-            </a:pPr>
-            <a:r>
-              <a:rPr lang="en-US" sz="1200" u="sng" dirty="0">
-                <a:solidFill>
-                  <a:srgbClr val="2F3C7E"/>
-                </a:solidFill>
-                <a:latin typeface="Calibri" pitchFamily="34" charset="0"/>
-                <a:ea typeface="Calibri" pitchFamily="34" charset="-122"/>
-                <a:cs typeface="Calibri" pitchFamily="34" charset="-120"/>
-                <a:hlinkClick r:id="rId3" invalidUrl="" action="" tgtFrame="" tooltip="" history="1" highlightClick="0" endSnd="0">
-                  <a:extLst>
-                    <a:ext uri="{A12FA001-AC4F-418D-AE19-62706E023703}">
-                      <ahyp:hlinkClr xmlns:ahyp="http://schemas.microsoft.com/office/drawing/2018/hyperlinkcolor" val="tx"/>
-                    </a:ext>
-                  </a:extLst>
-                </a:hlinkClick>
-              </a:rPr>
-              <a:t>API publique des avis Steam (notre collecte, 37 990 avis pondérés)</a:t>
-            </a:r>
-            <a:endParaRPr lang="en-US" sz="1200" dirty="0"/>
-          </a:p>
-          <a:p>
-            <a:pPr marL="342900" indent="-342900">
-              <a:spcAft>
-                <a:spcPts val="400"/>
-              </a:spcAft>
-              <a:buSzPct val="100000"/>
-              <a:buChar char="•"/>
-            </a:pPr>
-            <a:r>
-              <a:rPr lang="en-US" sz="1200" u="sng" dirty="0">
-                <a:solidFill>
-                  <a:srgbClr val="2F3C7E"/>
-                </a:solidFill>
-                <a:latin typeface="Calibri" pitchFamily="34" charset="0"/>
-                <a:ea typeface="Calibri" pitchFamily="34" charset="-122"/>
-                <a:cs typeface="Calibri" pitchFamily="34" charset="-120"/>
-                <a:hlinkClick r:id="rId4" invalidUrl="" action="" tgtFrame="" tooltip="" history="1" highlightClick="0" endSnd="0">
-                  <a:extLst>
-                    <a:ext uri="{A12FA001-AC4F-418D-AE19-62706E023703}">
-                      <ahyp:hlinkClr xmlns:ahyp="http://schemas.microsoft.com/office/drawing/2018/hyperlinkcolor" val="tx"/>
-                    </a:ext>
-                  </a:extLst>
-                </a:hlinkClick>
-              </a:rPr>
-              <a:t>Vidéo NetEase sur le matchmaking, 21/08/2025</a:t>
-            </a:r>
-            <a:endParaRPr lang="en-US" sz="1200" dirty="0"/>
-          </a:p>
-          <a:p>
-            <a:pPr marL="342900" indent="-342900">
-              <a:spcAft>
-                <a:spcPts val="400"/>
-              </a:spcAft>
-              <a:buSzPct val="100000"/>
-              <a:buChar char="•"/>
-            </a:pPr>
-            <a:r>
-              <a:rPr lang="en-US" sz="1200" u="sng" dirty="0">
-                <a:solidFill>
-                  <a:srgbClr val="2F3C7E"/>
-                </a:solidFill>
-                <a:latin typeface="Calibri" pitchFamily="34" charset="0"/>
-                <a:ea typeface="Calibri" pitchFamily="34" charset="-122"/>
-                <a:cs typeface="Calibri" pitchFamily="34" charset="-120"/>
-                <a:hlinkClick r:id="rId5" invalidUrl="" action="" tgtFrame="" tooltip="" history="1" highlightClick="0" endSnd="0">
-                  <a:extLst>
-                    <a:ext uri="{A12FA001-AC4F-418D-AE19-62706E023703}">
-                      <ahyp:hlinkClr xmlns:ahyp="http://schemas.microsoft.com/office/drawing/2018/hyperlinkcolor" val="tx"/>
-                    </a:ext>
-                  </a:extLst>
-                </a:hlinkClick>
-              </a:rPr>
-              <a:t>Notes de patch Season 5, placements (14/11/2025)</a:t>
-            </a:r>
-            <a:endParaRPr lang="en-US" sz="1200" dirty="0"/>
-          </a:p>
-          <a:p>
-            <a:pPr marL="342900" indent="-342900">
-              <a:spcAft>
-                <a:spcPts val="400"/>
-              </a:spcAft>
-              <a:buSzPct val="100000"/>
-              <a:buChar char="•"/>
-            </a:pPr>
-            <a:r>
-              <a:rPr lang="en-US" sz="1200" u="sng" dirty="0">
-                <a:solidFill>
-                  <a:srgbClr val="2F3C7E"/>
-                </a:solidFill>
-                <a:latin typeface="Calibri" pitchFamily="34" charset="0"/>
-                <a:ea typeface="Calibri" pitchFamily="34" charset="-122"/>
-                <a:cs typeface="Calibri" pitchFamily="34" charset="-120"/>
-                <a:hlinkClick r:id="rId6" invalidUrl="" action="" tgtFrame="" tooltip="" history="1" highlightClick="0" endSnd="0">
-                  <a:extLst>
-                    <a:ext uri="{A12FA001-AC4F-418D-AE19-62706E023703}">
-                      <ahyp:hlinkClr xmlns:ahyp="http://schemas.microsoft.com/office/drawing/2018/hyperlinkcolor" val="tx"/>
-                    </a:ext>
-                  </a:extLst>
-                </a:hlinkClick>
-              </a:rPr>
-              <a:t>Notes de patch Season 7, placement individuel (18/03/2026)</a:t>
-            </a:r>
-            <a:endParaRPr lang="en-US" sz="1200" dirty="0"/>
-          </a:p>
-          <a:p>
-            <a:pPr marL="342900" indent="-342900">
-              <a:spcAft>
-                <a:spcPts val="400"/>
-              </a:spcAft>
-              <a:buSzPct val="100000"/>
-              <a:buChar char="•"/>
-            </a:pPr>
-            <a:r>
-              <a:rPr lang="en-US" sz="1200" u="sng" dirty="0">
-                <a:solidFill>
-                  <a:srgbClr val="2F3C7E"/>
-                </a:solidFill>
-                <a:latin typeface="Calibri" pitchFamily="34" charset="0"/>
-                <a:ea typeface="Calibri" pitchFamily="34" charset="-122"/>
-                <a:cs typeface="Calibri" pitchFamily="34" charset="-120"/>
-                <a:hlinkClick r:id="rId7" invalidUrl="" action="" tgtFrame="" tooltip="" history="1" highlightClick="0" endSnd="0">
-                  <a:extLst>
-                    <a:ext uri="{A12FA001-AC4F-418D-AE19-62706E023703}">
-                      <ahyp:hlinkClr xmlns:ahyp="http://schemas.microsoft.com/office/drawing/2018/hyperlinkcolor" val="tx"/>
-                    </a:ext>
-                  </a:extLst>
-                </a:hlinkClick>
-              </a:rPr>
-              <a:t>Classé : Bronze III pour tous (PCGamesN)</a:t>
-            </a:r>
-            <a:endParaRPr lang="en-US" sz="1200" dirty="0"/>
-          </a:p>
-          <a:p>
-            <a:pPr marL="342900" indent="-342900">
-              <a:spcAft>
-                <a:spcPts val="400"/>
-              </a:spcAft>
-              <a:buSzPct val="100000"/>
-              <a:buChar char="•"/>
-            </a:pPr>
-            <a:r>
-              <a:rPr lang="en-US" sz="1200" u="sng" dirty="0">
-                <a:solidFill>
-                  <a:srgbClr val="2F3C7E"/>
-                </a:solidFill>
-                <a:latin typeface="Calibri" pitchFamily="34" charset="0"/>
-                <a:ea typeface="Calibri" pitchFamily="34" charset="-122"/>
-                <a:cs typeface="Calibri" pitchFamily="34" charset="-120"/>
-                <a:hlinkClick r:id="rId8" invalidUrl="" action="" tgtFrame="" tooltip="" history="1" highlightClick="0" endSnd="0">
-                  <a:extLst>
-                    <a:ext uri="{A12FA001-AC4F-418D-AE19-62706E023703}">
-                      <ahyp:hlinkClr xmlns:ahyp="http://schemas.microsoft.com/office/drawing/2018/hyperlinkcolor" val="tx"/>
-                    </a:ext>
-                  </a:extLst>
-                </a:hlinkClick>
-              </a:rPr>
-              <a:t>Crossplay : partie rapide commune, classé séparé (Esports Insider)</a:t>
-            </a:r>
-            <a:endParaRPr lang="en-US" sz="1200" dirty="0"/>
-          </a:p>
-          <a:p>
-            <a:pPr marL="342900" indent="-342900">
-              <a:spcAft>
-                <a:spcPts val="400"/>
-              </a:spcAft>
-              <a:buSzPct val="100000"/>
-              <a:buChar char="•"/>
-            </a:pPr>
-            <a:r>
-              <a:rPr lang="en-US" sz="1200" u="sng" dirty="0">
-                <a:solidFill>
-                  <a:srgbClr val="2F3C7E"/>
-                </a:solidFill>
-                <a:latin typeface="Calibri" pitchFamily="34" charset="0"/>
-                <a:ea typeface="Calibri" pitchFamily="34" charset="-122"/>
-                <a:cs typeface="Calibri" pitchFamily="34" charset="-120"/>
-                <a:hlinkClick r:id="rId9" invalidUrl="" action="" tgtFrame="" tooltip="" history="1" highlightClick="0" endSnd="0">
-                  <a:extLst>
-                    <a:ext uri="{A12FA001-AC4F-418D-AE19-62706E023703}">
-                      <ahyp:hlinkClr xmlns:ahyp="http://schemas.microsoft.com/office/drawing/2018/hyperlinkcolor" val="tx"/>
-                    </a:ext>
-                  </a:extLst>
-                </a:hlinkClick>
-              </a:rPr>
-              <a:t>Écart de niveau et churn (Heliyon, 2024, analogie)</a:t>
-            </a:r>
-            <a:endParaRPr lang="en-US" sz="1200" dirty="0"/>
-          </a:p>
-          <a:p>
-            <a:pPr marL="342900" indent="-342900">
-              <a:spcAft>
-                <a:spcPts val="400"/>
-              </a:spcAft>
-              <a:buSzPct val="100000"/>
-              <a:buChar char="•"/>
-            </a:pPr>
-            <a:r>
-              <a:rPr lang="en-US" sz="1200" u="sng" dirty="0">
-                <a:solidFill>
-                  <a:srgbClr val="2F3C7E"/>
-                </a:solidFill>
-                <a:latin typeface="Calibri" pitchFamily="34" charset="0"/>
-                <a:ea typeface="Calibri" pitchFamily="34" charset="-122"/>
-                <a:cs typeface="Calibri" pitchFamily="34" charset="-120"/>
-                <a:hlinkClick r:id="rId10" invalidUrl="" action="" tgtFrame="" tooltip="" history="1" highlightClick="0" endSnd="0">
-                  <a:extLst>
-                    <a:ext uri="{A12FA001-AC4F-418D-AE19-62706E023703}">
-                      <ahyp:hlinkClr xmlns:ahyp="http://schemas.microsoft.com/office/drawing/2018/hyperlinkcolor" val="tx"/>
-                    </a:ext>
-                  </a:extLst>
-                </a:hlinkClick>
-              </a:rPr>
-              <a:t>RGPD (EUR-Lex)</a:t>
-            </a:r>
-            <a:endParaRPr lang="en-US" sz="1200" dirty="0"/>
-          </a:p>
-          <a:p>
-            <a:pPr marL="342900" indent="-342900">
-              <a:spcAft>
-                <a:spcPts val="400"/>
-              </a:spcAft>
-              <a:buSzPct val="100000"/>
-              <a:buChar char="•"/>
-            </a:pPr>
-            <a:r>
-              <a:rPr lang="en-US" sz="1200" u="sng" dirty="0">
-                <a:solidFill>
-                  <a:srgbClr val="2F3C7E"/>
-                </a:solidFill>
-                <a:latin typeface="Calibri" pitchFamily="34" charset="0"/>
-                <a:ea typeface="Calibri" pitchFamily="34" charset="-122"/>
-                <a:cs typeface="Calibri" pitchFamily="34" charset="-120"/>
-                <a:hlinkClick r:id="rId11" invalidUrl="" action="" tgtFrame="" tooltip="" history="1" highlightClick="0" endSnd="0">
-                  <a:extLst>
-                    <a:ext uri="{A12FA001-AC4F-418D-AE19-62706E023703}">
-                      <ahyp:hlinkClr xmlns:ahyp="http://schemas.microsoft.com/office/drawing/2018/hyperlinkcolor" val="tx"/>
-                    </a:ext>
-                  </a:extLst>
-                </a:hlinkClick>
-              </a:rPr>
-              <a:t>AI Act (EUR-Lex)</a:t>
-            </a:r>
-            <a:endParaRPr lang="en-US" sz="1200" dirty="0"/>
-          </a:p>
-          <a:p>
-            <a:pPr marL="342900" indent="-342900">
-              <a:spcAft>
-                <a:spcPts val="400"/>
-              </a:spcAft>
-              <a:buSzPct val="100000"/>
-              <a:buChar char="•"/>
-            </a:pPr>
-            <a:r>
-              <a:rPr lang="en-US" sz="1200" u="sng" dirty="0">
-                <a:solidFill>
-                  <a:srgbClr val="2F3C7E"/>
-                </a:solidFill>
-                <a:latin typeface="Calibri" pitchFamily="34" charset="0"/>
-                <a:ea typeface="Calibri" pitchFamily="34" charset="-122"/>
-                <a:cs typeface="Calibri" pitchFamily="34" charset="-120"/>
-                <a:hlinkClick r:id="rId12" invalidUrl="" action="" tgtFrame="" tooltip="" history="1" highlightClick="0" endSnd="0">
-                  <a:extLst>
-                    <a:ext uri="{A12FA001-AC4F-418D-AE19-62706E023703}">
-                      <ahyp:hlinkClr xmlns:ahyp="http://schemas.microsoft.com/office/drawing/2018/hyperlinkcolor" val="tx"/>
-                    </a:ext>
-                  </a:extLst>
-                </a:hlinkClick>
-              </a:rPr>
-              <a:t>Plan de collecte complet (Google Docs)</a:t>
-            </a:r>
-            <a:endParaRPr lang="en-US" sz="1200" dirty="0"/>
-          </a:p>
-        </p:txBody>
-      </p:sp>
-      <p:sp>
-        <p:nvSpPr>
-          <p:cNvPr id="5" name="Text 3"/>
-          <p:cNvSpPr txBox="1"/>
-          <p:nvPr/>
-        </p:nvSpPr>
-        <p:spPr>
-          <a:xfrm>
-            <a:off x="8412480" y="4754880"/>
-            <a:ext cx="274320" cy="256032"/>
-          </a:xfrm>
-          <a:prstGeom prst="rect">
-            <a:avLst/>
-          </a:prstGeom>
-          <a:noFill/>
-          <a:ln/>
-        </p:spPr>
-        <p:txBody>
-          <a:bodyPr wrap="square" lIns="0" tIns="0" rIns="0" bIns="0" rtlCol="0" anchor="ctr"/>
-          <a:lstStyle/>
-          <a:p>
-            <a:pPr algn="r" indent="0" marL="0">
-              <a:buNone/>
-            </a:pPr>
-            <a:r>
-              <a:rPr lang="en-US" sz="900" dirty="0">
-                <a:solidFill>
-                  <a:srgbClr val="5E6378"/>
-                </a:solidFill>
-                <a:latin typeface="Calibri" pitchFamily="34" charset="0"/>
-                <a:ea typeface="Calibri" pitchFamily="34" charset="-122"/>
-                <a:cs typeface="Calibri" pitchFamily="34" charset="-120"/>
-              </a:rPr>
-              <a:t>10</a:t>
-            </a:r>
-            <a:endParaRPr lang="en-US" sz="900" dirty="0"/>
-          </a:p>
-        </p:txBody>
-      </p:sp>
-    </p:spTree>
-  </p:cSld>
-  <p:clrMapOvr>
-    <a:masterClrMapping/>
-  </p:clrMapOvr>
-</p:sld>
-</file>
-
 <file path=ppt/slides/slide2.xml><?xml version="1.0" encoding="utf-8"?>
 <p:sld xmlns:a="http://schemas.openxmlformats.org/drawingml/2006/main" xmlns:r="http://schemas.openxmlformats.org/officeDocument/2006/relationships" xmlns:p="http://schemas.openxmlformats.org/presentationml/2006/main">
   <p:cSld name="Slide 2">
@@ -3222,7 +2668,7 @@
                 <a:ea typeface="Calibri" pitchFamily="34" charset="-122"/>
                 <a:cs typeface="Calibri" pitchFamily="34" charset="-120"/>
               </a:rPr>
-              <a:t>Contexte · joueurs simultanés Steam, moyenne mensuelle (PC)</a:t>
+              <a:t>Contexte · joueurs simultanés Steam depuis le lancement (06/12/2024), moyenne mensuelle (PC)</a:t>
             </a:r>
             <a:endParaRPr lang="en-US" sz="1300" dirty="0"/>
           </a:p>
@@ -3261,7 +2707,7 @@
                 <a:ea typeface="Arial" pitchFamily="34" charset="-122"/>
                 <a:cs typeface="Arial" pitchFamily="34" charset="-120"/>
               </a:rPr>
-              <a:t>−77 %</a:t>
+              <a:t>−76 %</a:t>
             </a:r>
             <a:endParaRPr lang="en-US" sz="6000" dirty="0"/>
           </a:p>
@@ -3300,7 +2746,7 @@
                 <a:ea typeface="Calibri" pitchFamily="34" charset="-122"/>
                 <a:cs typeface="Calibri" pitchFamily="34" charset="-120"/>
               </a:rPr>
-              <a:t>de joueurs simultanés en moyenne entre décembre 2024 (279 K) et octobre 2025 (64 K)</a:t>
+              <a:t>de joueurs simultanés en moyenne entre le mois de lancement (déc. 2024 : 279 K) et les 30 derniers jours (68 K)</a:t>
             </a:r>
             <a:endParaRPr lang="en-US" sz="1300" dirty="0"/>
           </a:p>
@@ -3454,7 +2900,7 @@
                   </a:extLst>
                 </a:hlinkClick>
               </a:rPr>
-              <a:t>Steam Charts</a:t>
+              <a:t>Steam Charts (consulté le 30/09/2026 ; * sept. 2026 = 30 derniers jours)</a:t>
             </a:r>
             <a:pPr indent="0" marL="0">
               <a:buNone/>
@@ -4953,7 +4399,7 @@
                 <a:ea typeface="Calibri" pitchFamily="34" charset="-122"/>
                 <a:cs typeface="Calibri" pitchFamily="34" charset="-120"/>
               </a:rPr>
-              <a:t>Recommandation · objectif SMART et données à extraire</a:t>
+              <a:t>Recommandation · les données à extraire en priorité, et pourquoi</a:t>
             </a:r>
             <a:endParaRPr lang="en-US" sz="1300" dirty="0"/>
           </a:p>
@@ -4967,12 +4413,12 @@
         </p:nvSpPr>
         <p:spPr>
           <a:xfrm>
-            <a:off x="457200" y="1280160"/>
-            <a:ext cx="8229600" cy="960120"/>
+            <a:off x="457200" y="1188720"/>
+            <a:ext cx="8229600" cy="658368"/>
           </a:xfrm>
           <a:prstGeom prst="roundRect">
             <a:avLst>
-              <a:gd name="adj" fmla="val 7619"/>
+              <a:gd name="adj" fmla="val 11111"/>
             </a:avLst>
           </a:prstGeom>
           <a:solidFill>
@@ -4994,8 +4440,8 @@
         </p:nvSpPr>
         <p:spPr>
           <a:xfrm>
-            <a:off x="685800" y="1325880"/>
-            <a:ext cx="7772400" cy="868680"/>
+            <a:off x="640080" y="1207008"/>
+            <a:ext cx="7863840" cy="621792"/>
           </a:xfrm>
           <a:prstGeom prst="rect">
             <a:avLst/>
@@ -5011,7 +4457,7 @@
               <a:buNone/>
             </a:pPr>
             <a:r>
-              <a:rPr lang="en-US" sz="1400" b="1" dirty="0">
+              <a:rPr lang="en-US" sz="1200" b="1" dirty="0">
                 <a:solidFill>
                   <a:srgbClr val="E23636"/>
                 </a:solidFill>
@@ -5025,7 +4471,7 @@
               <a:buNone/>
             </a:pPr>
             <a:r>
-              <a:rPr lang="en-US" sz="1400" dirty="0">
+              <a:rPr lang="en-US" sz="1200" dirty="0">
                 <a:solidFill>
                   <a:srgbClr val="FFFFFF"/>
                 </a:solidFill>
@@ -5033,61 +4479,1318 @@
                 <a:ea typeface="Calibri" pitchFamily="34" charset="-122"/>
                 <a:cs typeface="Calibri" pitchFamily="34" charset="-120"/>
               </a:rPr>
-              <a:t>ramener à 1,2 le ratio de churn J7 entre les nouveaux comptes qui perdent au moins 7 de leurs 10 premiers matchs et les autres nouveaux comptes, d'ici le 31/03/2027.</a:t>
-            </a:r>
-            <a:endParaRPr lang="en-US" sz="1400" dirty="0"/>
-          </a:p>
-        </p:txBody>
-      </p:sp>
-      <p:sp>
-        <p:nvSpPr>
-          <p:cNvPr id="6" name="Shape 4"/>
-          <p:cNvSpPr/>
-          <p:nvPr/>
-        </p:nvSpPr>
-        <p:spPr>
-          <a:xfrm>
-            <a:off x="457200" y="2514600"/>
-            <a:ext cx="457200" cy="457200"/>
-          </a:xfrm>
-          <a:prstGeom prst="ellipse">
-            <a:avLst/>
-          </a:prstGeom>
-          <a:solidFill>
-            <a:srgbClr val="E23636"/>
-          </a:solidFill>
-          <a:ln w="12700">
-            <a:solidFill>
-              <a:srgbClr val="E23636"/>
-            </a:solidFill>
-            <a:prstDash val="solid"/>
-          </a:ln>
-        </p:spPr>
-      </p:sp>
-      <p:pic>
-        <p:nvPicPr>
-          <p:cNvPr id="7" name="Image 0" descr="preencoded.png">    </p:cNvPr>
-          <p:cNvPicPr>
-            <a:picLocks noChangeAspect="1"/>
-          </p:cNvPicPr>
-          <p:nvPr/>
-        </p:nvPicPr>
-        <p:blipFill>
-          <a:blip r:embed="rId1"/>
-          <a:stretch>
-            <a:fillRect/>
-          </a:stretch>
-        </p:blipFill>
-        <p:spPr>
-          <a:xfrm>
-            <a:off x="571500" y="2628900"/>
-            <a:ext cx="228600" cy="228600"/>
-          </a:xfrm>
-          <a:prstGeom prst="rect">
-            <a:avLst/>
-          </a:prstGeom>
-        </p:spPr>
-      </p:pic>
+              <a:t>d'ici le 31/03/2027, qu'un nouveau joueur qui perd au moins 7 de ses 10 premiers matchs ne parte pas plus de 1,2 fois plus souvent dans la semaine que les autres nouveaux.</a:t>
+            </a:r>
+            <a:endParaRPr lang="en-US" sz="1200" dirty="0"/>
+          </a:p>
+        </p:txBody>
+      </p:sp>
+      <p:graphicFrame>
+        <p:nvGraphicFramePr>
+          <p:cNvPr id="6" name="Table 0"/>
+          <p:cNvGraphicFramePr>
+            <a:graphicFrameLocks noGrp="1"/>
+          </p:cNvGraphicFramePr>
+          <p:nvPr>
+            <p:extLst>
+              <p:ext uri="{D42A27DB-BD31-4B8C-83A1-F6EECF244321}">
+                <p14:modId xmlns:p14="http://schemas.microsoft.com/office/powerpoint/2010/main" val="1579011935"/>
+              </p:ext>
+            </p:extLst>
+          </p:nvPr>
+        </p:nvGraphicFramePr>
+        <p:xfrm>
+          <a:off x="457200" y="1965960"/>
+          <a:ext cx="8229600" cy="914400"/>
+        </p:xfrm>
+        <a:graphic>
+          <a:graphicData uri="http://schemas.openxmlformats.org/drawingml/2006/table">
+            <a:tbl>
+              <a:tblPr/>
+              <a:tblGrid>
+                <a:gridCol w="2926080"/>
+                <a:gridCol w="2651760"/>
+                <a:gridCol w="2651760"/>
+              </a:tblGrid>
+              <a:tr h="256032">
+                <a:tc>
+                  <a:txBody>
+                    <a:bodyPr/>
+                    <a:lstStyle/>
+                    <a:p>
+                      <a:pPr indent="0" marL="0">
+                        <a:buNone/>
+                      </a:pPr>
+                      <a:r>
+                        <a:rPr lang="en-US" sz="1050" b="1" dirty="0">
+                          <a:solidFill>
+                            <a:srgbClr val="FFFFFF"/>
+                          </a:solidFill>
+                          <a:latin typeface="Arial" pitchFamily="34" charset="0"/>
+                          <a:ea typeface="Arial" pitchFamily="34" charset="-122"/>
+                          <a:cs typeface="Arial" pitchFamily="34" charset="-120"/>
+                        </a:rPr>
+                        <a:t>Donnée à extraire</a:t>
+                      </a:r>
+                      <a:endParaRPr lang="en-US" sz="1050" dirty="0">
+                        <a:latin typeface="Arial" charset="0"/>
+                        <a:ea typeface="Arial" charset="0"/>
+                        <a:cs typeface="Arial" charset="0"/>
+                      </a:endParaRPr>
+                    </a:p>
+                  </a:txBody>
+                  <a:tcPr marL="63500" marR="63500" marT="25400" marB="25400" anchor="ctr">
+                    <a:lnL w="6350" cap="flat" cmpd="sng" algn="ctr">
+                      <a:solidFill>
+                        <a:srgbClr val="D5D8E3"/>
+                      </a:solidFill>
+                      <a:prstDash val="solid"/>
+                      <a:round/>
+                      <a:headEnd type="none" w="med" len="med"/>
+                      <a:tailEnd type="none" w="med" len="med"/>
+                    </a:lnL>
+                    <a:lnR w="6350" cap="flat" cmpd="sng" algn="ctr">
+                      <a:solidFill>
+                        <a:srgbClr val="D5D8E3"/>
+                      </a:solidFill>
+                      <a:prstDash val="solid"/>
+                      <a:round/>
+                      <a:headEnd type="none" w="med" len="med"/>
+                      <a:tailEnd type="none" w="med" len="med"/>
+                    </a:lnR>
+                    <a:lnT w="6350" cap="flat" cmpd="sng" algn="ctr">
+                      <a:solidFill>
+                        <a:srgbClr val="D5D8E3"/>
+                      </a:solidFill>
+                      <a:prstDash val="solid"/>
+                      <a:round/>
+                      <a:headEnd type="none" w="med" len="med"/>
+                      <a:tailEnd type="none" w="med" len="med"/>
+                    </a:lnT>
+                    <a:lnB w="6350" cap="flat" cmpd="sng" algn="ctr">
+                      <a:solidFill>
+                        <a:srgbClr val="D5D8E3"/>
+                      </a:solidFill>
+                      <a:prstDash val="solid"/>
+                      <a:round/>
+                      <a:headEnd type="none" w="med" len="med"/>
+                      <a:tailEnd type="none" w="med" len="med"/>
+                    </a:lnB>
+                    <a:solidFill>
+                      <a:srgbClr val="E23636"/>
+                    </a:solidFill>
+                  </a:tcPr>
+                </a:tc>
+                <a:tc>
+                  <a:txBody>
+                    <a:bodyPr/>
+                    <a:lstStyle/>
+                    <a:p>
+                      <a:pPr indent="0" marL="0">
+                        <a:buNone/>
+                      </a:pPr>
+                      <a:r>
+                        <a:rPr lang="en-US" sz="1050" b="1" dirty="0">
+                          <a:solidFill>
+                            <a:srgbClr val="FFFFFF"/>
+                          </a:solidFill>
+                          <a:latin typeface="Arial" pitchFamily="34" charset="0"/>
+                          <a:ea typeface="Arial" pitchFamily="34" charset="-122"/>
+                          <a:cs typeface="Arial" pitchFamily="34" charset="-120"/>
+                        </a:rPr>
+                        <a:t>Ce qu'elle nous dit</a:t>
+                      </a:r>
+                      <a:endParaRPr lang="en-US" sz="1050" dirty="0">
+                        <a:latin typeface="Arial" charset="0"/>
+                        <a:ea typeface="Arial" charset="0"/>
+                        <a:cs typeface="Arial" charset="0"/>
+                      </a:endParaRPr>
+                    </a:p>
+                  </a:txBody>
+                  <a:tcPr marL="63500" marR="63500" marT="25400" marB="25400" anchor="ctr">
+                    <a:lnL w="6350" cap="flat" cmpd="sng" algn="ctr">
+                      <a:solidFill>
+                        <a:srgbClr val="D5D8E3"/>
+                      </a:solidFill>
+                      <a:prstDash val="solid"/>
+                      <a:round/>
+                      <a:headEnd type="none" w="med" len="med"/>
+                      <a:tailEnd type="none" w="med" len="med"/>
+                    </a:lnL>
+                    <a:lnR w="6350" cap="flat" cmpd="sng" algn="ctr">
+                      <a:solidFill>
+                        <a:srgbClr val="D5D8E3"/>
+                      </a:solidFill>
+                      <a:prstDash val="solid"/>
+                      <a:round/>
+                      <a:headEnd type="none" w="med" len="med"/>
+                      <a:tailEnd type="none" w="med" len="med"/>
+                    </a:lnR>
+                    <a:lnT w="6350" cap="flat" cmpd="sng" algn="ctr">
+                      <a:solidFill>
+                        <a:srgbClr val="D5D8E3"/>
+                      </a:solidFill>
+                      <a:prstDash val="solid"/>
+                      <a:round/>
+                      <a:headEnd type="none" w="med" len="med"/>
+                      <a:tailEnd type="none" w="med" len="med"/>
+                    </a:lnT>
+                    <a:lnB w="6350" cap="flat" cmpd="sng" algn="ctr">
+                      <a:solidFill>
+                        <a:srgbClr val="D5D8E3"/>
+                      </a:solidFill>
+                      <a:prstDash val="solid"/>
+                      <a:round/>
+                      <a:headEnd type="none" w="med" len="med"/>
+                      <a:tailEnd type="none" w="med" len="med"/>
+                    </a:lnB>
+                    <a:solidFill>
+                      <a:srgbClr val="E23636"/>
+                    </a:solidFill>
+                  </a:tcPr>
+                </a:tc>
+                <a:tc>
+                  <a:txBody>
+                    <a:bodyPr/>
+                    <a:lstStyle/>
+                    <a:p>
+                      <a:pPr indent="0" marL="0">
+                        <a:buNone/>
+                      </a:pPr>
+                      <a:r>
+                        <a:rPr lang="en-US" sz="1050" b="1" dirty="0">
+                          <a:solidFill>
+                            <a:srgbClr val="FFFFFF"/>
+                          </a:solidFill>
+                          <a:latin typeface="Arial" pitchFamily="34" charset="0"/>
+                          <a:ea typeface="Arial" pitchFamily="34" charset="-122"/>
+                          <a:cs typeface="Arial" pitchFamily="34" charset="-120"/>
+                        </a:rPr>
+                        <a:t>Pourquoi en priorité</a:t>
+                      </a:r>
+                      <a:endParaRPr lang="en-US" sz="1050" dirty="0">
+                        <a:latin typeface="Arial" charset="0"/>
+                        <a:ea typeface="Arial" charset="0"/>
+                        <a:cs typeface="Arial" charset="0"/>
+                      </a:endParaRPr>
+                    </a:p>
+                  </a:txBody>
+                  <a:tcPr marL="63500" marR="63500" marT="25400" marB="25400" anchor="ctr">
+                    <a:lnL w="6350" cap="flat" cmpd="sng" algn="ctr">
+                      <a:solidFill>
+                        <a:srgbClr val="D5D8E3"/>
+                      </a:solidFill>
+                      <a:prstDash val="solid"/>
+                      <a:round/>
+                      <a:headEnd type="none" w="med" len="med"/>
+                      <a:tailEnd type="none" w="med" len="med"/>
+                    </a:lnL>
+                    <a:lnR w="6350" cap="flat" cmpd="sng" algn="ctr">
+                      <a:solidFill>
+                        <a:srgbClr val="D5D8E3"/>
+                      </a:solidFill>
+                      <a:prstDash val="solid"/>
+                      <a:round/>
+                      <a:headEnd type="none" w="med" len="med"/>
+                      <a:tailEnd type="none" w="med" len="med"/>
+                    </a:lnR>
+                    <a:lnT w="6350" cap="flat" cmpd="sng" algn="ctr">
+                      <a:solidFill>
+                        <a:srgbClr val="D5D8E3"/>
+                      </a:solidFill>
+                      <a:prstDash val="solid"/>
+                      <a:round/>
+                      <a:headEnd type="none" w="med" len="med"/>
+                      <a:tailEnd type="none" w="med" len="med"/>
+                    </a:lnT>
+                    <a:lnB w="6350" cap="flat" cmpd="sng" algn="ctr">
+                      <a:solidFill>
+                        <a:srgbClr val="D5D8E3"/>
+                      </a:solidFill>
+                      <a:prstDash val="solid"/>
+                      <a:round/>
+                      <a:headEnd type="none" w="med" len="med"/>
+                      <a:tailEnd type="none" w="med" len="med"/>
+                    </a:lnB>
+                    <a:solidFill>
+                      <a:srgbClr val="E23636"/>
+                    </a:solidFill>
+                  </a:tcPr>
+                </a:tc>
+              </a:tr>
+              <a:tr h="365760">
+                <a:tc>
+                  <a:txBody>
+                    <a:bodyPr/>
+                    <a:lstStyle/>
+                    <a:p>
+                      <a:pPr indent="0" marL="0">
+                        <a:buNone/>
+                      </a:pPr>
+                      <a:r>
+                        <a:rPr lang="en-US" sz="950" dirty="0">
+                          <a:solidFill>
+                            <a:srgbClr val="1F2233"/>
+                          </a:solidFill>
+                          <a:latin typeface="Calibri" pitchFamily="34" charset="0"/>
+                          <a:ea typeface="Calibri" pitchFamily="34" charset="-122"/>
+                          <a:cs typeface="Calibri" pitchFamily="34" charset="-120"/>
+                        </a:rPr>
+                        <a:t>Résultats des 10 premiers matchs et départ à 7 jours</a:t>
+                      </a:r>
+                      <a:endParaRPr lang="en-US" sz="950" dirty="0">
+                        <a:latin typeface="Calibri" charset="0"/>
+                        <a:ea typeface="Calibri" charset="0"/>
+                        <a:cs typeface="Calibri" charset="0"/>
+                      </a:endParaRPr>
+                    </a:p>
+                  </a:txBody>
+                  <a:tcPr marL="63500" marR="63500" marT="25400" marB="25400" anchor="ctr">
+                    <a:lnL w="6350" cap="flat" cmpd="sng" algn="ctr">
+                      <a:solidFill>
+                        <a:srgbClr val="D5D8E3"/>
+                      </a:solidFill>
+                      <a:prstDash val="solid"/>
+                      <a:round/>
+                      <a:headEnd type="none" w="med" len="med"/>
+                      <a:tailEnd type="none" w="med" len="med"/>
+                    </a:lnL>
+                    <a:lnR w="6350" cap="flat" cmpd="sng" algn="ctr">
+                      <a:solidFill>
+                        <a:srgbClr val="D5D8E3"/>
+                      </a:solidFill>
+                      <a:prstDash val="solid"/>
+                      <a:round/>
+                      <a:headEnd type="none" w="med" len="med"/>
+                      <a:tailEnd type="none" w="med" len="med"/>
+                    </a:lnR>
+                    <a:lnT w="6350" cap="flat" cmpd="sng" algn="ctr">
+                      <a:solidFill>
+                        <a:srgbClr val="D5D8E3"/>
+                      </a:solidFill>
+                      <a:prstDash val="solid"/>
+                      <a:round/>
+                      <a:headEnd type="none" w="med" len="med"/>
+                      <a:tailEnd type="none" w="med" len="med"/>
+                    </a:lnT>
+                    <a:lnB w="6350" cap="flat" cmpd="sng" algn="ctr">
+                      <a:solidFill>
+                        <a:srgbClr val="D5D8E3"/>
+                      </a:solidFill>
+                      <a:prstDash val="solid"/>
+                      <a:round/>
+                      <a:headEnd type="none" w="med" len="med"/>
+                      <a:tailEnd type="none" w="med" len="med"/>
+                    </a:lnB>
+                    <a:solidFill>
+                      <a:srgbClr val="FFFFFF"/>
+                    </a:solidFill>
+                  </a:tcPr>
+                </a:tc>
+                <a:tc>
+                  <a:txBody>
+                    <a:bodyPr/>
+                    <a:lstStyle/>
+                    <a:p>
+                      <a:pPr indent="0" marL="0">
+                        <a:buNone/>
+                      </a:pPr>
+                      <a:r>
+                        <a:rPr lang="en-US" sz="950" dirty="0">
+                          <a:solidFill>
+                            <a:srgbClr val="1F2233"/>
+                          </a:solidFill>
+                          <a:latin typeface="Calibri" pitchFamily="34" charset="0"/>
+                          <a:ea typeface="Calibri" pitchFamily="34" charset="-122"/>
+                          <a:cs typeface="Calibri" pitchFamily="34" charset="-120"/>
+                        </a:rPr>
+                        <a:t>Si perdre au début fait partir</a:t>
+                      </a:r>
+                      <a:endParaRPr lang="en-US" sz="950" dirty="0">
+                        <a:latin typeface="Calibri" charset="0"/>
+                        <a:ea typeface="Calibri" charset="0"/>
+                        <a:cs typeface="Calibri" charset="0"/>
+                      </a:endParaRPr>
+                    </a:p>
+                  </a:txBody>
+                  <a:tcPr marL="63500" marR="63500" marT="25400" marB="25400" anchor="ctr">
+                    <a:lnL w="6350" cap="flat" cmpd="sng" algn="ctr">
+                      <a:solidFill>
+                        <a:srgbClr val="D5D8E3"/>
+                      </a:solidFill>
+                      <a:prstDash val="solid"/>
+                      <a:round/>
+                      <a:headEnd type="none" w="med" len="med"/>
+                      <a:tailEnd type="none" w="med" len="med"/>
+                    </a:lnL>
+                    <a:lnR w="6350" cap="flat" cmpd="sng" algn="ctr">
+                      <a:solidFill>
+                        <a:srgbClr val="D5D8E3"/>
+                      </a:solidFill>
+                      <a:prstDash val="solid"/>
+                      <a:round/>
+                      <a:headEnd type="none" w="med" len="med"/>
+                      <a:tailEnd type="none" w="med" len="med"/>
+                    </a:lnR>
+                    <a:lnT w="6350" cap="flat" cmpd="sng" algn="ctr">
+                      <a:solidFill>
+                        <a:srgbClr val="D5D8E3"/>
+                      </a:solidFill>
+                      <a:prstDash val="solid"/>
+                      <a:round/>
+                      <a:headEnd type="none" w="med" len="med"/>
+                      <a:tailEnd type="none" w="med" len="med"/>
+                    </a:lnT>
+                    <a:lnB w="6350" cap="flat" cmpd="sng" algn="ctr">
+                      <a:solidFill>
+                        <a:srgbClr val="D5D8E3"/>
+                      </a:solidFill>
+                      <a:prstDash val="solid"/>
+                      <a:round/>
+                      <a:headEnd type="none" w="med" len="med"/>
+                      <a:tailEnd type="none" w="med" len="med"/>
+                    </a:lnB>
+                    <a:solidFill>
+                      <a:srgbClr val="FFFFFF"/>
+                    </a:solidFill>
+                  </a:tcPr>
+                </a:tc>
+                <a:tc>
+                  <a:txBody>
+                    <a:bodyPr/>
+                    <a:lstStyle/>
+                    <a:p>
+                      <a:pPr indent="0" marL="0">
+                        <a:buNone/>
+                      </a:pPr>
+                      <a:r>
+                        <a:rPr lang="en-US" sz="950" dirty="0">
+                          <a:solidFill>
+                            <a:srgbClr val="1F2233"/>
+                          </a:solidFill>
+                          <a:latin typeface="Calibri" pitchFamily="34" charset="0"/>
+                          <a:ea typeface="Calibri" pitchFamily="34" charset="-122"/>
+                          <a:cs typeface="Calibri" pitchFamily="34" charset="-120"/>
+                        </a:rPr>
+                        <a:t>C'est la mesure de l'objectif : sans elle, pas de preuve du problème</a:t>
+                      </a:r>
+                      <a:endParaRPr lang="en-US" sz="950" dirty="0">
+                        <a:latin typeface="Calibri" charset="0"/>
+                        <a:ea typeface="Calibri" charset="0"/>
+                        <a:cs typeface="Calibri" charset="0"/>
+                      </a:endParaRPr>
+                    </a:p>
+                  </a:txBody>
+                  <a:tcPr marL="63500" marR="63500" marT="25400" marB="25400" anchor="ctr">
+                    <a:lnL w="6350" cap="flat" cmpd="sng" algn="ctr">
+                      <a:solidFill>
+                        <a:srgbClr val="D5D8E3"/>
+                      </a:solidFill>
+                      <a:prstDash val="solid"/>
+                      <a:round/>
+                      <a:headEnd type="none" w="med" len="med"/>
+                      <a:tailEnd type="none" w="med" len="med"/>
+                    </a:lnL>
+                    <a:lnR w="6350" cap="flat" cmpd="sng" algn="ctr">
+                      <a:solidFill>
+                        <a:srgbClr val="D5D8E3"/>
+                      </a:solidFill>
+                      <a:prstDash val="solid"/>
+                      <a:round/>
+                      <a:headEnd type="none" w="med" len="med"/>
+                      <a:tailEnd type="none" w="med" len="med"/>
+                    </a:lnR>
+                    <a:lnT w="6350" cap="flat" cmpd="sng" algn="ctr">
+                      <a:solidFill>
+                        <a:srgbClr val="D5D8E3"/>
+                      </a:solidFill>
+                      <a:prstDash val="solid"/>
+                      <a:round/>
+                      <a:headEnd type="none" w="med" len="med"/>
+                      <a:tailEnd type="none" w="med" len="med"/>
+                    </a:lnT>
+                    <a:lnB w="6350" cap="flat" cmpd="sng" algn="ctr">
+                      <a:solidFill>
+                        <a:srgbClr val="D5D8E3"/>
+                      </a:solidFill>
+                      <a:prstDash val="solid"/>
+                      <a:round/>
+                      <a:headEnd type="none" w="med" len="med"/>
+                      <a:tailEnd type="none" w="med" len="med"/>
+                    </a:lnB>
+                    <a:solidFill>
+                      <a:srgbClr val="FFFFFF"/>
+                    </a:solidFill>
+                  </a:tcPr>
+                </a:tc>
+              </a:tr>
+              <a:tr h="365760">
+                <a:tc>
+                  <a:txBody>
+                    <a:bodyPr/>
+                    <a:lstStyle/>
+                    <a:p>
+                      <a:pPr indent="0" marL="0">
+                        <a:buNone/>
+                      </a:pPr>
+                      <a:r>
+                        <a:rPr lang="en-US" sz="950" dirty="0">
+                          <a:solidFill>
+                            <a:srgbClr val="1F2233"/>
+                          </a:solidFill>
+                          <a:latin typeface="Calibri" pitchFamily="34" charset="0"/>
+                          <a:ea typeface="Calibri" pitchFamily="34" charset="-122"/>
+                          <a:cs typeface="Calibri" pitchFamily="34" charset="-120"/>
+                        </a:rPr>
+                        <a:t>Mode et plateforme de ces 10 premiers matchs</a:t>
+                      </a:r>
+                      <a:endParaRPr lang="en-US" sz="950" dirty="0">
+                        <a:latin typeface="Calibri" charset="0"/>
+                        <a:ea typeface="Calibri" charset="0"/>
+                        <a:cs typeface="Calibri" charset="0"/>
+                      </a:endParaRPr>
+                    </a:p>
+                  </a:txBody>
+                  <a:tcPr marL="63500" marR="63500" marT="25400" marB="25400" anchor="ctr">
+                    <a:lnL w="6350" cap="flat" cmpd="sng" algn="ctr">
+                      <a:solidFill>
+                        <a:srgbClr val="D5D8E3"/>
+                      </a:solidFill>
+                      <a:prstDash val="solid"/>
+                      <a:round/>
+                      <a:headEnd type="none" w="med" len="med"/>
+                      <a:tailEnd type="none" w="med" len="med"/>
+                    </a:lnL>
+                    <a:lnR w="6350" cap="flat" cmpd="sng" algn="ctr">
+                      <a:solidFill>
+                        <a:srgbClr val="D5D8E3"/>
+                      </a:solidFill>
+                      <a:prstDash val="solid"/>
+                      <a:round/>
+                      <a:headEnd type="none" w="med" len="med"/>
+                      <a:tailEnd type="none" w="med" len="med"/>
+                    </a:lnR>
+                    <a:lnT w="6350" cap="flat" cmpd="sng" algn="ctr">
+                      <a:solidFill>
+                        <a:srgbClr val="D5D8E3"/>
+                      </a:solidFill>
+                      <a:prstDash val="solid"/>
+                      <a:round/>
+                      <a:headEnd type="none" w="med" len="med"/>
+                      <a:tailEnd type="none" w="med" len="med"/>
+                    </a:lnT>
+                    <a:lnB w="6350" cap="flat" cmpd="sng" algn="ctr">
+                      <a:solidFill>
+                        <a:srgbClr val="D5D8E3"/>
+                      </a:solidFill>
+                      <a:prstDash val="solid"/>
+                      <a:round/>
+                      <a:headEnd type="none" w="med" len="med"/>
+                      <a:tailEnd type="none" w="med" len="med"/>
+                    </a:lnB>
+                    <a:solidFill>
+                      <a:srgbClr val="FFFFFF"/>
+                    </a:solidFill>
+                  </a:tcPr>
+                </a:tc>
+                <a:tc>
+                  <a:txBody>
+                    <a:bodyPr/>
+                    <a:lstStyle/>
+                    <a:p>
+                      <a:pPr indent="0" marL="0">
+                        <a:buNone/>
+                      </a:pPr>
+                      <a:r>
+                        <a:rPr lang="en-US" sz="950" dirty="0">
+                          <a:solidFill>
+                            <a:srgbClr val="1F2233"/>
+                          </a:solidFill>
+                          <a:latin typeface="Calibri" pitchFamily="34" charset="0"/>
+                          <a:ea typeface="Calibri" pitchFamily="34" charset="-122"/>
+                          <a:cs typeface="Calibri" pitchFamily="34" charset="-120"/>
+                        </a:rPr>
+                        <a:t>Où jouent les nouveaux : quel mode, PC ou console</a:t>
+                      </a:r>
+                      <a:endParaRPr lang="en-US" sz="950" dirty="0">
+                        <a:latin typeface="Calibri" charset="0"/>
+                        <a:ea typeface="Calibri" charset="0"/>
+                        <a:cs typeface="Calibri" charset="0"/>
+                      </a:endParaRPr>
+                    </a:p>
+                  </a:txBody>
+                  <a:tcPr marL="63500" marR="63500" marT="25400" marB="25400" anchor="ctr">
+                    <a:lnL w="6350" cap="flat" cmpd="sng" algn="ctr">
+                      <a:solidFill>
+                        <a:srgbClr val="D5D8E3"/>
+                      </a:solidFill>
+                      <a:prstDash val="solid"/>
+                      <a:round/>
+                      <a:headEnd type="none" w="med" len="med"/>
+                      <a:tailEnd type="none" w="med" len="med"/>
+                    </a:lnL>
+                    <a:lnR w="6350" cap="flat" cmpd="sng" algn="ctr">
+                      <a:solidFill>
+                        <a:srgbClr val="D5D8E3"/>
+                      </a:solidFill>
+                      <a:prstDash val="solid"/>
+                      <a:round/>
+                      <a:headEnd type="none" w="med" len="med"/>
+                      <a:tailEnd type="none" w="med" len="med"/>
+                    </a:lnR>
+                    <a:lnT w="6350" cap="flat" cmpd="sng" algn="ctr">
+                      <a:solidFill>
+                        <a:srgbClr val="D5D8E3"/>
+                      </a:solidFill>
+                      <a:prstDash val="solid"/>
+                      <a:round/>
+                      <a:headEnd type="none" w="med" len="med"/>
+                      <a:tailEnd type="none" w="med" len="med"/>
+                    </a:lnT>
+                    <a:lnB w="6350" cap="flat" cmpd="sng" algn="ctr">
+                      <a:solidFill>
+                        <a:srgbClr val="D5D8E3"/>
+                      </a:solidFill>
+                      <a:prstDash val="solid"/>
+                      <a:round/>
+                      <a:headEnd type="none" w="med" len="med"/>
+                      <a:tailEnd type="none" w="med" len="med"/>
+                    </a:lnB>
+                    <a:solidFill>
+                      <a:srgbClr val="FFFFFF"/>
+                    </a:solidFill>
+                  </a:tcPr>
+                </a:tc>
+                <a:tc>
+                  <a:txBody>
+                    <a:bodyPr/>
+                    <a:lstStyle/>
+                    <a:p>
+                      <a:pPr indent="0" marL="0">
+                        <a:buNone/>
+                      </a:pPr>
+                      <a:r>
+                        <a:rPr lang="en-US" sz="950" dirty="0">
+                          <a:solidFill>
+                            <a:srgbClr val="1F2233"/>
+                          </a:solidFill>
+                          <a:latin typeface="Calibri" pitchFamily="34" charset="0"/>
+                          <a:ea typeface="Calibri" pitchFamily="34" charset="-122"/>
+                          <a:cs typeface="Calibri" pitchFamily="34" charset="-120"/>
+                        </a:rPr>
+                        <a:t>Dit quel mode corriger en premier (Steam = PC seul)</a:t>
+                      </a:r>
+                      <a:endParaRPr lang="en-US" sz="950" dirty="0">
+                        <a:latin typeface="Calibri" charset="0"/>
+                        <a:ea typeface="Calibri" charset="0"/>
+                        <a:cs typeface="Calibri" charset="0"/>
+                      </a:endParaRPr>
+                    </a:p>
+                  </a:txBody>
+                  <a:tcPr marL="63500" marR="63500" marT="25400" marB="25400" anchor="ctr">
+                    <a:lnL w="6350" cap="flat" cmpd="sng" algn="ctr">
+                      <a:solidFill>
+                        <a:srgbClr val="D5D8E3"/>
+                      </a:solidFill>
+                      <a:prstDash val="solid"/>
+                      <a:round/>
+                      <a:headEnd type="none" w="med" len="med"/>
+                      <a:tailEnd type="none" w="med" len="med"/>
+                    </a:lnL>
+                    <a:lnR w="6350" cap="flat" cmpd="sng" algn="ctr">
+                      <a:solidFill>
+                        <a:srgbClr val="D5D8E3"/>
+                      </a:solidFill>
+                      <a:prstDash val="solid"/>
+                      <a:round/>
+                      <a:headEnd type="none" w="med" len="med"/>
+                      <a:tailEnd type="none" w="med" len="med"/>
+                    </a:lnR>
+                    <a:lnT w="6350" cap="flat" cmpd="sng" algn="ctr">
+                      <a:solidFill>
+                        <a:srgbClr val="D5D8E3"/>
+                      </a:solidFill>
+                      <a:prstDash val="solid"/>
+                      <a:round/>
+                      <a:headEnd type="none" w="med" len="med"/>
+                      <a:tailEnd type="none" w="med" len="med"/>
+                    </a:lnT>
+                    <a:lnB w="6350" cap="flat" cmpd="sng" algn="ctr">
+                      <a:solidFill>
+                        <a:srgbClr val="D5D8E3"/>
+                      </a:solidFill>
+                      <a:prstDash val="solid"/>
+                      <a:round/>
+                      <a:headEnd type="none" w="med" len="med"/>
+                      <a:tailEnd type="none" w="med" len="med"/>
+                    </a:lnB>
+                    <a:solidFill>
+                      <a:srgbClr val="FFFFFF"/>
+                    </a:solidFill>
+                  </a:tcPr>
+                </a:tc>
+              </a:tr>
+              <a:tr h="365760">
+                <a:tc>
+                  <a:txBody>
+                    <a:bodyPr/>
+                    <a:lstStyle/>
+                    <a:p>
+                      <a:pPr indent="0" marL="0">
+                        <a:buNone/>
+                      </a:pPr>
+                      <a:r>
+                        <a:rPr lang="en-US" sz="950" dirty="0">
+                          <a:solidFill>
+                            <a:srgbClr val="1F2233"/>
+                          </a:solidFill>
+                          <a:latin typeface="Calibri" pitchFamily="34" charset="0"/>
+                          <a:ea typeface="Calibri" pitchFamily="34" charset="-122"/>
+                          <a:cs typeface="Calibri" pitchFamily="34" charset="-120"/>
+                        </a:rPr>
+                        <a:t>Niveau de départ attribué comparé au niveau réel après 50 matchs</a:t>
+                      </a:r>
+                      <a:endParaRPr lang="en-US" sz="950" dirty="0">
+                        <a:latin typeface="Calibri" charset="0"/>
+                        <a:ea typeface="Calibri" charset="0"/>
+                        <a:cs typeface="Calibri" charset="0"/>
+                      </a:endParaRPr>
+                    </a:p>
+                  </a:txBody>
+                  <a:tcPr marL="63500" marR="63500" marT="25400" marB="25400" anchor="ctr">
+                    <a:lnL w="6350" cap="flat" cmpd="sng" algn="ctr">
+                      <a:solidFill>
+                        <a:srgbClr val="D5D8E3"/>
+                      </a:solidFill>
+                      <a:prstDash val="solid"/>
+                      <a:round/>
+                      <a:headEnd type="none" w="med" len="med"/>
+                      <a:tailEnd type="none" w="med" len="med"/>
+                    </a:lnL>
+                    <a:lnR w="6350" cap="flat" cmpd="sng" algn="ctr">
+                      <a:solidFill>
+                        <a:srgbClr val="D5D8E3"/>
+                      </a:solidFill>
+                      <a:prstDash val="solid"/>
+                      <a:round/>
+                      <a:headEnd type="none" w="med" len="med"/>
+                      <a:tailEnd type="none" w="med" len="med"/>
+                    </a:lnR>
+                    <a:lnT w="6350" cap="flat" cmpd="sng" algn="ctr">
+                      <a:solidFill>
+                        <a:srgbClr val="D5D8E3"/>
+                      </a:solidFill>
+                      <a:prstDash val="solid"/>
+                      <a:round/>
+                      <a:headEnd type="none" w="med" len="med"/>
+                      <a:tailEnd type="none" w="med" len="med"/>
+                    </a:lnT>
+                    <a:lnB w="6350" cap="flat" cmpd="sng" algn="ctr">
+                      <a:solidFill>
+                        <a:srgbClr val="D5D8E3"/>
+                      </a:solidFill>
+                      <a:prstDash val="solid"/>
+                      <a:round/>
+                      <a:headEnd type="none" w="med" len="med"/>
+                      <a:tailEnd type="none" w="med" len="med"/>
+                    </a:lnB>
+                    <a:solidFill>
+                      <a:srgbClr val="FFFFFF"/>
+                    </a:solidFill>
+                  </a:tcPr>
+                </a:tc>
+                <a:tc>
+                  <a:txBody>
+                    <a:bodyPr/>
+                    <a:lstStyle/>
+                    <a:p>
+                      <a:pPr indent="0" marL="0">
+                        <a:buNone/>
+                      </a:pPr>
+                      <a:r>
+                        <a:rPr lang="en-US" sz="950" dirty="0">
+                          <a:solidFill>
+                            <a:srgbClr val="1F2233"/>
+                          </a:solidFill>
+                          <a:latin typeface="Calibri" pitchFamily="34" charset="0"/>
+                          <a:ea typeface="Calibri" pitchFamily="34" charset="-122"/>
+                          <a:cs typeface="Calibri" pitchFamily="34" charset="-120"/>
+                        </a:rPr>
+                        <a:t>Si le jeu place mal un nouveau à l'arrivée</a:t>
+                      </a:r>
+                      <a:endParaRPr lang="en-US" sz="950" dirty="0">
+                        <a:latin typeface="Calibri" charset="0"/>
+                        <a:ea typeface="Calibri" charset="0"/>
+                        <a:cs typeface="Calibri" charset="0"/>
+                      </a:endParaRPr>
+                    </a:p>
+                  </a:txBody>
+                  <a:tcPr marL="63500" marR="63500" marT="25400" marB="25400" anchor="ctr">
+                    <a:lnL w="6350" cap="flat" cmpd="sng" algn="ctr">
+                      <a:solidFill>
+                        <a:srgbClr val="D5D8E3"/>
+                      </a:solidFill>
+                      <a:prstDash val="solid"/>
+                      <a:round/>
+                      <a:headEnd type="none" w="med" len="med"/>
+                      <a:tailEnd type="none" w="med" len="med"/>
+                    </a:lnL>
+                    <a:lnR w="6350" cap="flat" cmpd="sng" algn="ctr">
+                      <a:solidFill>
+                        <a:srgbClr val="D5D8E3"/>
+                      </a:solidFill>
+                      <a:prstDash val="solid"/>
+                      <a:round/>
+                      <a:headEnd type="none" w="med" len="med"/>
+                      <a:tailEnd type="none" w="med" len="med"/>
+                    </a:lnR>
+                    <a:lnT w="6350" cap="flat" cmpd="sng" algn="ctr">
+                      <a:solidFill>
+                        <a:srgbClr val="D5D8E3"/>
+                      </a:solidFill>
+                      <a:prstDash val="solid"/>
+                      <a:round/>
+                      <a:headEnd type="none" w="med" len="med"/>
+                      <a:tailEnd type="none" w="med" len="med"/>
+                    </a:lnT>
+                    <a:lnB w="6350" cap="flat" cmpd="sng" algn="ctr">
+                      <a:solidFill>
+                        <a:srgbClr val="D5D8E3"/>
+                      </a:solidFill>
+                      <a:prstDash val="solid"/>
+                      <a:round/>
+                      <a:headEnd type="none" w="med" len="med"/>
+                      <a:tailEnd type="none" w="med" len="med"/>
+                    </a:lnB>
+                    <a:solidFill>
+                      <a:srgbClr val="FFFFFF"/>
+                    </a:solidFill>
+                  </a:tcPr>
+                </a:tc>
+                <a:tc>
+                  <a:txBody>
+                    <a:bodyPr/>
+                    <a:lstStyle/>
+                    <a:p>
+                      <a:pPr indent="0" marL="0">
+                        <a:buNone/>
+                      </a:pPr>
+                      <a:r>
+                        <a:rPr lang="en-US" sz="950" dirty="0">
+                          <a:solidFill>
+                            <a:srgbClr val="1F2233"/>
+                          </a:solidFill>
+                          <a:latin typeface="Calibri" pitchFamily="34" charset="0"/>
+                          <a:ea typeface="Calibri" pitchFamily="34" charset="-122"/>
+                          <a:cs typeface="Calibri" pitchFamily="34" charset="-120"/>
+                        </a:rPr>
+                        <a:t>Teste la cause A (démarrage à froid)</a:t>
+                      </a:r>
+                      <a:endParaRPr lang="en-US" sz="950" dirty="0">
+                        <a:latin typeface="Calibri" charset="0"/>
+                        <a:ea typeface="Calibri" charset="0"/>
+                        <a:cs typeface="Calibri" charset="0"/>
+                      </a:endParaRPr>
+                    </a:p>
+                  </a:txBody>
+                  <a:tcPr marL="63500" marR="63500" marT="25400" marB="25400" anchor="ctr">
+                    <a:lnL w="6350" cap="flat" cmpd="sng" algn="ctr">
+                      <a:solidFill>
+                        <a:srgbClr val="D5D8E3"/>
+                      </a:solidFill>
+                      <a:prstDash val="solid"/>
+                      <a:round/>
+                      <a:headEnd type="none" w="med" len="med"/>
+                      <a:tailEnd type="none" w="med" len="med"/>
+                    </a:lnL>
+                    <a:lnR w="6350" cap="flat" cmpd="sng" algn="ctr">
+                      <a:solidFill>
+                        <a:srgbClr val="D5D8E3"/>
+                      </a:solidFill>
+                      <a:prstDash val="solid"/>
+                      <a:round/>
+                      <a:headEnd type="none" w="med" len="med"/>
+                      <a:tailEnd type="none" w="med" len="med"/>
+                    </a:lnR>
+                    <a:lnT w="6350" cap="flat" cmpd="sng" algn="ctr">
+                      <a:solidFill>
+                        <a:srgbClr val="D5D8E3"/>
+                      </a:solidFill>
+                      <a:prstDash val="solid"/>
+                      <a:round/>
+                      <a:headEnd type="none" w="med" len="med"/>
+                      <a:tailEnd type="none" w="med" len="med"/>
+                    </a:lnT>
+                    <a:lnB w="6350" cap="flat" cmpd="sng" algn="ctr">
+                      <a:solidFill>
+                        <a:srgbClr val="D5D8E3"/>
+                      </a:solidFill>
+                      <a:prstDash val="solid"/>
+                      <a:round/>
+                      <a:headEnd type="none" w="med" len="med"/>
+                      <a:tailEnd type="none" w="med" len="med"/>
+                    </a:lnB>
+                    <a:solidFill>
+                      <a:srgbClr val="FFFFFF"/>
+                    </a:solidFill>
+                  </a:tcPr>
+                </a:tc>
+              </a:tr>
+              <a:tr h="365760">
+                <a:tc>
+                  <a:txBody>
+                    <a:bodyPr/>
+                    <a:lstStyle/>
+                    <a:p>
+                      <a:pPr indent="0" marL="0">
+                        <a:buNone/>
+                      </a:pPr>
+                      <a:r>
+                        <a:rPr lang="en-US" sz="950" dirty="0">
+                          <a:solidFill>
+                            <a:srgbClr val="1F2233"/>
+                          </a:solidFill>
+                          <a:latin typeface="Calibri" pitchFamily="34" charset="0"/>
+                          <a:ea typeface="Calibri" pitchFamily="34" charset="-122"/>
+                          <a:cs typeface="Calibri" pitchFamily="34" charset="-120"/>
+                        </a:rPr>
+                        <a:t>Écart de niveau par match, selon les joueurs en file, l'heure, la région</a:t>
+                      </a:r>
+                      <a:endParaRPr lang="en-US" sz="950" dirty="0">
+                        <a:latin typeface="Calibri" charset="0"/>
+                        <a:ea typeface="Calibri" charset="0"/>
+                        <a:cs typeface="Calibri" charset="0"/>
+                      </a:endParaRPr>
+                    </a:p>
+                  </a:txBody>
+                  <a:tcPr marL="63500" marR="63500" marT="25400" marB="25400" anchor="ctr">
+                    <a:lnL w="6350" cap="flat" cmpd="sng" algn="ctr">
+                      <a:solidFill>
+                        <a:srgbClr val="D5D8E3"/>
+                      </a:solidFill>
+                      <a:prstDash val="solid"/>
+                      <a:round/>
+                      <a:headEnd type="none" w="med" len="med"/>
+                      <a:tailEnd type="none" w="med" len="med"/>
+                    </a:lnL>
+                    <a:lnR w="6350" cap="flat" cmpd="sng" algn="ctr">
+                      <a:solidFill>
+                        <a:srgbClr val="D5D8E3"/>
+                      </a:solidFill>
+                      <a:prstDash val="solid"/>
+                      <a:round/>
+                      <a:headEnd type="none" w="med" len="med"/>
+                      <a:tailEnd type="none" w="med" len="med"/>
+                    </a:lnR>
+                    <a:lnT w="6350" cap="flat" cmpd="sng" algn="ctr">
+                      <a:solidFill>
+                        <a:srgbClr val="D5D8E3"/>
+                      </a:solidFill>
+                      <a:prstDash val="solid"/>
+                      <a:round/>
+                      <a:headEnd type="none" w="med" len="med"/>
+                      <a:tailEnd type="none" w="med" len="med"/>
+                    </a:lnT>
+                    <a:lnB w="6350" cap="flat" cmpd="sng" algn="ctr">
+                      <a:solidFill>
+                        <a:srgbClr val="D5D8E3"/>
+                      </a:solidFill>
+                      <a:prstDash val="solid"/>
+                      <a:round/>
+                      <a:headEnd type="none" w="med" len="med"/>
+                      <a:tailEnd type="none" w="med" len="med"/>
+                    </a:lnB>
+                    <a:solidFill>
+                      <a:srgbClr val="FFFFFF"/>
+                    </a:solidFill>
+                  </a:tcPr>
+                </a:tc>
+                <a:tc>
+                  <a:txBody>
+                    <a:bodyPr/>
+                    <a:lstStyle/>
+                    <a:p>
+                      <a:pPr indent="0" marL="0">
+                        <a:buNone/>
+                      </a:pPr>
+                      <a:r>
+                        <a:rPr lang="en-US" sz="950" dirty="0">
+                          <a:solidFill>
+                            <a:srgbClr val="1F2233"/>
+                          </a:solidFill>
+                          <a:latin typeface="Calibri" pitchFamily="34" charset="0"/>
+                          <a:ea typeface="Calibri" pitchFamily="34" charset="-122"/>
+                          <a:cs typeface="Calibri" pitchFamily="34" charset="-120"/>
+                        </a:rPr>
+                        <a:t>Si l'écart grandit quand il y a peu de joueurs</a:t>
+                      </a:r>
+                      <a:endParaRPr lang="en-US" sz="950" dirty="0">
+                        <a:latin typeface="Calibri" charset="0"/>
+                        <a:ea typeface="Calibri" charset="0"/>
+                        <a:cs typeface="Calibri" charset="0"/>
+                      </a:endParaRPr>
+                    </a:p>
+                  </a:txBody>
+                  <a:tcPr marL="63500" marR="63500" marT="25400" marB="25400" anchor="ctr">
+                    <a:lnL w="6350" cap="flat" cmpd="sng" algn="ctr">
+                      <a:solidFill>
+                        <a:srgbClr val="D5D8E3"/>
+                      </a:solidFill>
+                      <a:prstDash val="solid"/>
+                      <a:round/>
+                      <a:headEnd type="none" w="med" len="med"/>
+                      <a:tailEnd type="none" w="med" len="med"/>
+                    </a:lnL>
+                    <a:lnR w="6350" cap="flat" cmpd="sng" algn="ctr">
+                      <a:solidFill>
+                        <a:srgbClr val="D5D8E3"/>
+                      </a:solidFill>
+                      <a:prstDash val="solid"/>
+                      <a:round/>
+                      <a:headEnd type="none" w="med" len="med"/>
+                      <a:tailEnd type="none" w="med" len="med"/>
+                    </a:lnR>
+                    <a:lnT w="6350" cap="flat" cmpd="sng" algn="ctr">
+                      <a:solidFill>
+                        <a:srgbClr val="D5D8E3"/>
+                      </a:solidFill>
+                      <a:prstDash val="solid"/>
+                      <a:round/>
+                      <a:headEnd type="none" w="med" len="med"/>
+                      <a:tailEnd type="none" w="med" len="med"/>
+                    </a:lnT>
+                    <a:lnB w="6350" cap="flat" cmpd="sng" algn="ctr">
+                      <a:solidFill>
+                        <a:srgbClr val="D5D8E3"/>
+                      </a:solidFill>
+                      <a:prstDash val="solid"/>
+                      <a:round/>
+                      <a:headEnd type="none" w="med" len="med"/>
+                      <a:tailEnd type="none" w="med" len="med"/>
+                    </a:lnB>
+                    <a:solidFill>
+                      <a:srgbClr val="FFFFFF"/>
+                    </a:solidFill>
+                  </a:tcPr>
+                </a:tc>
+                <a:tc>
+                  <a:txBody>
+                    <a:bodyPr/>
+                    <a:lstStyle/>
+                    <a:p>
+                      <a:pPr indent="0" marL="0">
+                        <a:buNone/>
+                      </a:pPr>
+                      <a:r>
+                        <a:rPr lang="en-US" sz="950" dirty="0">
+                          <a:solidFill>
+                            <a:srgbClr val="1F2233"/>
+                          </a:solidFill>
+                          <a:latin typeface="Calibri" pitchFamily="34" charset="0"/>
+                          <a:ea typeface="Calibri" pitchFamily="34" charset="-122"/>
+                          <a:cs typeface="Calibri" pitchFamily="34" charset="-120"/>
+                        </a:rPr>
+                        <a:t>Teste la cause B (manque de joueurs)</a:t>
+                      </a:r>
+                      <a:endParaRPr lang="en-US" sz="950" dirty="0">
+                        <a:latin typeface="Calibri" charset="0"/>
+                        <a:ea typeface="Calibri" charset="0"/>
+                        <a:cs typeface="Calibri" charset="0"/>
+                      </a:endParaRPr>
+                    </a:p>
+                  </a:txBody>
+                  <a:tcPr marL="63500" marR="63500" marT="25400" marB="25400" anchor="ctr">
+                    <a:lnL w="6350" cap="flat" cmpd="sng" algn="ctr">
+                      <a:solidFill>
+                        <a:srgbClr val="D5D8E3"/>
+                      </a:solidFill>
+                      <a:prstDash val="solid"/>
+                      <a:round/>
+                      <a:headEnd type="none" w="med" len="med"/>
+                      <a:tailEnd type="none" w="med" len="med"/>
+                    </a:lnL>
+                    <a:lnR w="6350" cap="flat" cmpd="sng" algn="ctr">
+                      <a:solidFill>
+                        <a:srgbClr val="D5D8E3"/>
+                      </a:solidFill>
+                      <a:prstDash val="solid"/>
+                      <a:round/>
+                      <a:headEnd type="none" w="med" len="med"/>
+                      <a:tailEnd type="none" w="med" len="med"/>
+                    </a:lnR>
+                    <a:lnT w="6350" cap="flat" cmpd="sng" algn="ctr">
+                      <a:solidFill>
+                        <a:srgbClr val="D5D8E3"/>
+                      </a:solidFill>
+                      <a:prstDash val="solid"/>
+                      <a:round/>
+                      <a:headEnd type="none" w="med" len="med"/>
+                      <a:tailEnd type="none" w="med" len="med"/>
+                    </a:lnT>
+                    <a:lnB w="6350" cap="flat" cmpd="sng" algn="ctr">
+                      <a:solidFill>
+                        <a:srgbClr val="D5D8E3"/>
+                      </a:solidFill>
+                      <a:prstDash val="solid"/>
+                      <a:round/>
+                      <a:headEnd type="none" w="med" len="med"/>
+                      <a:tailEnd type="none" w="med" len="med"/>
+                    </a:lnB>
+                    <a:solidFill>
+                      <a:srgbClr val="FFFFFF"/>
+                    </a:solidFill>
+                  </a:tcPr>
+                </a:tc>
+              </a:tr>
+              <a:tr h="365760">
+                <a:tc>
+                  <a:txBody>
+                    <a:bodyPr/>
+                    <a:lstStyle/>
+                    <a:p>
+                      <a:pPr indent="0" marL="0">
+                        <a:buNone/>
+                      </a:pPr>
+                      <a:r>
+                        <a:rPr lang="en-US" sz="950" dirty="0">
+                          <a:solidFill>
+                            <a:srgbClr val="1F2233"/>
+                          </a:solidFill>
+                          <a:latin typeface="Calibri" pitchFamily="34" charset="0"/>
+                          <a:ea typeface="Calibri" pitchFamily="34" charset="-122"/>
+                          <a:cs typeface="Calibri" pitchFamily="34" charset="-120"/>
+                        </a:rPr>
+                        <a:t>Départs en classé avant / après les placements de la saison 5</a:t>
+                      </a:r>
+                      <a:endParaRPr lang="en-US" sz="950" dirty="0">
+                        <a:latin typeface="Calibri" charset="0"/>
+                        <a:ea typeface="Calibri" charset="0"/>
+                        <a:cs typeface="Calibri" charset="0"/>
+                      </a:endParaRPr>
+                    </a:p>
+                  </a:txBody>
+                  <a:tcPr marL="63500" marR="63500" marT="25400" marB="25400" anchor="ctr">
+                    <a:lnL w="6350" cap="flat" cmpd="sng" algn="ctr">
+                      <a:solidFill>
+                        <a:srgbClr val="D5D8E3"/>
+                      </a:solidFill>
+                      <a:prstDash val="solid"/>
+                      <a:round/>
+                      <a:headEnd type="none" w="med" len="med"/>
+                      <a:tailEnd type="none" w="med" len="med"/>
+                    </a:lnL>
+                    <a:lnR w="6350" cap="flat" cmpd="sng" algn="ctr">
+                      <a:solidFill>
+                        <a:srgbClr val="D5D8E3"/>
+                      </a:solidFill>
+                      <a:prstDash val="solid"/>
+                      <a:round/>
+                      <a:headEnd type="none" w="med" len="med"/>
+                      <a:tailEnd type="none" w="med" len="med"/>
+                    </a:lnR>
+                    <a:lnT w="6350" cap="flat" cmpd="sng" algn="ctr">
+                      <a:solidFill>
+                        <a:srgbClr val="D5D8E3"/>
+                      </a:solidFill>
+                      <a:prstDash val="solid"/>
+                      <a:round/>
+                      <a:headEnd type="none" w="med" len="med"/>
+                      <a:tailEnd type="none" w="med" len="med"/>
+                    </a:lnT>
+                    <a:lnB w="6350" cap="flat" cmpd="sng" algn="ctr">
+                      <a:solidFill>
+                        <a:srgbClr val="D5D8E3"/>
+                      </a:solidFill>
+                      <a:prstDash val="solid"/>
+                      <a:round/>
+                      <a:headEnd type="none" w="med" len="med"/>
+                      <a:tailEnd type="none" w="med" len="med"/>
+                    </a:lnB>
+                    <a:solidFill>
+                      <a:srgbClr val="FFFFFF"/>
+                    </a:solidFill>
+                  </a:tcPr>
+                </a:tc>
+                <a:tc>
+                  <a:txBody>
+                    <a:bodyPr/>
+                    <a:lstStyle/>
+                    <a:p>
+                      <a:pPr indent="0" marL="0">
+                        <a:buNone/>
+                      </a:pPr>
+                      <a:r>
+                        <a:rPr lang="en-US" sz="950" dirty="0">
+                          <a:solidFill>
+                            <a:srgbClr val="1F2233"/>
+                          </a:solidFill>
+                          <a:latin typeface="Calibri" pitchFamily="34" charset="0"/>
+                          <a:ea typeface="Calibri" pitchFamily="34" charset="-122"/>
+                          <a:cs typeface="Calibri" pitchFamily="34" charset="-120"/>
+                        </a:rPr>
+                        <a:t>Si mieux placer les joueurs les a retenus</a:t>
+                      </a:r>
+                      <a:endParaRPr lang="en-US" sz="950" dirty="0">
+                        <a:latin typeface="Calibri" charset="0"/>
+                        <a:ea typeface="Calibri" charset="0"/>
+                        <a:cs typeface="Calibri" charset="0"/>
+                      </a:endParaRPr>
+                    </a:p>
+                  </a:txBody>
+                  <a:tcPr marL="63500" marR="63500" marT="25400" marB="25400" anchor="ctr">
+                    <a:lnL w="6350" cap="flat" cmpd="sng" algn="ctr">
+                      <a:solidFill>
+                        <a:srgbClr val="D5D8E3"/>
+                      </a:solidFill>
+                      <a:prstDash val="solid"/>
+                      <a:round/>
+                      <a:headEnd type="none" w="med" len="med"/>
+                      <a:tailEnd type="none" w="med" len="med"/>
+                    </a:lnL>
+                    <a:lnR w="6350" cap="flat" cmpd="sng" algn="ctr">
+                      <a:solidFill>
+                        <a:srgbClr val="D5D8E3"/>
+                      </a:solidFill>
+                      <a:prstDash val="solid"/>
+                      <a:round/>
+                      <a:headEnd type="none" w="med" len="med"/>
+                      <a:tailEnd type="none" w="med" len="med"/>
+                    </a:lnR>
+                    <a:lnT w="6350" cap="flat" cmpd="sng" algn="ctr">
+                      <a:solidFill>
+                        <a:srgbClr val="D5D8E3"/>
+                      </a:solidFill>
+                      <a:prstDash val="solid"/>
+                      <a:round/>
+                      <a:headEnd type="none" w="med" len="med"/>
+                      <a:tailEnd type="none" w="med" len="med"/>
+                    </a:lnT>
+                    <a:lnB w="6350" cap="flat" cmpd="sng" algn="ctr">
+                      <a:solidFill>
+                        <a:srgbClr val="D5D8E3"/>
+                      </a:solidFill>
+                      <a:prstDash val="solid"/>
+                      <a:round/>
+                      <a:headEnd type="none" w="med" len="med"/>
+                      <a:tailEnd type="none" w="med" len="med"/>
+                    </a:lnB>
+                    <a:solidFill>
+                      <a:srgbClr val="FFFFFF"/>
+                    </a:solidFill>
+                  </a:tcPr>
+                </a:tc>
+                <a:tc>
+                  <a:txBody>
+                    <a:bodyPr/>
+                    <a:lstStyle/>
+                    <a:p>
+                      <a:pPr indent="0" marL="0">
+                        <a:buNone/>
+                      </a:pPr>
+                      <a:r>
+                        <a:rPr lang="en-US" sz="950" dirty="0">
+                          <a:solidFill>
+                            <a:srgbClr val="1F2233"/>
+                          </a:solidFill>
+                          <a:latin typeface="Calibri" pitchFamily="34" charset="0"/>
+                          <a:ea typeface="Calibri" pitchFamily="34" charset="-122"/>
+                          <a:cs typeface="Calibri" pitchFamily="34" charset="-120"/>
+                        </a:rPr>
+                        <a:t>Expérience déjà faite par NetEase : la preuve la moins chère</a:t>
+                      </a:r>
+                      <a:endParaRPr lang="en-US" sz="950" dirty="0">
+                        <a:latin typeface="Calibri" charset="0"/>
+                        <a:ea typeface="Calibri" charset="0"/>
+                        <a:cs typeface="Calibri" charset="0"/>
+                      </a:endParaRPr>
+                    </a:p>
+                  </a:txBody>
+                  <a:tcPr marL="63500" marR="63500" marT="25400" marB="25400" anchor="ctr">
+                    <a:lnL w="6350" cap="flat" cmpd="sng" algn="ctr">
+                      <a:solidFill>
+                        <a:srgbClr val="D5D8E3"/>
+                      </a:solidFill>
+                      <a:prstDash val="solid"/>
+                      <a:round/>
+                      <a:headEnd type="none" w="med" len="med"/>
+                      <a:tailEnd type="none" w="med" len="med"/>
+                    </a:lnL>
+                    <a:lnR w="6350" cap="flat" cmpd="sng" algn="ctr">
+                      <a:solidFill>
+                        <a:srgbClr val="D5D8E3"/>
+                      </a:solidFill>
+                      <a:prstDash val="solid"/>
+                      <a:round/>
+                      <a:headEnd type="none" w="med" len="med"/>
+                      <a:tailEnd type="none" w="med" len="med"/>
+                    </a:lnR>
+                    <a:lnT w="6350" cap="flat" cmpd="sng" algn="ctr">
+                      <a:solidFill>
+                        <a:srgbClr val="D5D8E3"/>
+                      </a:solidFill>
+                      <a:prstDash val="solid"/>
+                      <a:round/>
+                      <a:headEnd type="none" w="med" len="med"/>
+                      <a:tailEnd type="none" w="med" len="med"/>
+                    </a:lnT>
+                    <a:lnB w="6350" cap="flat" cmpd="sng" algn="ctr">
+                      <a:solidFill>
+                        <a:srgbClr val="D5D8E3"/>
+                      </a:solidFill>
+                      <a:prstDash val="solid"/>
+                      <a:round/>
+                      <a:headEnd type="none" w="med" len="med"/>
+                      <a:tailEnd type="none" w="med" len="med"/>
+                    </a:lnB>
+                    <a:solidFill>
+                      <a:srgbClr val="FFFFFF"/>
+                    </a:solidFill>
+                  </a:tcPr>
+                </a:tc>
+              </a:tr>
+            </a:tbl>
+          </a:graphicData>
+        </a:graphic>
+      </p:graphicFrame>
+      <p:sp>
+        <p:nvSpPr>
+          <p:cNvPr id="7" name="Text 4"/>
+          <p:cNvSpPr txBox="1"/>
+          <p:nvPr/>
+        </p:nvSpPr>
+        <p:spPr>
+          <a:xfrm>
+            <a:off x="457200" y="4370832"/>
+            <a:ext cx="8229600" cy="347472"/>
+          </a:xfrm>
+          <a:prstGeom prst="rect">
+            <a:avLst/>
+          </a:prstGeom>
+          <a:noFill/>
+          <a:ln/>
+        </p:spPr>
+        <p:txBody>
+          <a:bodyPr wrap="square" lIns="0" tIns="0" rIns="0" bIns="0" rtlCol="0" anchor="ctr"/>
+          <a:lstStyle/>
+          <a:p>
+            <a:pPr indent="0" marL="0">
+              <a:buNone/>
+            </a:pPr>
+            <a:r>
+              <a:rPr lang="en-US" sz="950" i="1" dirty="0">
+                <a:solidFill>
+                  <a:srgbClr val="5E6378"/>
+                </a:solidFill>
+                <a:latin typeface="Calibri" pitchFamily="34" charset="0"/>
+                <a:ea typeface="Calibri" pitchFamily="34" charset="-122"/>
+                <a:cs typeface="Calibri" pitchFamily="34" charset="-120"/>
+              </a:rPr>
+              <a:t>Ensuite, pour écarter les autres explications : héros joué, parties avec bots, joueurs en groupe, comptes arrivés en 2025. Toutes ces données existent déjà dans vos serveurs.</a:t>
+            </a:r>
+            <a:endParaRPr lang="en-US" sz="950" dirty="0"/>
+          </a:p>
+        </p:txBody>
+      </p:sp>
       <p:sp>
         <p:nvSpPr>
           <p:cNvPr id="8" name="Text 5"/>
@@ -5096,8 +5799,8 @@
         </p:nvSpPr>
         <p:spPr>
           <a:xfrm>
-            <a:off x="1051560" y="2468880"/>
-            <a:ext cx="3474720" cy="320040"/>
+            <a:off x="457200" y="4754880"/>
+            <a:ext cx="8229600" cy="256032"/>
           </a:xfrm>
           <a:prstGeom prst="rect">
             <a:avLst/>
@@ -5113,465 +5816,6 @@
               <a:buNone/>
             </a:pPr>
             <a:r>
-              <a:rPr lang="en-US" sz="1300" b="1" dirty="0">
-                <a:solidFill>
-                  <a:srgbClr val="1F2233"/>
-                </a:solidFill>
-                <a:latin typeface="Arial" pitchFamily="34" charset="0"/>
-                <a:ea typeface="Arial" pitchFamily="34" charset="-122"/>
-                <a:cs typeface="Arial" pitchFamily="34" charset="-120"/>
-              </a:rPr>
-              <a:t>Mesurer</a:t>
-            </a:r>
-            <a:endParaRPr lang="en-US" sz="1300" dirty="0"/>
-          </a:p>
-        </p:txBody>
-      </p:sp>
-      <p:sp>
-        <p:nvSpPr>
-          <p:cNvPr id="9" name="Text 6"/>
-          <p:cNvSpPr txBox="1"/>
-          <p:nvPr/>
-        </p:nvSpPr>
-        <p:spPr>
-          <a:xfrm>
-            <a:off x="1051560" y="2788920"/>
-            <a:ext cx="3474720" cy="594360"/>
-          </a:xfrm>
-          <a:prstGeom prst="rect">
-            <a:avLst/>
-          </a:prstGeom>
-          <a:noFill/>
-          <a:ln/>
-        </p:spPr>
-        <p:txBody>
-          <a:bodyPr wrap="square" lIns="0" tIns="0" rIns="0" bIns="0" rtlCol="0" anchor="t"/>
-          <a:lstStyle/>
-          <a:p>
-            <a:pPr indent="0" marL="0">
-              <a:buNone/>
-            </a:pPr>
-            <a:r>
-              <a:rPr lang="en-US" sz="1100" dirty="0">
-                <a:solidFill>
-                  <a:srgbClr val="1F2233"/>
-                </a:solidFill>
-                <a:latin typeface="Calibri" pitchFamily="34" charset="0"/>
-                <a:ea typeface="Calibri" pitchFamily="34" charset="-122"/>
-                <a:cs typeface="Calibri" pitchFamily="34" charset="-120"/>
-              </a:rPr>
-              <a:t>D2 churn J7 × 10 premiers matchs · D0 mode et plateforme</a:t>
-            </a:r>
-            <a:endParaRPr lang="en-US" sz="1100" dirty="0"/>
-          </a:p>
-        </p:txBody>
-      </p:sp>
-      <p:sp>
-        <p:nvSpPr>
-          <p:cNvPr id="10" name="Shape 7"/>
-          <p:cNvSpPr/>
-          <p:nvPr/>
-        </p:nvSpPr>
-        <p:spPr>
-          <a:xfrm>
-            <a:off x="4663440" y="2514600"/>
-            <a:ext cx="457200" cy="457200"/>
-          </a:xfrm>
-          <a:prstGeom prst="ellipse">
-            <a:avLst/>
-          </a:prstGeom>
-          <a:solidFill>
-            <a:srgbClr val="E23636"/>
-          </a:solidFill>
-          <a:ln w="12700">
-            <a:solidFill>
-              <a:srgbClr val="E23636"/>
-            </a:solidFill>
-            <a:prstDash val="solid"/>
-          </a:ln>
-        </p:spPr>
-      </p:sp>
-      <p:pic>
-        <p:nvPicPr>
-          <p:cNvPr id="11" name="Image 1" descr="preencoded.png">    </p:cNvPr>
-          <p:cNvPicPr>
-            <a:picLocks noChangeAspect="1"/>
-          </p:cNvPicPr>
-          <p:nvPr/>
-        </p:nvPicPr>
-        <p:blipFill>
-          <a:blip r:embed="rId2"/>
-          <a:stretch>
-            <a:fillRect/>
-          </a:stretch>
-        </p:blipFill>
-        <p:spPr>
-          <a:xfrm>
-            <a:off x="4777740" y="2628900"/>
-            <a:ext cx="228600" cy="228600"/>
-          </a:xfrm>
-          <a:prstGeom prst="rect">
-            <a:avLst/>
-          </a:prstGeom>
-        </p:spPr>
-      </p:pic>
-      <p:sp>
-        <p:nvSpPr>
-          <p:cNvPr id="12" name="Text 8"/>
-          <p:cNvSpPr txBox="1"/>
-          <p:nvPr/>
-        </p:nvSpPr>
-        <p:spPr>
-          <a:xfrm>
-            <a:off x="5257800" y="2468880"/>
-            <a:ext cx="3474720" cy="320040"/>
-          </a:xfrm>
-          <a:prstGeom prst="rect">
-            <a:avLst/>
-          </a:prstGeom>
-          <a:noFill/>
-          <a:ln/>
-        </p:spPr>
-        <p:txBody>
-          <a:bodyPr wrap="square" lIns="0" tIns="0" rIns="0" bIns="0" rtlCol="0" anchor="ctr"/>
-          <a:lstStyle/>
-          <a:p>
-            <a:pPr indent="0" marL="0">
-              <a:buNone/>
-            </a:pPr>
-            <a:r>
-              <a:rPr lang="en-US" sz="1300" b="1" dirty="0">
-                <a:solidFill>
-                  <a:srgbClr val="1F2233"/>
-                </a:solidFill>
-                <a:latin typeface="Arial" pitchFamily="34" charset="0"/>
-                <a:ea typeface="Arial" pitchFamily="34" charset="-122"/>
-                <a:cs typeface="Arial" pitchFamily="34" charset="-120"/>
-              </a:rPr>
-              <a:t>Trouver la cause</a:t>
-            </a:r>
-            <a:endParaRPr lang="en-US" sz="1300" dirty="0"/>
-          </a:p>
-        </p:txBody>
-      </p:sp>
-      <p:sp>
-        <p:nvSpPr>
-          <p:cNvPr id="13" name="Text 9"/>
-          <p:cNvSpPr txBox="1"/>
-          <p:nvPr/>
-        </p:nvSpPr>
-        <p:spPr>
-          <a:xfrm>
-            <a:off x="5257800" y="2788920"/>
-            <a:ext cx="3474720" cy="594360"/>
-          </a:xfrm>
-          <a:prstGeom prst="rect">
-            <a:avLst/>
-          </a:prstGeom>
-          <a:noFill/>
-          <a:ln/>
-        </p:spPr>
-        <p:txBody>
-          <a:bodyPr wrap="square" lIns="0" tIns="0" rIns="0" bIns="0" rtlCol="0" anchor="t"/>
-          <a:lstStyle/>
-          <a:p>
-            <a:pPr indent="0" marL="0">
-              <a:buNone/>
-            </a:pPr>
-            <a:r>
-              <a:rPr lang="en-US" sz="1100" dirty="0">
-                <a:solidFill>
-                  <a:srgbClr val="1F2233"/>
-                </a:solidFill>
-                <a:latin typeface="Calibri" pitchFamily="34" charset="0"/>
-                <a:ea typeface="Calibri" pitchFamily="34" charset="-122"/>
-                <a:cs typeface="Calibri" pitchFamily="34" charset="-120"/>
-              </a:rPr>
-              <a:t>D3 MMR de départ (A) · D1 fourchette × joueurs en file (B) · D8 écart subi · D11 groupes</a:t>
-            </a:r>
-            <a:endParaRPr lang="en-US" sz="1100" dirty="0"/>
-          </a:p>
-        </p:txBody>
-      </p:sp>
-      <p:sp>
-        <p:nvSpPr>
-          <p:cNvPr id="14" name="Shape 10"/>
-          <p:cNvSpPr/>
-          <p:nvPr/>
-        </p:nvSpPr>
-        <p:spPr>
-          <a:xfrm>
-            <a:off x="457200" y="3611880"/>
-            <a:ext cx="457200" cy="457200"/>
-          </a:xfrm>
-          <a:prstGeom prst="ellipse">
-            <a:avLst/>
-          </a:prstGeom>
-          <a:solidFill>
-            <a:srgbClr val="E23636"/>
-          </a:solidFill>
-          <a:ln w="12700">
-            <a:solidFill>
-              <a:srgbClr val="E23636"/>
-            </a:solidFill>
-            <a:prstDash val="solid"/>
-          </a:ln>
-        </p:spPr>
-      </p:sp>
-      <p:pic>
-        <p:nvPicPr>
-          <p:cNvPr id="15" name="Image 2" descr="preencoded.png">    </p:cNvPr>
-          <p:cNvPicPr>
-            <a:picLocks noChangeAspect="1"/>
-          </p:cNvPicPr>
-          <p:nvPr/>
-        </p:nvPicPr>
-        <p:blipFill>
-          <a:blip r:embed="rId3"/>
-          <a:stretch>
-            <a:fillRect/>
-          </a:stretch>
-        </p:blipFill>
-        <p:spPr>
-          <a:xfrm>
-            <a:off x="571500" y="3726180"/>
-            <a:ext cx="228600" cy="228600"/>
-          </a:xfrm>
-          <a:prstGeom prst="rect">
-            <a:avLst/>
-          </a:prstGeom>
-        </p:spPr>
-      </p:pic>
-      <p:sp>
-        <p:nvSpPr>
-          <p:cNvPr id="16" name="Text 11"/>
-          <p:cNvSpPr txBox="1"/>
-          <p:nvPr/>
-        </p:nvSpPr>
-        <p:spPr>
-          <a:xfrm>
-            <a:off x="1051560" y="3566160"/>
-            <a:ext cx="3474720" cy="320040"/>
-          </a:xfrm>
-          <a:prstGeom prst="rect">
-            <a:avLst/>
-          </a:prstGeom>
-          <a:noFill/>
-          <a:ln/>
-        </p:spPr>
-        <p:txBody>
-          <a:bodyPr wrap="square" lIns="0" tIns="0" rIns="0" bIns="0" rtlCol="0" anchor="ctr"/>
-          <a:lstStyle/>
-          <a:p>
-            <a:pPr indent="0" marL="0">
-              <a:buNone/>
-            </a:pPr>
-            <a:r>
-              <a:rPr lang="en-US" sz="1300" b="1" dirty="0">
-                <a:solidFill>
-                  <a:srgbClr val="1F2233"/>
-                </a:solidFill>
-                <a:latin typeface="Arial" pitchFamily="34" charset="0"/>
-                <a:ea typeface="Arial" pitchFamily="34" charset="-122"/>
-                <a:cs typeface="Arial" pitchFamily="34" charset="-120"/>
-              </a:rPr>
-              <a:t>Apprendre du classé</a:t>
-            </a:r>
-            <a:endParaRPr lang="en-US" sz="1300" dirty="0"/>
-          </a:p>
-        </p:txBody>
-      </p:sp>
-      <p:sp>
-        <p:nvSpPr>
-          <p:cNvPr id="17" name="Text 12"/>
-          <p:cNvSpPr txBox="1"/>
-          <p:nvPr/>
-        </p:nvSpPr>
-        <p:spPr>
-          <a:xfrm>
-            <a:off x="1051560" y="3886200"/>
-            <a:ext cx="3474720" cy="594360"/>
-          </a:xfrm>
-          <a:prstGeom prst="rect">
-            <a:avLst/>
-          </a:prstGeom>
-          <a:noFill/>
-          <a:ln/>
-        </p:spPr>
-        <p:txBody>
-          <a:bodyPr wrap="square" lIns="0" tIns="0" rIns="0" bIns="0" rtlCol="0" anchor="t"/>
-          <a:lstStyle/>
-          <a:p>
-            <a:pPr indent="0" marL="0">
-              <a:buNone/>
-            </a:pPr>
-            <a:r>
-              <a:rPr lang="en-US" sz="1100" dirty="0">
-                <a:solidFill>
-                  <a:srgbClr val="1F2233"/>
-                </a:solidFill>
-                <a:latin typeface="Calibri" pitchFamily="34" charset="0"/>
-                <a:ea typeface="Calibri" pitchFamily="34" charset="-122"/>
-                <a:cs typeface="Calibri" pitchFamily="34" charset="-120"/>
-              </a:rPr>
-              <a:t>D10 rétention avant / après la S5 · D5 écart en classé</a:t>
-            </a:r>
-            <a:endParaRPr lang="en-US" sz="1100" dirty="0"/>
-          </a:p>
-        </p:txBody>
-      </p:sp>
-      <p:sp>
-        <p:nvSpPr>
-          <p:cNvPr id="18" name="Shape 13"/>
-          <p:cNvSpPr/>
-          <p:nvPr/>
-        </p:nvSpPr>
-        <p:spPr>
-          <a:xfrm>
-            <a:off x="4663440" y="3611880"/>
-            <a:ext cx="457200" cy="457200"/>
-          </a:xfrm>
-          <a:prstGeom prst="ellipse">
-            <a:avLst/>
-          </a:prstGeom>
-          <a:solidFill>
-            <a:srgbClr val="E23636"/>
-          </a:solidFill>
-          <a:ln w="12700">
-            <a:solidFill>
-              <a:srgbClr val="E23636"/>
-            </a:solidFill>
-            <a:prstDash val="solid"/>
-          </a:ln>
-        </p:spPr>
-      </p:sp>
-      <p:pic>
-        <p:nvPicPr>
-          <p:cNvPr id="19" name="Image 3" descr="preencoded.png">    </p:cNvPr>
-          <p:cNvPicPr>
-            <a:picLocks noChangeAspect="1"/>
-          </p:cNvPicPr>
-          <p:nvPr/>
-        </p:nvPicPr>
-        <p:blipFill>
-          <a:blip r:embed="rId4"/>
-          <a:stretch>
-            <a:fillRect/>
-          </a:stretch>
-        </p:blipFill>
-        <p:spPr>
-          <a:xfrm>
-            <a:off x="4777740" y="3726180"/>
-            <a:ext cx="228600" cy="228600"/>
-          </a:xfrm>
-          <a:prstGeom prst="rect">
-            <a:avLst/>
-          </a:prstGeom>
-        </p:spPr>
-      </p:pic>
-      <p:sp>
-        <p:nvSpPr>
-          <p:cNvPr id="20" name="Text 14"/>
-          <p:cNvSpPr txBox="1"/>
-          <p:nvPr/>
-        </p:nvSpPr>
-        <p:spPr>
-          <a:xfrm>
-            <a:off x="5257800" y="3566160"/>
-            <a:ext cx="3474720" cy="320040"/>
-          </a:xfrm>
-          <a:prstGeom prst="rect">
-            <a:avLst/>
-          </a:prstGeom>
-          <a:noFill/>
-          <a:ln/>
-        </p:spPr>
-        <p:txBody>
-          <a:bodyPr wrap="square" lIns="0" tIns="0" rIns="0" bIns="0" rtlCol="0" anchor="ctr"/>
-          <a:lstStyle/>
-          <a:p>
-            <a:pPr indent="0" marL="0">
-              <a:buNone/>
-            </a:pPr>
-            <a:r>
-              <a:rPr lang="en-US" sz="1300" b="1" dirty="0">
-                <a:solidFill>
-                  <a:srgbClr val="1F2233"/>
-                </a:solidFill>
-                <a:latin typeface="Arial" pitchFamily="34" charset="0"/>
-                <a:ea typeface="Arial" pitchFamily="34" charset="-122"/>
-                <a:cs typeface="Arial" pitchFamily="34" charset="-120"/>
-              </a:rPr>
-              <a:t>Écarter les autres pistes</a:t>
-            </a:r>
-            <a:endParaRPr lang="en-US" sz="1300" dirty="0"/>
-          </a:p>
-        </p:txBody>
-      </p:sp>
-      <p:sp>
-        <p:nvSpPr>
-          <p:cNvPr id="21" name="Text 15"/>
-          <p:cNvSpPr txBox="1"/>
-          <p:nvPr/>
-        </p:nvSpPr>
-        <p:spPr>
-          <a:xfrm>
-            <a:off x="5257800" y="3886200"/>
-            <a:ext cx="3474720" cy="594360"/>
-          </a:xfrm>
-          <a:prstGeom prst="rect">
-            <a:avLst/>
-          </a:prstGeom>
-          <a:noFill/>
-          <a:ln/>
-        </p:spPr>
-        <p:txBody>
-          <a:bodyPr wrap="square" lIns="0" tIns="0" rIns="0" bIns="0" rtlCol="0" anchor="t"/>
-          <a:lstStyle/>
-          <a:p>
-            <a:pPr indent="0" marL="0">
-              <a:buNone/>
-            </a:pPr>
-            <a:r>
-              <a:rPr lang="en-US" sz="1100" dirty="0">
-                <a:solidFill>
-                  <a:srgbClr val="1F2233"/>
-                </a:solidFill>
-                <a:latin typeface="Calibri" pitchFamily="34" charset="0"/>
-                <a:ea typeface="Calibri" pitchFamily="34" charset="-122"/>
-                <a:cs typeface="Calibri" pitchFamily="34" charset="-120"/>
-              </a:rPr>
-              <a:t>D4 filtrage · D9 cohortes 2025 · D6 compositions · D7 bots</a:t>
-            </a:r>
-            <a:endParaRPr lang="en-US" sz="1100" dirty="0"/>
-          </a:p>
-        </p:txBody>
-      </p:sp>
-      <p:sp>
-        <p:nvSpPr>
-          <p:cNvPr id="22" name="Text 16"/>
-          <p:cNvSpPr txBox="1"/>
-          <p:nvPr/>
-        </p:nvSpPr>
-        <p:spPr>
-          <a:xfrm>
-            <a:off x="457200" y="4754880"/>
-            <a:ext cx="8229600" cy="256032"/>
-          </a:xfrm>
-          <a:prstGeom prst="rect">
-            <a:avLst/>
-          </a:prstGeom>
-          <a:noFill/>
-          <a:ln/>
-        </p:spPr>
-        <p:txBody>
-          <a:bodyPr wrap="square" lIns="0" tIns="0" rIns="0" bIns="0" rtlCol="0" anchor="ctr"/>
-          <a:lstStyle/>
-          <a:p>
-            <a:pPr indent="0" marL="0">
-              <a:buNone/>
-            </a:pPr>
-            <a:r>
               <a:rPr lang="en-US" sz="900" dirty="0">
                 <a:solidFill>
                   <a:srgbClr val="5E6378"/>
@@ -5593,7 +5837,7 @@
                 <a:latin typeface="Calibri" pitchFamily="34" charset="0"/>
                 <a:ea typeface="Calibri" pitchFamily="34" charset="-122"/>
                 <a:cs typeface="Calibri" pitchFamily="34" charset="-120"/>
-                <a:hlinkClick r:id="rId5" invalidUrl="" action="" tgtFrame="" tooltip="" history="1" highlightClick="0" endSnd="0">
+                <a:hlinkClick r:id="rId1" invalidUrl="" action="" tgtFrame="" tooltip="" history="1" highlightClick="0" endSnd="0">
                   <a:extLst>
                     <a:ext uri="{A12FA001-AC4F-418D-AE19-62706E023703}">
                       <ahyp:hlinkClr xmlns:ahyp="http://schemas.microsoft.com/office/drawing/2018/hyperlinkcolor" val="tx"/>
@@ -5601,7 +5845,7 @@
                   </a:extLst>
                 </a:hlinkClick>
               </a:rPr>
-              <a:t>plan de collecte complet (matrice ICE, D0 à D20)</a:t>
+              <a:t>plan de collecte complet (12 données notées, détail et justification)</a:t>
             </a:r>
             <a:endParaRPr lang="en-US" sz="900" dirty="0"/>
           </a:p>
@@ -5609,7 +5853,7 @@
       </p:sp>
       <p:sp>
         <p:nvSpPr>
-          <p:cNvPr id="23" name="Text 17"/>
+          <p:cNvPr id="9" name="Text 6"/>
           <p:cNvSpPr txBox="1"/>
           <p:nvPr/>
         </p:nvSpPr>
@@ -5750,7 +5994,7 @@
                 <a:ea typeface="Calibri" pitchFamily="34" charset="-122"/>
                 <a:cs typeface="Calibri" pitchFamily="34" charset="-120"/>
               </a:rPr>
-              <a:t>Recommandation · tests A/B de 60 jours, seulement si le ratio dépasse 1,2</a:t>
+              <a:t>Recommandation · deux causes possibles ; tests A/B de 60 jours si l'audit confirme le problème</a:t>
             </a:r>
             <a:endParaRPr lang="en-US" sz="1300" dirty="0"/>
           </a:p>
@@ -5764,12 +6008,12 @@
         </p:nvSpPr>
         <p:spPr>
           <a:xfrm>
-            <a:off x="457200" y="1325880"/>
-            <a:ext cx="4023360" cy="2103120"/>
+            <a:off x="457200" y="1188720"/>
+            <a:ext cx="4023360" cy="2788920"/>
           </a:xfrm>
           <a:prstGeom prst="roundRect">
             <a:avLst>
-              <a:gd name="adj" fmla="val 3478"/>
+              <a:gd name="adj" fmla="val 2623"/>
             </a:avLst>
           </a:prstGeom>
           <a:solidFill>
@@ -5791,8 +6035,8 @@
         </p:nvSpPr>
         <p:spPr>
           <a:xfrm>
-            <a:off x="685800" y="1508760"/>
-            <a:ext cx="457200" cy="457200"/>
+            <a:off x="640080" y="1298448"/>
+            <a:ext cx="411480" cy="411480"/>
           </a:xfrm>
           <a:prstGeom prst="ellipse">
             <a:avLst/>
@@ -5824,8 +6068,8 @@
         </p:blipFill>
         <p:spPr>
           <a:xfrm>
-            <a:off x="800100" y="1623060"/>
-            <a:ext cx="228600" cy="228600"/>
+            <a:off x="742950" y="1401318"/>
+            <a:ext cx="205740" cy="205740"/>
           </a:xfrm>
           <a:prstGeom prst="rect">
             <a:avLst/>
@@ -5840,8 +6084,8 @@
         </p:nvSpPr>
         <p:spPr>
           <a:xfrm>
-            <a:off x="1280160" y="1554480"/>
-            <a:ext cx="3017520" cy="411480"/>
+            <a:off x="1188720" y="1298448"/>
+            <a:ext cx="3154680" cy="411480"/>
           </a:xfrm>
           <a:prstGeom prst="rect">
             <a:avLst/>
@@ -5865,7 +6109,7 @@
                 <a:ea typeface="Arial" pitchFamily="34" charset="-122"/>
                 <a:cs typeface="Arial" pitchFamily="34" charset="-120"/>
               </a:rPr>
-              <a:t>Si cause A : démarrage à froid</a:t>
+              <a:t>Cause A : démarrage à froid</a:t>
             </a:r>
             <a:endParaRPr lang="en-US" sz="1400" dirty="0"/>
           </a:p>
@@ -5879,8 +6123,8 @@
         </p:nvSpPr>
         <p:spPr>
           <a:xfrm>
-            <a:off x="731520" y="2103120"/>
-            <a:ext cx="3566160" cy="1234440"/>
+            <a:off x="640080" y="1801368"/>
+            <a:ext cx="3657600" cy="658368"/>
           </a:xfrm>
           <a:prstGeom prst="rect">
             <a:avLst/>
@@ -5889,18 +6133,110 @@
           <a:ln/>
         </p:spPr>
         <p:txBody>
-          <a:bodyPr wrap="square" rtlCol="0" anchor="t"/>
-          <a:lstStyle/>
+          <a:bodyPr wrap="square" lIns="0" tIns="0" rIns="0" bIns="0" rtlCol="0" anchor="t"/>
+          <a:lstStyle/>
+          <a:p>
+            <a:pPr indent="0" marL="0">
+              <a:buNone/>
+            </a:pPr>
+            <a:r>
+              <a:rPr lang="en-US" sz="1100" dirty="0">
+                <a:solidFill>
+                  <a:srgbClr val="1F2233"/>
+                </a:solidFill>
+                <a:latin typeface="Calibri" pitchFamily="34" charset="0"/>
+                <a:ea typeface="Calibri" pitchFamily="34" charset="-122"/>
+                <a:cs typeface="Calibri" pitchFamily="34" charset="-120"/>
+              </a:rPr>
+              <a:t>Le jeu ne connaît pas le niveau d'un nouveau compte. Il lui donne un niveau de départ par défaut et le place mal tant qu'il n'a pas assez joué.</a:t>
+            </a:r>
+            <a:endParaRPr lang="en-US" sz="1100" dirty="0"/>
+          </a:p>
+        </p:txBody>
+      </p:sp>
+      <p:sp>
+        <p:nvSpPr>
+          <p:cNvPr id="9" name="Text 6"/>
+          <p:cNvSpPr txBox="1"/>
+          <p:nvPr/>
+        </p:nvSpPr>
+        <p:spPr>
+          <a:xfrm>
+            <a:off x="640080" y="2468880"/>
+            <a:ext cx="3657600" cy="347472"/>
+          </a:xfrm>
+          <a:prstGeom prst="rect">
+            <a:avLst/>
+          </a:prstGeom>
+          <a:noFill/>
+          <a:ln/>
+        </p:spPr>
+        <p:txBody>
+          <a:bodyPr wrap="square" lIns="0" tIns="0" rIns="0" bIns="0" rtlCol="0" anchor="t"/>
+          <a:lstStyle/>
+          <a:p>
+            <a:pPr indent="0" marL="0">
+              <a:buNone/>
+            </a:pPr>
+            <a:r>
+              <a:rPr lang="en-US" sz="1000" i="1" dirty="0">
+                <a:solidFill>
+                  <a:srgbClr val="5E6378"/>
+                </a:solidFill>
+                <a:latin typeface="Calibri" pitchFamily="34" charset="0"/>
+                <a:ea typeface="Calibri" pitchFamily="34" charset="-122"/>
+                <a:cs typeface="Calibri" pitchFamily="34" charset="-120"/>
+              </a:rPr>
+              <a:t>Dans les données : l'écart est fort sur les premiers matchs, à toute heure.</a:t>
+            </a:r>
+            <a:endParaRPr lang="en-US" sz="1000" dirty="0"/>
+          </a:p>
+        </p:txBody>
+      </p:sp>
+      <p:sp>
+        <p:nvSpPr>
+          <p:cNvPr id="10" name="Text 7"/>
+          <p:cNvSpPr txBox="1"/>
+          <p:nvPr/>
+        </p:nvSpPr>
+        <p:spPr>
+          <a:xfrm>
+            <a:off x="594360" y="2834640"/>
+            <a:ext cx="3749040" cy="1097280"/>
+          </a:xfrm>
+          <a:prstGeom prst="rect">
+            <a:avLst/>
+          </a:prstGeom>
+          <a:noFill/>
+          <a:ln/>
+        </p:spPr>
+        <p:txBody>
+          <a:bodyPr wrap="square" lIns="0" tIns="0" rIns="0" bIns="0" rtlCol="0" anchor="t"/>
+          <a:lstStyle/>
+          <a:p>
+            <a:pPr indent="0" marL="0">
+              <a:buNone/>
+            </a:pPr>
+            <a:r>
+              <a:rPr lang="en-US" sz="1050" b="1" dirty="0">
+                <a:solidFill>
+                  <a:srgbClr val="E23636"/>
+                </a:solidFill>
+                <a:latin typeface="Calibri" pitchFamily="34" charset="0"/>
+                <a:ea typeface="Calibri" pitchFamily="34" charset="-122"/>
+                <a:cs typeface="Calibri" pitchFamily="34" charset="-120"/>
+              </a:rPr>
+              <a:t>Leviers à tester</a:t>
+            </a:r>
+            <a:endParaRPr lang="en-US" sz="1050" dirty="0"/>
+          </a:p>
           <a:p>
             <a:pPr marL="342900" indent="-342900">
-              <a:spcAft>
-                <a:spcPts val="600"/>
-              </a:spcAft>
               <a:buSzPct val="100000"/>
               <a:buChar char="•"/>
             </a:pPr>
             <a:r>
-              <a:rPr lang="en-US" sz="1200" dirty="0">
+              <a:rPr lang="en-US" sz="1050" dirty="0">
                 <a:solidFill>
                   <a:srgbClr val="1F2233"/>
                 </a:solidFill>
@@ -5908,20 +6244,17 @@
                 <a:ea typeface="Calibri" pitchFamily="34" charset="-122"/>
                 <a:cs typeface="Calibri" pitchFamily="34" charset="-120"/>
               </a:rPr>
-              <a:t>MMR de départ plus prudent</a:t>
-            </a:r>
-            <a:endParaRPr lang="en-US" sz="1200" dirty="0"/>
+              <a:t>Niveau de départ plus prudent</a:t>
+            </a:r>
+            <a:endParaRPr lang="en-US" sz="1050" dirty="0"/>
           </a:p>
           <a:p>
             <a:pPr marL="342900" indent="-342900">
-              <a:spcAft>
-                <a:spcPts val="600"/>
-              </a:spcAft>
               <a:buSzPct val="100000"/>
               <a:buChar char="•"/>
             </a:pPr>
             <a:r>
-              <a:rPr lang="en-US" sz="1200" dirty="0">
+              <a:rPr lang="en-US" sz="1050" dirty="0">
                 <a:solidFill>
                   <a:srgbClr val="1F2233"/>
                 </a:solidFill>
@@ -5929,26 +6262,26 @@
                 <a:ea typeface="Calibri" pitchFamily="34" charset="-122"/>
                 <a:cs typeface="Calibri" pitchFamily="34" charset="-120"/>
               </a:rPr>
-              <a:t>Convergence accélérée des nouveaux comptes (freine aussi les smurfs, sans sanction)</a:t>
-            </a:r>
-            <a:endParaRPr lang="en-US" sz="1200" dirty="0"/>
-          </a:p>
-        </p:txBody>
-      </p:sp>
-      <p:sp>
-        <p:nvSpPr>
-          <p:cNvPr id="9" name="Shape 6"/>
+              <a:t>Ajustement plus rapide du niveau des nouveaux comptes (freine aussi les joueurs confirmés qui se recréent un compte)</a:t>
+            </a:r>
+            <a:endParaRPr lang="en-US" sz="1050" dirty="0"/>
+          </a:p>
+        </p:txBody>
+      </p:sp>
+      <p:sp>
+        <p:nvSpPr>
+          <p:cNvPr id="11" name="Shape 8"/>
           <p:cNvSpPr/>
           <p:nvPr/>
         </p:nvSpPr>
         <p:spPr>
           <a:xfrm>
-            <a:off x="4663440" y="1325880"/>
-            <a:ext cx="4023360" cy="2103120"/>
+            <a:off x="4663440" y="1188720"/>
+            <a:ext cx="4023360" cy="2788920"/>
           </a:xfrm>
           <a:prstGeom prst="roundRect">
             <a:avLst>
-              <a:gd name="adj" fmla="val 3478"/>
+              <a:gd name="adj" fmla="val 2623"/>
             </a:avLst>
           </a:prstGeom>
           <a:solidFill>
@@ -5964,14 +6297,14 @@
       </p:sp>
       <p:sp>
         <p:nvSpPr>
-          <p:cNvPr id="10" name="Shape 7"/>
+          <p:cNvPr id="12" name="Shape 9"/>
           <p:cNvSpPr/>
           <p:nvPr/>
         </p:nvSpPr>
         <p:spPr>
           <a:xfrm>
-            <a:off x="4892040" y="1508760"/>
-            <a:ext cx="457200" cy="457200"/>
+            <a:off x="4846320" y="1298448"/>
+            <a:ext cx="411480" cy="411480"/>
           </a:xfrm>
           <a:prstGeom prst="ellipse">
             <a:avLst/>
@@ -5989,7 +6322,7 @@
       </p:sp>
       <p:pic>
         <p:nvPicPr>
-          <p:cNvPr id="11" name="Image 1" descr="preencoded.png">    </p:cNvPr>
+          <p:cNvPr id="13" name="Image 1" descr="preencoded.png">    </p:cNvPr>
           <p:cNvPicPr>
             <a:picLocks noChangeAspect="1"/>
           </p:cNvPicPr>
@@ -6003,8 +6336,8 @@
         </p:blipFill>
         <p:spPr>
           <a:xfrm>
-            <a:off x="5006340" y="1623060"/>
-            <a:ext cx="228600" cy="228600"/>
+            <a:off x="4949190" y="1401318"/>
+            <a:ext cx="205740" cy="205740"/>
           </a:xfrm>
           <a:prstGeom prst="rect">
             <a:avLst/>
@@ -6013,14 +6346,14 @@
       </p:pic>
       <p:sp>
         <p:nvSpPr>
-          <p:cNvPr id="12" name="Text 8"/>
+          <p:cNvPr id="14" name="Text 10"/>
           <p:cNvSpPr txBox="1"/>
           <p:nvPr/>
         </p:nvSpPr>
         <p:spPr>
           <a:xfrm>
-            <a:off x="5486400" y="1554480"/>
-            <a:ext cx="3017520" cy="411480"/>
+            <a:off x="5394960" y="1298448"/>
+            <a:ext cx="3154680" cy="411480"/>
           </a:xfrm>
           <a:prstGeom prst="rect">
             <a:avLst/>
@@ -6044,7 +6377,7 @@
                 <a:ea typeface="Arial" pitchFamily="34" charset="-122"/>
                 <a:cs typeface="Arial" pitchFamily="34" charset="-120"/>
               </a:rPr>
-              <a:t>Si cause B : manque de joueurs</a:t>
+              <a:t>Cause B : manque de joueurs</a:t>
             </a:r>
             <a:endParaRPr lang="en-US" sz="1400" dirty="0"/>
           </a:p>
@@ -6052,14 +6385,14 @@
       </p:sp>
       <p:sp>
         <p:nvSpPr>
-          <p:cNvPr id="13" name="Text 9"/>
+          <p:cNvPr id="15" name="Text 11"/>
           <p:cNvSpPr txBox="1"/>
           <p:nvPr/>
         </p:nvSpPr>
         <p:spPr>
           <a:xfrm>
-            <a:off x="4937760" y="2103120"/>
-            <a:ext cx="3566160" cy="1234440"/>
+            <a:off x="4846320" y="1801368"/>
+            <a:ext cx="3657600" cy="658368"/>
           </a:xfrm>
           <a:prstGeom prst="rect">
             <a:avLst/>
@@ -6068,18 +6401,110 @@
           <a:ln/>
         </p:spPr>
         <p:txBody>
-          <a:bodyPr wrap="square" rtlCol="0" anchor="t"/>
-          <a:lstStyle/>
+          <a:bodyPr wrap="square" lIns="0" tIns="0" rIns="0" bIns="0" rtlCol="0" anchor="t"/>
+          <a:lstStyle/>
+          <a:p>
+            <a:pPr indent="0" marL="0">
+              <a:buNone/>
+            </a:pPr>
+            <a:r>
+              <a:rPr lang="en-US" sz="1100" dirty="0">
+                <a:solidFill>
+                  <a:srgbClr val="1F2233"/>
+                </a:solidFill>
+                <a:latin typeface="Calibri" pitchFamily="34" charset="0"/>
+                <a:ea typeface="Calibri" pitchFamily="34" charset="-122"/>
+                <a:cs typeface="Calibri" pitchFamily="34" charset="-120"/>
+              </a:rPr>
+              <a:t>Quand peu de joueurs sont en file (heures creuses, petites régions), le jeu élargit l'écart de niveau accepté pour lancer la partie plus vite.</a:t>
+            </a:r>
+            <a:endParaRPr lang="en-US" sz="1100" dirty="0"/>
+          </a:p>
+        </p:txBody>
+      </p:sp>
+      <p:sp>
+        <p:nvSpPr>
+          <p:cNvPr id="16" name="Text 12"/>
+          <p:cNvSpPr txBox="1"/>
+          <p:nvPr/>
+        </p:nvSpPr>
+        <p:spPr>
+          <a:xfrm>
+            <a:off x="4846320" y="2468880"/>
+            <a:ext cx="3657600" cy="347472"/>
+          </a:xfrm>
+          <a:prstGeom prst="rect">
+            <a:avLst/>
+          </a:prstGeom>
+          <a:noFill/>
+          <a:ln/>
+        </p:spPr>
+        <p:txBody>
+          <a:bodyPr wrap="square" lIns="0" tIns="0" rIns="0" bIns="0" rtlCol="0" anchor="t"/>
+          <a:lstStyle/>
+          <a:p>
+            <a:pPr indent="0" marL="0">
+              <a:buNone/>
+            </a:pPr>
+            <a:r>
+              <a:rPr lang="en-US" sz="1000" i="1" dirty="0">
+                <a:solidFill>
+                  <a:srgbClr val="5E6378"/>
+                </a:solidFill>
+                <a:latin typeface="Calibri" pitchFamily="34" charset="0"/>
+                <a:ea typeface="Calibri" pitchFamily="34" charset="-122"/>
+                <a:cs typeface="Calibri" pitchFamily="34" charset="-120"/>
+              </a:rPr>
+              <a:t>Dans les données : l'écart grandit quand la file se vide, pour tous.</a:t>
+            </a:r>
+            <a:endParaRPr lang="en-US" sz="1000" dirty="0"/>
+          </a:p>
+        </p:txBody>
+      </p:sp>
+      <p:sp>
+        <p:nvSpPr>
+          <p:cNvPr id="17" name="Text 13"/>
+          <p:cNvSpPr txBox="1"/>
+          <p:nvPr/>
+        </p:nvSpPr>
+        <p:spPr>
+          <a:xfrm>
+            <a:off x="4800600" y="2834640"/>
+            <a:ext cx="3749040" cy="1097280"/>
+          </a:xfrm>
+          <a:prstGeom prst="rect">
+            <a:avLst/>
+          </a:prstGeom>
+          <a:noFill/>
+          <a:ln/>
+        </p:spPr>
+        <p:txBody>
+          <a:bodyPr wrap="square" lIns="0" tIns="0" rIns="0" bIns="0" rtlCol="0" anchor="t"/>
+          <a:lstStyle/>
+          <a:p>
+            <a:pPr indent="0" marL="0">
+              <a:buNone/>
+            </a:pPr>
+            <a:r>
+              <a:rPr lang="en-US" sz="1050" b="1" dirty="0">
+                <a:solidFill>
+                  <a:srgbClr val="E23636"/>
+                </a:solidFill>
+                <a:latin typeface="Calibri" pitchFamily="34" charset="0"/>
+                <a:ea typeface="Calibri" pitchFamily="34" charset="-122"/>
+                <a:cs typeface="Calibri" pitchFamily="34" charset="-120"/>
+              </a:rPr>
+              <a:t>Leviers à tester</a:t>
+            </a:r>
+            <a:endParaRPr lang="en-US" sz="1050" dirty="0"/>
+          </a:p>
           <a:p>
             <a:pPr marL="342900" indent="-342900">
-              <a:spcAft>
-                <a:spcPts val="600"/>
-              </a:spcAft>
               <a:buSzPct val="100000"/>
               <a:buChar char="•"/>
             </a:pPr>
             <a:r>
-              <a:rPr lang="en-US" sz="1200" dirty="0">
+              <a:rPr lang="en-US" sz="1050" dirty="0">
                 <a:solidFill>
                   <a:srgbClr val="1F2233"/>
                 </a:solidFill>
@@ -6087,20 +6512,17 @@
                 <a:ea typeface="Calibri" pitchFamily="34" charset="-122"/>
                 <a:cs typeface="Calibri" pitchFamily="34" charset="-120"/>
               </a:rPr>
-              <a:t>Fourchette resserrée aux heures creuses</a:t>
-            </a:r>
-            <a:endParaRPr lang="en-US" sz="1200" dirty="0"/>
+              <a:t>Écart resserré aux heures creuses</a:t>
+            </a:r>
+            <a:endParaRPr lang="en-US" sz="1050" dirty="0"/>
           </a:p>
           <a:p>
             <a:pPr marL="342900" indent="-342900">
-              <a:spcAft>
-                <a:spcPts val="600"/>
-              </a:spcAft>
               <a:buSzPct val="100000"/>
               <a:buChar char="•"/>
             </a:pPr>
             <a:r>
-              <a:rPr lang="en-US" sz="1200" dirty="0">
+              <a:rPr lang="en-US" sz="1050" dirty="0">
                 <a:solidFill>
                   <a:srgbClr val="1F2233"/>
                 </a:solidFill>
@@ -6110,18 +6532,15 @@
               </a:rPr>
               <a:t>Regroupement de régions si besoin</a:t>
             </a:r>
-            <a:endParaRPr lang="en-US" sz="1200" dirty="0"/>
+            <a:endParaRPr lang="en-US" sz="1050" dirty="0"/>
           </a:p>
           <a:p>
             <a:pPr marL="342900" indent="-342900">
-              <a:spcAft>
-                <a:spcPts val="600"/>
-              </a:spcAft>
               <a:buSzPct val="100000"/>
               <a:buChar char="•"/>
             </a:pPr>
             <a:r>
-              <a:rPr lang="en-US" sz="1200" dirty="0">
+              <a:rPr lang="en-US" sz="1050" dirty="0">
                 <a:solidFill>
                   <a:srgbClr val="1F2233"/>
                 </a:solidFill>
@@ -6129,22 +6548,22 @@
                 <a:ea typeface="Calibri" pitchFamily="34" charset="-122"/>
                 <a:cs typeface="Calibri" pitchFamily="34" charset="-120"/>
               </a:rPr>
-              <a:t>Arrêt si l'attente p90 dépasse 5 min</a:t>
-            </a:r>
-            <a:endParaRPr lang="en-US" sz="1200" dirty="0"/>
-          </a:p>
-        </p:txBody>
-      </p:sp>
-      <p:sp>
-        <p:nvSpPr>
-          <p:cNvPr id="14" name="Text 10"/>
+              <a:t>Arrêt si 10 % des joueurs attendent plus de 5 min</a:t>
+            </a:r>
+            <a:endParaRPr lang="en-US" sz="1050" dirty="0"/>
+          </a:p>
+        </p:txBody>
+      </p:sp>
+      <p:sp>
+        <p:nvSpPr>
+          <p:cNvPr id="18" name="Text 14"/>
           <p:cNvSpPr txBox="1"/>
           <p:nvPr/>
         </p:nvSpPr>
         <p:spPr>
           <a:xfrm>
-            <a:off x="457200" y="3611880"/>
-            <a:ext cx="8229600" cy="822960"/>
+            <a:off x="457200" y="4087368"/>
+            <a:ext cx="8229600" cy="594360"/>
           </a:xfrm>
           <a:prstGeom prst="rect">
             <a:avLst/>
@@ -6160,7 +6579,7 @@
               <a:buNone/>
             </a:pPr>
             <a:r>
-              <a:rPr lang="en-US" sz="1200" b="1" dirty="0">
+              <a:rPr lang="en-US" sz="1100" b="1" dirty="0">
                 <a:solidFill>
                   <a:srgbClr val="1F2233"/>
                 </a:solidFill>
@@ -6174,7 +6593,7 @@
               <a:buNone/>
             </a:pPr>
             <a:r>
-              <a:rPr lang="en-US" sz="1200" dirty="0">
+              <a:rPr lang="en-US" sz="1100" dirty="0">
                 <a:solidFill>
                   <a:srgbClr val="1F2233"/>
                 </a:solidFill>
@@ -6182,13 +6601,13 @@
                 <a:ea typeface="Calibri" pitchFamily="34" charset="-122"/>
                 <a:cs typeface="Calibri" pitchFamily="34" charset="-120"/>
               </a:rPr>
-              <a:t>file débutants jusqu'au niveau 15, isolement des groupes en partie rapide, étiquette « match d'entraînement » sur les parties avec bots. </a:t>
-            </a:r>
-            <a:pPr indent="0" marL="0">
-              <a:buNone/>
-            </a:pPr>
-            <a:r>
-              <a:rPr lang="en-US" sz="1200" b="1" dirty="0">
+              <a:t>file débutants jusqu'au niveau 15, groupes séparés des joueurs seuls en partie rapide, étiquette « match d'entraînement » sur les parties avec bots. </a:t>
+            </a:r>
+            <a:pPr indent="0" marL="0">
+              <a:buNone/>
+            </a:pPr>
+            <a:r>
+              <a:rPr lang="en-US" sz="1100" b="1" dirty="0">
                 <a:solidFill>
                   <a:srgbClr val="E23636"/>
                 </a:solidFill>
@@ -6202,7 +6621,7 @@
               <a:buNone/>
             </a:pPr>
             <a:r>
-              <a:rPr lang="en-US" sz="1200" dirty="0">
+              <a:rPr lang="en-US" sz="1100" dirty="0">
                 <a:solidFill>
                   <a:srgbClr val="1F2233"/>
                 </a:solidFill>
@@ -6210,15 +6629,15 @@
                 <a:ea typeface="Calibri" pitchFamily="34" charset="-122"/>
                 <a:cs typeface="Calibri" pitchFamily="34" charset="-120"/>
               </a:rPr>
-              <a:t>garde-fous de rôles (identité du jeu, liberté de composition).</a:t>
-            </a:r>
-            <a:endParaRPr lang="en-US" sz="1200" dirty="0"/>
-          </a:p>
-        </p:txBody>
-      </p:sp>
-      <p:sp>
-        <p:nvSpPr>
-          <p:cNvPr id="15" name="Text 11"/>
+              <a:t>rôles imposés (liberté de composition).</a:t>
+            </a:r>
+            <a:endParaRPr lang="en-US" sz="1100" dirty="0"/>
+          </a:p>
+        </p:txBody>
+      </p:sp>
+      <p:sp>
+        <p:nvSpPr>
+          <p:cNvPr id="19" name="Text 15"/>
           <p:cNvSpPr txBox="1"/>
           <p:nvPr/>
         </p:nvSpPr>
@@ -6270,7 +6689,7 @@
                   </a:extLst>
                 </a:hlinkClick>
               </a:rPr>
-              <a:t>vidéo NetEase du 21/08/2025</a:t>
+              <a:t>vidéo NetEase du 21/08/2025 (écart élargi quand la file est longue)</a:t>
             </a:r>
             <a:pPr indent="0" marL="0">
               <a:buNone/>
@@ -6313,7 +6732,7 @@
       </p:sp>
       <p:sp>
         <p:nvSpPr>
-          <p:cNvPr id="16" name="Text 12"/>
+          <p:cNvPr id="20" name="Text 16"/>
           <p:cNvSpPr txBox="1"/>
           <p:nvPr/>
         </p:nvSpPr>
@@ -7701,7 +8120,7 @@
                 <a:ea typeface="Calibri" pitchFamily="34" charset="-122"/>
                 <a:cs typeface="Calibri" pitchFamily="34" charset="-120"/>
               </a:rPr>
-              <a:t>des 10 premiers matchs en partie rapide (D0) : on la vise en premier</a:t>
+              <a:t>des 10 premiers matchs en partie rapide : on la corrige en premier</a:t>
             </a:r>
             <a:endParaRPr lang="en-US" sz="1100" dirty="0"/>
           </a:p>
@@ -8161,7 +8580,7 @@
     <p:bg>
       <p:bgPr>
         <a:solidFill>
-          <a:srgbClr val="161A33"/>
+          <a:srgbClr val="FFFFFF"/>
         </a:solidFill>
       </p:bgPr>
     </p:bg>
@@ -8206,13 +8625,13 @@
             <a:r>
               <a:rPr lang="en-US" sz="2800" b="1" dirty="0">
                 <a:solidFill>
-                  <a:srgbClr val="FFFFFF"/>
+                  <a:srgbClr val="1F2233"/>
                 </a:solidFill>
                 <a:latin typeface="Arial" pitchFamily="34" charset="0"/>
                 <a:ea typeface="Arial" pitchFamily="34" charset="-122"/>
                 <a:cs typeface="Arial" pitchFamily="34" charset="-120"/>
               </a:rPr>
-              <a:t>Ce que nous vous demandons aujourd'hui</a:t>
+              <a:t>Sources</a:t>
             </a:r>
             <a:endParaRPr lang="en-US" sz="2800" dirty="0"/>
           </a:p>
@@ -8220,63 +8639,14 @@
       </p:sp>
       <p:sp>
         <p:nvSpPr>
-          <p:cNvPr id="3" name="Shape 1"/>
-          <p:cNvSpPr/>
-          <p:nvPr/>
-        </p:nvSpPr>
-        <p:spPr>
-          <a:xfrm>
-            <a:off x="457200" y="1234440"/>
-            <a:ext cx="640080" cy="640080"/>
-          </a:xfrm>
-          <a:prstGeom prst="ellipse">
-            <a:avLst/>
-          </a:prstGeom>
-          <a:solidFill>
-            <a:srgbClr val="E23636"/>
-          </a:solidFill>
-          <a:ln w="12700">
-            <a:solidFill>
-              <a:srgbClr val="E23636"/>
-            </a:solidFill>
-            <a:prstDash val="solid"/>
-          </a:ln>
-        </p:spPr>
-      </p:sp>
-      <p:pic>
-        <p:nvPicPr>
-          <p:cNvPr id="4" name="Image 0" descr="preencoded.png">    </p:cNvPr>
-          <p:cNvPicPr>
-            <a:picLocks noChangeAspect="1"/>
-          </p:cNvPicPr>
-          <p:nvPr/>
-        </p:nvPicPr>
-        <p:blipFill>
-          <a:blip r:embed="rId1"/>
-          <a:stretch>
-            <a:fillRect/>
-          </a:stretch>
-        </p:blipFill>
-        <p:spPr>
-          <a:xfrm>
-            <a:off x="617220" y="1394460"/>
-            <a:ext cx="320040" cy="320040"/>
-          </a:xfrm>
-          <a:prstGeom prst="rect">
-            <a:avLst/>
-          </a:prstGeom>
-        </p:spPr>
-      </p:pic>
-      <p:sp>
-        <p:nvSpPr>
-          <p:cNvPr id="5" name="Text 2"/>
+          <p:cNvPr id="3" name="Text 1"/>
           <p:cNvSpPr txBox="1"/>
           <p:nvPr/>
         </p:nvSpPr>
         <p:spPr>
           <a:xfrm>
-            <a:off x="1325880" y="1234440"/>
-            <a:ext cx="7315200" cy="411480"/>
+            <a:off x="457200" y="804672"/>
+            <a:ext cx="8229600" cy="320040"/>
           </a:xfrm>
           <a:prstGeom prst="rect">
             <a:avLst/>
@@ -8292,30 +8662,30 @@
               <a:buNone/>
             </a:pPr>
             <a:r>
-              <a:rPr lang="en-US" sz="2000" b="1" dirty="0">
-                <a:solidFill>
-                  <a:srgbClr val="FFFFFF"/>
-                </a:solidFill>
-                <a:latin typeface="Arial" pitchFamily="34" charset="0"/>
-                <a:ea typeface="Arial" pitchFamily="34" charset="-122"/>
-                <a:cs typeface="Arial" pitchFamily="34" charset="-120"/>
-              </a:rPr>
-              <a:t>Signer l'accord de sous-traitance RGPD</a:t>
-            </a:r>
-            <a:endParaRPr lang="en-US" sz="2000" dirty="0"/>
-          </a:p>
-        </p:txBody>
-      </p:sp>
-      <p:sp>
-        <p:nvSpPr>
-          <p:cNvPr id="6" name="Text 3"/>
+              <a:rPr lang="en-US" sz="1300" dirty="0">
+                <a:solidFill>
+                  <a:srgbClr val="5E6378"/>
+                </a:solidFill>
+                <a:latin typeface="Calibri" pitchFamily="34" charset="0"/>
+                <a:ea typeface="Calibri" pitchFamily="34" charset="-122"/>
+                <a:cs typeface="Calibri" pitchFamily="34" charset="-120"/>
+              </a:rPr>
+              <a:t>Annexe · consultées les 29 et 30/09/2026 · liens cliquables</a:t>
+            </a:r>
+            <a:endParaRPr lang="en-US" sz="1300" dirty="0"/>
+          </a:p>
+        </p:txBody>
+      </p:sp>
+      <p:sp>
+        <p:nvSpPr>
+          <p:cNvPr id="4" name="Text 2"/>
           <p:cNvSpPr txBox="1"/>
           <p:nvPr/>
         </p:nvSpPr>
         <p:spPr>
           <a:xfrm>
-            <a:off x="1325880" y="1645920"/>
-            <a:ext cx="7315200" cy="365760"/>
+            <a:off x="457200" y="1234440"/>
+            <a:ext cx="8229600" cy="3474720"/>
           </a:xfrm>
           <a:prstGeom prst="rect">
             <a:avLst/>
@@ -8324,86 +8694,356 @@
           <a:ln/>
         </p:spPr>
         <p:txBody>
-          <a:bodyPr wrap="square" lIns="0" tIns="0" rIns="0" bIns="0" rtlCol="0" anchor="ctr"/>
-          <a:lstStyle/>
-          <a:p>
-            <a:pPr indent="0" marL="0">
-              <a:buNone/>
-            </a:pPr>
-            <a:r>
-              <a:rPr lang="en-US" sz="1400" dirty="0">
-                <a:solidFill>
-                  <a:srgbClr val="C9CCDA"/>
-                </a:solidFill>
-                <a:latin typeface="Calibri" pitchFamily="34" charset="0"/>
-                <a:ea typeface="Calibri" pitchFamily="34" charset="-122"/>
-                <a:cs typeface="Calibri" pitchFamily="34" charset="-120"/>
-              </a:rPr>
-              <a:t>et valider le hachage des identifiants</a:t>
-            </a:r>
-            <a:endParaRPr lang="en-US" sz="1400" dirty="0"/>
-          </a:p>
-        </p:txBody>
-      </p:sp>
-      <p:sp>
-        <p:nvSpPr>
-          <p:cNvPr id="7" name="Shape 4"/>
-          <p:cNvSpPr/>
-          <p:nvPr/>
-        </p:nvSpPr>
-        <p:spPr>
-          <a:xfrm>
-            <a:off x="457200" y="2423160"/>
-            <a:ext cx="640080" cy="640080"/>
-          </a:xfrm>
-          <a:prstGeom prst="ellipse">
-            <a:avLst/>
-          </a:prstGeom>
-          <a:solidFill>
-            <a:srgbClr val="E23636"/>
-          </a:solidFill>
-          <a:ln w="12700">
-            <a:solidFill>
-              <a:srgbClr val="E23636"/>
-            </a:solidFill>
-            <a:prstDash val="solid"/>
-          </a:ln>
-        </p:spPr>
-      </p:sp>
-      <p:pic>
-        <p:nvPicPr>
-          <p:cNvPr id="8" name="Image 1" descr="preencoded.png">    </p:cNvPr>
-          <p:cNvPicPr>
-            <a:picLocks noChangeAspect="1"/>
-          </p:cNvPicPr>
-          <p:nvPr/>
-        </p:nvPicPr>
-        <p:blipFill>
-          <a:blip r:embed="rId2"/>
-          <a:stretch>
-            <a:fillRect/>
-          </a:stretch>
-        </p:blipFill>
-        <p:spPr>
-          <a:xfrm>
-            <a:off x="617220" y="2583180"/>
-            <a:ext cx="320040" cy="320040"/>
-          </a:xfrm>
-          <a:prstGeom prst="rect">
-            <a:avLst/>
-          </a:prstGeom>
-        </p:spPr>
-      </p:pic>
-      <p:sp>
-        <p:nvSpPr>
-          <p:cNvPr id="9" name="Text 5"/>
+          <a:bodyPr wrap="square" rtlCol="0" anchor="t"/>
+          <a:lstStyle/>
+          <a:p>
+            <a:pPr marL="342900" indent="-342900">
+              <a:spcAft>
+                <a:spcPts val="400"/>
+              </a:spcAft>
+              <a:buSzPct val="100000"/>
+              <a:buChar char="•"/>
+            </a:pPr>
+            <a:r>
+              <a:rPr lang="en-US" sz="1200" u="sng" dirty="0">
+                <a:solidFill>
+                  <a:srgbClr val="2F3C7E"/>
+                </a:solidFill>
+                <a:latin typeface="Calibri" pitchFamily="34" charset="0"/>
+                <a:ea typeface="Calibri" pitchFamily="34" charset="-122"/>
+                <a:cs typeface="Calibri" pitchFamily="34" charset="-120"/>
+                <a:hlinkClick r:id="rId1" invalidUrl="" action="" tgtFrame="" tooltip="" history="1" highlightClick="0" endSnd="0">
+                  <a:extLst>
+                    <a:ext uri="{A12FA001-AC4F-418D-AE19-62706E023703}">
+                      <ahyp:hlinkClr xmlns:ahyp="http://schemas.microsoft.com/office/drawing/2018/hyperlinkcolor" val="tx"/>
+                    </a:ext>
+                  </a:extLst>
+                </a:hlinkClick>
+              </a:rPr>
+              <a:t>Steam Charts, moyennes mensuelles (PC)</a:t>
+            </a:r>
+            <a:endParaRPr lang="en-US" sz="1200" dirty="0"/>
+          </a:p>
+          <a:p>
+            <a:pPr marL="342900" indent="-342900">
+              <a:spcAft>
+                <a:spcPts val="400"/>
+              </a:spcAft>
+              <a:buSzPct val="100000"/>
+              <a:buChar char="•"/>
+            </a:pPr>
+            <a:r>
+              <a:rPr lang="en-US" sz="1200" u="sng" dirty="0">
+                <a:solidFill>
+                  <a:srgbClr val="2F3C7E"/>
+                </a:solidFill>
+                <a:latin typeface="Calibri" pitchFamily="34" charset="0"/>
+                <a:ea typeface="Calibri" pitchFamily="34" charset="-122"/>
+                <a:cs typeface="Calibri" pitchFamily="34" charset="-120"/>
+                <a:hlinkClick r:id="rId2" invalidUrl="" action="" tgtFrame="" tooltip="" history="1" highlightClick="0" endSnd="0">
+                  <a:extLst>
+                    <a:ext uri="{A12FA001-AC4F-418D-AE19-62706E023703}">
+                      <ahyp:hlinkClr xmlns:ahyp="http://schemas.microsoft.com/office/drawing/2018/hyperlinkcolor" val="tx"/>
+                    </a:ext>
+                  </a:extLst>
+                </a:hlinkClick>
+              </a:rPr>
+              <a:t>40 millions de joueurs, rapport NetEase (Game World Observer)</a:t>
+            </a:r>
+            <a:endParaRPr lang="en-US" sz="1200" dirty="0"/>
+          </a:p>
+          <a:p>
+            <a:pPr marL="342900" indent="-342900">
+              <a:spcAft>
+                <a:spcPts val="400"/>
+              </a:spcAft>
+              <a:buSzPct val="100000"/>
+              <a:buChar char="•"/>
+            </a:pPr>
+            <a:r>
+              <a:rPr lang="en-US" sz="1200" u="sng" dirty="0">
+                <a:solidFill>
+                  <a:srgbClr val="2F3C7E"/>
+                </a:solidFill>
+                <a:latin typeface="Calibri" pitchFamily="34" charset="0"/>
+                <a:ea typeface="Calibri" pitchFamily="34" charset="-122"/>
+                <a:cs typeface="Calibri" pitchFamily="34" charset="-120"/>
+                <a:hlinkClick r:id="rId3" invalidUrl="" action="" tgtFrame="" tooltip="" history="1" highlightClick="0" endSnd="0">
+                  <a:extLst>
+                    <a:ext uri="{A12FA001-AC4F-418D-AE19-62706E023703}">
+                      <ahyp:hlinkClr xmlns:ahyp="http://schemas.microsoft.com/office/drawing/2018/hyperlinkcolor" val="tx"/>
+                    </a:ext>
+                  </a:extLst>
+                </a:hlinkClick>
+              </a:rPr>
+              <a:t>API publique des avis Steam (notre collecte, 37 990 avis pondérés)</a:t>
+            </a:r>
+            <a:endParaRPr lang="en-US" sz="1200" dirty="0"/>
+          </a:p>
+          <a:p>
+            <a:pPr marL="342900" indent="-342900">
+              <a:spcAft>
+                <a:spcPts val="400"/>
+              </a:spcAft>
+              <a:buSzPct val="100000"/>
+              <a:buChar char="•"/>
+            </a:pPr>
+            <a:r>
+              <a:rPr lang="en-US" sz="1200" u="sng" dirty="0">
+                <a:solidFill>
+                  <a:srgbClr val="2F3C7E"/>
+                </a:solidFill>
+                <a:latin typeface="Calibri" pitchFamily="34" charset="0"/>
+                <a:ea typeface="Calibri" pitchFamily="34" charset="-122"/>
+                <a:cs typeface="Calibri" pitchFamily="34" charset="-120"/>
+                <a:hlinkClick r:id="rId4" invalidUrl="" action="" tgtFrame="" tooltip="" history="1" highlightClick="0" endSnd="0">
+                  <a:extLst>
+                    <a:ext uri="{A12FA001-AC4F-418D-AE19-62706E023703}">
+                      <ahyp:hlinkClr xmlns:ahyp="http://schemas.microsoft.com/office/drawing/2018/hyperlinkcolor" val="tx"/>
+                    </a:ext>
+                  </a:extLst>
+                </a:hlinkClick>
+              </a:rPr>
+              <a:t>Vidéo NetEase sur le matchmaking, 21/08/2025</a:t>
+            </a:r>
+            <a:endParaRPr lang="en-US" sz="1200" dirty="0"/>
+          </a:p>
+          <a:p>
+            <a:pPr marL="342900" indent="-342900">
+              <a:spcAft>
+                <a:spcPts val="400"/>
+              </a:spcAft>
+              <a:buSzPct val="100000"/>
+              <a:buChar char="•"/>
+            </a:pPr>
+            <a:r>
+              <a:rPr lang="en-US" sz="1200" u="sng" dirty="0">
+                <a:solidFill>
+                  <a:srgbClr val="2F3C7E"/>
+                </a:solidFill>
+                <a:latin typeface="Calibri" pitchFamily="34" charset="0"/>
+                <a:ea typeface="Calibri" pitchFamily="34" charset="-122"/>
+                <a:cs typeface="Calibri" pitchFamily="34" charset="-120"/>
+                <a:hlinkClick r:id="rId5" invalidUrl="" action="" tgtFrame="" tooltip="" history="1" highlightClick="0" endSnd="0">
+                  <a:extLst>
+                    <a:ext uri="{A12FA001-AC4F-418D-AE19-62706E023703}">
+                      <ahyp:hlinkClr xmlns:ahyp="http://schemas.microsoft.com/office/drawing/2018/hyperlinkcolor" val="tx"/>
+                    </a:ext>
+                  </a:extLst>
+                </a:hlinkClick>
+              </a:rPr>
+              <a:t>Notes de patch Season 5, placements (14/11/2025)</a:t>
+            </a:r>
+            <a:endParaRPr lang="en-US" sz="1200" dirty="0"/>
+          </a:p>
+          <a:p>
+            <a:pPr marL="342900" indent="-342900">
+              <a:spcAft>
+                <a:spcPts val="400"/>
+              </a:spcAft>
+              <a:buSzPct val="100000"/>
+              <a:buChar char="•"/>
+            </a:pPr>
+            <a:r>
+              <a:rPr lang="en-US" sz="1200" u="sng" dirty="0">
+                <a:solidFill>
+                  <a:srgbClr val="2F3C7E"/>
+                </a:solidFill>
+                <a:latin typeface="Calibri" pitchFamily="34" charset="0"/>
+                <a:ea typeface="Calibri" pitchFamily="34" charset="-122"/>
+                <a:cs typeface="Calibri" pitchFamily="34" charset="-120"/>
+                <a:hlinkClick r:id="rId6" invalidUrl="" action="" tgtFrame="" tooltip="" history="1" highlightClick="0" endSnd="0">
+                  <a:extLst>
+                    <a:ext uri="{A12FA001-AC4F-418D-AE19-62706E023703}">
+                      <ahyp:hlinkClr xmlns:ahyp="http://schemas.microsoft.com/office/drawing/2018/hyperlinkcolor" val="tx"/>
+                    </a:ext>
+                  </a:extLst>
+                </a:hlinkClick>
+              </a:rPr>
+              <a:t>Notes de patch Season 7, placement individuel (18/03/2026)</a:t>
+            </a:r>
+            <a:endParaRPr lang="en-US" sz="1200" dirty="0"/>
+          </a:p>
+          <a:p>
+            <a:pPr marL="342900" indent="-342900">
+              <a:spcAft>
+                <a:spcPts val="400"/>
+              </a:spcAft>
+              <a:buSzPct val="100000"/>
+              <a:buChar char="•"/>
+            </a:pPr>
+            <a:r>
+              <a:rPr lang="en-US" sz="1200" u="sng" dirty="0">
+                <a:solidFill>
+                  <a:srgbClr val="2F3C7E"/>
+                </a:solidFill>
+                <a:latin typeface="Calibri" pitchFamily="34" charset="0"/>
+                <a:ea typeface="Calibri" pitchFamily="34" charset="-122"/>
+                <a:cs typeface="Calibri" pitchFamily="34" charset="-120"/>
+                <a:hlinkClick r:id="rId7" invalidUrl="" action="" tgtFrame="" tooltip="" history="1" highlightClick="0" endSnd="0">
+                  <a:extLst>
+                    <a:ext uri="{A12FA001-AC4F-418D-AE19-62706E023703}">
+                      <ahyp:hlinkClr xmlns:ahyp="http://schemas.microsoft.com/office/drawing/2018/hyperlinkcolor" val="tx"/>
+                    </a:ext>
+                  </a:extLst>
+                </a:hlinkClick>
+              </a:rPr>
+              <a:t>Classé : Bronze III pour tous (PCGamesN)</a:t>
+            </a:r>
+            <a:endParaRPr lang="en-US" sz="1200" dirty="0"/>
+          </a:p>
+          <a:p>
+            <a:pPr marL="342900" indent="-342900">
+              <a:spcAft>
+                <a:spcPts val="400"/>
+              </a:spcAft>
+              <a:buSzPct val="100000"/>
+              <a:buChar char="•"/>
+            </a:pPr>
+            <a:r>
+              <a:rPr lang="en-US" sz="1200" u="sng" dirty="0">
+                <a:solidFill>
+                  <a:srgbClr val="2F3C7E"/>
+                </a:solidFill>
+                <a:latin typeface="Calibri" pitchFamily="34" charset="0"/>
+                <a:ea typeface="Calibri" pitchFamily="34" charset="-122"/>
+                <a:cs typeface="Calibri" pitchFamily="34" charset="-120"/>
+                <a:hlinkClick r:id="rId8" invalidUrl="" action="" tgtFrame="" tooltip="" history="1" highlightClick="0" endSnd="0">
+                  <a:extLst>
+                    <a:ext uri="{A12FA001-AC4F-418D-AE19-62706E023703}">
+                      <ahyp:hlinkClr xmlns:ahyp="http://schemas.microsoft.com/office/drawing/2018/hyperlinkcolor" val="tx"/>
+                    </a:ext>
+                  </a:extLst>
+                </a:hlinkClick>
+              </a:rPr>
+              <a:t>Crossplay : partie rapide commune, classé séparé (Esports Insider)</a:t>
+            </a:r>
+            <a:endParaRPr lang="en-US" sz="1200" dirty="0"/>
+          </a:p>
+          <a:p>
+            <a:pPr marL="342900" indent="-342900">
+              <a:spcAft>
+                <a:spcPts val="400"/>
+              </a:spcAft>
+              <a:buSzPct val="100000"/>
+              <a:buChar char="•"/>
+            </a:pPr>
+            <a:r>
+              <a:rPr lang="en-US" sz="1200" u="sng" dirty="0">
+                <a:solidFill>
+                  <a:srgbClr val="2F3C7E"/>
+                </a:solidFill>
+                <a:latin typeface="Calibri" pitchFamily="34" charset="0"/>
+                <a:ea typeface="Calibri" pitchFamily="34" charset="-122"/>
+                <a:cs typeface="Calibri" pitchFamily="34" charset="-120"/>
+                <a:hlinkClick r:id="rId9" invalidUrl="" action="" tgtFrame="" tooltip="" history="1" highlightClick="0" endSnd="0">
+                  <a:extLst>
+                    <a:ext uri="{A12FA001-AC4F-418D-AE19-62706E023703}">
+                      <ahyp:hlinkClr xmlns:ahyp="http://schemas.microsoft.com/office/drawing/2018/hyperlinkcolor" val="tx"/>
+                    </a:ext>
+                  </a:extLst>
+                </a:hlinkClick>
+              </a:rPr>
+              <a:t>Écart de niveau et churn (Heliyon, 2024, analogie)</a:t>
+            </a:r>
+            <a:endParaRPr lang="en-US" sz="1200" dirty="0"/>
+          </a:p>
+          <a:p>
+            <a:pPr marL="342900" indent="-342900">
+              <a:spcAft>
+                <a:spcPts val="400"/>
+              </a:spcAft>
+              <a:buSzPct val="100000"/>
+              <a:buChar char="•"/>
+            </a:pPr>
+            <a:r>
+              <a:rPr lang="en-US" sz="1200" u="sng" dirty="0">
+                <a:solidFill>
+                  <a:srgbClr val="2F3C7E"/>
+                </a:solidFill>
+                <a:latin typeface="Calibri" pitchFamily="34" charset="0"/>
+                <a:ea typeface="Calibri" pitchFamily="34" charset="-122"/>
+                <a:cs typeface="Calibri" pitchFamily="34" charset="-120"/>
+                <a:hlinkClick r:id="rId10" invalidUrl="" action="" tgtFrame="" tooltip="" history="1" highlightClick="0" endSnd="0">
+                  <a:extLst>
+                    <a:ext uri="{A12FA001-AC4F-418D-AE19-62706E023703}">
+                      <ahyp:hlinkClr xmlns:ahyp="http://schemas.microsoft.com/office/drawing/2018/hyperlinkcolor" val="tx"/>
+                    </a:ext>
+                  </a:extLst>
+                </a:hlinkClick>
+              </a:rPr>
+              <a:t>RGPD (EUR-Lex)</a:t>
+            </a:r>
+            <a:endParaRPr lang="en-US" sz="1200" dirty="0"/>
+          </a:p>
+          <a:p>
+            <a:pPr marL="342900" indent="-342900">
+              <a:spcAft>
+                <a:spcPts val="400"/>
+              </a:spcAft>
+              <a:buSzPct val="100000"/>
+              <a:buChar char="•"/>
+            </a:pPr>
+            <a:r>
+              <a:rPr lang="en-US" sz="1200" u="sng" dirty="0">
+                <a:solidFill>
+                  <a:srgbClr val="2F3C7E"/>
+                </a:solidFill>
+                <a:latin typeface="Calibri" pitchFamily="34" charset="0"/>
+                <a:ea typeface="Calibri" pitchFamily="34" charset="-122"/>
+                <a:cs typeface="Calibri" pitchFamily="34" charset="-120"/>
+                <a:hlinkClick r:id="rId11" invalidUrl="" action="" tgtFrame="" tooltip="" history="1" highlightClick="0" endSnd="0">
+                  <a:extLst>
+                    <a:ext uri="{A12FA001-AC4F-418D-AE19-62706E023703}">
+                      <ahyp:hlinkClr xmlns:ahyp="http://schemas.microsoft.com/office/drawing/2018/hyperlinkcolor" val="tx"/>
+                    </a:ext>
+                  </a:extLst>
+                </a:hlinkClick>
+              </a:rPr>
+              <a:t>AI Act (EUR-Lex)</a:t>
+            </a:r>
+            <a:endParaRPr lang="en-US" sz="1200" dirty="0"/>
+          </a:p>
+          <a:p>
+            <a:pPr marL="342900" indent="-342900">
+              <a:spcAft>
+                <a:spcPts val="400"/>
+              </a:spcAft>
+              <a:buSzPct val="100000"/>
+              <a:buChar char="•"/>
+            </a:pPr>
+            <a:r>
+              <a:rPr lang="en-US" sz="1200" u="sng" dirty="0">
+                <a:solidFill>
+                  <a:srgbClr val="2F3C7E"/>
+                </a:solidFill>
+                <a:latin typeface="Calibri" pitchFamily="34" charset="0"/>
+                <a:ea typeface="Calibri" pitchFamily="34" charset="-122"/>
+                <a:cs typeface="Calibri" pitchFamily="34" charset="-120"/>
+                <a:hlinkClick r:id="rId12" invalidUrl="" action="" tgtFrame="" tooltip="" history="1" highlightClick="0" endSnd="0">
+                  <a:extLst>
+                    <a:ext uri="{A12FA001-AC4F-418D-AE19-62706E023703}">
+                      <ahyp:hlinkClr xmlns:ahyp="http://schemas.microsoft.com/office/drawing/2018/hyperlinkcolor" val="tx"/>
+                    </a:ext>
+                  </a:extLst>
+                </a:hlinkClick>
+              </a:rPr>
+              <a:t>Plan de collecte complet (Google Docs)</a:t>
+            </a:r>
+            <a:endParaRPr lang="en-US" sz="1200" dirty="0"/>
+          </a:p>
+        </p:txBody>
+      </p:sp>
+      <p:sp>
+        <p:nvSpPr>
+          <p:cNvPr id="5" name="Text 3"/>
           <p:cNvSpPr txBox="1"/>
           <p:nvPr/>
         </p:nvSpPr>
         <p:spPr>
           <a:xfrm>
-            <a:off x="1325880" y="2423160"/>
-            <a:ext cx="7315200" cy="411480"/>
+            <a:off x="8412480" y="4754880"/>
+            <a:ext cx="274320" cy="256032"/>
           </a:xfrm>
           <a:prstGeom prst="rect">
             <a:avLst/>
@@ -8415,130 +9055,13 @@
           <a:bodyPr wrap="square" lIns="0" tIns="0" rIns="0" bIns="0" rtlCol="0" anchor="ctr"/>
           <a:lstStyle/>
           <a:p>
-            <a:pPr indent="0" marL="0">
-              <a:buNone/>
-            </a:pPr>
-            <a:r>
-              <a:rPr lang="en-US" sz="2000" b="1" dirty="0">
-                <a:solidFill>
-                  <a:srgbClr val="FFFFFF"/>
-                </a:solidFill>
-                <a:latin typeface="Arial" pitchFamily="34" charset="0"/>
-                <a:ea typeface="Arial" pitchFamily="34" charset="-122"/>
-                <a:cs typeface="Arial" pitchFamily="34" charset="-120"/>
-              </a:rPr>
-              <a:t>Lancer l'audit de 30 jours</a:t>
-            </a:r>
-            <a:endParaRPr lang="en-US" sz="2000" dirty="0"/>
-          </a:p>
-        </p:txBody>
-      </p:sp>
-      <p:sp>
-        <p:nvSpPr>
-          <p:cNvPr id="10" name="Text 6"/>
-          <p:cNvSpPr txBox="1"/>
-          <p:nvPr/>
-        </p:nvSpPr>
-        <p:spPr>
-          <a:xfrm>
-            <a:off x="1325880" y="2834640"/>
-            <a:ext cx="7315200" cy="365760"/>
-          </a:xfrm>
-          <a:prstGeom prst="rect">
-            <a:avLst/>
-          </a:prstGeom>
-          <a:noFill/>
-          <a:ln/>
-        </p:spPr>
-        <p:txBody>
-          <a:bodyPr wrap="square" lIns="0" tIns="0" rIns="0" bIns="0" rtlCol="0" anchor="ctr"/>
-          <a:lstStyle/>
-          <a:p>
-            <a:pPr indent="0" marL="0">
-              <a:buNone/>
-            </a:pPr>
-            <a:r>
-              <a:rPr lang="en-US" sz="1400" dirty="0">
-                <a:solidFill>
-                  <a:srgbClr val="C9CCDA"/>
-                </a:solidFill>
-                <a:latin typeface="Calibri" pitchFamily="34" charset="0"/>
-                <a:ea typeface="Calibri" pitchFamily="34" charset="-122"/>
-                <a:cs typeface="Calibri" pitchFamily="34" charset="-120"/>
-              </a:rPr>
-              <a:t>environ 33 jours-homme, plafonnés à cette phase ; tests A/B chiffrés à part</a:t>
-            </a:r>
-            <a:endParaRPr lang="en-US" sz="1400" dirty="0"/>
-          </a:p>
-        </p:txBody>
-      </p:sp>
-      <p:sp>
-        <p:nvSpPr>
-          <p:cNvPr id="11" name="Text 7"/>
-          <p:cNvSpPr txBox="1"/>
-          <p:nvPr/>
-        </p:nvSpPr>
-        <p:spPr>
-          <a:xfrm>
-            <a:off x="457200" y="3749040"/>
-            <a:ext cx="8229600" cy="731520"/>
-          </a:xfrm>
-          <a:prstGeom prst="rect">
-            <a:avLst/>
-          </a:prstGeom>
-          <a:noFill/>
-          <a:ln/>
-        </p:spPr>
-        <p:txBody>
-          <a:bodyPr wrap="square" lIns="0" tIns="0" rIns="0" bIns="0" rtlCol="0" anchor="ctr"/>
-          <a:lstStyle/>
-          <a:p>
-            <a:pPr indent="0" marL="0">
-              <a:buNone/>
-            </a:pPr>
-            <a:r>
-              <a:rPr lang="en-US" sz="1400" i="1" dirty="0">
-                <a:solidFill>
-                  <a:srgbClr val="FFFFFF"/>
-                </a:solidFill>
-                <a:latin typeface="Calibri" pitchFamily="34" charset="0"/>
-                <a:ea typeface="Calibri" pitchFamily="34" charset="-122"/>
-                <a:cs typeface="Calibri" pitchFamily="34" charset="-120"/>
-              </a:rPr>
-              <a:t>Si H5 est confirmée, le matchmaking des nouveaux devient votre levier de rétention prioritaire. Si elle est réfutée, vous évitez d'investir au mauvais endroit.</a:t>
-            </a:r>
-            <a:endParaRPr lang="en-US" sz="1400" dirty="0"/>
-          </a:p>
-        </p:txBody>
-      </p:sp>
-      <p:sp>
-        <p:nvSpPr>
-          <p:cNvPr id="12" name="Text 8"/>
-          <p:cNvSpPr txBox="1"/>
-          <p:nvPr/>
-        </p:nvSpPr>
-        <p:spPr>
-          <a:xfrm>
-            <a:off x="8412480" y="4754880"/>
-            <a:ext cx="274320" cy="256032"/>
-          </a:xfrm>
-          <a:prstGeom prst="rect">
-            <a:avLst/>
-          </a:prstGeom>
-          <a:noFill/>
-          <a:ln/>
-        </p:spPr>
-        <p:txBody>
-          <a:bodyPr wrap="square" lIns="0" tIns="0" rIns="0" bIns="0" rtlCol="0" anchor="ctr"/>
-          <a:lstStyle/>
-          <a:p>
             <a:pPr algn="r" indent="0" marL="0">
               <a:buNone/>
             </a:pPr>
             <a:r>
               <a:rPr lang="en-US" sz="900" dirty="0">
                 <a:solidFill>
-                  <a:srgbClr val="C9CCDA"/>
+                  <a:srgbClr val="5E6378"/>
                 </a:solidFill>
                 <a:latin typeface="Calibri" pitchFamily="34" charset="0"/>
                 <a:ea typeface="Calibri" pitchFamily="34" charset="-122"/>

</xml_diff>

<commit_message>
Pitch : slide sourcée sur les deux publics du lancement (vétérans / joueurs venus pour Marvel)
Co-Authored-By: Claude Opus 5.5 <noreply@anthropic.com>
Claude-Session: https://claude.ai/code/session_012kyLDzFB57v6JCyVf6ygKi
</commit_message>
<xml_diff>
--- a/docs/presentation/pitch_marvel_rivals_netease.pptx
+++ b/docs/presentation/pitch_marvel_rivals_netease.pptx
@@ -14,9 +14,10 @@
     <p:sldId id="262" r:id="rId8"/>
     <p:sldId id="263" r:id="rId9"/>
     <p:sldId id="264" r:id="rId10"/>
+    <p:sldId id="265" r:id="rId11"/>
   </p:sldIdLst>
   <p:notesMasterIdLst>
-    <p:notesMasterId r:id="rId11"/>
+    <p:notesMasterId r:id="rId12"/>
   </p:notesMasterIdLst>
   <p:sldSz cx="9144000" cy="5143500"/>
   <p:notesSz cx="5143500" cy="9144000"/>
@@ -1363,6 +1364,94 @@
 </p:notes>
 </file>
 
+<file path=ppt/notesSlides/notesSlide10.xml><?xml version="1.0" encoding="utf-8"?>
+<p:notes xmlns:a="http://schemas.openxmlformats.org/drawingml/2006/main" xmlns:r="http://schemas.openxmlformats.org/officeDocument/2006/relationships" xmlns:p="http://schemas.openxmlformats.org/presentationml/2006/main">
+  <p:cSld>
+    <p:spTree>
+      <p:nvGrpSpPr>
+        <p:cNvPr id="1" name=""/>
+        <p:cNvGrpSpPr/>
+        <p:nvPr/>
+      </p:nvGrpSpPr>
+      <p:grpSpPr>
+        <a:xfrm>
+          <a:off x="0" y="0"/>
+          <a:ext cx="0" cy="0"/>
+          <a:chOff x="0" y="0"/>
+          <a:chExt cx="0" cy="0"/>
+        </a:xfrm>
+      </p:grpSpPr>
+      <p:sp>
+        <p:nvSpPr>
+          <p:cNvPr id="2" name="Slide Image Placeholder 1"/>
+          <p:cNvSpPr>
+            <a:spLocks noGrp="1" noRot="1" noChangeAspect="1"/>
+          </p:cNvSpPr>
+          <p:nvPr>
+            <p:ph type="sldImg"/>
+          </p:nvPr>
+        </p:nvSpPr>
+        <p:spPr/>
+      </p:sp>
+      <p:sp>
+        <p:nvSpPr>
+          <p:cNvPr id="3" name="Notes Placeholder 2"/>
+          <p:cNvSpPr>
+            <a:spLocks noGrp="1"/>
+          </p:cNvSpPr>
+          <p:nvPr>
+            <p:ph type="body" idx="1"/>
+          </p:nvPr>
+        </p:nvSpPr>
+        <p:spPr/>
+        <p:txBody>
+          <a:bodyPr/>
+          <a:lstStyle/>
+          <a:p>
+            <a:r>
+              <a:rPr lang="en-US" dirty="0"/>
+              <a:t>Annexe, à montrer seulement si on vous demande une source.</a:t>
+            </a:r>
+            <a:endParaRPr lang="en-US" dirty="0"/>
+          </a:p>
+        </p:txBody>
+      </p:sp>
+      <p:sp>
+        <p:nvSpPr>
+          <p:cNvPr id="4" name="Slide Number Placeholder 3"/>
+          <p:cNvSpPr>
+            <a:spLocks noGrp="1"/>
+          </p:cNvSpPr>
+          <p:nvPr>
+            <p:ph type="sldNum" sz="quarter" idx="10"/>
+          </p:nvPr>
+        </p:nvSpPr>
+        <p:spPr/>
+        <p:txBody>
+          <a:bodyPr/>
+          <a:lstStyle/>
+          <a:p>
+            <a:fld id="{F7021451-1387-4CA6-816F-3879F97B5CBC}" type="slidenum">
+              <a:rPr lang="en-US"/>
+              <a:t>10</a:t>
+            </a:fld>
+            <a:endParaRPr lang="en-US"/>
+          </a:p>
+        </p:txBody>
+      </p:sp>
+    </p:spTree>
+    <p:extLst>
+      <p:ext uri="{BB962C8B-B14F-4D97-AF65-F5344CB8AC3E}">
+        <p14:creationId xmlns:p14="http://schemas.microsoft.com/office/powerpoint/2010/main" val="1024086991"/>
+      </p:ext>
+    </p:extLst>
+  </p:cSld>
+  <p:clrMapOvr>
+    <a:masterClrMapping/>
+  </p:clrMapOvr>
+</p:notes>
+</file>
+
 <file path=ppt/notesSlides/notesSlide2.xml><?xml version="1.0" encoding="utf-8"?>
 <p:notes xmlns:a="http://schemas.openxmlformats.org/drawingml/2006/main" xmlns:r="http://schemas.openxmlformats.org/officeDocument/2006/relationships" xmlns:p="http://schemas.openxmlformats.org/presentationml/2006/main">
   <p:cSld>
@@ -1497,7 +1586,7 @@
           <a:p>
             <a:r>
               <a:rPr lang="en-US" dirty="0"/>
-              <a:t>Notre hypothèse principale, H5, en trois temps. En 2025, tout le monde arrive sans calibrage ; les moins expérimentés perdent et partent. Il reste surtout des joueurs expérimentés. Aujourd'hui, un nouveau arrive en partie rapide face à eux, dans des parties que le manque de joueurs élargit ; il part à son tour. Deux causes possibles : un MMR de départ mal réglé, ou le manque de joueurs. Elles appellent des leviers différents, c'est pourquoi on audite avant d'agir.</a:t>
+              <a:t>30 secondes. Au lancement, deux publics arrivent en même temps. D'un côté, des vétérans du genre : selon Newzoo, 45 % des joueurs qui ont quitté Overwatch 2 en décembre 2024 ont joué à Marvel Rivals, et Overwatch 2 perd 22 % de joueurs sur PC ce mois-là. Attention, « ont joué » ne veut pas dire « ont migré ». De l'autre, un public massif venu pour Marvel : 10 millions en trois jours, 40 millions en trois mois, dont beaucoup découvrent le genre. Le jeu ne les distingue pas : tout le monde commence en Bronze III. Ensuite la base se durcit : chez les auteurs d'avis Steam, les plus de 200 heures passent de 5 % à 42 %. Ce chiffre grimpe aussi parce que le jeu vieillit, mais la presse fait le même constat.</a:t>
             </a:r>
             <a:endParaRPr lang="en-US" dirty="0"/>
           </a:p>
@@ -1585,7 +1674,7 @@
           <a:p>
             <a:r>
               <a:rPr lang="en-US" dirty="0"/>
-              <a:t>Les faits qui appuient H5. Pendant la chute, la part des avis négatifs qui parlent du matchmaking passe de 7 à 41 %. Les explications officielles d'août 2025 ne la font pas baisser. En revanche, quand NetEase ajoute des placements en classé, les avis négatifs chutent de 36 à 14 %. Mais la partie rapide, par où passent tous les nouveaux, n'a jamais été corrigée. Ce sont des corrélations : seules vos données internes peuvent trancher.</a:t>
+              <a:t>Notre hypothèse principale, H5, en trois temps. En 2025, tout le monde arrive sans calibrage ; les moins expérimentés perdent et partent. Il reste surtout des joueurs expérimentés. Aujourd'hui, un nouveau arrive en partie rapide face à eux, dans des parties que le manque de joueurs élargit ; il part à son tour. Deux causes possibles : un MMR de départ mal réglé, ou le manque de joueurs. Elles appellent des leviers différents, c'est pourquoi on audite avant d'agir.</a:t>
             </a:r>
             <a:endParaRPr lang="en-US" dirty="0"/>
           </a:p>
@@ -1673,7 +1762,7 @@
           <a:p>
             <a:r>
               <a:rPr lang="en-US" dirty="0"/>
-              <a:t>Recommandation, première partie : d'abord mesurer. L'objectif traduit notre hypothèse en chiffre : si perdre au début fait partir, les nouveaux qui perdent partent plus que les autres. On vise un écart d'au plus 1,2 fois au 31 mars 2027. Cinq données d'abord. Un : les résultats des dix premiers matchs et le départ à sept jours, c'est la mesure même de l'objectif. Deux : dans quel mode et sur quelle plateforme jouent les nouveaux, pour savoir quoi corriger en premier. Trois et quatre : chacune teste une des deux causes possibles. Cinq : NetEase a déjà changé le placement en classé à la saison 5 ; comparer avant et après, c'est une expérience gratuite. Tout existe déjà dans vos serveurs : pas de nouvelle collecte. Et si l'écart est déjà sous 1,2, on n'investit pas dans le matchmaking.</a:t>
+              <a:t>Les faits qui appuient H5. Pendant la chute, la part des avis négatifs qui parlent du matchmaking passe de 7 à 41 %. Les explications officielles d'août 2025 ne la font pas baisser. En revanche, quand NetEase ajoute des placements en classé, les avis négatifs chutent de 36 à 14 %. Mais la partie rapide, par où passent tous les nouveaux, n'a jamais été corrigée. Ce sont des corrélations : seules vos données internes peuvent trancher.</a:t>
             </a:r>
             <a:endParaRPr lang="en-US" dirty="0"/>
           </a:p>
@@ -1761,7 +1850,7 @@
           <a:p>
             <a:r>
               <a:rPr lang="en-US" dirty="0"/>
-              <a:t>Recommandation, deuxième partie. Deux causes peuvent expliquer que les nouveaux perdent trop. Cause A, le démarrage à froid : le jeu ne sait rien d'un nouveau compte, il lui donne un niveau par défaut et le place mal pendant ses premiers matchs. Cause B, le manque de joueurs : quand la file est vide, le jeu accepte des écarts de niveau plus grands pour lancer la partie ; NetEase l'a lui-même expliqué en août 2025. Les données les distinguent : A, l'écart est fort sur les premiers matchs à toute heure ; B, il grandit quand la file se vide. On ne teste que le levier de la cause trouvée, avec un groupe témoin. Nous écartons les rôles imposés : la liberté de composition fait partie de l'identité du jeu.</a:t>
+              <a:t>Recommandation, première partie : d'abord mesurer. L'objectif traduit notre hypothèse en chiffre : si perdre au début fait partir, les nouveaux qui perdent partent plus que les autres. On vise un écart d'au plus 1,2 fois au 31 mars 2027. Cinq données d'abord. Un : les résultats des dix premiers matchs et le départ à sept jours, c'est la mesure même de l'objectif. Deux : dans quel mode et sur quelle plateforme jouent les nouveaux, pour savoir quoi corriger en premier. Trois et quatre : chacune teste une des deux causes possibles. Cinq : NetEase a déjà changé le placement en classé à la saison 5 ; comparer avant et après, c'est une expérience gratuite. Tout existe déjà dans vos serveurs : pas de nouvelle collecte. Et si l'écart est déjà sous 1,2, on n'investit pas dans le matchmaking.</a:t>
             </a:r>
             <a:endParaRPr lang="en-US" dirty="0"/>
           </a:p>
@@ -1849,7 +1938,7 @@
           <a:p>
             <a:r>
               <a:rPr lang="en-US" dirty="0"/>
-              <a:t>La roadmap, une minute. Trente jours d'audit, qui démarrent quand l'accord de sous-traitance et le hachage sont validés : c'est J0. Si le ratio est déjà sous 1,2, on s'arrête et on bascule sur le plan B (équilibrage, monétisation, attrition naturelle), avec les données déjà extraites. Sinon, 60 jours de tests A/B contre un groupe témoin, puis généralisation jusqu'au 31 mars 2027.</a:t>
+              <a:t>Recommandation, deuxième partie. Deux causes peuvent expliquer que les nouveaux perdent trop. Cause A, le démarrage à froid : le jeu ne sait rien d'un nouveau compte, il lui donne un niveau par défaut et le place mal pendant ses premiers matchs. Cause B, le manque de joueurs : quand la file est vide, le jeu accepte des écarts de niveau plus grands pour lancer la partie ; NetEase l'a lui-même expliqué en août 2025. Les données les distinguent : A, l'écart est fort sur les premiers matchs à toute heure ; B, il grandit quand la file se vide. On ne teste que le levier de la cause trouvée, avec un groupe témoin. Nous écartons les rôles imposés : la liberté de composition fait partie de l'identité du jeu.</a:t>
             </a:r>
             <a:endParaRPr lang="en-US" dirty="0"/>
           </a:p>
@@ -1937,7 +2026,7 @@
           <a:p>
             <a:r>
               <a:rPr lang="en-US" dirty="0"/>
-              <a:t>30 secondes sur les garde-fous. Chaque KPI a un seuil qui déclenche une décision : 1,2 pour lancer les tests, 5 minutes d'attente pour les arrêter, 50 % pour choisir le mode visé. Côté risques : accord de sous-traitance et pseudonymisation, aucun profilage individuel, et jamais de bots cachés. Pour démarrer, nous vous demandons deux choses : signer l'accord de sous-traitance et lancer l'audit de 30 jours, environ 33 jours-homme. Si l'hypothèse est confirmée, vous tenez votre levier de rétention ; sinon, vous évitez d'investir au mauvais endroit. Merci, je prends vos questions.</a:t>
+              <a:t>La roadmap, une minute. Trente jours d'audit, qui démarrent quand l'accord de sous-traitance et le hachage sont validés : c'est J0. Si le ratio est déjà sous 1,2, on s'arrête et on bascule sur le plan B (équilibrage, monétisation, attrition naturelle), avec les données déjà extraites. Sinon, 60 jours de tests A/B contre un groupe témoin, puis généralisation jusqu'au 31 mars 2027.</a:t>
             </a:r>
             <a:endParaRPr lang="en-US" dirty="0"/>
           </a:p>
@@ -2025,7 +2114,7 @@
           <a:p>
             <a:r>
               <a:rPr lang="en-US" dirty="0"/>
-              <a:t>Annexe, à montrer seulement si on vous demande une source.</a:t>
+              <a:t>30 secondes sur les garde-fous. Chaque KPI a un seuil qui déclenche une décision : 1,2 pour lancer les tests, 5 minutes d'attente pour les arrêter, 50 % pour choisir le mode visé. Côté risques : accord de sous-traitance et pseudonymisation, aucun profilage individuel, et jamais de bots cachés. Pour démarrer, nous vous demandons deux choses : signer l'accord de sous-traitance et lancer l'audit de 30 jours, environ 33 jours-homme. Si l'hypothèse est confirmée, vous tenez votre levier de rétention ; sinon, vous évitez d'investir au mauvais endroit. Merci, je prends vos questions.</a:t>
             </a:r>
             <a:endParaRPr lang="en-US" dirty="0"/>
           </a:p>
@@ -2572,6 +2661,597 @@
 </p:sld>
 </file>
 
+<file path=ppt/slides/slide10.xml><?xml version="1.0" encoding="utf-8"?>
+<p:sld xmlns:a="http://schemas.openxmlformats.org/drawingml/2006/main" xmlns:r="http://schemas.openxmlformats.org/officeDocument/2006/relationships" xmlns:p="http://schemas.openxmlformats.org/presentationml/2006/main">
+  <p:cSld name="Slide 10">
+    <p:bg>
+      <p:bgPr>
+        <a:solidFill>
+          <a:srgbClr val="FFFFFF"/>
+        </a:solidFill>
+      </p:bgPr>
+    </p:bg>
+    <p:spTree>
+      <p:nvGrpSpPr>
+        <p:cNvPr id="1" name=""/>
+        <p:cNvGrpSpPr/>
+        <p:nvPr/>
+      </p:nvGrpSpPr>
+      <p:grpSpPr>
+        <a:xfrm>
+          <a:off x="0" y="0"/>
+          <a:ext cx="0" cy="0"/>
+          <a:chOff x="0" y="0"/>
+          <a:chExt cx="0" cy="0"/>
+        </a:xfrm>
+      </p:grpSpPr>
+      <p:sp>
+        <p:nvSpPr>
+          <p:cNvPr id="2" name="Text 0"/>
+          <p:cNvSpPr txBox="1"/>
+          <p:nvPr/>
+        </p:nvSpPr>
+        <p:spPr>
+          <a:xfrm>
+            <a:off x="457200" y="274320"/>
+            <a:ext cx="8229600" cy="548640"/>
+          </a:xfrm>
+          <a:prstGeom prst="rect">
+            <a:avLst/>
+          </a:prstGeom>
+          <a:noFill/>
+          <a:ln/>
+        </p:spPr>
+        <p:txBody>
+          <a:bodyPr wrap="square" lIns="0" tIns="0" rIns="0" bIns="0" rtlCol="0" anchor="ctr"/>
+          <a:lstStyle/>
+          <a:p>
+            <a:pPr indent="0" marL="0">
+              <a:buNone/>
+            </a:pPr>
+            <a:r>
+              <a:rPr lang="en-US" sz="2800" b="1" dirty="0">
+                <a:solidFill>
+                  <a:srgbClr val="1F2233"/>
+                </a:solidFill>
+                <a:latin typeface="Arial" pitchFamily="34" charset="0"/>
+                <a:ea typeface="Arial" pitchFamily="34" charset="-122"/>
+                <a:cs typeface="Arial" pitchFamily="34" charset="-120"/>
+              </a:rPr>
+              <a:t>Sources</a:t>
+            </a:r>
+            <a:endParaRPr lang="en-US" sz="2800" dirty="0"/>
+          </a:p>
+        </p:txBody>
+      </p:sp>
+      <p:sp>
+        <p:nvSpPr>
+          <p:cNvPr id="3" name="Text 1"/>
+          <p:cNvSpPr txBox="1"/>
+          <p:nvPr/>
+        </p:nvSpPr>
+        <p:spPr>
+          <a:xfrm>
+            <a:off x="457200" y="804672"/>
+            <a:ext cx="8229600" cy="320040"/>
+          </a:xfrm>
+          <a:prstGeom prst="rect">
+            <a:avLst/>
+          </a:prstGeom>
+          <a:noFill/>
+          <a:ln/>
+        </p:spPr>
+        <p:txBody>
+          <a:bodyPr wrap="square" lIns="0" tIns="0" rIns="0" bIns="0" rtlCol="0" anchor="ctr"/>
+          <a:lstStyle/>
+          <a:p>
+            <a:pPr indent="0" marL="0">
+              <a:buNone/>
+            </a:pPr>
+            <a:r>
+              <a:rPr lang="en-US" sz="1300" dirty="0">
+                <a:solidFill>
+                  <a:srgbClr val="5E6378"/>
+                </a:solidFill>
+                <a:latin typeface="Calibri" pitchFamily="34" charset="0"/>
+                <a:ea typeface="Calibri" pitchFamily="34" charset="-122"/>
+                <a:cs typeface="Calibri" pitchFamily="34" charset="-120"/>
+              </a:rPr>
+              <a:t>Annexe · consultées les 29 et 30/09/2026 · liens cliquables</a:t>
+            </a:r>
+            <a:endParaRPr lang="en-US" sz="1300" dirty="0"/>
+          </a:p>
+        </p:txBody>
+      </p:sp>
+      <p:sp>
+        <p:nvSpPr>
+          <p:cNvPr id="4" name="Text 2"/>
+          <p:cNvSpPr txBox="1"/>
+          <p:nvPr/>
+        </p:nvSpPr>
+        <p:spPr>
+          <a:xfrm>
+            <a:off x="457200" y="1234440"/>
+            <a:ext cx="8229600" cy="3474720"/>
+          </a:xfrm>
+          <a:prstGeom prst="rect">
+            <a:avLst/>
+          </a:prstGeom>
+          <a:noFill/>
+          <a:ln/>
+        </p:spPr>
+        <p:txBody>
+          <a:bodyPr wrap="square" rtlCol="0" anchor="t"/>
+          <a:lstStyle/>
+          <a:p>
+            <a:pPr marL="342900" indent="-342900">
+              <a:spcAft>
+                <a:spcPts val="200"/>
+              </a:spcAft>
+              <a:buSzPct val="100000"/>
+              <a:buChar char="•"/>
+            </a:pPr>
+            <a:r>
+              <a:rPr lang="en-US" sz="1050" u="sng" dirty="0">
+                <a:solidFill>
+                  <a:srgbClr val="2F3C7E"/>
+                </a:solidFill>
+                <a:latin typeface="Calibri" pitchFamily="34" charset="0"/>
+                <a:ea typeface="Calibri" pitchFamily="34" charset="-122"/>
+                <a:cs typeface="Calibri" pitchFamily="34" charset="-120"/>
+                <a:hlinkClick r:id="rId1" invalidUrl="" action="" tgtFrame="" tooltip="" history="1" highlightClick="0" endSnd="0">
+                  <a:extLst>
+                    <a:ext uri="{A12FA001-AC4F-418D-AE19-62706E023703}">
+                      <ahyp:hlinkClr xmlns:ahyp="http://schemas.microsoft.com/office/drawing/2018/hyperlinkcolor" val="tx"/>
+                    </a:ext>
+                  </a:extLst>
+                </a:hlinkClick>
+              </a:rPr>
+              <a:t>Steam Charts, moyennes mensuelles (PC)</a:t>
+            </a:r>
+            <a:endParaRPr lang="en-US" sz="1050" dirty="0"/>
+          </a:p>
+          <a:p>
+            <a:pPr marL="342900" indent="-342900">
+              <a:spcAft>
+                <a:spcPts val="200"/>
+              </a:spcAft>
+              <a:buSzPct val="100000"/>
+              <a:buChar char="•"/>
+            </a:pPr>
+            <a:r>
+              <a:rPr lang="en-US" sz="1050" u="sng" dirty="0">
+                <a:solidFill>
+                  <a:srgbClr val="2F3C7E"/>
+                </a:solidFill>
+                <a:latin typeface="Calibri" pitchFamily="34" charset="0"/>
+                <a:ea typeface="Calibri" pitchFamily="34" charset="-122"/>
+                <a:cs typeface="Calibri" pitchFamily="34" charset="-120"/>
+                <a:hlinkClick r:id="rId2" invalidUrl="" action="" tgtFrame="" tooltip="" history="1" highlightClick="0" endSnd="0">
+                  <a:extLst>
+                    <a:ext uri="{A12FA001-AC4F-418D-AE19-62706E023703}">
+                      <ahyp:hlinkClr xmlns:ahyp="http://schemas.microsoft.com/office/drawing/2018/hyperlinkcolor" val="tx"/>
+                    </a:ext>
+                  </a:extLst>
+                </a:hlinkClick>
+              </a:rPr>
+              <a:t>40 millions de joueurs, rapport NetEase (Game World Observer)</a:t>
+            </a:r>
+            <a:endParaRPr lang="en-US" sz="1050" dirty="0"/>
+          </a:p>
+          <a:p>
+            <a:pPr marL="342900" indent="-342900">
+              <a:spcAft>
+                <a:spcPts val="200"/>
+              </a:spcAft>
+              <a:buSzPct val="100000"/>
+              <a:buChar char="•"/>
+            </a:pPr>
+            <a:r>
+              <a:rPr lang="en-US" sz="1050" u="sng" dirty="0">
+                <a:solidFill>
+                  <a:srgbClr val="2F3C7E"/>
+                </a:solidFill>
+                <a:latin typeface="Calibri" pitchFamily="34" charset="0"/>
+                <a:ea typeface="Calibri" pitchFamily="34" charset="-122"/>
+                <a:cs typeface="Calibri" pitchFamily="34" charset="-120"/>
+                <a:hlinkClick r:id="rId3" invalidUrl="" action="" tgtFrame="" tooltip="" history="1" highlightClick="0" endSnd="0">
+                  <a:extLst>
+                    <a:ext uri="{A12FA001-AC4F-418D-AE19-62706E023703}">
+                      <ahyp:hlinkClr xmlns:ahyp="http://schemas.microsoft.com/office/drawing/2018/hyperlinkcolor" val="tx"/>
+                    </a:ext>
+                  </a:extLst>
+                </a:hlinkClick>
+              </a:rPr>
+              <a:t>API publique des avis Steam (notre collecte, 37 990 avis pondérés)</a:t>
+            </a:r>
+            <a:endParaRPr lang="en-US" sz="1050" dirty="0"/>
+          </a:p>
+          <a:p>
+            <a:pPr marL="342900" indent="-342900">
+              <a:spcAft>
+                <a:spcPts val="200"/>
+              </a:spcAft>
+              <a:buSzPct val="100000"/>
+              <a:buChar char="•"/>
+            </a:pPr>
+            <a:r>
+              <a:rPr lang="en-US" sz="1050" u="sng" dirty="0">
+                <a:solidFill>
+                  <a:srgbClr val="2F3C7E"/>
+                </a:solidFill>
+                <a:latin typeface="Calibri" pitchFamily="34" charset="0"/>
+                <a:ea typeface="Calibri" pitchFamily="34" charset="-122"/>
+                <a:cs typeface="Calibri" pitchFamily="34" charset="-120"/>
+                <a:hlinkClick r:id="rId4" invalidUrl="" action="" tgtFrame="" tooltip="" history="1" highlightClick="0" endSnd="0">
+                  <a:extLst>
+                    <a:ext uri="{A12FA001-AC4F-418D-AE19-62706E023703}">
+                      <ahyp:hlinkClr xmlns:ahyp="http://schemas.microsoft.com/office/drawing/2018/hyperlinkcolor" val="tx"/>
+                    </a:ext>
+                  </a:extLst>
+                </a:hlinkClick>
+              </a:rPr>
+              <a:t>Vidéo NetEase sur le matchmaking, 21/08/2025</a:t>
+            </a:r>
+            <a:endParaRPr lang="en-US" sz="1050" dirty="0"/>
+          </a:p>
+          <a:p>
+            <a:pPr marL="342900" indent="-342900">
+              <a:spcAft>
+                <a:spcPts val="200"/>
+              </a:spcAft>
+              <a:buSzPct val="100000"/>
+              <a:buChar char="•"/>
+            </a:pPr>
+            <a:r>
+              <a:rPr lang="en-US" sz="1050" u="sng" dirty="0">
+                <a:solidFill>
+                  <a:srgbClr val="2F3C7E"/>
+                </a:solidFill>
+                <a:latin typeface="Calibri" pitchFamily="34" charset="0"/>
+                <a:ea typeface="Calibri" pitchFamily="34" charset="-122"/>
+                <a:cs typeface="Calibri" pitchFamily="34" charset="-120"/>
+                <a:hlinkClick r:id="rId5" invalidUrl="" action="" tgtFrame="" tooltip="" history="1" highlightClick="0" endSnd="0">
+                  <a:extLst>
+                    <a:ext uri="{A12FA001-AC4F-418D-AE19-62706E023703}">
+                      <ahyp:hlinkClr xmlns:ahyp="http://schemas.microsoft.com/office/drawing/2018/hyperlinkcolor" val="tx"/>
+                    </a:ext>
+                  </a:extLst>
+                </a:hlinkClick>
+              </a:rPr>
+              <a:t>Notes de patch Season 5, placements (14/11/2025)</a:t>
+            </a:r>
+            <a:endParaRPr lang="en-US" sz="1050" dirty="0"/>
+          </a:p>
+          <a:p>
+            <a:pPr marL="342900" indent="-342900">
+              <a:spcAft>
+                <a:spcPts val="200"/>
+              </a:spcAft>
+              <a:buSzPct val="100000"/>
+              <a:buChar char="•"/>
+            </a:pPr>
+            <a:r>
+              <a:rPr lang="en-US" sz="1050" u="sng" dirty="0">
+                <a:solidFill>
+                  <a:srgbClr val="2F3C7E"/>
+                </a:solidFill>
+                <a:latin typeface="Calibri" pitchFamily="34" charset="0"/>
+                <a:ea typeface="Calibri" pitchFamily="34" charset="-122"/>
+                <a:cs typeface="Calibri" pitchFamily="34" charset="-120"/>
+                <a:hlinkClick r:id="rId6" invalidUrl="" action="" tgtFrame="" tooltip="" history="1" highlightClick="0" endSnd="0">
+                  <a:extLst>
+                    <a:ext uri="{A12FA001-AC4F-418D-AE19-62706E023703}">
+                      <ahyp:hlinkClr xmlns:ahyp="http://schemas.microsoft.com/office/drawing/2018/hyperlinkcolor" val="tx"/>
+                    </a:ext>
+                  </a:extLst>
+                </a:hlinkClick>
+              </a:rPr>
+              <a:t>Notes de patch Season 7, placement individuel (18/03/2026)</a:t>
+            </a:r>
+            <a:endParaRPr lang="en-US" sz="1050" dirty="0"/>
+          </a:p>
+          <a:p>
+            <a:pPr marL="342900" indent="-342900">
+              <a:spcAft>
+                <a:spcPts val="200"/>
+              </a:spcAft>
+              <a:buSzPct val="100000"/>
+              <a:buChar char="•"/>
+            </a:pPr>
+            <a:r>
+              <a:rPr lang="en-US" sz="1050" u="sng" dirty="0">
+                <a:solidFill>
+                  <a:srgbClr val="2F3C7E"/>
+                </a:solidFill>
+                <a:latin typeface="Calibri" pitchFamily="34" charset="0"/>
+                <a:ea typeface="Calibri" pitchFamily="34" charset="-122"/>
+                <a:cs typeface="Calibri" pitchFamily="34" charset="-120"/>
+                <a:hlinkClick r:id="rId7" invalidUrl="" action="" tgtFrame="" tooltip="" history="1" highlightClick="0" endSnd="0">
+                  <a:extLst>
+                    <a:ext uri="{A12FA001-AC4F-418D-AE19-62706E023703}">
+                      <ahyp:hlinkClr xmlns:ahyp="http://schemas.microsoft.com/office/drawing/2018/hyperlinkcolor" val="tx"/>
+                    </a:ext>
+                  </a:extLst>
+                </a:hlinkClick>
+              </a:rPr>
+              <a:t>Classé : Bronze III pour tous (PCGamesN)</a:t>
+            </a:r>
+            <a:endParaRPr lang="en-US" sz="1050" dirty="0"/>
+          </a:p>
+          <a:p>
+            <a:pPr marL="342900" indent="-342900">
+              <a:spcAft>
+                <a:spcPts val="200"/>
+              </a:spcAft>
+              <a:buSzPct val="100000"/>
+              <a:buChar char="•"/>
+            </a:pPr>
+            <a:r>
+              <a:rPr lang="en-US" sz="1050" u="sng" dirty="0">
+                <a:solidFill>
+                  <a:srgbClr val="2F3C7E"/>
+                </a:solidFill>
+                <a:latin typeface="Calibri" pitchFamily="34" charset="0"/>
+                <a:ea typeface="Calibri" pitchFamily="34" charset="-122"/>
+                <a:cs typeface="Calibri" pitchFamily="34" charset="-120"/>
+                <a:hlinkClick r:id="rId8" invalidUrl="" action="" tgtFrame="" tooltip="" history="1" highlightClick="0" endSnd="0">
+                  <a:extLst>
+                    <a:ext uri="{A12FA001-AC4F-418D-AE19-62706E023703}">
+                      <ahyp:hlinkClr xmlns:ahyp="http://schemas.microsoft.com/office/drawing/2018/hyperlinkcolor" val="tx"/>
+                    </a:ext>
+                  </a:extLst>
+                </a:hlinkClick>
+              </a:rPr>
+              <a:t>45 % des joueurs ayant quitté Overwatch 2 ont joué à Marvel Rivals (Newzoo, via Insider Gaming, 09/04/2025)</a:t>
+            </a:r>
+            <a:endParaRPr lang="en-US" sz="1050" dirty="0"/>
+          </a:p>
+          <a:p>
+            <a:pPr marL="342900" indent="-342900">
+              <a:spcAft>
+                <a:spcPts val="200"/>
+              </a:spcAft>
+              <a:buSzPct val="100000"/>
+              <a:buChar char="•"/>
+            </a:pPr>
+            <a:r>
+              <a:rPr lang="en-US" sz="1050" u="sng" dirty="0">
+                <a:solidFill>
+                  <a:srgbClr val="2F3C7E"/>
+                </a:solidFill>
+                <a:latin typeface="Calibri" pitchFamily="34" charset="0"/>
+                <a:ea typeface="Calibri" pitchFamily="34" charset="-122"/>
+                <a:cs typeface="Calibri" pitchFamily="34" charset="-120"/>
+                <a:hlinkClick r:id="rId9" invalidUrl="" action="" tgtFrame="" tooltip="" history="1" highlightClick="0" endSnd="0">
+                  <a:extLst>
+                    <a:ext uri="{A12FA001-AC4F-418D-AE19-62706E023703}">
+                      <ahyp:hlinkClr xmlns:ahyp="http://schemas.microsoft.com/office/drawing/2018/hyperlinkcolor" val="tx"/>
+                    </a:ext>
+                  </a:extLst>
+                </a:hlinkClick>
+              </a:rPr>
+              <a:t>Overwatch 2 : baisse des joueurs moyens sur PC (VGC)</a:t>
+            </a:r>
+            <a:endParaRPr lang="en-US" sz="1050" dirty="0"/>
+          </a:p>
+          <a:p>
+            <a:pPr marL="342900" indent="-342900">
+              <a:spcAft>
+                <a:spcPts val="200"/>
+              </a:spcAft>
+              <a:buSzPct val="100000"/>
+              <a:buChar char="•"/>
+            </a:pPr>
+            <a:r>
+              <a:rPr lang="en-US" sz="1050" u="sng" dirty="0">
+                <a:solidFill>
+                  <a:srgbClr val="2F3C7E"/>
+                </a:solidFill>
+                <a:latin typeface="Calibri" pitchFamily="34" charset="0"/>
+                <a:ea typeface="Calibri" pitchFamily="34" charset="-122"/>
+                <a:cs typeface="Calibri" pitchFamily="34" charset="-120"/>
+                <a:hlinkClick r:id="rId10" invalidUrl="" action="" tgtFrame="" tooltip="" history="1" highlightClick="0" endSnd="0">
+                  <a:extLst>
+                    <a:ext uri="{A12FA001-AC4F-418D-AE19-62706E023703}">
+                      <ahyp:hlinkClr xmlns:ahyp="http://schemas.microsoft.com/office/drawing/2018/hyperlinkcolor" val="tx"/>
+                    </a:ext>
+                  </a:extLst>
+                </a:hlinkClick>
+              </a:rPr>
+              <a:t>« Plus un jeu pour le fan occasionnel » (TheGamer, 09/08/2025)</a:t>
+            </a:r>
+            <a:endParaRPr lang="en-US" sz="1050" dirty="0"/>
+          </a:p>
+          <a:p>
+            <a:pPr marL="342900" indent="-342900">
+              <a:spcAft>
+                <a:spcPts val="200"/>
+              </a:spcAft>
+              <a:buSzPct val="100000"/>
+              <a:buChar char="•"/>
+            </a:pPr>
+            <a:r>
+              <a:rPr lang="en-US" sz="1050" u="sng" dirty="0">
+                <a:solidFill>
+                  <a:srgbClr val="2F3C7E"/>
+                </a:solidFill>
+                <a:latin typeface="Calibri" pitchFamily="34" charset="0"/>
+                <a:ea typeface="Calibri" pitchFamily="34" charset="-122"/>
+                <a:cs typeface="Calibri" pitchFamily="34" charset="-120"/>
+                <a:hlinkClick r:id="rId11" invalidUrl="" action="" tgtFrame="" tooltip="" history="1" highlightClick="0" endSnd="0">
+                  <a:extLst>
+                    <a:ext uri="{A12FA001-AC4F-418D-AE19-62706E023703}">
+                      <ahyp:hlinkClr xmlns:ahyp="http://schemas.microsoft.com/office/drawing/2018/hyperlinkcolor" val="tx"/>
+                    </a:ext>
+                  </a:extLst>
+                </a:hlinkClick>
+              </a:rPr>
+              <a:t>Crossplay : partie rapide commune, classé séparé (Esports Insider)</a:t>
+            </a:r>
+            <a:endParaRPr lang="en-US" sz="1050" dirty="0"/>
+          </a:p>
+          <a:p>
+            <a:pPr marL="342900" indent="-342900">
+              <a:spcAft>
+                <a:spcPts val="200"/>
+              </a:spcAft>
+              <a:buSzPct val="100000"/>
+              <a:buChar char="•"/>
+            </a:pPr>
+            <a:r>
+              <a:rPr lang="en-US" sz="1050" u="sng" dirty="0">
+                <a:solidFill>
+                  <a:srgbClr val="2F3C7E"/>
+                </a:solidFill>
+                <a:latin typeface="Calibri" pitchFamily="34" charset="0"/>
+                <a:ea typeface="Calibri" pitchFamily="34" charset="-122"/>
+                <a:cs typeface="Calibri" pitchFamily="34" charset="-120"/>
+                <a:hlinkClick r:id="rId12" invalidUrl="" action="" tgtFrame="" tooltip="" history="1" highlightClick="0" endSnd="0">
+                  <a:extLst>
+                    <a:ext uri="{A12FA001-AC4F-418D-AE19-62706E023703}">
+                      <ahyp:hlinkClr xmlns:ahyp="http://schemas.microsoft.com/office/drawing/2018/hyperlinkcolor" val="tx"/>
+                    </a:ext>
+                  </a:extLst>
+                </a:hlinkClick>
+              </a:rPr>
+              <a:t>Écart de niveau et churn (Heliyon, 2024, analogie)</a:t>
+            </a:r>
+            <a:endParaRPr lang="en-US" sz="1050" dirty="0"/>
+          </a:p>
+          <a:p>
+            <a:pPr marL="342900" indent="-342900">
+              <a:spcAft>
+                <a:spcPts val="200"/>
+              </a:spcAft>
+              <a:buSzPct val="100000"/>
+              <a:buChar char="•"/>
+            </a:pPr>
+            <a:r>
+              <a:rPr lang="en-US" sz="1050" u="sng" dirty="0">
+                <a:solidFill>
+                  <a:srgbClr val="2F3C7E"/>
+                </a:solidFill>
+                <a:latin typeface="Calibri" pitchFamily="34" charset="0"/>
+                <a:ea typeface="Calibri" pitchFamily="34" charset="-122"/>
+                <a:cs typeface="Calibri" pitchFamily="34" charset="-120"/>
+                <a:hlinkClick r:id="rId13" invalidUrl="" action="" tgtFrame="" tooltip="" history="1" highlightClick="0" endSnd="0">
+                  <a:extLst>
+                    <a:ext uri="{A12FA001-AC4F-418D-AE19-62706E023703}">
+                      <ahyp:hlinkClr xmlns:ahyp="http://schemas.microsoft.com/office/drawing/2018/hyperlinkcolor" val="tx"/>
+                    </a:ext>
+                  </a:extLst>
+                </a:hlinkClick>
+              </a:rPr>
+              <a:t>RGPD (EUR-Lex)</a:t>
+            </a:r>
+            <a:endParaRPr lang="en-US" sz="1050" dirty="0"/>
+          </a:p>
+          <a:p>
+            <a:pPr marL="342900" indent="-342900">
+              <a:spcAft>
+                <a:spcPts val="200"/>
+              </a:spcAft>
+              <a:buSzPct val="100000"/>
+              <a:buChar char="•"/>
+            </a:pPr>
+            <a:r>
+              <a:rPr lang="en-US" sz="1050" u="sng" dirty="0">
+                <a:solidFill>
+                  <a:srgbClr val="2F3C7E"/>
+                </a:solidFill>
+                <a:latin typeface="Calibri" pitchFamily="34" charset="0"/>
+                <a:ea typeface="Calibri" pitchFamily="34" charset="-122"/>
+                <a:cs typeface="Calibri" pitchFamily="34" charset="-120"/>
+                <a:hlinkClick r:id="rId14" invalidUrl="" action="" tgtFrame="" tooltip="" history="1" highlightClick="0" endSnd="0">
+                  <a:extLst>
+                    <a:ext uri="{A12FA001-AC4F-418D-AE19-62706E023703}">
+                      <ahyp:hlinkClr xmlns:ahyp="http://schemas.microsoft.com/office/drawing/2018/hyperlinkcolor" val="tx"/>
+                    </a:ext>
+                  </a:extLst>
+                </a:hlinkClick>
+              </a:rPr>
+              <a:t>AI Act (EUR-Lex)</a:t>
+            </a:r>
+            <a:endParaRPr lang="en-US" sz="1050" dirty="0"/>
+          </a:p>
+          <a:p>
+            <a:pPr marL="342900" indent="-342900">
+              <a:spcAft>
+                <a:spcPts val="200"/>
+              </a:spcAft>
+              <a:buSzPct val="100000"/>
+              <a:buChar char="•"/>
+            </a:pPr>
+            <a:r>
+              <a:rPr lang="en-US" sz="1050" u="sng" dirty="0">
+                <a:solidFill>
+                  <a:srgbClr val="2F3C7E"/>
+                </a:solidFill>
+                <a:latin typeface="Calibri" pitchFamily="34" charset="0"/>
+                <a:ea typeface="Calibri" pitchFamily="34" charset="-122"/>
+                <a:cs typeface="Calibri" pitchFamily="34" charset="-120"/>
+                <a:hlinkClick r:id="rId15" invalidUrl="" action="" tgtFrame="" tooltip="" history="1" highlightClick="0" endSnd="0">
+                  <a:extLst>
+                    <a:ext uri="{A12FA001-AC4F-418D-AE19-62706E023703}">
+                      <ahyp:hlinkClr xmlns:ahyp="http://schemas.microsoft.com/office/drawing/2018/hyperlinkcolor" val="tx"/>
+                    </a:ext>
+                  </a:extLst>
+                </a:hlinkClick>
+              </a:rPr>
+              <a:t>Plan de collecte complet (Google Docs)</a:t>
+            </a:r>
+            <a:endParaRPr lang="en-US" sz="1050" dirty="0"/>
+          </a:p>
+        </p:txBody>
+      </p:sp>
+      <p:sp>
+        <p:nvSpPr>
+          <p:cNvPr id="5" name="Text 3"/>
+          <p:cNvSpPr txBox="1"/>
+          <p:nvPr/>
+        </p:nvSpPr>
+        <p:spPr>
+          <a:xfrm>
+            <a:off x="8412480" y="4754880"/>
+            <a:ext cx="274320" cy="256032"/>
+          </a:xfrm>
+          <a:prstGeom prst="rect">
+            <a:avLst/>
+          </a:prstGeom>
+          <a:noFill/>
+          <a:ln/>
+        </p:spPr>
+        <p:txBody>
+          <a:bodyPr wrap="square" lIns="0" tIns="0" rIns="0" bIns="0" rtlCol="0" anchor="ctr"/>
+          <a:lstStyle/>
+          <a:p>
+            <a:pPr algn="r" indent="0" marL="0">
+              <a:buNone/>
+            </a:pPr>
+            <a:r>
+              <a:rPr lang="en-US" sz="900" dirty="0">
+                <a:solidFill>
+                  <a:srgbClr val="5E6378"/>
+                </a:solidFill>
+                <a:latin typeface="Calibri" pitchFamily="34" charset="0"/>
+                <a:ea typeface="Calibri" pitchFamily="34" charset="-122"/>
+                <a:cs typeface="Calibri" pitchFamily="34" charset="-120"/>
+              </a:rPr>
+              <a:t>10</a:t>
+            </a:r>
+            <a:endParaRPr lang="en-US" sz="900" dirty="0"/>
+          </a:p>
+        </p:txBody>
+      </p:sp>
+    </p:spTree>
+  </p:cSld>
+  <p:clrMapOvr>
+    <a:masterClrMapping/>
+  </p:clrMapOvr>
+</p:sld>
+</file>
+
 <file path=ppt/slides/slide2.xml><?xml version="1.0" encoding="utf-8"?>
 <p:sld xmlns:a="http://schemas.openxmlformats.org/drawingml/2006/main" xmlns:r="http://schemas.openxmlformats.org/officeDocument/2006/relationships" xmlns:p="http://schemas.openxmlformats.org/presentationml/2006/main">
   <p:cSld name="Slide 2">
@@ -3045,6 +3725,980 @@
                 <a:ea typeface="Arial" pitchFamily="34" charset="-122"/>
                 <a:cs typeface="Arial" pitchFamily="34" charset="-120"/>
               </a:rPr>
+              <a:t>Au lancement, deux publics se croisent</a:t>
+            </a:r>
+            <a:endParaRPr lang="en-US" sz="2800" dirty="0"/>
+          </a:p>
+        </p:txBody>
+      </p:sp>
+      <p:sp>
+        <p:nvSpPr>
+          <p:cNvPr id="3" name="Text 1"/>
+          <p:cNvSpPr txBox="1"/>
+          <p:nvPr/>
+        </p:nvSpPr>
+        <p:spPr>
+          <a:xfrm>
+            <a:off x="457200" y="804672"/>
+            <a:ext cx="8229600" cy="320040"/>
+          </a:xfrm>
+          <a:prstGeom prst="rect">
+            <a:avLst/>
+          </a:prstGeom>
+          <a:noFill/>
+          <a:ln/>
+        </p:spPr>
+        <p:txBody>
+          <a:bodyPr wrap="square" lIns="0" tIns="0" rIns="0" bIns="0" rtlCol="0" anchor="ctr"/>
+          <a:lstStyle/>
+          <a:p>
+            <a:pPr indent="0" marL="0">
+              <a:buNone/>
+            </a:pPr>
+            <a:r>
+              <a:rPr lang="en-US" sz="1300" dirty="0">
+                <a:solidFill>
+                  <a:srgbClr val="5E6378"/>
+                </a:solidFill>
+                <a:latin typeface="Calibri" pitchFamily="34" charset="0"/>
+                <a:ea typeface="Calibri" pitchFamily="34" charset="-122"/>
+                <a:cs typeface="Calibri" pitchFamily="34" charset="-120"/>
+              </a:rPr>
+              <a:t>Contexte · qui est arrivé en décembre 2024</a:t>
+            </a:r>
+            <a:endParaRPr lang="en-US" sz="1300" dirty="0"/>
+          </a:p>
+        </p:txBody>
+      </p:sp>
+      <p:sp>
+        <p:nvSpPr>
+          <p:cNvPr id="4" name="Shape 2"/>
+          <p:cNvSpPr/>
+          <p:nvPr/>
+        </p:nvSpPr>
+        <p:spPr>
+          <a:xfrm>
+            <a:off x="457200" y="1234440"/>
+            <a:ext cx="4023360" cy="2331720"/>
+          </a:xfrm>
+          <a:prstGeom prst="roundRect">
+            <a:avLst>
+              <a:gd name="adj" fmla="val 3137"/>
+            </a:avLst>
+          </a:prstGeom>
+          <a:solidFill>
+            <a:srgbClr val="FFFFFF"/>
+          </a:solidFill>
+          <a:ln w="12700">
+            <a:solidFill>
+              <a:srgbClr val="E3E5EE"/>
+            </a:solidFill>
+            <a:prstDash val="solid"/>
+          </a:ln>
+        </p:spPr>
+      </p:sp>
+      <p:sp>
+        <p:nvSpPr>
+          <p:cNvPr id="5" name="Shape 3"/>
+          <p:cNvSpPr/>
+          <p:nvPr/>
+        </p:nvSpPr>
+        <p:spPr>
+          <a:xfrm>
+            <a:off x="640080" y="1371600"/>
+            <a:ext cx="411480" cy="411480"/>
+          </a:xfrm>
+          <a:prstGeom prst="ellipse">
+            <a:avLst/>
+          </a:prstGeom>
+          <a:solidFill>
+            <a:srgbClr val="161A33"/>
+          </a:solidFill>
+          <a:ln w="12700">
+            <a:solidFill>
+              <a:srgbClr val="161A33"/>
+            </a:solidFill>
+            <a:prstDash val="solid"/>
+          </a:ln>
+        </p:spPr>
+      </p:sp>
+      <p:pic>
+        <p:nvPicPr>
+          <p:cNvPr id="6" name="Image 0" descr="preencoded.png">    </p:cNvPr>
+          <p:cNvPicPr>
+            <a:picLocks noChangeAspect="1"/>
+          </p:cNvPicPr>
+          <p:nvPr/>
+        </p:nvPicPr>
+        <p:blipFill>
+          <a:blip r:embed="rId1"/>
+          <a:stretch>
+            <a:fillRect/>
+          </a:stretch>
+        </p:blipFill>
+        <p:spPr>
+          <a:xfrm>
+            <a:off x="742950" y="1474470"/>
+            <a:ext cx="205740" cy="205740"/>
+          </a:xfrm>
+          <a:prstGeom prst="rect">
+            <a:avLst/>
+          </a:prstGeom>
+        </p:spPr>
+      </p:pic>
+      <p:sp>
+        <p:nvSpPr>
+          <p:cNvPr id="7" name="Text 4"/>
+          <p:cNvSpPr txBox="1"/>
+          <p:nvPr/>
+        </p:nvSpPr>
+        <p:spPr>
+          <a:xfrm>
+            <a:off x="1188720" y="1371600"/>
+            <a:ext cx="3154680" cy="411480"/>
+          </a:xfrm>
+          <a:prstGeom prst="rect">
+            <a:avLst/>
+          </a:prstGeom>
+          <a:noFill/>
+          <a:ln/>
+        </p:spPr>
+        <p:txBody>
+          <a:bodyPr wrap="square" lIns="0" tIns="0" rIns="0" bIns="0" rtlCol="0" anchor="ctr"/>
+          <a:lstStyle/>
+          <a:p>
+            <a:pPr indent="0" marL="0">
+              <a:buNone/>
+            </a:pPr>
+            <a:r>
+              <a:rPr lang="en-US" sz="1500" b="1" dirty="0">
+                <a:solidFill>
+                  <a:srgbClr val="1F2233"/>
+                </a:solidFill>
+                <a:latin typeface="Arial" pitchFamily="34" charset="0"/>
+                <a:ea typeface="Arial" pitchFamily="34" charset="-122"/>
+                <a:cs typeface="Arial" pitchFamily="34" charset="-120"/>
+              </a:rPr>
+              <a:t>Les vétérans du genre</a:t>
+            </a:r>
+            <a:endParaRPr lang="en-US" sz="1500" dirty="0"/>
+          </a:p>
+        </p:txBody>
+      </p:sp>
+      <p:sp>
+        <p:nvSpPr>
+          <p:cNvPr id="8" name="Text 5"/>
+          <p:cNvSpPr txBox="1"/>
+          <p:nvPr/>
+        </p:nvSpPr>
+        <p:spPr>
+          <a:xfrm>
+            <a:off x="640080" y="1901952"/>
+            <a:ext cx="3657600" cy="1188720"/>
+          </a:xfrm>
+          <a:prstGeom prst="rect">
+            <a:avLst/>
+          </a:prstGeom>
+          <a:noFill/>
+          <a:ln/>
+        </p:spPr>
+        <p:txBody>
+          <a:bodyPr wrap="square" lIns="0" tIns="0" rIns="0" bIns="0" rtlCol="0" anchor="t"/>
+          <a:lstStyle/>
+          <a:p>
+            <a:pPr indent="0" marL="0">
+              <a:buNone/>
+            </a:pPr>
+            <a:r>
+              <a:rPr lang="en-US" sz="1600" b="1" dirty="0">
+                <a:solidFill>
+                  <a:srgbClr val="161A33"/>
+                </a:solidFill>
+                <a:latin typeface="Calibri" pitchFamily="34" charset="0"/>
+                <a:ea typeface="Calibri" pitchFamily="34" charset="-122"/>
+                <a:cs typeface="Calibri" pitchFamily="34" charset="-120"/>
+              </a:rPr>
+              <a:t>45 %</a:t>
+            </a:r>
+            <a:pPr indent="0" marL="0">
+              <a:buNone/>
+            </a:pPr>
+            <a:r>
+              <a:rPr lang="en-US" sz="1100" dirty="0">
+                <a:solidFill>
+                  <a:srgbClr val="1F2233"/>
+                </a:solidFill>
+                <a:latin typeface="Calibri" pitchFamily="34" charset="0"/>
+                <a:ea typeface="Calibri" pitchFamily="34" charset="-122"/>
+                <a:cs typeface="Calibri" pitchFamily="34" charset="-120"/>
+              </a:rPr>
+              <a:t> des joueurs qui ont arrêté Overwatch 2 en décembre 2024 ont joué à Marvel Rivals (Newzoo)</a:t>
+            </a:r>
+            <a:endParaRPr lang="en-US" sz="1100" dirty="0"/>
+          </a:p>
+          <a:p>
+            <a:pPr indent="0" marL="0">
+              <a:buNone/>
+            </a:pPr>
+            <a:r>
+              <a:rPr lang="en-US" sz="500" dirty="0">
+                <a:solidFill>
+                  <a:srgbClr val="000000"/>
+                </a:solidFill>
+                <a:latin typeface="Calibri" pitchFamily="34" charset="0"/>
+                <a:ea typeface="Calibri" pitchFamily="34" charset="-122"/>
+                <a:cs typeface="Calibri" pitchFamily="34" charset="-120"/>
+              </a:rPr>
+              <a:t> </a:t>
+            </a:r>
+            <a:endParaRPr lang="en-US" sz="1100" dirty="0"/>
+          </a:p>
+          <a:p>
+            <a:pPr indent="0" marL="0">
+              <a:buNone/>
+            </a:pPr>
+            <a:r>
+              <a:rPr lang="en-US" sz="1600" b="1" dirty="0">
+                <a:solidFill>
+                  <a:srgbClr val="161A33"/>
+                </a:solidFill>
+                <a:latin typeface="Calibri" pitchFamily="34" charset="0"/>
+                <a:ea typeface="Calibri" pitchFamily="34" charset="-122"/>
+                <a:cs typeface="Calibri" pitchFamily="34" charset="-120"/>
+              </a:rPr>
+              <a:t>−22 %</a:t>
+            </a:r>
+            <a:pPr indent="0" marL="0">
+              <a:buNone/>
+            </a:pPr>
+            <a:r>
+              <a:rPr lang="en-US" sz="1100" dirty="0">
+                <a:solidFill>
+                  <a:srgbClr val="1F2233"/>
+                </a:solidFill>
+                <a:latin typeface="Calibri" pitchFamily="34" charset="0"/>
+                <a:ea typeface="Calibri" pitchFamily="34" charset="-122"/>
+                <a:cs typeface="Calibri" pitchFamily="34" charset="-120"/>
+              </a:rPr>
+              <a:t> de joueurs moyens sur Overwatch 2 (PC) le mois du lancement de Marvel Rivals</a:t>
+            </a:r>
+            <a:endParaRPr lang="en-US" sz="1100" dirty="0"/>
+          </a:p>
+        </p:txBody>
+      </p:sp>
+      <p:sp>
+        <p:nvSpPr>
+          <p:cNvPr id="9" name="Text 6"/>
+          <p:cNvSpPr txBox="1"/>
+          <p:nvPr/>
+        </p:nvSpPr>
+        <p:spPr>
+          <a:xfrm>
+            <a:off x="640080" y="3127248"/>
+            <a:ext cx="3657600" cy="365760"/>
+          </a:xfrm>
+          <a:prstGeom prst="rect">
+            <a:avLst/>
+          </a:prstGeom>
+          <a:noFill/>
+          <a:ln/>
+        </p:spPr>
+        <p:txBody>
+          <a:bodyPr wrap="square" lIns="0" tIns="0" rIns="0" bIns="0" rtlCol="0" anchor="t"/>
+          <a:lstStyle/>
+          <a:p>
+            <a:pPr indent="0" marL="0">
+              <a:buNone/>
+            </a:pPr>
+            <a:r>
+              <a:rPr lang="en-US" sz="1100" i="1" dirty="0">
+                <a:solidFill>
+                  <a:srgbClr val="5E6378"/>
+                </a:solidFill>
+                <a:latin typeface="Calibri" pitchFamily="34" charset="0"/>
+                <a:ea typeface="Calibri" pitchFamily="34" charset="-122"/>
+                <a:cs typeface="Calibri" pitchFamily="34" charset="-120"/>
+              </a:rPr>
+              <a:t>Ils maîtrisent déjà les rôles, la visée et le jeu d'équipe.</a:t>
+            </a:r>
+            <a:endParaRPr lang="en-US" sz="1100" dirty="0"/>
+          </a:p>
+        </p:txBody>
+      </p:sp>
+      <p:sp>
+        <p:nvSpPr>
+          <p:cNvPr id="10" name="Shape 7"/>
+          <p:cNvSpPr/>
+          <p:nvPr/>
+        </p:nvSpPr>
+        <p:spPr>
+          <a:xfrm>
+            <a:off x="4663440" y="1234440"/>
+            <a:ext cx="4023360" cy="2331720"/>
+          </a:xfrm>
+          <a:prstGeom prst="roundRect">
+            <a:avLst>
+              <a:gd name="adj" fmla="val 3137"/>
+            </a:avLst>
+          </a:prstGeom>
+          <a:solidFill>
+            <a:srgbClr val="FFFFFF"/>
+          </a:solidFill>
+          <a:ln w="12700">
+            <a:solidFill>
+              <a:srgbClr val="E3E5EE"/>
+            </a:solidFill>
+            <a:prstDash val="solid"/>
+          </a:ln>
+        </p:spPr>
+      </p:sp>
+      <p:sp>
+        <p:nvSpPr>
+          <p:cNvPr id="11" name="Shape 8"/>
+          <p:cNvSpPr/>
+          <p:nvPr/>
+        </p:nvSpPr>
+        <p:spPr>
+          <a:xfrm>
+            <a:off x="4846320" y="1371600"/>
+            <a:ext cx="411480" cy="411480"/>
+          </a:xfrm>
+          <a:prstGeom prst="ellipse">
+            <a:avLst/>
+          </a:prstGeom>
+          <a:solidFill>
+            <a:srgbClr val="E23636"/>
+          </a:solidFill>
+          <a:ln w="12700">
+            <a:solidFill>
+              <a:srgbClr val="E23636"/>
+            </a:solidFill>
+            <a:prstDash val="solid"/>
+          </a:ln>
+        </p:spPr>
+      </p:sp>
+      <p:pic>
+        <p:nvPicPr>
+          <p:cNvPr id="12" name="Image 1" descr="preencoded.png">    </p:cNvPr>
+          <p:cNvPicPr>
+            <a:picLocks noChangeAspect="1"/>
+          </p:cNvPicPr>
+          <p:nvPr/>
+        </p:nvPicPr>
+        <p:blipFill>
+          <a:blip r:embed="rId2"/>
+          <a:stretch>
+            <a:fillRect/>
+          </a:stretch>
+        </p:blipFill>
+        <p:spPr>
+          <a:xfrm>
+            <a:off x="4949190" y="1474470"/>
+            <a:ext cx="205740" cy="205740"/>
+          </a:xfrm>
+          <a:prstGeom prst="rect">
+            <a:avLst/>
+          </a:prstGeom>
+        </p:spPr>
+      </p:pic>
+      <p:sp>
+        <p:nvSpPr>
+          <p:cNvPr id="13" name="Text 9"/>
+          <p:cNvSpPr txBox="1"/>
+          <p:nvPr/>
+        </p:nvSpPr>
+        <p:spPr>
+          <a:xfrm>
+            <a:off x="5394960" y="1371600"/>
+            <a:ext cx="3154680" cy="411480"/>
+          </a:xfrm>
+          <a:prstGeom prst="rect">
+            <a:avLst/>
+          </a:prstGeom>
+          <a:noFill/>
+          <a:ln/>
+        </p:spPr>
+        <p:txBody>
+          <a:bodyPr wrap="square" lIns="0" tIns="0" rIns="0" bIns="0" rtlCol="0" anchor="ctr"/>
+          <a:lstStyle/>
+          <a:p>
+            <a:pPr indent="0" marL="0">
+              <a:buNone/>
+            </a:pPr>
+            <a:r>
+              <a:rPr lang="en-US" sz="1500" b="1" dirty="0">
+                <a:solidFill>
+                  <a:srgbClr val="1F2233"/>
+                </a:solidFill>
+                <a:latin typeface="Arial" pitchFamily="34" charset="0"/>
+                <a:ea typeface="Arial" pitchFamily="34" charset="-122"/>
+                <a:cs typeface="Arial" pitchFamily="34" charset="-120"/>
+              </a:rPr>
+              <a:t>Les joueurs venus pour Marvel</a:t>
+            </a:r>
+            <a:endParaRPr lang="en-US" sz="1500" dirty="0"/>
+          </a:p>
+        </p:txBody>
+      </p:sp>
+      <p:sp>
+        <p:nvSpPr>
+          <p:cNvPr id="14" name="Text 10"/>
+          <p:cNvSpPr txBox="1"/>
+          <p:nvPr/>
+        </p:nvSpPr>
+        <p:spPr>
+          <a:xfrm>
+            <a:off x="4846320" y="1901952"/>
+            <a:ext cx="3657600" cy="1188720"/>
+          </a:xfrm>
+          <a:prstGeom prst="rect">
+            <a:avLst/>
+          </a:prstGeom>
+          <a:noFill/>
+          <a:ln/>
+        </p:spPr>
+        <p:txBody>
+          <a:bodyPr wrap="square" lIns="0" tIns="0" rIns="0" bIns="0" rtlCol="0" anchor="t"/>
+          <a:lstStyle/>
+          <a:p>
+            <a:pPr indent="0" marL="0">
+              <a:buNone/>
+            </a:pPr>
+            <a:r>
+              <a:rPr lang="en-US" sz="1600" b="1" dirty="0">
+                <a:solidFill>
+                  <a:srgbClr val="E23636"/>
+                </a:solidFill>
+                <a:latin typeface="Calibri" pitchFamily="34" charset="0"/>
+                <a:ea typeface="Calibri" pitchFamily="34" charset="-122"/>
+                <a:cs typeface="Calibri" pitchFamily="34" charset="-120"/>
+              </a:rPr>
+              <a:t>10 M</a:t>
+            </a:r>
+            <a:pPr indent="0" marL="0">
+              <a:buNone/>
+            </a:pPr>
+            <a:r>
+              <a:rPr lang="en-US" sz="1100" dirty="0">
+                <a:solidFill>
+                  <a:srgbClr val="1F2233"/>
+                </a:solidFill>
+                <a:latin typeface="Calibri" pitchFamily="34" charset="0"/>
+                <a:ea typeface="Calibri" pitchFamily="34" charset="-122"/>
+                <a:cs typeface="Calibri" pitchFamily="34" charset="-120"/>
+              </a:rPr>
+              <a:t> de joueurs en 3 jours, 20 M en moins de 2 semaines, 40 M en 3 mois</a:t>
+            </a:r>
+            <a:endParaRPr lang="en-US" sz="1100" dirty="0"/>
+          </a:p>
+          <a:p>
+            <a:pPr indent="0" marL="0">
+              <a:buNone/>
+            </a:pPr>
+            <a:r>
+              <a:rPr lang="en-US" sz="500" dirty="0">
+                <a:solidFill>
+                  <a:srgbClr val="000000"/>
+                </a:solidFill>
+                <a:latin typeface="Calibri" pitchFamily="34" charset="0"/>
+                <a:ea typeface="Calibri" pitchFamily="34" charset="-122"/>
+                <a:cs typeface="Calibri" pitchFamily="34" charset="-120"/>
+              </a:rPr>
+              <a:t> </a:t>
+            </a:r>
+            <a:endParaRPr lang="en-US" sz="1100" dirty="0"/>
+          </a:p>
+          <a:p>
+            <a:pPr indent="0" marL="0">
+              <a:buNone/>
+            </a:pPr>
+            <a:r>
+              <a:rPr lang="en-US" sz="1600" b="1" dirty="0">
+                <a:solidFill>
+                  <a:srgbClr val="E23636"/>
+                </a:solidFill>
+                <a:latin typeface="Calibri" pitchFamily="34" charset="0"/>
+                <a:ea typeface="Calibri" pitchFamily="34" charset="-122"/>
+                <a:cs typeface="Calibri" pitchFamily="34" charset="-120"/>
+              </a:rPr>
+              <a:t>Gratuit</a:t>
+            </a:r>
+            <a:pPr indent="0" marL="0">
+              <a:buNone/>
+            </a:pPr>
+            <a:r>
+              <a:rPr lang="en-US" sz="1100" dirty="0">
+                <a:solidFill>
+                  <a:srgbClr val="1F2233"/>
+                </a:solidFill>
+                <a:latin typeface="Calibri" pitchFamily="34" charset="0"/>
+                <a:ea typeface="Calibri" pitchFamily="34" charset="-122"/>
+                <a:cs typeface="Calibri" pitchFamily="34" charset="-120"/>
+              </a:rPr>
+              <a:t> et porté par une licence grand public : beaucoup découvrent le hero shooter</a:t>
+            </a:r>
+            <a:endParaRPr lang="en-US" sz="1100" dirty="0"/>
+          </a:p>
+        </p:txBody>
+      </p:sp>
+      <p:sp>
+        <p:nvSpPr>
+          <p:cNvPr id="15" name="Text 11"/>
+          <p:cNvSpPr txBox="1"/>
+          <p:nvPr/>
+        </p:nvSpPr>
+        <p:spPr>
+          <a:xfrm>
+            <a:off x="4846320" y="3127248"/>
+            <a:ext cx="3657600" cy="365760"/>
+          </a:xfrm>
+          <a:prstGeom prst="rect">
+            <a:avLst/>
+          </a:prstGeom>
+          <a:noFill/>
+          <a:ln/>
+        </p:spPr>
+        <p:txBody>
+          <a:bodyPr wrap="square" lIns="0" tIns="0" rIns="0" bIns="0" rtlCol="0" anchor="t"/>
+          <a:lstStyle/>
+          <a:p>
+            <a:pPr indent="0" marL="0">
+              <a:buNone/>
+            </a:pPr>
+            <a:r>
+              <a:rPr lang="en-US" sz="1100" i="1" dirty="0">
+                <a:solidFill>
+                  <a:srgbClr val="5E6378"/>
+                </a:solidFill>
+                <a:latin typeface="Calibri" pitchFamily="34" charset="0"/>
+                <a:ea typeface="Calibri" pitchFamily="34" charset="-122"/>
+                <a:cs typeface="Calibri" pitchFamily="34" charset="-120"/>
+              </a:rPr>
+              <a:t>Ils apprennent le jeu en même temps qu'ils le jouent.</a:t>
+            </a:r>
+            <a:endParaRPr lang="en-US" sz="1100" dirty="0"/>
+          </a:p>
+        </p:txBody>
+      </p:sp>
+      <p:sp>
+        <p:nvSpPr>
+          <p:cNvPr id="16" name="Shape 12"/>
+          <p:cNvSpPr/>
+          <p:nvPr/>
+        </p:nvSpPr>
+        <p:spPr>
+          <a:xfrm>
+            <a:off x="457200" y="3703320"/>
+            <a:ext cx="8229600" cy="960120"/>
+          </a:xfrm>
+          <a:prstGeom prst="roundRect">
+            <a:avLst>
+              <a:gd name="adj" fmla="val 7619"/>
+            </a:avLst>
+          </a:prstGeom>
+          <a:solidFill>
+            <a:srgbClr val="161A33"/>
+          </a:solidFill>
+          <a:ln w="12700">
+            <a:solidFill>
+              <a:srgbClr val="161A33"/>
+            </a:solidFill>
+            <a:prstDash val="solid"/>
+          </a:ln>
+        </p:spPr>
+      </p:sp>
+      <p:sp>
+        <p:nvSpPr>
+          <p:cNvPr id="17" name="Text 13"/>
+          <p:cNvSpPr txBox="1"/>
+          <p:nvPr/>
+        </p:nvSpPr>
+        <p:spPr>
+          <a:xfrm>
+            <a:off x="640080" y="3730752"/>
+            <a:ext cx="7863840" cy="914400"/>
+          </a:xfrm>
+          <a:prstGeom prst="rect">
+            <a:avLst/>
+          </a:prstGeom>
+          <a:noFill/>
+          <a:ln/>
+        </p:spPr>
+        <p:txBody>
+          <a:bodyPr wrap="square" lIns="0" tIns="0" rIns="0" bIns="0" rtlCol="0" anchor="ctr"/>
+          <a:lstStyle/>
+          <a:p>
+            <a:pPr indent="0" marL="0">
+              <a:buNone/>
+            </a:pPr>
+            <a:r>
+              <a:rPr lang="en-US" sz="1150" b="1" dirty="0">
+                <a:solidFill>
+                  <a:srgbClr val="E23636"/>
+                </a:solidFill>
+                <a:latin typeface="Calibri" pitchFamily="34" charset="0"/>
+                <a:ea typeface="Calibri" pitchFamily="34" charset="-122"/>
+                <a:cs typeface="Calibri" pitchFamily="34" charset="-120"/>
+              </a:rPr>
+              <a:t>Sans calibrage, ils se croisent. </a:t>
+            </a:r>
+            <a:pPr indent="0" marL="0">
+              <a:buNone/>
+            </a:pPr>
+            <a:r>
+              <a:rPr lang="en-US" sz="1150" dirty="0">
+                <a:solidFill>
+                  <a:srgbClr val="FFFFFF"/>
+                </a:solidFill>
+                <a:latin typeface="Calibri" pitchFamily="34" charset="0"/>
+                <a:ea typeface="Calibri" pitchFamily="34" charset="-122"/>
+                <a:cs typeface="Calibri" pitchFamily="34" charset="-120"/>
+              </a:rPr>
+              <a:t>Tout le monde démarre en Bronze III en classé jusqu'à la saison 5. Ensuite, la base se durcit : parmi les auteurs d'avis Steam, 5 % avaient plus de 200 h de jeu fin 2024, 42 % à l'été 2025. La presse résume : « plus un jeu pour le fan de Marvel occasionnel » (TheGamer, 09/08/2025).</a:t>
+            </a:r>
+            <a:endParaRPr lang="en-US" sz="1150" dirty="0"/>
+          </a:p>
+        </p:txBody>
+      </p:sp>
+      <p:sp>
+        <p:nvSpPr>
+          <p:cNvPr id="18" name="Text 14"/>
+          <p:cNvSpPr txBox="1"/>
+          <p:nvPr/>
+        </p:nvSpPr>
+        <p:spPr>
+          <a:xfrm>
+            <a:off x="457200" y="4754880"/>
+            <a:ext cx="8229600" cy="256032"/>
+          </a:xfrm>
+          <a:prstGeom prst="rect">
+            <a:avLst/>
+          </a:prstGeom>
+          <a:noFill/>
+          <a:ln/>
+        </p:spPr>
+        <p:txBody>
+          <a:bodyPr wrap="square" lIns="0" tIns="0" rIns="0" bIns="0" rtlCol="0" anchor="ctr"/>
+          <a:lstStyle/>
+          <a:p>
+            <a:pPr indent="0" marL="0">
+              <a:buNone/>
+            </a:pPr>
+            <a:r>
+              <a:rPr lang="en-US" sz="900" dirty="0">
+                <a:solidFill>
+                  <a:srgbClr val="5E6378"/>
+                </a:solidFill>
+                <a:latin typeface="Calibri" pitchFamily="34" charset="0"/>
+                <a:ea typeface="Calibri" pitchFamily="34" charset="-122"/>
+                <a:cs typeface="Calibri" pitchFamily="34" charset="-120"/>
+              </a:rPr>
+              <a:t>Sources : </a:t>
+            </a:r>
+            <a:pPr indent="0" marL="0">
+              <a:buNone/>
+            </a:pPr>
+            <a:r>
+              <a:rPr lang="en-US" sz="900" u="sng" dirty="0">
+                <a:solidFill>
+                  <a:srgbClr val="2F3C7E"/>
+                </a:solidFill>
+                <a:latin typeface="Calibri" pitchFamily="34" charset="0"/>
+                <a:ea typeface="Calibri" pitchFamily="34" charset="-122"/>
+                <a:cs typeface="Calibri" pitchFamily="34" charset="-120"/>
+                <a:hlinkClick r:id="rId3" invalidUrl="" action="" tgtFrame="" tooltip="" history="1" highlightClick="0" endSnd="0">
+                  <a:extLst>
+                    <a:ext uri="{A12FA001-AC4F-418D-AE19-62706E023703}">
+                      <ahyp:hlinkClr xmlns:ahyp="http://schemas.microsoft.com/office/drawing/2018/hyperlinkcolor" val="tx"/>
+                    </a:ext>
+                  </a:extLst>
+                </a:hlinkClick>
+              </a:rPr>
+              <a:t>Newzoo (09/04/2025)</a:t>
+            </a:r>
+            <a:pPr indent="0" marL="0">
+              <a:buNone/>
+            </a:pPr>
+            <a:r>
+              <a:rPr lang="en-US" sz="900" dirty="0">
+                <a:solidFill>
+                  <a:srgbClr val="5E6378"/>
+                </a:solidFill>
+                <a:latin typeface="Calibri" pitchFamily="34" charset="0"/>
+                <a:ea typeface="Calibri" pitchFamily="34" charset="-122"/>
+                <a:cs typeface="Calibri" pitchFamily="34" charset="-120"/>
+              </a:rPr>
+              <a:t> · </a:t>
+            </a:r>
+            <a:pPr indent="0" marL="0">
+              <a:buNone/>
+            </a:pPr>
+            <a:r>
+              <a:rPr lang="en-US" sz="900" u="sng" dirty="0">
+                <a:solidFill>
+                  <a:srgbClr val="2F3C7E"/>
+                </a:solidFill>
+                <a:latin typeface="Calibri" pitchFamily="34" charset="0"/>
+                <a:ea typeface="Calibri" pitchFamily="34" charset="-122"/>
+                <a:cs typeface="Calibri" pitchFamily="34" charset="-120"/>
+                <a:hlinkClick r:id="rId4" invalidUrl="" action="" tgtFrame="" tooltip="" history="1" highlightClick="0" endSnd="0">
+                  <a:extLst>
+                    <a:ext uri="{A12FA001-AC4F-418D-AE19-62706E023703}">
+                      <ahyp:hlinkClr xmlns:ahyp="http://schemas.microsoft.com/office/drawing/2018/hyperlinkcolor" val="tx"/>
+                    </a:ext>
+                  </a:extLst>
+                </a:hlinkClick>
+              </a:rPr>
+              <a:t>VGC</a:t>
+            </a:r>
+            <a:pPr indent="0" marL="0">
+              <a:buNone/>
+            </a:pPr>
+            <a:r>
+              <a:rPr lang="en-US" sz="900" dirty="0">
+                <a:solidFill>
+                  <a:srgbClr val="5E6378"/>
+                </a:solidFill>
+                <a:latin typeface="Calibri" pitchFamily="34" charset="0"/>
+                <a:ea typeface="Calibri" pitchFamily="34" charset="-122"/>
+                <a:cs typeface="Calibri" pitchFamily="34" charset="-120"/>
+              </a:rPr>
+              <a:t> · </a:t>
+            </a:r>
+            <a:pPr indent="0" marL="0">
+              <a:buNone/>
+            </a:pPr>
+            <a:r>
+              <a:rPr lang="en-US" sz="900" u="sng" dirty="0">
+                <a:solidFill>
+                  <a:srgbClr val="2F3C7E"/>
+                </a:solidFill>
+                <a:latin typeface="Calibri" pitchFamily="34" charset="0"/>
+                <a:ea typeface="Calibri" pitchFamily="34" charset="-122"/>
+                <a:cs typeface="Calibri" pitchFamily="34" charset="-120"/>
+                <a:hlinkClick r:id="rId5" invalidUrl="" action="" tgtFrame="" tooltip="" history="1" highlightClick="0" endSnd="0">
+                  <a:extLst>
+                    <a:ext uri="{A12FA001-AC4F-418D-AE19-62706E023703}">
+                      <ahyp:hlinkClr xmlns:ahyp="http://schemas.microsoft.com/office/drawing/2018/hyperlinkcolor" val="tx"/>
+                    </a:ext>
+                  </a:extLst>
+                </a:hlinkClick>
+              </a:rPr>
+              <a:t>GWO</a:t>
+            </a:r>
+            <a:pPr indent="0" marL="0">
+              <a:buNone/>
+            </a:pPr>
+            <a:r>
+              <a:rPr lang="en-US" sz="900" dirty="0">
+                <a:solidFill>
+                  <a:srgbClr val="5E6378"/>
+                </a:solidFill>
+                <a:latin typeface="Calibri" pitchFamily="34" charset="0"/>
+                <a:ea typeface="Calibri" pitchFamily="34" charset="-122"/>
+                <a:cs typeface="Calibri" pitchFamily="34" charset="-120"/>
+              </a:rPr>
+              <a:t> · </a:t>
+            </a:r>
+            <a:pPr indent="0" marL="0">
+              <a:buNone/>
+            </a:pPr>
+            <a:r>
+              <a:rPr lang="en-US" sz="900" u="sng" dirty="0">
+                <a:solidFill>
+                  <a:srgbClr val="2F3C7E"/>
+                </a:solidFill>
+                <a:latin typeface="Calibri" pitchFamily="34" charset="0"/>
+                <a:ea typeface="Calibri" pitchFamily="34" charset="-122"/>
+                <a:cs typeface="Calibri" pitchFamily="34" charset="-120"/>
+                <a:hlinkClick r:id="rId6" invalidUrl="" action="" tgtFrame="" tooltip="" history="1" highlightClick="0" endSnd="0">
+                  <a:extLst>
+                    <a:ext uri="{A12FA001-AC4F-418D-AE19-62706E023703}">
+                      <ahyp:hlinkClr xmlns:ahyp="http://schemas.microsoft.com/office/drawing/2018/hyperlinkcolor" val="tx"/>
+                    </a:ext>
+                  </a:extLst>
+                </a:hlinkClick>
+              </a:rPr>
+              <a:t>PCGamesN</a:t>
+            </a:r>
+            <a:pPr indent="0" marL="0">
+              <a:buNone/>
+            </a:pPr>
+            <a:r>
+              <a:rPr lang="en-US" sz="900" dirty="0">
+                <a:solidFill>
+                  <a:srgbClr val="5E6378"/>
+                </a:solidFill>
+                <a:latin typeface="Calibri" pitchFamily="34" charset="0"/>
+                <a:ea typeface="Calibri" pitchFamily="34" charset="-122"/>
+                <a:cs typeface="Calibri" pitchFamily="34" charset="-120"/>
+              </a:rPr>
+              <a:t> · </a:t>
+            </a:r>
+            <a:pPr indent="0" marL="0">
+              <a:buNone/>
+            </a:pPr>
+            <a:r>
+              <a:rPr lang="en-US" sz="900" u="sng" dirty="0">
+                <a:solidFill>
+                  <a:srgbClr val="2F3C7E"/>
+                </a:solidFill>
+                <a:latin typeface="Calibri" pitchFamily="34" charset="0"/>
+                <a:ea typeface="Calibri" pitchFamily="34" charset="-122"/>
+                <a:cs typeface="Calibri" pitchFamily="34" charset="-120"/>
+                <a:hlinkClick r:id="rId7" invalidUrl="" action="" tgtFrame="" tooltip="" history="1" highlightClick="0" endSnd="0">
+                  <a:extLst>
+                    <a:ext uri="{A12FA001-AC4F-418D-AE19-62706E023703}">
+                      <ahyp:hlinkClr xmlns:ahyp="http://schemas.microsoft.com/office/drawing/2018/hyperlinkcolor" val="tx"/>
+                    </a:ext>
+                  </a:extLst>
+                </a:hlinkClick>
+              </a:rPr>
+              <a:t>avis Steam</a:t>
+            </a:r>
+            <a:pPr indent="0" marL="0">
+              <a:buNone/>
+            </a:pPr>
+            <a:r>
+              <a:rPr lang="en-US" sz="900" dirty="0">
+                <a:solidFill>
+                  <a:srgbClr val="5E6378"/>
+                </a:solidFill>
+                <a:latin typeface="Calibri" pitchFamily="34" charset="0"/>
+                <a:ea typeface="Calibri" pitchFamily="34" charset="-122"/>
+                <a:cs typeface="Calibri" pitchFamily="34" charset="-120"/>
+              </a:rPr>
+              <a:t> · </a:t>
+            </a:r>
+            <a:pPr indent="0" marL="0">
+              <a:buNone/>
+            </a:pPr>
+            <a:r>
+              <a:rPr lang="en-US" sz="900" u="sng" dirty="0">
+                <a:solidFill>
+                  <a:srgbClr val="2F3C7E"/>
+                </a:solidFill>
+                <a:latin typeface="Calibri" pitchFamily="34" charset="0"/>
+                <a:ea typeface="Calibri" pitchFamily="34" charset="-122"/>
+                <a:cs typeface="Calibri" pitchFamily="34" charset="-120"/>
+                <a:hlinkClick r:id="rId8" invalidUrl="" action="" tgtFrame="" tooltip="" history="1" highlightClick="0" endSnd="0">
+                  <a:extLst>
+                    <a:ext uri="{A12FA001-AC4F-418D-AE19-62706E023703}">
+                      <ahyp:hlinkClr xmlns:ahyp="http://schemas.microsoft.com/office/drawing/2018/hyperlinkcolor" val="tx"/>
+                    </a:ext>
+                  </a:extLst>
+                </a:hlinkClick>
+              </a:rPr>
+              <a:t>TheGamer</a:t>
+            </a:r>
+            <a:endParaRPr lang="en-US" sz="900" dirty="0"/>
+          </a:p>
+        </p:txBody>
+      </p:sp>
+      <p:sp>
+        <p:nvSpPr>
+          <p:cNvPr id="19" name="Text 15"/>
+          <p:cNvSpPr txBox="1"/>
+          <p:nvPr/>
+        </p:nvSpPr>
+        <p:spPr>
+          <a:xfrm>
+            <a:off x="8412480" y="4754880"/>
+            <a:ext cx="274320" cy="256032"/>
+          </a:xfrm>
+          <a:prstGeom prst="rect">
+            <a:avLst/>
+          </a:prstGeom>
+          <a:noFill/>
+          <a:ln/>
+        </p:spPr>
+        <p:txBody>
+          <a:bodyPr wrap="square" lIns="0" tIns="0" rIns="0" bIns="0" rtlCol="0" anchor="ctr"/>
+          <a:lstStyle/>
+          <a:p>
+            <a:pPr algn="r" indent="0" marL="0">
+              <a:buNone/>
+            </a:pPr>
+            <a:r>
+              <a:rPr lang="en-US" sz="900" dirty="0">
+                <a:solidFill>
+                  <a:srgbClr val="5E6378"/>
+                </a:solidFill>
+                <a:latin typeface="Calibri" pitchFamily="34" charset="0"/>
+                <a:ea typeface="Calibri" pitchFamily="34" charset="-122"/>
+                <a:cs typeface="Calibri" pitchFamily="34" charset="-120"/>
+              </a:rPr>
+              <a:t>3</a:t>
+            </a:r>
+            <a:endParaRPr lang="en-US" sz="900" dirty="0"/>
+          </a:p>
+        </p:txBody>
+      </p:sp>
+    </p:spTree>
+  </p:cSld>
+  <p:clrMapOvr>
+    <a:masterClrMapping/>
+  </p:clrMapOvr>
+</p:sld>
+</file>
+
+<file path=ppt/slides/slide4.xml><?xml version="1.0" encoding="utf-8"?>
+<p:sld xmlns:a="http://schemas.openxmlformats.org/drawingml/2006/main" xmlns:r="http://schemas.openxmlformats.org/officeDocument/2006/relationships" xmlns:p="http://schemas.openxmlformats.org/presentationml/2006/main">
+  <p:cSld name="Slide 4">
+    <p:bg>
+      <p:bgPr>
+        <a:solidFill>
+          <a:srgbClr val="F4F5F9"/>
+        </a:solidFill>
+      </p:bgPr>
+    </p:bg>
+    <p:spTree>
+      <p:nvGrpSpPr>
+        <p:cNvPr id="1" name=""/>
+        <p:cNvGrpSpPr/>
+        <p:nvPr/>
+      </p:nvGrpSpPr>
+      <p:grpSpPr>
+        <a:xfrm>
+          <a:off x="0" y="0"/>
+          <a:ext cx="0" cy="0"/>
+          <a:chOff x="0" y="0"/>
+          <a:chExt cx="0" cy="0"/>
+        </a:xfrm>
+      </p:grpSpPr>
+      <p:sp>
+        <p:nvSpPr>
+          <p:cNvPr id="2" name="Text 0"/>
+          <p:cNvSpPr txBox="1"/>
+          <p:nvPr/>
+        </p:nvSpPr>
+        <p:spPr>
+          <a:xfrm>
+            <a:off x="457200" y="274320"/>
+            <a:ext cx="8229600" cy="548640"/>
+          </a:xfrm>
+          <a:prstGeom prst="rect">
+            <a:avLst/>
+          </a:prstGeom>
+          <a:noFill/>
+          <a:ln/>
+        </p:spPr>
+        <p:txBody>
+          <a:bodyPr wrap="square" lIns="0" tIns="0" rIns="0" bIns="0" rtlCol="0" anchor="ctr"/>
+          <a:lstStyle/>
+          <a:p>
+            <a:pPr indent="0" marL="0">
+              <a:buNone/>
+            </a:pPr>
+            <a:r>
+              <a:rPr lang="en-US" sz="2800" b="1" dirty="0">
+                <a:solidFill>
+                  <a:srgbClr val="1F2233"/>
+                </a:solidFill>
+                <a:latin typeface="Arial" pitchFamily="34" charset="0"/>
+                <a:ea typeface="Arial" pitchFamily="34" charset="-122"/>
+                <a:cs typeface="Arial" pitchFamily="34" charset="-120"/>
+              </a:rPr>
               <a:t>H5 : les nouveaux perdent trop tôt et partent</a:t>
             </a:r>
             <a:endParaRPr lang="en-US" sz="2800" dirty="0"/>
@@ -3245,7 +4899,7 @@
                 <a:ea typeface="Calibri" pitchFamily="34" charset="-122"/>
                 <a:cs typeface="Calibri" pitchFamily="34" charset="-120"/>
               </a:rPr>
-              <a:t>Des joueurs de tous niveaux arrivent en même temps, sans calibrage (Bronze III pour tous en classé jusqu'à la S5). Les moins expérimentés perdent lourdement et partent.</a:t>
+              <a:t>Vétérans et nouveaux venus se rencontrent sans calibrage. Les moins expérimentés perdent lourdement et partent.</a:t>
             </a:r>
             <a:endParaRPr lang="en-US" sz="1100" dirty="0"/>
           </a:p>
@@ -3686,42 +5340,7 @@
                   </a:extLst>
                 </a:hlinkClick>
               </a:rPr>
-              <a:t>PCGamesN (Bronze III)</a:t>
-            </a:r>
-            <a:pPr indent="0" marL="0">
-              <a:buNone/>
-            </a:pPr>
-            <a:r>
-              <a:rPr lang="en-US" sz="900" dirty="0">
-                <a:solidFill>
-                  <a:srgbClr val="5E6378"/>
-                </a:solidFill>
-                <a:latin typeface="Calibri" pitchFamily="34" charset="0"/>
-                <a:ea typeface="Calibri" pitchFamily="34" charset="-122"/>
-                <a:cs typeface="Calibri" pitchFamily="34" charset="-120"/>
-              </a:rPr>
-              <a:t> · </a:t>
-            </a:r>
-            <a:pPr indent="0" marL="0">
-              <a:buNone/>
-            </a:pPr>
-            <a:r>
-              <a:rPr lang="en-US" sz="900" u="sng" dirty="0">
-                <a:solidFill>
-                  <a:srgbClr val="2F3C7E"/>
-                </a:solidFill>
-                <a:latin typeface="Calibri" pitchFamily="34" charset="0"/>
-                <a:ea typeface="Calibri" pitchFamily="34" charset="-122"/>
-                <a:cs typeface="Calibri" pitchFamily="34" charset="-120"/>
-                <a:hlinkClick r:id="rId5" invalidUrl="" action="" tgtFrame="" tooltip="" history="1" highlightClick="0" endSnd="0">
-                  <a:extLst>
-                    <a:ext uri="{A12FA001-AC4F-418D-AE19-62706E023703}">
-                      <ahyp:hlinkClr xmlns:ahyp="http://schemas.microsoft.com/office/drawing/2018/hyperlinkcolor" val="tx"/>
-                    </a:ext>
-                  </a:extLst>
-                </a:hlinkClick>
-              </a:rPr>
-              <a:t>vidéo NetEase du 21/08/2025 (fourchette)</a:t>
+              <a:t>vidéo NetEase du 21/08/2025 (fourchette élargie)</a:t>
             </a:r>
             <a:endParaRPr lang="en-US" sz="900" dirty="0"/>
           </a:p>
@@ -3760,7 +5379,7 @@
                 <a:ea typeface="Calibri" pitchFamily="34" charset="-122"/>
                 <a:cs typeface="Calibri" pitchFamily="34" charset="-120"/>
               </a:rPr>
-              <a:t>3</a:t>
+              <a:t>4</a:t>
             </a:r>
             <a:endParaRPr lang="en-US" sz="900" dirty="0"/>
           </a:p>
@@ -3774,9 +5393,9 @@
 </p:sld>
 </file>
 
-<file path=ppt/slides/slide4.xml><?xml version="1.0" encoding="utf-8"?>
+<file path=ppt/slides/slide5.xml><?xml version="1.0" encoding="utf-8"?>
 <p:sld xmlns:a="http://schemas.openxmlformats.org/drawingml/2006/main" xmlns:r="http://schemas.openxmlformats.org/officeDocument/2006/relationships" xmlns:p="http://schemas.openxmlformats.org/presentationml/2006/main">
-  <p:cSld name="Slide 4">
+  <p:cSld name="Slide 5">
     <p:bg>
       <p:bgPr>
         <a:solidFill>
@@ -4289,7 +5908,7 @@
                 <a:ea typeface="Calibri" pitchFamily="34" charset="-122"/>
                 <a:cs typeface="Calibri" pitchFamily="34" charset="-120"/>
               </a:rPr>
-              <a:t>4</a:t>
+              <a:t>5</a:t>
             </a:r>
             <a:endParaRPr lang="en-US" sz="900" dirty="0"/>
           </a:p>
@@ -4303,9 +5922,9 @@
 </p:sld>
 </file>
 
-<file path=ppt/slides/slide5.xml><?xml version="1.0" encoding="utf-8"?>
+<file path=ppt/slides/slide6.xml><?xml version="1.0" encoding="utf-8"?>
 <p:sld xmlns:a="http://schemas.openxmlformats.org/drawingml/2006/main" xmlns:r="http://schemas.openxmlformats.org/officeDocument/2006/relationships" xmlns:p="http://schemas.openxmlformats.org/presentationml/2006/main">
-  <p:cSld name="Slide 5">
+  <p:cSld name="Slide 6">
     <p:bg>
       <p:bgPr>
         <a:solidFill>
@@ -4487,7 +6106,7 @@
       </p:sp>
       <p:graphicFrame>
         <p:nvGraphicFramePr>
-          <p:cNvPr id="6" name="Table 0"/>
+          <p:cNvPr id="7" name="Table 0"/>
           <p:cNvGraphicFramePr>
             <a:graphicFrameLocks noGrp="1"/>
           </p:cNvGraphicFramePr>
@@ -5884,7 +7503,7 @@
                 <a:ea typeface="Calibri" pitchFamily="34" charset="-122"/>
                 <a:cs typeface="Calibri" pitchFamily="34" charset="-120"/>
               </a:rPr>
-              <a:t>5</a:t>
+              <a:t>6</a:t>
             </a:r>
             <a:endParaRPr lang="en-US" sz="900" dirty="0"/>
           </a:p>
@@ -5898,9 +7517,9 @@
 </p:sld>
 </file>
 
-<file path=ppt/slides/slide6.xml><?xml version="1.0" encoding="utf-8"?>
+<file path=ppt/slides/slide7.xml><?xml version="1.0" encoding="utf-8"?>
 <p:sld xmlns:a="http://schemas.openxmlformats.org/drawingml/2006/main" xmlns:r="http://schemas.openxmlformats.org/officeDocument/2006/relationships" xmlns:p="http://schemas.openxmlformats.org/presentationml/2006/main">
-  <p:cSld name="Slide 6">
+  <p:cSld name="Slide 7">
     <p:bg>
       <p:bgPr>
         <a:solidFill>
@@ -6763,7 +8382,7 @@
                 <a:ea typeface="Calibri" pitchFamily="34" charset="-122"/>
                 <a:cs typeface="Calibri" pitchFamily="34" charset="-120"/>
               </a:rPr>
-              <a:t>6</a:t>
+              <a:t>7</a:t>
             </a:r>
             <a:endParaRPr lang="en-US" sz="900" dirty="0"/>
           </a:p>
@@ -6777,9 +8396,9 @@
 </p:sld>
 </file>
 
-<file path=ppt/slides/slide7.xml><?xml version="1.0" encoding="utf-8"?>
+<file path=ppt/slides/slide8.xml><?xml version="1.0" encoding="utf-8"?>
 <p:sld xmlns:a="http://schemas.openxmlformats.org/drawingml/2006/main" xmlns:r="http://schemas.openxmlformats.org/officeDocument/2006/relationships" xmlns:p="http://schemas.openxmlformats.org/presentationml/2006/main">
-  <p:cSld name="Slide 7">
+  <p:cSld name="Slide 8">
     <p:bg>
       <p:bgPr>
         <a:solidFill>
@@ -7665,871 +9284,6 @@
       <p:sp>
         <p:nvSpPr>
           <p:cNvPr id="25" name="Text 23"/>
-          <p:cNvSpPr txBox="1"/>
-          <p:nvPr/>
-        </p:nvSpPr>
-        <p:spPr>
-          <a:xfrm>
-            <a:off x="8412480" y="4754880"/>
-            <a:ext cx="274320" cy="256032"/>
-          </a:xfrm>
-          <a:prstGeom prst="rect">
-            <a:avLst/>
-          </a:prstGeom>
-          <a:noFill/>
-          <a:ln/>
-        </p:spPr>
-        <p:txBody>
-          <a:bodyPr wrap="square" lIns="0" tIns="0" rIns="0" bIns="0" rtlCol="0" anchor="ctr"/>
-          <a:lstStyle/>
-          <a:p>
-            <a:pPr algn="r" indent="0" marL="0">
-              <a:buNone/>
-            </a:pPr>
-            <a:r>
-              <a:rPr lang="en-US" sz="900" dirty="0">
-                <a:solidFill>
-                  <a:srgbClr val="5E6378"/>
-                </a:solidFill>
-                <a:latin typeface="Calibri" pitchFamily="34" charset="0"/>
-                <a:ea typeface="Calibri" pitchFamily="34" charset="-122"/>
-                <a:cs typeface="Calibri" pitchFamily="34" charset="-120"/>
-              </a:rPr>
-              <a:t>7</a:t>
-            </a:r>
-            <a:endParaRPr lang="en-US" sz="900" dirty="0"/>
-          </a:p>
-        </p:txBody>
-      </p:sp>
-    </p:spTree>
-  </p:cSld>
-  <p:clrMapOvr>
-    <a:masterClrMapping/>
-  </p:clrMapOvr>
-</p:sld>
-</file>
-
-<file path=ppt/slides/slide8.xml><?xml version="1.0" encoding="utf-8"?>
-<p:sld xmlns:a="http://schemas.openxmlformats.org/drawingml/2006/main" xmlns:r="http://schemas.openxmlformats.org/officeDocument/2006/relationships" xmlns:p="http://schemas.openxmlformats.org/presentationml/2006/main">
-  <p:cSld name="Slide 8">
-    <p:bg>
-      <p:bgPr>
-        <a:solidFill>
-          <a:srgbClr val="FFFFFF"/>
-        </a:solidFill>
-      </p:bgPr>
-    </p:bg>
-    <p:spTree>
-      <p:nvGrpSpPr>
-        <p:cNvPr id="1" name=""/>
-        <p:cNvGrpSpPr/>
-        <p:nvPr/>
-      </p:nvGrpSpPr>
-      <p:grpSpPr>
-        <a:xfrm>
-          <a:off x="0" y="0"/>
-          <a:ext cx="0" cy="0"/>
-          <a:chOff x="0" y="0"/>
-          <a:chExt cx="0" cy="0"/>
-        </a:xfrm>
-      </p:grpSpPr>
-      <p:sp>
-        <p:nvSpPr>
-          <p:cNvPr id="2" name="Text 0"/>
-          <p:cNvSpPr txBox="1"/>
-          <p:nvPr/>
-        </p:nvSpPr>
-        <p:spPr>
-          <a:xfrm>
-            <a:off x="457200" y="274320"/>
-            <a:ext cx="8229600" cy="548640"/>
-          </a:xfrm>
-          <a:prstGeom prst="rect">
-            <a:avLst/>
-          </a:prstGeom>
-          <a:noFill/>
-          <a:ln/>
-        </p:spPr>
-        <p:txBody>
-          <a:bodyPr wrap="square" lIns="0" tIns="0" rIns="0" bIns="0" rtlCol="0" anchor="ctr"/>
-          <a:lstStyle/>
-          <a:p>
-            <a:pPr indent="0" marL="0">
-              <a:buNone/>
-            </a:pPr>
-            <a:r>
-              <a:rPr lang="en-US" sz="2800" b="1" dirty="0">
-                <a:solidFill>
-                  <a:srgbClr val="1F2233"/>
-                </a:solidFill>
-                <a:latin typeface="Arial" pitchFamily="34" charset="0"/>
-                <a:ea typeface="Arial" pitchFamily="34" charset="-122"/>
-                <a:cs typeface="Arial" pitchFamily="34" charset="-120"/>
-              </a:rPr>
-              <a:t>Des seuils qui déclenchent une décision</a:t>
-            </a:r>
-            <a:endParaRPr lang="en-US" sz="2800" dirty="0"/>
-          </a:p>
-        </p:txBody>
-      </p:sp>
-      <p:sp>
-        <p:nvSpPr>
-          <p:cNvPr id="3" name="Text 1"/>
-          <p:cNvSpPr txBox="1"/>
-          <p:nvPr/>
-        </p:nvSpPr>
-        <p:spPr>
-          <a:xfrm>
-            <a:off x="457200" y="804672"/>
-            <a:ext cx="8229600" cy="320040"/>
-          </a:xfrm>
-          <a:prstGeom prst="rect">
-            <a:avLst/>
-          </a:prstGeom>
-          <a:noFill/>
-          <a:ln/>
-        </p:spPr>
-        <p:txBody>
-          <a:bodyPr wrap="square" lIns="0" tIns="0" rIns="0" bIns="0" rtlCol="0" anchor="ctr"/>
-          <a:lstStyle/>
-          <a:p>
-            <a:pPr indent="0" marL="0">
-              <a:buNone/>
-            </a:pPr>
-            <a:r>
-              <a:rPr lang="en-US" sz="1300" dirty="0">
-                <a:solidFill>
-                  <a:srgbClr val="5E6378"/>
-                </a:solidFill>
-                <a:latin typeface="Calibri" pitchFamily="34" charset="0"/>
-                <a:ea typeface="Calibri" pitchFamily="34" charset="-122"/>
-                <a:cs typeface="Calibri" pitchFamily="34" charset="-120"/>
-              </a:rPr>
-              <a:t>KPIs et risques</a:t>
-            </a:r>
-            <a:endParaRPr lang="en-US" sz="1300" dirty="0"/>
-          </a:p>
-        </p:txBody>
-      </p:sp>
-      <p:sp>
-        <p:nvSpPr>
-          <p:cNvPr id="4" name="Shape 2"/>
-          <p:cNvSpPr/>
-          <p:nvPr/>
-        </p:nvSpPr>
-        <p:spPr>
-          <a:xfrm>
-            <a:off x="457200" y="1280160"/>
-            <a:ext cx="2606040" cy="1325880"/>
-          </a:xfrm>
-          <a:prstGeom prst="roundRect">
-            <a:avLst>
-              <a:gd name="adj" fmla="val 5517"/>
-            </a:avLst>
-          </a:prstGeom>
-          <a:solidFill>
-            <a:srgbClr val="161A33"/>
-          </a:solidFill>
-          <a:ln w="12700">
-            <a:solidFill>
-              <a:srgbClr val="161A33"/>
-            </a:solidFill>
-            <a:prstDash val="solid"/>
-          </a:ln>
-        </p:spPr>
-      </p:sp>
-      <p:sp>
-        <p:nvSpPr>
-          <p:cNvPr id="5" name="Text 3"/>
-          <p:cNvSpPr txBox="1"/>
-          <p:nvPr/>
-        </p:nvSpPr>
-        <p:spPr>
-          <a:xfrm>
-            <a:off x="640080" y="1371600"/>
-            <a:ext cx="2240280" cy="548640"/>
-          </a:xfrm>
-          <a:prstGeom prst="rect">
-            <a:avLst/>
-          </a:prstGeom>
-          <a:noFill/>
-          <a:ln/>
-        </p:spPr>
-        <p:txBody>
-          <a:bodyPr wrap="square" lIns="0" tIns="0" rIns="0" bIns="0" rtlCol="0" anchor="ctr"/>
-          <a:lstStyle/>
-          <a:p>
-            <a:pPr indent="0" marL="0">
-              <a:buNone/>
-            </a:pPr>
-            <a:r>
-              <a:rPr lang="en-US" sz="2800" b="1" dirty="0">
-                <a:solidFill>
-                  <a:srgbClr val="E23636"/>
-                </a:solidFill>
-                <a:latin typeface="Arial" pitchFamily="34" charset="0"/>
-                <a:ea typeface="Arial" pitchFamily="34" charset="-122"/>
-                <a:cs typeface="Arial" pitchFamily="34" charset="-120"/>
-              </a:rPr>
-              <a:t>&gt; 1,2</a:t>
-            </a:r>
-            <a:endParaRPr lang="en-US" sz="2800" dirty="0"/>
-          </a:p>
-        </p:txBody>
-      </p:sp>
-      <p:sp>
-        <p:nvSpPr>
-          <p:cNvPr id="6" name="Text 4"/>
-          <p:cNvSpPr txBox="1"/>
-          <p:nvPr/>
-        </p:nvSpPr>
-        <p:spPr>
-          <a:xfrm>
-            <a:off x="640080" y="1920240"/>
-            <a:ext cx="2240280" cy="640080"/>
-          </a:xfrm>
-          <a:prstGeom prst="rect">
-            <a:avLst/>
-          </a:prstGeom>
-          <a:noFill/>
-          <a:ln/>
-        </p:spPr>
-        <p:txBody>
-          <a:bodyPr wrap="square" lIns="0" tIns="0" rIns="0" bIns="0" rtlCol="0" anchor="t"/>
-          <a:lstStyle/>
-          <a:p>
-            <a:pPr indent="0" marL="0">
-              <a:buNone/>
-            </a:pPr>
-            <a:r>
-              <a:rPr lang="en-US" sz="1100" dirty="0">
-                <a:solidFill>
-                  <a:srgbClr val="FFFFFF"/>
-                </a:solidFill>
-                <a:latin typeface="Calibri" pitchFamily="34" charset="0"/>
-                <a:ea typeface="Calibri" pitchFamily="34" charset="-122"/>
-                <a:cs typeface="Calibri" pitchFamily="34" charset="-120"/>
-              </a:rPr>
-              <a:t>ratio de churn J7 à l'audit : on lance les tests</a:t>
-            </a:r>
-            <a:endParaRPr lang="en-US" sz="1100" dirty="0"/>
-          </a:p>
-        </p:txBody>
-      </p:sp>
-      <p:sp>
-        <p:nvSpPr>
-          <p:cNvPr id="7" name="Shape 5"/>
-          <p:cNvSpPr/>
-          <p:nvPr/>
-        </p:nvSpPr>
-        <p:spPr>
-          <a:xfrm>
-            <a:off x="3246120" y="1280160"/>
-            <a:ext cx="2606040" cy="1325880"/>
-          </a:xfrm>
-          <a:prstGeom prst="roundRect">
-            <a:avLst>
-              <a:gd name="adj" fmla="val 5517"/>
-            </a:avLst>
-          </a:prstGeom>
-          <a:solidFill>
-            <a:srgbClr val="161A33"/>
-          </a:solidFill>
-          <a:ln w="12700">
-            <a:solidFill>
-              <a:srgbClr val="161A33"/>
-            </a:solidFill>
-            <a:prstDash val="solid"/>
-          </a:ln>
-        </p:spPr>
-      </p:sp>
-      <p:sp>
-        <p:nvSpPr>
-          <p:cNvPr id="8" name="Text 6"/>
-          <p:cNvSpPr txBox="1"/>
-          <p:nvPr/>
-        </p:nvSpPr>
-        <p:spPr>
-          <a:xfrm>
-            <a:off x="3429000" y="1371600"/>
-            <a:ext cx="2240280" cy="548640"/>
-          </a:xfrm>
-          <a:prstGeom prst="rect">
-            <a:avLst/>
-          </a:prstGeom>
-          <a:noFill/>
-          <a:ln/>
-        </p:spPr>
-        <p:txBody>
-          <a:bodyPr wrap="square" lIns="0" tIns="0" rIns="0" bIns="0" rtlCol="0" anchor="ctr"/>
-          <a:lstStyle/>
-          <a:p>
-            <a:pPr indent="0" marL="0">
-              <a:buNone/>
-            </a:pPr>
-            <a:r>
-              <a:rPr lang="en-US" sz="2800" b="1" dirty="0">
-                <a:solidFill>
-                  <a:srgbClr val="E23636"/>
-                </a:solidFill>
-                <a:latin typeface="Arial" pitchFamily="34" charset="0"/>
-                <a:ea typeface="Arial" pitchFamily="34" charset="-122"/>
-                <a:cs typeface="Arial" pitchFamily="34" charset="-120"/>
-              </a:rPr>
-              <a:t>&gt; 5 min</a:t>
-            </a:r>
-            <a:endParaRPr lang="en-US" sz="2800" dirty="0"/>
-          </a:p>
-        </p:txBody>
-      </p:sp>
-      <p:sp>
-        <p:nvSpPr>
-          <p:cNvPr id="9" name="Text 7"/>
-          <p:cNvSpPr txBox="1"/>
-          <p:nvPr/>
-        </p:nvSpPr>
-        <p:spPr>
-          <a:xfrm>
-            <a:off x="3429000" y="1920240"/>
-            <a:ext cx="2240280" cy="640080"/>
-          </a:xfrm>
-          <a:prstGeom prst="rect">
-            <a:avLst/>
-          </a:prstGeom>
-          <a:noFill/>
-          <a:ln/>
-        </p:spPr>
-        <p:txBody>
-          <a:bodyPr wrap="square" lIns="0" tIns="0" rIns="0" bIns="0" rtlCol="0" anchor="t"/>
-          <a:lstStyle/>
-          <a:p>
-            <a:pPr indent="0" marL="0">
-              <a:buNone/>
-            </a:pPr>
-            <a:r>
-              <a:rPr lang="en-US" sz="1100" dirty="0">
-                <a:solidFill>
-                  <a:srgbClr val="FFFFFF"/>
-                </a:solidFill>
-                <a:latin typeface="Calibri" pitchFamily="34" charset="0"/>
-                <a:ea typeface="Calibri" pitchFamily="34" charset="-122"/>
-                <a:cs typeface="Calibri" pitchFamily="34" charset="-120"/>
-              </a:rPr>
-              <a:t>attente p90 : on arrête le resserrement</a:t>
-            </a:r>
-            <a:endParaRPr lang="en-US" sz="1100" dirty="0"/>
-          </a:p>
-        </p:txBody>
-      </p:sp>
-      <p:sp>
-        <p:nvSpPr>
-          <p:cNvPr id="10" name="Shape 8"/>
-          <p:cNvSpPr/>
-          <p:nvPr/>
-        </p:nvSpPr>
-        <p:spPr>
-          <a:xfrm>
-            <a:off x="6035040" y="1280160"/>
-            <a:ext cx="2606040" cy="1325880"/>
-          </a:xfrm>
-          <a:prstGeom prst="roundRect">
-            <a:avLst>
-              <a:gd name="adj" fmla="val 5517"/>
-            </a:avLst>
-          </a:prstGeom>
-          <a:solidFill>
-            <a:srgbClr val="161A33"/>
-          </a:solidFill>
-          <a:ln w="12700">
-            <a:solidFill>
-              <a:srgbClr val="161A33"/>
-            </a:solidFill>
-            <a:prstDash val="solid"/>
-          </a:ln>
-        </p:spPr>
-      </p:sp>
-      <p:sp>
-        <p:nvSpPr>
-          <p:cNvPr id="11" name="Text 9"/>
-          <p:cNvSpPr txBox="1"/>
-          <p:nvPr/>
-        </p:nvSpPr>
-        <p:spPr>
-          <a:xfrm>
-            <a:off x="6217920" y="1371600"/>
-            <a:ext cx="2240280" cy="548640"/>
-          </a:xfrm>
-          <a:prstGeom prst="rect">
-            <a:avLst/>
-          </a:prstGeom>
-          <a:noFill/>
-          <a:ln/>
-        </p:spPr>
-        <p:txBody>
-          <a:bodyPr wrap="square" lIns="0" tIns="0" rIns="0" bIns="0" rtlCol="0" anchor="ctr"/>
-          <a:lstStyle/>
-          <a:p>
-            <a:pPr indent="0" marL="0">
-              <a:buNone/>
-            </a:pPr>
-            <a:r>
-              <a:rPr lang="en-US" sz="2800" b="1" dirty="0">
-                <a:solidFill>
-                  <a:srgbClr val="E23636"/>
-                </a:solidFill>
-                <a:latin typeface="Arial" pitchFamily="34" charset="0"/>
-                <a:ea typeface="Arial" pitchFamily="34" charset="-122"/>
-                <a:cs typeface="Arial" pitchFamily="34" charset="-120"/>
-              </a:rPr>
-              <a:t>&gt; 50 %</a:t>
-            </a:r>
-            <a:endParaRPr lang="en-US" sz="2800" dirty="0"/>
-          </a:p>
-        </p:txBody>
-      </p:sp>
-      <p:sp>
-        <p:nvSpPr>
-          <p:cNvPr id="12" name="Text 10"/>
-          <p:cNvSpPr txBox="1"/>
-          <p:nvPr/>
-        </p:nvSpPr>
-        <p:spPr>
-          <a:xfrm>
-            <a:off x="6217920" y="1920240"/>
-            <a:ext cx="2240280" cy="640080"/>
-          </a:xfrm>
-          <a:prstGeom prst="rect">
-            <a:avLst/>
-          </a:prstGeom>
-          <a:noFill/>
-          <a:ln/>
-        </p:spPr>
-        <p:txBody>
-          <a:bodyPr wrap="square" lIns="0" tIns="0" rIns="0" bIns="0" rtlCol="0" anchor="t"/>
-          <a:lstStyle/>
-          <a:p>
-            <a:pPr indent="0" marL="0">
-              <a:buNone/>
-            </a:pPr>
-            <a:r>
-              <a:rPr lang="en-US" sz="1100" dirty="0">
-                <a:solidFill>
-                  <a:srgbClr val="FFFFFF"/>
-                </a:solidFill>
-                <a:latin typeface="Calibri" pitchFamily="34" charset="0"/>
-                <a:ea typeface="Calibri" pitchFamily="34" charset="-122"/>
-                <a:cs typeface="Calibri" pitchFamily="34" charset="-120"/>
-              </a:rPr>
-              <a:t>des 10 premiers matchs en partie rapide : on la corrige en premier</a:t>
-            </a:r>
-            <a:endParaRPr lang="en-US" sz="1100" dirty="0"/>
-          </a:p>
-        </p:txBody>
-      </p:sp>
-      <p:sp>
-        <p:nvSpPr>
-          <p:cNvPr id="13" name="Shape 11"/>
-          <p:cNvSpPr/>
-          <p:nvPr/>
-        </p:nvSpPr>
-        <p:spPr>
-          <a:xfrm>
-            <a:off x="457200" y="2834640"/>
-            <a:ext cx="411480" cy="411480"/>
-          </a:xfrm>
-          <a:prstGeom prst="ellipse">
-            <a:avLst/>
-          </a:prstGeom>
-          <a:solidFill>
-            <a:srgbClr val="E23636"/>
-          </a:solidFill>
-          <a:ln w="12700">
-            <a:solidFill>
-              <a:srgbClr val="E23636"/>
-            </a:solidFill>
-            <a:prstDash val="solid"/>
-          </a:ln>
-        </p:spPr>
-      </p:sp>
-      <p:pic>
-        <p:nvPicPr>
-          <p:cNvPr id="14" name="Image 0" descr="preencoded.png">    </p:cNvPr>
-          <p:cNvPicPr>
-            <a:picLocks noChangeAspect="1"/>
-          </p:cNvPicPr>
-          <p:nvPr/>
-        </p:nvPicPr>
-        <p:blipFill>
-          <a:blip r:embed="rId1"/>
-          <a:stretch>
-            <a:fillRect/>
-          </a:stretch>
-        </p:blipFill>
-        <p:spPr>
-          <a:xfrm>
-            <a:off x="560070" y="2937510"/>
-            <a:ext cx="205740" cy="205740"/>
-          </a:xfrm>
-          <a:prstGeom prst="rect">
-            <a:avLst/>
-          </a:prstGeom>
-        </p:spPr>
-      </p:pic>
-      <p:sp>
-        <p:nvSpPr>
-          <p:cNvPr id="15" name="Text 12"/>
-          <p:cNvSpPr txBox="1"/>
-          <p:nvPr/>
-        </p:nvSpPr>
-        <p:spPr>
-          <a:xfrm>
-            <a:off x="1005840" y="2788920"/>
-            <a:ext cx="7680960" cy="548640"/>
-          </a:xfrm>
-          <a:prstGeom prst="rect">
-            <a:avLst/>
-          </a:prstGeom>
-          <a:noFill/>
-          <a:ln/>
-        </p:spPr>
-        <p:txBody>
-          <a:bodyPr wrap="square" lIns="0" tIns="0" rIns="0" bIns="0" rtlCol="0" anchor="ctr"/>
-          <a:lstStyle/>
-          <a:p>
-            <a:pPr indent="0" marL="0">
-              <a:buNone/>
-            </a:pPr>
-            <a:r>
-              <a:rPr lang="en-US" sz="1100" b="1" dirty="0">
-                <a:solidFill>
-                  <a:srgbClr val="1F2233"/>
-                </a:solidFill>
-                <a:latin typeface="Calibri" pitchFamily="34" charset="0"/>
-                <a:ea typeface="Calibri" pitchFamily="34" charset="-122"/>
-                <a:cs typeface="Calibri" pitchFamily="34" charset="-120"/>
-              </a:rPr>
-              <a:t>Données personnelles (RGPD) : </a:t>
-            </a:r>
-            <a:pPr indent="0" marL="0">
-              <a:buNone/>
-            </a:pPr>
-            <a:r>
-              <a:rPr lang="en-US" sz="1100" dirty="0">
-                <a:solidFill>
-                  <a:srgbClr val="1F2233"/>
-                </a:solidFill>
-                <a:latin typeface="Calibri" pitchFamily="34" charset="0"/>
-                <a:ea typeface="Calibri" pitchFamily="34" charset="-122"/>
-                <a:cs typeface="Calibri" pitchFamily="34" charset="-120"/>
-              </a:rPr>
-              <a:t>Accord de sous-traitance, identifiants hachés par NetEase, analyse dans votre environnement, mineurs exclus.</a:t>
-            </a:r>
-            <a:endParaRPr lang="en-US" sz="1100" dirty="0"/>
-          </a:p>
-        </p:txBody>
-      </p:sp>
-      <p:sp>
-        <p:nvSpPr>
-          <p:cNvPr id="16" name="Shape 13"/>
-          <p:cNvSpPr/>
-          <p:nvPr/>
-        </p:nvSpPr>
-        <p:spPr>
-          <a:xfrm>
-            <a:off x="457200" y="3456432"/>
-            <a:ext cx="411480" cy="411480"/>
-          </a:xfrm>
-          <a:prstGeom prst="ellipse">
-            <a:avLst/>
-          </a:prstGeom>
-          <a:solidFill>
-            <a:srgbClr val="E23636"/>
-          </a:solidFill>
-          <a:ln w="12700">
-            <a:solidFill>
-              <a:srgbClr val="E23636"/>
-            </a:solidFill>
-            <a:prstDash val="solid"/>
-          </a:ln>
-        </p:spPr>
-      </p:sp>
-      <p:pic>
-        <p:nvPicPr>
-          <p:cNvPr id="17" name="Image 1" descr="preencoded.png">    </p:cNvPr>
-          <p:cNvPicPr>
-            <a:picLocks noChangeAspect="1"/>
-          </p:cNvPicPr>
-          <p:nvPr/>
-        </p:nvPicPr>
-        <p:blipFill>
-          <a:blip r:embed="rId2"/>
-          <a:stretch>
-            <a:fillRect/>
-          </a:stretch>
-        </p:blipFill>
-        <p:spPr>
-          <a:xfrm>
-            <a:off x="560070" y="3559302"/>
-            <a:ext cx="205740" cy="205740"/>
-          </a:xfrm>
-          <a:prstGeom prst="rect">
-            <a:avLst/>
-          </a:prstGeom>
-        </p:spPr>
-      </p:pic>
-      <p:sp>
-        <p:nvSpPr>
-          <p:cNvPr id="18" name="Text 14"/>
-          <p:cNvSpPr txBox="1"/>
-          <p:nvPr/>
-        </p:nvSpPr>
-        <p:spPr>
-          <a:xfrm>
-            <a:off x="1005840" y="3410712"/>
-            <a:ext cx="7680960" cy="548640"/>
-          </a:xfrm>
-          <a:prstGeom prst="rect">
-            <a:avLst/>
-          </a:prstGeom>
-          <a:noFill/>
-          <a:ln/>
-        </p:spPr>
-        <p:txBody>
-          <a:bodyPr wrap="square" lIns="0" tIns="0" rIns="0" bIns="0" rtlCol="0" anchor="ctr"/>
-          <a:lstStyle/>
-          <a:p>
-            <a:pPr indent="0" marL="0">
-              <a:buNone/>
-            </a:pPr>
-            <a:r>
-              <a:rPr lang="en-US" sz="1100" b="1" dirty="0">
-                <a:solidFill>
-                  <a:srgbClr val="1F2233"/>
-                </a:solidFill>
-                <a:latin typeface="Calibri" pitchFamily="34" charset="0"/>
-                <a:ea typeface="Calibri" pitchFamily="34" charset="-122"/>
-                <a:cs typeface="Calibri" pitchFamily="34" charset="-120"/>
-              </a:rPr>
-              <a:t>AI Act : </a:t>
-            </a:r>
-            <a:pPr indent="0" marL="0">
-              <a:buNone/>
-            </a:pPr>
-            <a:r>
-              <a:rPr lang="en-US" sz="1100" dirty="0">
-                <a:solidFill>
-                  <a:srgbClr val="1F2233"/>
-                </a:solidFill>
-                <a:latin typeface="Calibri" pitchFamily="34" charset="0"/>
-                <a:ea typeface="Calibri" pitchFamily="34" charset="-122"/>
-                <a:cs typeface="Calibri" pitchFamily="34" charset="-120"/>
-              </a:rPr>
-              <a:t>Aucun profilage individuel des « perdants » : leviers appliqués à tous les nouveaux comptes. Lecture à valider par un juriste.</a:t>
-            </a:r>
-            <a:endParaRPr lang="en-US" sz="1100" dirty="0"/>
-          </a:p>
-        </p:txBody>
-      </p:sp>
-      <p:sp>
-        <p:nvSpPr>
-          <p:cNvPr id="19" name="Shape 15"/>
-          <p:cNvSpPr/>
-          <p:nvPr/>
-        </p:nvSpPr>
-        <p:spPr>
-          <a:xfrm>
-            <a:off x="457200" y="4078224"/>
-            <a:ext cx="411480" cy="411480"/>
-          </a:xfrm>
-          <a:prstGeom prst="ellipse">
-            <a:avLst/>
-          </a:prstGeom>
-          <a:solidFill>
-            <a:srgbClr val="E23636"/>
-          </a:solidFill>
-          <a:ln w="12700">
-            <a:solidFill>
-              <a:srgbClr val="E23636"/>
-            </a:solidFill>
-            <a:prstDash val="solid"/>
-          </a:ln>
-        </p:spPr>
-      </p:sp>
-      <p:pic>
-        <p:nvPicPr>
-          <p:cNvPr id="20" name="Image 2" descr="preencoded.png">    </p:cNvPr>
-          <p:cNvPicPr>
-            <a:picLocks noChangeAspect="1"/>
-          </p:cNvPicPr>
-          <p:nvPr/>
-        </p:nvPicPr>
-        <p:blipFill>
-          <a:blip r:embed="rId3"/>
-          <a:stretch>
-            <a:fillRect/>
-          </a:stretch>
-        </p:blipFill>
-        <p:spPr>
-          <a:xfrm>
-            <a:off x="560070" y="4181094"/>
-            <a:ext cx="205740" cy="205740"/>
-          </a:xfrm>
-          <a:prstGeom prst="rect">
-            <a:avLst/>
-          </a:prstGeom>
-        </p:spPr>
-      </p:pic>
-      <p:sp>
-        <p:nvSpPr>
-          <p:cNvPr id="21" name="Text 16"/>
-          <p:cNvSpPr txBox="1"/>
-          <p:nvPr/>
-        </p:nvSpPr>
-        <p:spPr>
-          <a:xfrm>
-            <a:off x="1005840" y="4032504"/>
-            <a:ext cx="7680960" cy="548640"/>
-          </a:xfrm>
-          <a:prstGeom prst="rect">
-            <a:avLst/>
-          </a:prstGeom>
-          <a:noFill/>
-          <a:ln/>
-        </p:spPr>
-        <p:txBody>
-          <a:bodyPr wrap="square" lIns="0" tIns="0" rIns="0" bIns="0" rtlCol="0" anchor="ctr"/>
-          <a:lstStyle/>
-          <a:p>
-            <a:pPr indent="0" marL="0">
-              <a:buNone/>
-            </a:pPr>
-            <a:r>
-              <a:rPr lang="en-US" sz="1100" b="1" dirty="0">
-                <a:solidFill>
-                  <a:srgbClr val="1F2233"/>
-                </a:solidFill>
-                <a:latin typeface="Calibri" pitchFamily="34" charset="0"/>
-                <a:ea typeface="Calibri" pitchFamily="34" charset="-122"/>
-                <a:cs typeface="Calibri" pitchFamily="34" charset="-120"/>
-              </a:rPr>
-              <a:t>Bots : </a:t>
-            </a:r>
-            <a:pPr indent="0" marL="0">
-              <a:buNone/>
-            </a:pPr>
-            <a:r>
-              <a:rPr lang="en-US" sz="1100" dirty="0">
-                <a:solidFill>
-                  <a:srgbClr val="1F2233"/>
-                </a:solidFill>
-                <a:latin typeface="Calibri" pitchFamily="34" charset="0"/>
-                <a:ea typeface="Calibri" pitchFamily="34" charset="-122"/>
-                <a:cs typeface="Calibri" pitchFamily="34" charset="-120"/>
-              </a:rPr>
-              <a:t>Jamais cachés : étiquette neutre, message préparé avec Marvel.</a:t>
-            </a:r>
-            <a:endParaRPr lang="en-US" sz="1100" dirty="0"/>
-          </a:p>
-        </p:txBody>
-      </p:sp>
-      <p:sp>
-        <p:nvSpPr>
-          <p:cNvPr id="22" name="Text 17"/>
-          <p:cNvSpPr txBox="1"/>
-          <p:nvPr/>
-        </p:nvSpPr>
-        <p:spPr>
-          <a:xfrm>
-            <a:off x="457200" y="4754880"/>
-            <a:ext cx="8229600" cy="256032"/>
-          </a:xfrm>
-          <a:prstGeom prst="rect">
-            <a:avLst/>
-          </a:prstGeom>
-          <a:noFill/>
-          <a:ln/>
-        </p:spPr>
-        <p:txBody>
-          <a:bodyPr wrap="square" lIns="0" tIns="0" rIns="0" bIns="0" rtlCol="0" anchor="ctr"/>
-          <a:lstStyle/>
-          <a:p>
-            <a:pPr indent="0" marL="0">
-              <a:buNone/>
-            </a:pPr>
-            <a:r>
-              <a:rPr lang="en-US" sz="900" dirty="0">
-                <a:solidFill>
-                  <a:srgbClr val="5E6378"/>
-                </a:solidFill>
-                <a:latin typeface="Calibri" pitchFamily="34" charset="0"/>
-                <a:ea typeface="Calibri" pitchFamily="34" charset="-122"/>
-                <a:cs typeface="Calibri" pitchFamily="34" charset="-120"/>
-              </a:rPr>
-              <a:t>Sources : </a:t>
-            </a:r>
-            <a:pPr indent="0" marL="0">
-              <a:buNone/>
-            </a:pPr>
-            <a:r>
-              <a:rPr lang="en-US" sz="900" u="sng" dirty="0">
-                <a:solidFill>
-                  <a:srgbClr val="2F3C7E"/>
-                </a:solidFill>
-                <a:latin typeface="Calibri" pitchFamily="34" charset="0"/>
-                <a:ea typeface="Calibri" pitchFamily="34" charset="-122"/>
-                <a:cs typeface="Calibri" pitchFamily="34" charset="-120"/>
-                <a:hlinkClick r:id="rId4" invalidUrl="" action="" tgtFrame="" tooltip="" history="1" highlightClick="0" endSnd="0">
-                  <a:extLst>
-                    <a:ext uri="{A12FA001-AC4F-418D-AE19-62706E023703}">
-                      <ahyp:hlinkClr xmlns:ahyp="http://schemas.microsoft.com/office/drawing/2018/hyperlinkcolor" val="tx"/>
-                    </a:ext>
-                  </a:extLst>
-                </a:hlinkClick>
-              </a:rPr>
-              <a:t>RGPD</a:t>
-            </a:r>
-            <a:pPr indent="0" marL="0">
-              <a:buNone/>
-            </a:pPr>
-            <a:r>
-              <a:rPr lang="en-US" sz="900" dirty="0">
-                <a:solidFill>
-                  <a:srgbClr val="5E6378"/>
-                </a:solidFill>
-                <a:latin typeface="Calibri" pitchFamily="34" charset="0"/>
-                <a:ea typeface="Calibri" pitchFamily="34" charset="-122"/>
-                <a:cs typeface="Calibri" pitchFamily="34" charset="-120"/>
-              </a:rPr>
-              <a:t> · </a:t>
-            </a:r>
-            <a:pPr indent="0" marL="0">
-              <a:buNone/>
-            </a:pPr>
-            <a:r>
-              <a:rPr lang="en-US" sz="900" u="sng" dirty="0">
-                <a:solidFill>
-                  <a:srgbClr val="2F3C7E"/>
-                </a:solidFill>
-                <a:latin typeface="Calibri" pitchFamily="34" charset="0"/>
-                <a:ea typeface="Calibri" pitchFamily="34" charset="-122"/>
-                <a:cs typeface="Calibri" pitchFamily="34" charset="-120"/>
-                <a:hlinkClick r:id="rId5" invalidUrl="" action="" tgtFrame="" tooltip="" history="1" highlightClick="0" endSnd="0">
-                  <a:extLst>
-                    <a:ext uri="{A12FA001-AC4F-418D-AE19-62706E023703}">
-                      <ahyp:hlinkClr xmlns:ahyp="http://schemas.microsoft.com/office/drawing/2018/hyperlinkcolor" val="tx"/>
-                    </a:ext>
-                  </a:extLst>
-                </a:hlinkClick>
-              </a:rPr>
-              <a:t>AI Act</a:t>
-            </a:r>
-            <a:endParaRPr lang="en-US" sz="900" dirty="0"/>
-          </a:p>
-        </p:txBody>
-      </p:sp>
-      <p:sp>
-        <p:nvSpPr>
-          <p:cNvPr id="23" name="Text 18"/>
           <p:cNvSpPr txBox="1"/>
           <p:nvPr/>
         </p:nvSpPr>
@@ -8631,7 +9385,7 @@
                 <a:ea typeface="Arial" pitchFamily="34" charset="-122"/>
                 <a:cs typeface="Arial" pitchFamily="34" charset="-120"/>
               </a:rPr>
-              <a:t>Sources</a:t>
+              <a:t>Des seuils qui déclenchent une décision</a:t>
             </a:r>
             <a:endParaRPr lang="en-US" sz="2800" dirty="0"/>
           </a:p>
@@ -8670,7 +9424,7 @@
                 <a:ea typeface="Calibri" pitchFamily="34" charset="-122"/>
                 <a:cs typeface="Calibri" pitchFamily="34" charset="-120"/>
               </a:rPr>
-              <a:t>Annexe · consultées les 29 et 30/09/2026 · liens cliquables</a:t>
+              <a:t>KPIs et risques</a:t>
             </a:r>
             <a:endParaRPr lang="en-US" sz="1300" dirty="0"/>
           </a:p>
@@ -8678,14 +9432,41 @@
       </p:sp>
       <p:sp>
         <p:nvSpPr>
-          <p:cNvPr id="4" name="Text 2"/>
+          <p:cNvPr id="4" name="Shape 2"/>
+          <p:cNvSpPr/>
+          <p:nvPr/>
+        </p:nvSpPr>
+        <p:spPr>
+          <a:xfrm>
+            <a:off x="457200" y="1280160"/>
+            <a:ext cx="2606040" cy="1325880"/>
+          </a:xfrm>
+          <a:prstGeom prst="roundRect">
+            <a:avLst>
+              <a:gd name="adj" fmla="val 5517"/>
+            </a:avLst>
+          </a:prstGeom>
+          <a:solidFill>
+            <a:srgbClr val="161A33"/>
+          </a:solidFill>
+          <a:ln w="12700">
+            <a:solidFill>
+              <a:srgbClr val="161A33"/>
+            </a:solidFill>
+            <a:prstDash val="solid"/>
+          </a:ln>
+        </p:spPr>
+      </p:sp>
+      <p:sp>
+        <p:nvSpPr>
+          <p:cNvPr id="5" name="Text 3"/>
           <p:cNvSpPr txBox="1"/>
           <p:nvPr/>
         </p:nvSpPr>
         <p:spPr>
           <a:xfrm>
-            <a:off x="457200" y="1234440"/>
-            <a:ext cx="8229600" cy="3474720"/>
+            <a:off x="640080" y="1371600"/>
+            <a:ext cx="2240280" cy="548640"/>
           </a:xfrm>
           <a:prstGeom prst="rect">
             <a:avLst/>
@@ -8694,102 +9475,622 @@
           <a:ln/>
         </p:spPr>
         <p:txBody>
-          <a:bodyPr wrap="square" rtlCol="0" anchor="t"/>
-          <a:lstStyle/>
-          <a:p>
-            <a:pPr marL="342900" indent="-342900">
-              <a:spcAft>
-                <a:spcPts val="400"/>
-              </a:spcAft>
-              <a:buSzPct val="100000"/>
-              <a:buChar char="•"/>
-            </a:pPr>
-            <a:r>
-              <a:rPr lang="en-US" sz="1200" u="sng" dirty="0">
-                <a:solidFill>
-                  <a:srgbClr val="2F3C7E"/>
-                </a:solidFill>
-                <a:latin typeface="Calibri" pitchFamily="34" charset="0"/>
-                <a:ea typeface="Calibri" pitchFamily="34" charset="-122"/>
-                <a:cs typeface="Calibri" pitchFamily="34" charset="-120"/>
-                <a:hlinkClick r:id="rId1" invalidUrl="" action="" tgtFrame="" tooltip="" history="1" highlightClick="0" endSnd="0">
-                  <a:extLst>
-                    <a:ext uri="{A12FA001-AC4F-418D-AE19-62706E023703}">
-                      <ahyp:hlinkClr xmlns:ahyp="http://schemas.microsoft.com/office/drawing/2018/hyperlinkcolor" val="tx"/>
-                    </a:ext>
-                  </a:extLst>
-                </a:hlinkClick>
-              </a:rPr>
-              <a:t>Steam Charts, moyennes mensuelles (PC)</a:t>
-            </a:r>
-            <a:endParaRPr lang="en-US" sz="1200" dirty="0"/>
-          </a:p>
-          <a:p>
-            <a:pPr marL="342900" indent="-342900">
-              <a:spcAft>
-                <a:spcPts val="400"/>
-              </a:spcAft>
-              <a:buSzPct val="100000"/>
-              <a:buChar char="•"/>
-            </a:pPr>
-            <a:r>
-              <a:rPr lang="en-US" sz="1200" u="sng" dirty="0">
-                <a:solidFill>
-                  <a:srgbClr val="2F3C7E"/>
-                </a:solidFill>
-                <a:latin typeface="Calibri" pitchFamily="34" charset="0"/>
-                <a:ea typeface="Calibri" pitchFamily="34" charset="-122"/>
-                <a:cs typeface="Calibri" pitchFamily="34" charset="-120"/>
-                <a:hlinkClick r:id="rId2" invalidUrl="" action="" tgtFrame="" tooltip="" history="1" highlightClick="0" endSnd="0">
-                  <a:extLst>
-                    <a:ext uri="{A12FA001-AC4F-418D-AE19-62706E023703}">
-                      <ahyp:hlinkClr xmlns:ahyp="http://schemas.microsoft.com/office/drawing/2018/hyperlinkcolor" val="tx"/>
-                    </a:ext>
-                  </a:extLst>
-                </a:hlinkClick>
-              </a:rPr>
-              <a:t>40 millions de joueurs, rapport NetEase (Game World Observer)</a:t>
-            </a:r>
-            <a:endParaRPr lang="en-US" sz="1200" dirty="0"/>
-          </a:p>
-          <a:p>
-            <a:pPr marL="342900" indent="-342900">
-              <a:spcAft>
-                <a:spcPts val="400"/>
-              </a:spcAft>
-              <a:buSzPct val="100000"/>
-              <a:buChar char="•"/>
-            </a:pPr>
-            <a:r>
-              <a:rPr lang="en-US" sz="1200" u="sng" dirty="0">
-                <a:solidFill>
-                  <a:srgbClr val="2F3C7E"/>
-                </a:solidFill>
-                <a:latin typeface="Calibri" pitchFamily="34" charset="0"/>
-                <a:ea typeface="Calibri" pitchFamily="34" charset="-122"/>
-                <a:cs typeface="Calibri" pitchFamily="34" charset="-120"/>
-                <a:hlinkClick r:id="rId3" invalidUrl="" action="" tgtFrame="" tooltip="" history="1" highlightClick="0" endSnd="0">
-                  <a:extLst>
-                    <a:ext uri="{A12FA001-AC4F-418D-AE19-62706E023703}">
-                      <ahyp:hlinkClr xmlns:ahyp="http://schemas.microsoft.com/office/drawing/2018/hyperlinkcolor" val="tx"/>
-                    </a:ext>
-                  </a:extLst>
-                </a:hlinkClick>
-              </a:rPr>
-              <a:t>API publique des avis Steam (notre collecte, 37 990 avis pondérés)</a:t>
-            </a:r>
-            <a:endParaRPr lang="en-US" sz="1200" dirty="0"/>
-          </a:p>
-          <a:p>
-            <a:pPr marL="342900" indent="-342900">
-              <a:spcAft>
-                <a:spcPts val="400"/>
-              </a:spcAft>
-              <a:buSzPct val="100000"/>
-              <a:buChar char="•"/>
-            </a:pPr>
-            <a:r>
-              <a:rPr lang="en-US" sz="1200" u="sng" dirty="0">
+          <a:bodyPr wrap="square" lIns="0" tIns="0" rIns="0" bIns="0" rtlCol="0" anchor="ctr"/>
+          <a:lstStyle/>
+          <a:p>
+            <a:pPr indent="0" marL="0">
+              <a:buNone/>
+            </a:pPr>
+            <a:r>
+              <a:rPr lang="en-US" sz="2800" b="1" dirty="0">
+                <a:solidFill>
+                  <a:srgbClr val="E23636"/>
+                </a:solidFill>
+                <a:latin typeface="Arial" pitchFamily="34" charset="0"/>
+                <a:ea typeface="Arial" pitchFamily="34" charset="-122"/>
+                <a:cs typeface="Arial" pitchFamily="34" charset="-120"/>
+              </a:rPr>
+              <a:t>&gt; 1,2</a:t>
+            </a:r>
+            <a:endParaRPr lang="en-US" sz="2800" dirty="0"/>
+          </a:p>
+        </p:txBody>
+      </p:sp>
+      <p:sp>
+        <p:nvSpPr>
+          <p:cNvPr id="6" name="Text 4"/>
+          <p:cNvSpPr txBox="1"/>
+          <p:nvPr/>
+        </p:nvSpPr>
+        <p:spPr>
+          <a:xfrm>
+            <a:off x="640080" y="1920240"/>
+            <a:ext cx="2240280" cy="640080"/>
+          </a:xfrm>
+          <a:prstGeom prst="rect">
+            <a:avLst/>
+          </a:prstGeom>
+          <a:noFill/>
+          <a:ln/>
+        </p:spPr>
+        <p:txBody>
+          <a:bodyPr wrap="square" lIns="0" tIns="0" rIns="0" bIns="0" rtlCol="0" anchor="t"/>
+          <a:lstStyle/>
+          <a:p>
+            <a:pPr indent="0" marL="0">
+              <a:buNone/>
+            </a:pPr>
+            <a:r>
+              <a:rPr lang="en-US" sz="1100" dirty="0">
+                <a:solidFill>
+                  <a:srgbClr val="FFFFFF"/>
+                </a:solidFill>
+                <a:latin typeface="Calibri" pitchFamily="34" charset="0"/>
+                <a:ea typeface="Calibri" pitchFamily="34" charset="-122"/>
+                <a:cs typeface="Calibri" pitchFamily="34" charset="-120"/>
+              </a:rPr>
+              <a:t>ratio de churn J7 à l'audit : on lance les tests</a:t>
+            </a:r>
+            <a:endParaRPr lang="en-US" sz="1100" dirty="0"/>
+          </a:p>
+        </p:txBody>
+      </p:sp>
+      <p:sp>
+        <p:nvSpPr>
+          <p:cNvPr id="7" name="Shape 5"/>
+          <p:cNvSpPr/>
+          <p:nvPr/>
+        </p:nvSpPr>
+        <p:spPr>
+          <a:xfrm>
+            <a:off x="3246120" y="1280160"/>
+            <a:ext cx="2606040" cy="1325880"/>
+          </a:xfrm>
+          <a:prstGeom prst="roundRect">
+            <a:avLst>
+              <a:gd name="adj" fmla="val 5517"/>
+            </a:avLst>
+          </a:prstGeom>
+          <a:solidFill>
+            <a:srgbClr val="161A33"/>
+          </a:solidFill>
+          <a:ln w="12700">
+            <a:solidFill>
+              <a:srgbClr val="161A33"/>
+            </a:solidFill>
+            <a:prstDash val="solid"/>
+          </a:ln>
+        </p:spPr>
+      </p:sp>
+      <p:sp>
+        <p:nvSpPr>
+          <p:cNvPr id="8" name="Text 6"/>
+          <p:cNvSpPr txBox="1"/>
+          <p:nvPr/>
+        </p:nvSpPr>
+        <p:spPr>
+          <a:xfrm>
+            <a:off x="3429000" y="1371600"/>
+            <a:ext cx="2240280" cy="548640"/>
+          </a:xfrm>
+          <a:prstGeom prst="rect">
+            <a:avLst/>
+          </a:prstGeom>
+          <a:noFill/>
+          <a:ln/>
+        </p:spPr>
+        <p:txBody>
+          <a:bodyPr wrap="square" lIns="0" tIns="0" rIns="0" bIns="0" rtlCol="0" anchor="ctr"/>
+          <a:lstStyle/>
+          <a:p>
+            <a:pPr indent="0" marL="0">
+              <a:buNone/>
+            </a:pPr>
+            <a:r>
+              <a:rPr lang="en-US" sz="2800" b="1" dirty="0">
+                <a:solidFill>
+                  <a:srgbClr val="E23636"/>
+                </a:solidFill>
+                <a:latin typeface="Arial" pitchFamily="34" charset="0"/>
+                <a:ea typeface="Arial" pitchFamily="34" charset="-122"/>
+                <a:cs typeface="Arial" pitchFamily="34" charset="-120"/>
+              </a:rPr>
+              <a:t>&gt; 5 min</a:t>
+            </a:r>
+            <a:endParaRPr lang="en-US" sz="2800" dirty="0"/>
+          </a:p>
+        </p:txBody>
+      </p:sp>
+      <p:sp>
+        <p:nvSpPr>
+          <p:cNvPr id="9" name="Text 7"/>
+          <p:cNvSpPr txBox="1"/>
+          <p:nvPr/>
+        </p:nvSpPr>
+        <p:spPr>
+          <a:xfrm>
+            <a:off x="3429000" y="1920240"/>
+            <a:ext cx="2240280" cy="640080"/>
+          </a:xfrm>
+          <a:prstGeom prst="rect">
+            <a:avLst/>
+          </a:prstGeom>
+          <a:noFill/>
+          <a:ln/>
+        </p:spPr>
+        <p:txBody>
+          <a:bodyPr wrap="square" lIns="0" tIns="0" rIns="0" bIns="0" rtlCol="0" anchor="t"/>
+          <a:lstStyle/>
+          <a:p>
+            <a:pPr indent="0" marL="0">
+              <a:buNone/>
+            </a:pPr>
+            <a:r>
+              <a:rPr lang="en-US" sz="1100" dirty="0">
+                <a:solidFill>
+                  <a:srgbClr val="FFFFFF"/>
+                </a:solidFill>
+                <a:latin typeface="Calibri" pitchFamily="34" charset="0"/>
+                <a:ea typeface="Calibri" pitchFamily="34" charset="-122"/>
+                <a:cs typeface="Calibri" pitchFamily="34" charset="-120"/>
+              </a:rPr>
+              <a:t>attente p90 : on arrête le resserrement</a:t>
+            </a:r>
+            <a:endParaRPr lang="en-US" sz="1100" dirty="0"/>
+          </a:p>
+        </p:txBody>
+      </p:sp>
+      <p:sp>
+        <p:nvSpPr>
+          <p:cNvPr id="10" name="Shape 8"/>
+          <p:cNvSpPr/>
+          <p:nvPr/>
+        </p:nvSpPr>
+        <p:spPr>
+          <a:xfrm>
+            <a:off x="6035040" y="1280160"/>
+            <a:ext cx="2606040" cy="1325880"/>
+          </a:xfrm>
+          <a:prstGeom prst="roundRect">
+            <a:avLst>
+              <a:gd name="adj" fmla="val 5517"/>
+            </a:avLst>
+          </a:prstGeom>
+          <a:solidFill>
+            <a:srgbClr val="161A33"/>
+          </a:solidFill>
+          <a:ln w="12700">
+            <a:solidFill>
+              <a:srgbClr val="161A33"/>
+            </a:solidFill>
+            <a:prstDash val="solid"/>
+          </a:ln>
+        </p:spPr>
+      </p:sp>
+      <p:sp>
+        <p:nvSpPr>
+          <p:cNvPr id="11" name="Text 9"/>
+          <p:cNvSpPr txBox="1"/>
+          <p:nvPr/>
+        </p:nvSpPr>
+        <p:spPr>
+          <a:xfrm>
+            <a:off x="6217920" y="1371600"/>
+            <a:ext cx="2240280" cy="548640"/>
+          </a:xfrm>
+          <a:prstGeom prst="rect">
+            <a:avLst/>
+          </a:prstGeom>
+          <a:noFill/>
+          <a:ln/>
+        </p:spPr>
+        <p:txBody>
+          <a:bodyPr wrap="square" lIns="0" tIns="0" rIns="0" bIns="0" rtlCol="0" anchor="ctr"/>
+          <a:lstStyle/>
+          <a:p>
+            <a:pPr indent="0" marL="0">
+              <a:buNone/>
+            </a:pPr>
+            <a:r>
+              <a:rPr lang="en-US" sz="2800" b="1" dirty="0">
+                <a:solidFill>
+                  <a:srgbClr val="E23636"/>
+                </a:solidFill>
+                <a:latin typeface="Arial" pitchFamily="34" charset="0"/>
+                <a:ea typeface="Arial" pitchFamily="34" charset="-122"/>
+                <a:cs typeface="Arial" pitchFamily="34" charset="-120"/>
+              </a:rPr>
+              <a:t>&gt; 50 %</a:t>
+            </a:r>
+            <a:endParaRPr lang="en-US" sz="2800" dirty="0"/>
+          </a:p>
+        </p:txBody>
+      </p:sp>
+      <p:sp>
+        <p:nvSpPr>
+          <p:cNvPr id="12" name="Text 10"/>
+          <p:cNvSpPr txBox="1"/>
+          <p:nvPr/>
+        </p:nvSpPr>
+        <p:spPr>
+          <a:xfrm>
+            <a:off x="6217920" y="1920240"/>
+            <a:ext cx="2240280" cy="640080"/>
+          </a:xfrm>
+          <a:prstGeom prst="rect">
+            <a:avLst/>
+          </a:prstGeom>
+          <a:noFill/>
+          <a:ln/>
+        </p:spPr>
+        <p:txBody>
+          <a:bodyPr wrap="square" lIns="0" tIns="0" rIns="0" bIns="0" rtlCol="0" anchor="t"/>
+          <a:lstStyle/>
+          <a:p>
+            <a:pPr indent="0" marL="0">
+              <a:buNone/>
+            </a:pPr>
+            <a:r>
+              <a:rPr lang="en-US" sz="1100" dirty="0">
+                <a:solidFill>
+                  <a:srgbClr val="FFFFFF"/>
+                </a:solidFill>
+                <a:latin typeface="Calibri" pitchFamily="34" charset="0"/>
+                <a:ea typeface="Calibri" pitchFamily="34" charset="-122"/>
+                <a:cs typeface="Calibri" pitchFamily="34" charset="-120"/>
+              </a:rPr>
+              <a:t>des 10 premiers matchs en partie rapide : on la corrige en premier</a:t>
+            </a:r>
+            <a:endParaRPr lang="en-US" sz="1100" dirty="0"/>
+          </a:p>
+        </p:txBody>
+      </p:sp>
+      <p:sp>
+        <p:nvSpPr>
+          <p:cNvPr id="13" name="Shape 11"/>
+          <p:cNvSpPr/>
+          <p:nvPr/>
+        </p:nvSpPr>
+        <p:spPr>
+          <a:xfrm>
+            <a:off x="457200" y="2834640"/>
+            <a:ext cx="411480" cy="411480"/>
+          </a:xfrm>
+          <a:prstGeom prst="ellipse">
+            <a:avLst/>
+          </a:prstGeom>
+          <a:solidFill>
+            <a:srgbClr val="E23636"/>
+          </a:solidFill>
+          <a:ln w="12700">
+            <a:solidFill>
+              <a:srgbClr val="E23636"/>
+            </a:solidFill>
+            <a:prstDash val="solid"/>
+          </a:ln>
+        </p:spPr>
+      </p:sp>
+      <p:pic>
+        <p:nvPicPr>
+          <p:cNvPr id="14" name="Image 0" descr="preencoded.png">    </p:cNvPr>
+          <p:cNvPicPr>
+            <a:picLocks noChangeAspect="1"/>
+          </p:cNvPicPr>
+          <p:nvPr/>
+        </p:nvPicPr>
+        <p:blipFill>
+          <a:blip r:embed="rId1"/>
+          <a:stretch>
+            <a:fillRect/>
+          </a:stretch>
+        </p:blipFill>
+        <p:spPr>
+          <a:xfrm>
+            <a:off x="560070" y="2937510"/>
+            <a:ext cx="205740" cy="205740"/>
+          </a:xfrm>
+          <a:prstGeom prst="rect">
+            <a:avLst/>
+          </a:prstGeom>
+        </p:spPr>
+      </p:pic>
+      <p:sp>
+        <p:nvSpPr>
+          <p:cNvPr id="15" name="Text 12"/>
+          <p:cNvSpPr txBox="1"/>
+          <p:nvPr/>
+        </p:nvSpPr>
+        <p:spPr>
+          <a:xfrm>
+            <a:off x="1005840" y="2788920"/>
+            <a:ext cx="7680960" cy="548640"/>
+          </a:xfrm>
+          <a:prstGeom prst="rect">
+            <a:avLst/>
+          </a:prstGeom>
+          <a:noFill/>
+          <a:ln/>
+        </p:spPr>
+        <p:txBody>
+          <a:bodyPr wrap="square" lIns="0" tIns="0" rIns="0" bIns="0" rtlCol="0" anchor="ctr"/>
+          <a:lstStyle/>
+          <a:p>
+            <a:pPr indent="0" marL="0">
+              <a:buNone/>
+            </a:pPr>
+            <a:r>
+              <a:rPr lang="en-US" sz="1100" b="1" dirty="0">
+                <a:solidFill>
+                  <a:srgbClr val="1F2233"/>
+                </a:solidFill>
+                <a:latin typeface="Calibri" pitchFamily="34" charset="0"/>
+                <a:ea typeface="Calibri" pitchFamily="34" charset="-122"/>
+                <a:cs typeface="Calibri" pitchFamily="34" charset="-120"/>
+              </a:rPr>
+              <a:t>Données personnelles (RGPD) : </a:t>
+            </a:r>
+            <a:pPr indent="0" marL="0">
+              <a:buNone/>
+            </a:pPr>
+            <a:r>
+              <a:rPr lang="en-US" sz="1100" dirty="0">
+                <a:solidFill>
+                  <a:srgbClr val="1F2233"/>
+                </a:solidFill>
+                <a:latin typeface="Calibri" pitchFamily="34" charset="0"/>
+                <a:ea typeface="Calibri" pitchFamily="34" charset="-122"/>
+                <a:cs typeface="Calibri" pitchFamily="34" charset="-120"/>
+              </a:rPr>
+              <a:t>Accord de sous-traitance, identifiants hachés par NetEase, analyse dans votre environnement, mineurs exclus.</a:t>
+            </a:r>
+            <a:endParaRPr lang="en-US" sz="1100" dirty="0"/>
+          </a:p>
+        </p:txBody>
+      </p:sp>
+      <p:sp>
+        <p:nvSpPr>
+          <p:cNvPr id="16" name="Shape 13"/>
+          <p:cNvSpPr/>
+          <p:nvPr/>
+        </p:nvSpPr>
+        <p:spPr>
+          <a:xfrm>
+            <a:off x="457200" y="3456432"/>
+            <a:ext cx="411480" cy="411480"/>
+          </a:xfrm>
+          <a:prstGeom prst="ellipse">
+            <a:avLst/>
+          </a:prstGeom>
+          <a:solidFill>
+            <a:srgbClr val="E23636"/>
+          </a:solidFill>
+          <a:ln w="12700">
+            <a:solidFill>
+              <a:srgbClr val="E23636"/>
+            </a:solidFill>
+            <a:prstDash val="solid"/>
+          </a:ln>
+        </p:spPr>
+      </p:sp>
+      <p:pic>
+        <p:nvPicPr>
+          <p:cNvPr id="17" name="Image 1" descr="preencoded.png">    </p:cNvPr>
+          <p:cNvPicPr>
+            <a:picLocks noChangeAspect="1"/>
+          </p:cNvPicPr>
+          <p:nvPr/>
+        </p:nvPicPr>
+        <p:blipFill>
+          <a:blip r:embed="rId2"/>
+          <a:stretch>
+            <a:fillRect/>
+          </a:stretch>
+        </p:blipFill>
+        <p:spPr>
+          <a:xfrm>
+            <a:off x="560070" y="3559302"/>
+            <a:ext cx="205740" cy="205740"/>
+          </a:xfrm>
+          <a:prstGeom prst="rect">
+            <a:avLst/>
+          </a:prstGeom>
+        </p:spPr>
+      </p:pic>
+      <p:sp>
+        <p:nvSpPr>
+          <p:cNvPr id="18" name="Text 14"/>
+          <p:cNvSpPr txBox="1"/>
+          <p:nvPr/>
+        </p:nvSpPr>
+        <p:spPr>
+          <a:xfrm>
+            <a:off x="1005840" y="3410712"/>
+            <a:ext cx="7680960" cy="548640"/>
+          </a:xfrm>
+          <a:prstGeom prst="rect">
+            <a:avLst/>
+          </a:prstGeom>
+          <a:noFill/>
+          <a:ln/>
+        </p:spPr>
+        <p:txBody>
+          <a:bodyPr wrap="square" lIns="0" tIns="0" rIns="0" bIns="0" rtlCol="0" anchor="ctr"/>
+          <a:lstStyle/>
+          <a:p>
+            <a:pPr indent="0" marL="0">
+              <a:buNone/>
+            </a:pPr>
+            <a:r>
+              <a:rPr lang="en-US" sz="1100" b="1" dirty="0">
+                <a:solidFill>
+                  <a:srgbClr val="1F2233"/>
+                </a:solidFill>
+                <a:latin typeface="Calibri" pitchFamily="34" charset="0"/>
+                <a:ea typeface="Calibri" pitchFamily="34" charset="-122"/>
+                <a:cs typeface="Calibri" pitchFamily="34" charset="-120"/>
+              </a:rPr>
+              <a:t>AI Act : </a:t>
+            </a:r>
+            <a:pPr indent="0" marL="0">
+              <a:buNone/>
+            </a:pPr>
+            <a:r>
+              <a:rPr lang="en-US" sz="1100" dirty="0">
+                <a:solidFill>
+                  <a:srgbClr val="1F2233"/>
+                </a:solidFill>
+                <a:latin typeface="Calibri" pitchFamily="34" charset="0"/>
+                <a:ea typeface="Calibri" pitchFamily="34" charset="-122"/>
+                <a:cs typeface="Calibri" pitchFamily="34" charset="-120"/>
+              </a:rPr>
+              <a:t>Aucun profilage individuel des « perdants » : leviers appliqués à tous les nouveaux comptes. Lecture à valider par un juriste.</a:t>
+            </a:r>
+            <a:endParaRPr lang="en-US" sz="1100" dirty="0"/>
+          </a:p>
+        </p:txBody>
+      </p:sp>
+      <p:sp>
+        <p:nvSpPr>
+          <p:cNvPr id="19" name="Shape 15"/>
+          <p:cNvSpPr/>
+          <p:nvPr/>
+        </p:nvSpPr>
+        <p:spPr>
+          <a:xfrm>
+            <a:off x="457200" y="4078224"/>
+            <a:ext cx="411480" cy="411480"/>
+          </a:xfrm>
+          <a:prstGeom prst="ellipse">
+            <a:avLst/>
+          </a:prstGeom>
+          <a:solidFill>
+            <a:srgbClr val="E23636"/>
+          </a:solidFill>
+          <a:ln w="12700">
+            <a:solidFill>
+              <a:srgbClr val="E23636"/>
+            </a:solidFill>
+            <a:prstDash val="solid"/>
+          </a:ln>
+        </p:spPr>
+      </p:sp>
+      <p:pic>
+        <p:nvPicPr>
+          <p:cNvPr id="20" name="Image 2" descr="preencoded.png">    </p:cNvPr>
+          <p:cNvPicPr>
+            <a:picLocks noChangeAspect="1"/>
+          </p:cNvPicPr>
+          <p:nvPr/>
+        </p:nvPicPr>
+        <p:blipFill>
+          <a:blip r:embed="rId3"/>
+          <a:stretch>
+            <a:fillRect/>
+          </a:stretch>
+        </p:blipFill>
+        <p:spPr>
+          <a:xfrm>
+            <a:off x="560070" y="4181094"/>
+            <a:ext cx="205740" cy="205740"/>
+          </a:xfrm>
+          <a:prstGeom prst="rect">
+            <a:avLst/>
+          </a:prstGeom>
+        </p:spPr>
+      </p:pic>
+      <p:sp>
+        <p:nvSpPr>
+          <p:cNvPr id="21" name="Text 16"/>
+          <p:cNvSpPr txBox="1"/>
+          <p:nvPr/>
+        </p:nvSpPr>
+        <p:spPr>
+          <a:xfrm>
+            <a:off x="1005840" y="4032504"/>
+            <a:ext cx="7680960" cy="548640"/>
+          </a:xfrm>
+          <a:prstGeom prst="rect">
+            <a:avLst/>
+          </a:prstGeom>
+          <a:noFill/>
+          <a:ln/>
+        </p:spPr>
+        <p:txBody>
+          <a:bodyPr wrap="square" lIns="0" tIns="0" rIns="0" bIns="0" rtlCol="0" anchor="ctr"/>
+          <a:lstStyle/>
+          <a:p>
+            <a:pPr indent="0" marL="0">
+              <a:buNone/>
+            </a:pPr>
+            <a:r>
+              <a:rPr lang="en-US" sz="1100" b="1" dirty="0">
+                <a:solidFill>
+                  <a:srgbClr val="1F2233"/>
+                </a:solidFill>
+                <a:latin typeface="Calibri" pitchFamily="34" charset="0"/>
+                <a:ea typeface="Calibri" pitchFamily="34" charset="-122"/>
+                <a:cs typeface="Calibri" pitchFamily="34" charset="-120"/>
+              </a:rPr>
+              <a:t>Bots : </a:t>
+            </a:r>
+            <a:pPr indent="0" marL="0">
+              <a:buNone/>
+            </a:pPr>
+            <a:r>
+              <a:rPr lang="en-US" sz="1100" dirty="0">
+                <a:solidFill>
+                  <a:srgbClr val="1F2233"/>
+                </a:solidFill>
+                <a:latin typeface="Calibri" pitchFamily="34" charset="0"/>
+                <a:ea typeface="Calibri" pitchFamily="34" charset="-122"/>
+                <a:cs typeface="Calibri" pitchFamily="34" charset="-120"/>
+              </a:rPr>
+              <a:t>Jamais cachés : étiquette neutre, message préparé avec Marvel.</a:t>
+            </a:r>
+            <a:endParaRPr lang="en-US" sz="1100" dirty="0"/>
+          </a:p>
+        </p:txBody>
+      </p:sp>
+      <p:sp>
+        <p:nvSpPr>
+          <p:cNvPr id="22" name="Text 17"/>
+          <p:cNvSpPr txBox="1"/>
+          <p:nvPr/>
+        </p:nvSpPr>
+        <p:spPr>
+          <a:xfrm>
+            <a:off x="457200" y="4754880"/>
+            <a:ext cx="8229600" cy="256032"/>
+          </a:xfrm>
+          <a:prstGeom prst="rect">
+            <a:avLst/>
+          </a:prstGeom>
+          <a:noFill/>
+          <a:ln/>
+        </p:spPr>
+        <p:txBody>
+          <a:bodyPr wrap="square" lIns="0" tIns="0" rIns="0" bIns="0" rtlCol="0" anchor="ctr"/>
+          <a:lstStyle/>
+          <a:p>
+            <a:pPr indent="0" marL="0">
+              <a:buNone/>
+            </a:pPr>
+            <a:r>
+              <a:rPr lang="en-US" sz="900" dirty="0">
+                <a:solidFill>
+                  <a:srgbClr val="5E6378"/>
+                </a:solidFill>
+                <a:latin typeface="Calibri" pitchFamily="34" charset="0"/>
+                <a:ea typeface="Calibri" pitchFamily="34" charset="-122"/>
+                <a:cs typeface="Calibri" pitchFamily="34" charset="-120"/>
+              </a:rPr>
+              <a:t>Sources : </a:t>
+            </a:r>
+            <a:pPr indent="0" marL="0">
+              <a:buNone/>
+            </a:pPr>
+            <a:r>
+              <a:rPr lang="en-US" sz="900" u="sng" dirty="0">
                 <a:solidFill>
                   <a:srgbClr val="2F3C7E"/>
                 </a:solidFill>
@@ -8804,20 +10105,27 @@
                   </a:extLst>
                 </a:hlinkClick>
               </a:rPr>
-              <a:t>Vidéo NetEase sur le matchmaking, 21/08/2025</a:t>
-            </a:r>
-            <a:endParaRPr lang="en-US" sz="1200" dirty="0"/>
-          </a:p>
-          <a:p>
-            <a:pPr marL="342900" indent="-342900">
-              <a:spcAft>
-                <a:spcPts val="400"/>
-              </a:spcAft>
-              <a:buSzPct val="100000"/>
-              <a:buChar char="•"/>
-            </a:pPr>
-            <a:r>
-              <a:rPr lang="en-US" sz="1200" u="sng" dirty="0">
+              <a:t>RGPD</a:t>
+            </a:r>
+            <a:pPr indent="0" marL="0">
+              <a:buNone/>
+            </a:pPr>
+            <a:r>
+              <a:rPr lang="en-US" sz="900" dirty="0">
+                <a:solidFill>
+                  <a:srgbClr val="5E6378"/>
+                </a:solidFill>
+                <a:latin typeface="Calibri" pitchFamily="34" charset="0"/>
+                <a:ea typeface="Calibri" pitchFamily="34" charset="-122"/>
+                <a:cs typeface="Calibri" pitchFamily="34" charset="-120"/>
+              </a:rPr>
+              <a:t> · </a:t>
+            </a:r>
+            <a:pPr indent="0" marL="0">
+              <a:buNone/>
+            </a:pPr>
+            <a:r>
+              <a:rPr lang="en-US" sz="900" u="sng" dirty="0">
                 <a:solidFill>
                   <a:srgbClr val="2F3C7E"/>
                 </a:solidFill>
@@ -8832,211 +10140,15 @@
                   </a:extLst>
                 </a:hlinkClick>
               </a:rPr>
-              <a:t>Notes de patch Season 5, placements (14/11/2025)</a:t>
-            </a:r>
-            <a:endParaRPr lang="en-US" sz="1200" dirty="0"/>
-          </a:p>
-          <a:p>
-            <a:pPr marL="342900" indent="-342900">
-              <a:spcAft>
-                <a:spcPts val="400"/>
-              </a:spcAft>
-              <a:buSzPct val="100000"/>
-              <a:buChar char="•"/>
-            </a:pPr>
-            <a:r>
-              <a:rPr lang="en-US" sz="1200" u="sng" dirty="0">
-                <a:solidFill>
-                  <a:srgbClr val="2F3C7E"/>
-                </a:solidFill>
-                <a:latin typeface="Calibri" pitchFamily="34" charset="0"/>
-                <a:ea typeface="Calibri" pitchFamily="34" charset="-122"/>
-                <a:cs typeface="Calibri" pitchFamily="34" charset="-120"/>
-                <a:hlinkClick r:id="rId6" invalidUrl="" action="" tgtFrame="" tooltip="" history="1" highlightClick="0" endSnd="0">
-                  <a:extLst>
-                    <a:ext uri="{A12FA001-AC4F-418D-AE19-62706E023703}">
-                      <ahyp:hlinkClr xmlns:ahyp="http://schemas.microsoft.com/office/drawing/2018/hyperlinkcolor" val="tx"/>
-                    </a:ext>
-                  </a:extLst>
-                </a:hlinkClick>
-              </a:rPr>
-              <a:t>Notes de patch Season 7, placement individuel (18/03/2026)</a:t>
-            </a:r>
-            <a:endParaRPr lang="en-US" sz="1200" dirty="0"/>
-          </a:p>
-          <a:p>
-            <a:pPr marL="342900" indent="-342900">
-              <a:spcAft>
-                <a:spcPts val="400"/>
-              </a:spcAft>
-              <a:buSzPct val="100000"/>
-              <a:buChar char="•"/>
-            </a:pPr>
-            <a:r>
-              <a:rPr lang="en-US" sz="1200" u="sng" dirty="0">
-                <a:solidFill>
-                  <a:srgbClr val="2F3C7E"/>
-                </a:solidFill>
-                <a:latin typeface="Calibri" pitchFamily="34" charset="0"/>
-                <a:ea typeface="Calibri" pitchFamily="34" charset="-122"/>
-                <a:cs typeface="Calibri" pitchFamily="34" charset="-120"/>
-                <a:hlinkClick r:id="rId7" invalidUrl="" action="" tgtFrame="" tooltip="" history="1" highlightClick="0" endSnd="0">
-                  <a:extLst>
-                    <a:ext uri="{A12FA001-AC4F-418D-AE19-62706E023703}">
-                      <ahyp:hlinkClr xmlns:ahyp="http://schemas.microsoft.com/office/drawing/2018/hyperlinkcolor" val="tx"/>
-                    </a:ext>
-                  </a:extLst>
-                </a:hlinkClick>
-              </a:rPr>
-              <a:t>Classé : Bronze III pour tous (PCGamesN)</a:t>
-            </a:r>
-            <a:endParaRPr lang="en-US" sz="1200" dirty="0"/>
-          </a:p>
-          <a:p>
-            <a:pPr marL="342900" indent="-342900">
-              <a:spcAft>
-                <a:spcPts val="400"/>
-              </a:spcAft>
-              <a:buSzPct val="100000"/>
-              <a:buChar char="•"/>
-            </a:pPr>
-            <a:r>
-              <a:rPr lang="en-US" sz="1200" u="sng" dirty="0">
-                <a:solidFill>
-                  <a:srgbClr val="2F3C7E"/>
-                </a:solidFill>
-                <a:latin typeface="Calibri" pitchFamily="34" charset="0"/>
-                <a:ea typeface="Calibri" pitchFamily="34" charset="-122"/>
-                <a:cs typeface="Calibri" pitchFamily="34" charset="-120"/>
-                <a:hlinkClick r:id="rId8" invalidUrl="" action="" tgtFrame="" tooltip="" history="1" highlightClick="0" endSnd="0">
-                  <a:extLst>
-                    <a:ext uri="{A12FA001-AC4F-418D-AE19-62706E023703}">
-                      <ahyp:hlinkClr xmlns:ahyp="http://schemas.microsoft.com/office/drawing/2018/hyperlinkcolor" val="tx"/>
-                    </a:ext>
-                  </a:extLst>
-                </a:hlinkClick>
-              </a:rPr>
-              <a:t>Crossplay : partie rapide commune, classé séparé (Esports Insider)</a:t>
-            </a:r>
-            <a:endParaRPr lang="en-US" sz="1200" dirty="0"/>
-          </a:p>
-          <a:p>
-            <a:pPr marL="342900" indent="-342900">
-              <a:spcAft>
-                <a:spcPts val="400"/>
-              </a:spcAft>
-              <a:buSzPct val="100000"/>
-              <a:buChar char="•"/>
-            </a:pPr>
-            <a:r>
-              <a:rPr lang="en-US" sz="1200" u="sng" dirty="0">
-                <a:solidFill>
-                  <a:srgbClr val="2F3C7E"/>
-                </a:solidFill>
-                <a:latin typeface="Calibri" pitchFamily="34" charset="0"/>
-                <a:ea typeface="Calibri" pitchFamily="34" charset="-122"/>
-                <a:cs typeface="Calibri" pitchFamily="34" charset="-120"/>
-                <a:hlinkClick r:id="rId9" invalidUrl="" action="" tgtFrame="" tooltip="" history="1" highlightClick="0" endSnd="0">
-                  <a:extLst>
-                    <a:ext uri="{A12FA001-AC4F-418D-AE19-62706E023703}">
-                      <ahyp:hlinkClr xmlns:ahyp="http://schemas.microsoft.com/office/drawing/2018/hyperlinkcolor" val="tx"/>
-                    </a:ext>
-                  </a:extLst>
-                </a:hlinkClick>
-              </a:rPr>
-              <a:t>Écart de niveau et churn (Heliyon, 2024, analogie)</a:t>
-            </a:r>
-            <a:endParaRPr lang="en-US" sz="1200" dirty="0"/>
-          </a:p>
-          <a:p>
-            <a:pPr marL="342900" indent="-342900">
-              <a:spcAft>
-                <a:spcPts val="400"/>
-              </a:spcAft>
-              <a:buSzPct val="100000"/>
-              <a:buChar char="•"/>
-            </a:pPr>
-            <a:r>
-              <a:rPr lang="en-US" sz="1200" u="sng" dirty="0">
-                <a:solidFill>
-                  <a:srgbClr val="2F3C7E"/>
-                </a:solidFill>
-                <a:latin typeface="Calibri" pitchFamily="34" charset="0"/>
-                <a:ea typeface="Calibri" pitchFamily="34" charset="-122"/>
-                <a:cs typeface="Calibri" pitchFamily="34" charset="-120"/>
-                <a:hlinkClick r:id="rId10" invalidUrl="" action="" tgtFrame="" tooltip="" history="1" highlightClick="0" endSnd="0">
-                  <a:extLst>
-                    <a:ext uri="{A12FA001-AC4F-418D-AE19-62706E023703}">
-                      <ahyp:hlinkClr xmlns:ahyp="http://schemas.microsoft.com/office/drawing/2018/hyperlinkcolor" val="tx"/>
-                    </a:ext>
-                  </a:extLst>
-                </a:hlinkClick>
-              </a:rPr>
-              <a:t>RGPD (EUR-Lex)</a:t>
-            </a:r>
-            <a:endParaRPr lang="en-US" sz="1200" dirty="0"/>
-          </a:p>
-          <a:p>
-            <a:pPr marL="342900" indent="-342900">
-              <a:spcAft>
-                <a:spcPts val="400"/>
-              </a:spcAft>
-              <a:buSzPct val="100000"/>
-              <a:buChar char="•"/>
-            </a:pPr>
-            <a:r>
-              <a:rPr lang="en-US" sz="1200" u="sng" dirty="0">
-                <a:solidFill>
-                  <a:srgbClr val="2F3C7E"/>
-                </a:solidFill>
-                <a:latin typeface="Calibri" pitchFamily="34" charset="0"/>
-                <a:ea typeface="Calibri" pitchFamily="34" charset="-122"/>
-                <a:cs typeface="Calibri" pitchFamily="34" charset="-120"/>
-                <a:hlinkClick r:id="rId11" invalidUrl="" action="" tgtFrame="" tooltip="" history="1" highlightClick="0" endSnd="0">
-                  <a:extLst>
-                    <a:ext uri="{A12FA001-AC4F-418D-AE19-62706E023703}">
-                      <ahyp:hlinkClr xmlns:ahyp="http://schemas.microsoft.com/office/drawing/2018/hyperlinkcolor" val="tx"/>
-                    </a:ext>
-                  </a:extLst>
-                </a:hlinkClick>
-              </a:rPr>
-              <a:t>AI Act (EUR-Lex)</a:t>
-            </a:r>
-            <a:endParaRPr lang="en-US" sz="1200" dirty="0"/>
-          </a:p>
-          <a:p>
-            <a:pPr marL="342900" indent="-342900">
-              <a:spcAft>
-                <a:spcPts val="400"/>
-              </a:spcAft>
-              <a:buSzPct val="100000"/>
-              <a:buChar char="•"/>
-            </a:pPr>
-            <a:r>
-              <a:rPr lang="en-US" sz="1200" u="sng" dirty="0">
-                <a:solidFill>
-                  <a:srgbClr val="2F3C7E"/>
-                </a:solidFill>
-                <a:latin typeface="Calibri" pitchFamily="34" charset="0"/>
-                <a:ea typeface="Calibri" pitchFamily="34" charset="-122"/>
-                <a:cs typeface="Calibri" pitchFamily="34" charset="-120"/>
-                <a:hlinkClick r:id="rId12" invalidUrl="" action="" tgtFrame="" tooltip="" history="1" highlightClick="0" endSnd="0">
-                  <a:extLst>
-                    <a:ext uri="{A12FA001-AC4F-418D-AE19-62706E023703}">
-                      <ahyp:hlinkClr xmlns:ahyp="http://schemas.microsoft.com/office/drawing/2018/hyperlinkcolor" val="tx"/>
-                    </a:ext>
-                  </a:extLst>
-                </a:hlinkClick>
-              </a:rPr>
-              <a:t>Plan de collecte complet (Google Docs)</a:t>
-            </a:r>
-            <a:endParaRPr lang="en-US" sz="1200" dirty="0"/>
-          </a:p>
-        </p:txBody>
-      </p:sp>
-      <p:sp>
-        <p:nvSpPr>
-          <p:cNvPr id="5" name="Text 3"/>
+              <a:t>AI Act</a:t>
+            </a:r>
+            <a:endParaRPr lang="en-US" sz="900" dirty="0"/>
+          </a:p>
+        </p:txBody>
+      </p:sp>
+      <p:sp>
+        <p:nvSpPr>
+          <p:cNvPr id="23" name="Text 18"/>
           <p:cNvSpPr txBox="1"/>
           <p:nvPr/>
         </p:nvSpPr>

</xml_diff>

<commit_message>
Pitch : notes orateur ramenées à environ 550 mots (5 min)
Co-Authored-By: Claude Opus 5.5 <noreply@anthropic.com>
Claude-Session: https://claude.ai/code/session_012kyLDzFB57v6JCyVf6ygKi
</commit_message>
<xml_diff>
--- a/docs/presentation/pitch_marvel_rivals_netease.pptx
+++ b/docs/presentation/pitch_marvel_rivals_netease.pptx
@@ -1324,7 +1324,7 @@
           <a:p>
             <a:r>
               <a:rPr lang="en-US" dirty="0"/>
-              <a:t>[10 s] 644 000 joueurs en janvier 2025, 98 000 dix mois plus tard. Je suis mandaté par votre comité pour comprendre pourquoi les joueurs ne restent pas, et quoi mesurer pour le savoir.</a:t>
+              <a:t>[10 s] 644 000 joueurs en janvier 2025, 98 000 dix mois plus tard. Votre comité m'a demandé pourquoi les joueurs ne restent pas.</a:t>
             </a:r>
             <a:endParaRPr lang="en-US" dirty="0"/>
           </a:p>
@@ -1412,7 +1412,7 @@
           <a:p>
             <a:r>
               <a:rPr lang="en-US" dirty="0"/>
-              <a:t>[30 s] Chaque KPI a un seuil qui déclenche une décision : 1,2 pour lancer les tests, chez les nouveaux comme chez les revenants ; 5 minutes d'attente pour les arrêter ; 50 % pour choisir le mode visé. Base légale : contrat pour le matchmaking, intérêt légitime documenté pour l'audit. Et si l'hypothèse tombe, le plan B réutilise les mêmes données. Pour démarrer : signer l'accord de sous-traitance et lancer l'audit de 30 jours. Merci, je prends vos questions.</a:t>
+              <a:t>[30 s] Chaque KPI déclenche une décision : 1,2 pour lancer les tests, 5 minutes pour les arrêter, 50 % pour choisir le mode. Base légale : contrat pour le matchmaking, intérêt légitime documenté pour l'audit. Pour démarrer : signer l'accord de sous-traitance et lancer l'audit. Merci.</a:t>
             </a:r>
             <a:endParaRPr lang="en-US" dirty="0"/>
           </a:p>
@@ -1676,7 +1676,7 @@
           <a:p>
             <a:r>
               <a:rPr lang="en-US" dirty="0"/>
-              <a:t>[20 s] Le problème, prouvé par les données. Un : moins 85 % de pic à pic, moins 76 % en moyenne depuis la sortie. Deux : chaque saison ramène des joueurs, et en deux mois ils sont repartis. Trois : ceux qui partent accusent le matchmaking, de 7 à 41 % des avis négatifs, au point que NetEase a dû démentir publiquement un matchmaking truqué. Ma question : pourquoi les joueurs vivent-ils le matchmaking comme injuste au point de partir ?</a:t>
+              <a:t>[20 s] Le problème, prouvé par les données. Moins 85 % de pic à pic. Chaque saison ramène des joueurs, repartis en deux mois. Et ceux qui partent accusent le matchmaking : de 7 à 41 % des avis négatifs, au point que NetEase a dû démentir un matchmaking truqué.</a:t>
             </a:r>
             <a:endParaRPr lang="en-US" dirty="0"/>
           </a:p>
@@ -1764,7 +1764,7 @@
           <a:p>
             <a:r>
               <a:rPr lang="en-US" dirty="0"/>
-              <a:t>[30 s] Pourquoi ce problème existe ? Notre hypothèse, H5. Au lancement, deux publics opposés arrivent en même temps : des vétérans du genre, puisque 45 % des joueurs qui ont quitté Overwatch 2 en décembre ont joué à Marvel Rivals, et un grand public venu pour Marvel, 40 millions en trois mois. Sans calibrage, ils se croisent : les écarts de niveau donnent l'impression d'un matchmaking injuste, et les moins expérimentés partent. Il reste surtout des vétérans. Attention : Newzoo dit « ont joué », pas « ont migré ».</a:t>
+              <a:t>[30 s] Pourquoi ? Notre hypothèse. Au lancement, deux publics opposés arrivent ensemble : des vétérans, 45 % des joueurs qui ont quitté Overwatch 2 ont essayé Marvel Rivals, et un grand public venu pour Marvel. Sans calibrage, ils se croisent : le matchmaking paraît injuste, les moins expérimentés partent. Il reste surtout des vétérans.</a:t>
             </a:r>
             <a:endParaRPr lang="en-US" dirty="0"/>
           </a:p>
@@ -1852,7 +1852,7 @@
           <a:p>
             <a:r>
               <a:rPr lang="en-US" dirty="0"/>
-              <a:t>[30 s] Et aujourd'hui ? Deux mécanismes entretiennent ces écarts. Pour les nouveaux, en partie rapide : faute de joueurs, le matchmaking accepte des écarts plus grands, NetEase l'a reconnu ; le nouveau tombe sur les vétérans et part. Pour les joueurs de retour, en classé : leur rang n'est abaissé que de six divisions, même après des mois d'absence ; ils affrontent des joueurs plus en forme, perdent, et repartent. C'est cohérent avec les retours de saison qui ne durent pas. Mais ce sont des hypothèses : seules vos données peuvent trancher.</a:t>
+              <a:t>[30 s] Aujourd'hui, deux mécanismes entretiennent ces écarts. En partie rapide, faute de joueurs, le matchmaking accepte des écarts plus grands, NetEase l'a reconnu : le nouveau tombe sur des vétérans et part. En classé, un joueur qui revient après des mois retrouve un rang à peine abaissé, perd, et repart. Ce sont des hypothèses : vos données trancheront.</a:t>
             </a:r>
             <a:endParaRPr lang="en-US" dirty="0"/>
           </a:p>
@@ -1940,7 +1940,7 @@
           <a:p>
             <a:r>
               <a:rPr lang="en-US" dirty="0"/>
-              <a:t>[45 s] Recommandation : d'abord mesurer. L'objectif traduit l'hypothèse en chiffre : un joueur qui perd au début ne doit pas partir plus de 1,2 fois plus souvent que les autres, chez les nouveaux comme chez les revenants, d'ici fin mars 2027. Six données d'abord. La première mesure l'objectif. La deuxième dit où jouent les nouveaux. Les trois suivantes testent chacune une cause : le niveau de départ, le manque de joueurs, le rang au retour. La dernière exploite une expérience que NetEase a déjà faite en saison 5. Tout est déjà dans vos serveurs.</a:t>
+              <a:t>[45 s] D'abord mesurer. L'objectif : d'ici fin mars 2027, un joueur qui perd au début ne doit pas partir plus de 1,2 fois plus souvent que les autres, nouveau ou de retour. Six données d'abord : la première mesure l'objectif, la deuxième dit où jouent les nouveaux, trois testent chacune une cause, la dernière exploite une expérience déjà faite en saison 5.</a:t>
             </a:r>
             <a:endParaRPr lang="en-US" dirty="0"/>
           </a:p>
@@ -2028,7 +2028,7 @@
           <a:p>
             <a:r>
               <a:rPr lang="en-US" dirty="0"/>
-              <a:t>[20 s] Voici la matrice complète. Chaque donnée est notée sur l'impact sur la décision, la confiance et la facilité. Treize sont indispensables, et toutes existent déjà dans votre télémétrie : l'audit ne demande aucune nouvelle collecte. Les données écartées, à droite, je les détaille juste après.</a:t>
+              <a:t>[15 s] La matrice complète : treize données indispensables, toutes déjà dans votre télémétrie. Aucune nouvelle collecte pour l'audit.</a:t>
             </a:r>
             <a:endParaRPr lang="en-US" dirty="0"/>
           </a:p>
@@ -2116,7 +2116,7 @@
           <a:p>
             <a:r>
               <a:rPr lang="en-US" dirty="0"/>
-              <a:t>[35 s] On ne teste que si l'audit confirme le problème, et on teste le levier de la cause trouvée. A, démarrage à froid : le jeu place mal un nouveau ; on rend le niveau de départ plus prudent. B, manque de joueurs : on resserre l'écart aux heures creuses, et on arrête si l'attente dépasse 5 minutes. C, rang périmé : on ajoute des matchs de recalibrage au retour d'une longue absence. Chaque test a son groupe témoin tiré au sort.</a:t>
+              <a:t>[35 s] On ne teste que si l'audit confirme le problème, et seulement le levier de la cause trouvée. Démarrage à froid : niveau de départ plus prudent. Manque de joueurs : écart resserré aux heures creuses, arrêté si l'attente dépasse 5 minutes. Rang périmé : matchs de recalibrage au retour. Toujours avec un groupe témoin.</a:t>
             </a:r>
             <a:endParaRPr lang="en-US" dirty="0"/>
           </a:p>
@@ -2204,7 +2204,7 @@
           <a:p>
             <a:r>
               <a:rPr lang="en-US" dirty="0"/>
-              <a:t>[20 s] Ce que nous avons volontairement écarté. Les données personnelles qu'aucune décision n'exige : historique sur d'autres jeux, chat, âge, téléphone. Le benchmark Newzoo, trop biaisé pour étudier des débutants. Les rôles imposés, contraires à l'identité du jeu. Et les avis Steam ne servent que de contrôle, jamais de preuve.</a:t>
+              <a:t>[20 s] Nous avons volontairement écarté les données personnelles qu'aucune décision n'exige, le benchmark Newzoo, trop biaisé, et les rôles imposés, contraires à l'identité du jeu.</a:t>
             </a:r>
             <a:endParaRPr lang="en-US" dirty="0"/>
           </a:p>
@@ -2292,7 +2292,7 @@
           <a:p>
             <a:r>
               <a:rPr lang="en-US" dirty="0"/>
-              <a:t>[60 s] La roadmap : quand, qui, combien. Trente jours d'audit, avec un data analyst à temps plein et un data engineer à mi-temps, soit environ 33 jours-homme, sans aucune licence nouvelle : tout passe par votre télémétrie, votre entrepôt et vos outils de BI. Si le ratio est déjà sous 1,2 sur les deux cohortes, on s'arrête et on bascule sur le plan B. Sinon, soixante jours de tests A/B avec votre équipe matchmaking, chiffrés par vos soins avant lancement. Puis généralisation et pilotage mensuel jusqu'au 31 mars 2027.</a:t>
+              <a:t>[60 s] Quand, qui, combien. Trente jours d'audit : un data analyst et un data engineer à mi-temps, environ 33 jours-homme, sans licence nouvelle, sur votre stack existante. Si le ratio est déjà sous 1,2, on s'arrête : plan B. Sinon, soixante jours de tests avec votre équipe matchmaking, puis généralisation jusqu'au 31 mars 2027.</a:t>
             </a:r>
             <a:endParaRPr lang="en-US" dirty="0"/>
           </a:p>

</xml_diff>

<commit_message>
Pitch : problème business énoncé en slide 2 ; export PDF retiré
Co-Authored-By: Claude Opus 5.5 <noreply@anthropic.com>
Claude-Session: https://claude.ai/code/session_012kyLDzFB57v6JCyVf6ygKi
</commit_message>
<xml_diff>
--- a/docs/presentation/pitch_marvel_rivals_netease.pptx
+++ b/docs/presentation/pitch_marvel_rivals_netease.pptx
@@ -1676,7 +1676,7 @@
           <a:p>
             <a:r>
               <a:rPr lang="en-US" dirty="0"/>
-              <a:t>[20 s] Le problème, prouvé par les données. Moins 85 % de pic à pic. Chaque saison ramène des joueurs, repartis en deux mois. Et ceux qui partent accusent le matchmaking : de 7 à 41 % des avis négatifs, au point que NetEase a dû démentir un matchmaking truqué.</a:t>
+              <a:t>[20 s] Le problème business : Marvel Rivals perd ses joueurs et ne parvient plus à en regagner. Les preuves : moins 85 % de pic à pic. Chaque saison ramène des joueurs, repartis en deux mois. Et ceux qui partent accusent le matchmaking : de 7 à 41 % des avis négatifs, au point que NetEase a dû démentir un matchmaking truqué.</a:t>
             </a:r>
             <a:endParaRPr lang="en-US" dirty="0"/>
           </a:p>
@@ -6970,7 +6970,7 @@
                 <a:ea typeface="Arial" pitchFamily="34" charset="-122"/>
                 <a:cs typeface="Arial" pitchFamily="34" charset="-120"/>
               </a:rPr>
-              <a:t>Le jeu perd ses joueurs et ne les regagne pas</a:t>
+              <a:t>Le problème business</a:t>
             </a:r>
             <a:endParaRPr lang="en-US" sz="2600" dirty="0"/>
           </a:p>
@@ -7015,15 +7015,95 @@
           </a:p>
         </p:txBody>
       </p:sp>
+      <p:sp>
+        <p:nvSpPr>
+          <p:cNvPr id="4" name="Shape 2"/>
+          <p:cNvSpPr/>
+          <p:nvPr/>
+        </p:nvSpPr>
+        <p:spPr>
+          <a:xfrm>
+            <a:off x="457200" y="1143000"/>
+            <a:ext cx="8229600" cy="566928"/>
+          </a:xfrm>
+          <a:prstGeom prst="roundRect">
+            <a:avLst>
+              <a:gd name="adj" fmla="val 12903"/>
+            </a:avLst>
+          </a:prstGeom>
+          <a:solidFill>
+            <a:srgbClr val="161A33"/>
+          </a:solidFill>
+          <a:ln w="12700">
+            <a:solidFill>
+              <a:srgbClr val="161A33"/>
+            </a:solidFill>
+            <a:prstDash val="solid"/>
+          </a:ln>
+        </p:spPr>
+      </p:sp>
+      <p:sp>
+        <p:nvSpPr>
+          <p:cNvPr id="5" name="Text 3"/>
+          <p:cNvSpPr txBox="1"/>
+          <p:nvPr/>
+        </p:nvSpPr>
+        <p:spPr>
+          <a:xfrm>
+            <a:off x="640080" y="1161288"/>
+            <a:ext cx="7863840" cy="530352"/>
+          </a:xfrm>
+          <a:prstGeom prst="rect">
+            <a:avLst/>
+          </a:prstGeom>
+          <a:noFill/>
+          <a:ln/>
+        </p:spPr>
+        <p:txBody>
+          <a:bodyPr wrap="square" lIns="0" tIns="0" rIns="0" bIns="0" rtlCol="0" anchor="ctr"/>
+          <a:lstStyle/>
+          <a:p>
+            <a:pPr indent="0" marL="0">
+              <a:buNone/>
+            </a:pPr>
+            <a:r>
+              <a:rPr lang="en-US" sz="1300" b="1" dirty="0">
+                <a:solidFill>
+                  <a:srgbClr val="E23636"/>
+                </a:solidFill>
+                <a:latin typeface="Calibri" pitchFamily="34" charset="0"/>
+                <a:ea typeface="Calibri" pitchFamily="34" charset="-122"/>
+                <a:cs typeface="Calibri" pitchFamily="34" charset="-120"/>
+              </a:rPr>
+              <a:t>B : </a:t>
+            </a:r>
+            <a:pPr indent="0" marL="0">
+              <a:buNone/>
+            </a:pPr>
+            <a:r>
+              <a:rPr lang="en-US" sz="1300" dirty="0">
+                <a:solidFill>
+                  <a:srgbClr val="FFFFFF"/>
+                </a:solidFill>
+                <a:latin typeface="Calibri" pitchFamily="34" charset="0"/>
+                <a:ea typeface="Calibri" pitchFamily="34" charset="-122"/>
+                <a:cs typeface="Calibri" pitchFamily="34" charset="-120"/>
+              </a:rPr>
+              <a:t>Marvel Rivals perd ses joueurs et ne parvient plus à en regagner ; ceux qui partent accusent d'abord le matchmaking.</a:t>
+            </a:r>
+            <a:endParaRPr lang="en-US" sz="1300" dirty="0"/>
+          </a:p>
+        </p:txBody>
+      </p:sp>
       <p:graphicFrame>
         <p:nvGraphicFramePr>
-          <p:cNvPr id="4" name="Chart 0" descr=""/>
+          <p:cNvPr id="6" name="Chart 0" descr=""/>
           <p:cNvGraphicFramePr/>
           <p:nvPr/>
         </p:nvGraphicFramePr>
         <p:xfrm>
-          <a:off x="320040" y="1143000"/>
-          <a:ext cx="4251960" cy="2514600"/>
+          <a:off x="320040" y="1783080"/>
+          <a:ext cx="4251960" cy="1965960"/>
         </p:xfrm>
         <a:graphic xmlns:a="http://schemas.openxmlformats.org/drawingml/2006/main">
           <a:graphicData uri="http://schemas.openxmlformats.org/drawingml/2006/chart">
@@ -7033,13 +7113,13 @@
       </p:graphicFrame>
       <p:graphicFrame>
         <p:nvGraphicFramePr>
-          <p:cNvPr id="5" name="Chart 1" descr=""/>
+          <p:cNvPr id="7" name="Chart 1" descr=""/>
           <p:cNvGraphicFramePr/>
           <p:nvPr/>
         </p:nvGraphicFramePr>
         <p:xfrm>
-          <a:off x="4572000" y="1143000"/>
-          <a:ext cx="4251960" cy="2514600"/>
+          <a:off x="4572000" y="1783080"/>
+          <a:ext cx="4251960" cy="1965960"/>
         </p:xfrm>
         <a:graphic xmlns:a="http://schemas.openxmlformats.org/drawingml/2006/main">
           <a:graphicData uri="http://schemas.openxmlformats.org/drawingml/2006/chart">
@@ -7049,14 +7129,14 @@
       </p:graphicFrame>
       <p:sp>
         <p:nvSpPr>
-          <p:cNvPr id="6" name="Text 2"/>
+          <p:cNvPr id="8" name="Text 4"/>
           <p:cNvSpPr txBox="1"/>
           <p:nvPr/>
         </p:nvSpPr>
         <p:spPr>
           <a:xfrm>
-            <a:off x="457200" y="3749040"/>
-            <a:ext cx="2651760" cy="411480"/>
+            <a:off x="457200" y="3794760"/>
+            <a:ext cx="2651760" cy="384048"/>
           </a:xfrm>
           <a:prstGeom prst="rect">
             <a:avLst/>
@@ -7072,7 +7152,7 @@
               <a:buNone/>
             </a:pPr>
             <a:r>
-              <a:rPr lang="en-US" sz="2200" b="1" dirty="0">
+              <a:rPr lang="en-US" sz="2000" b="1" dirty="0">
                 <a:solidFill>
                   <a:srgbClr val="E23636"/>
                 </a:solidFill>
@@ -7082,19 +7162,19 @@
               </a:rPr>
               <a:t>−85 %</a:t>
             </a:r>
-            <a:endParaRPr lang="en-US" sz="2200" dirty="0"/>
-          </a:p>
-        </p:txBody>
-      </p:sp>
-      <p:sp>
-        <p:nvSpPr>
-          <p:cNvPr id="7" name="Text 3"/>
+            <a:endParaRPr lang="en-US" sz="2000" dirty="0"/>
+          </a:p>
+        </p:txBody>
+      </p:sp>
+      <p:sp>
+        <p:nvSpPr>
+          <p:cNvPr id="9" name="Text 5"/>
           <p:cNvSpPr txBox="1"/>
           <p:nvPr/>
         </p:nvSpPr>
         <p:spPr>
           <a:xfrm>
-            <a:off x="457200" y="4160520"/>
+            <a:off x="457200" y="4178808"/>
             <a:ext cx="2651760" cy="548640"/>
           </a:xfrm>
           <a:prstGeom prst="rect">
@@ -7111,7 +7191,7 @@
               <a:buNone/>
             </a:pPr>
             <a:r>
-              <a:rPr lang="en-US" sz="1000" dirty="0">
+              <a:rPr lang="en-US" sz="950" dirty="0">
                 <a:solidFill>
                   <a:srgbClr val="1F2233"/>
                 </a:solidFill>
@@ -7121,20 +7201,20 @@
               </a:rPr>
               <a:t>de pic à pic (644 K → 98 K) ; −76 % en moyenne depuis la sortie</a:t>
             </a:r>
-            <a:endParaRPr lang="en-US" sz="1000" dirty="0"/>
-          </a:p>
-        </p:txBody>
-      </p:sp>
-      <p:sp>
-        <p:nvSpPr>
-          <p:cNvPr id="8" name="Text 4"/>
+            <a:endParaRPr lang="en-US" sz="950" dirty="0"/>
+          </a:p>
+        </p:txBody>
+      </p:sp>
+      <p:sp>
+        <p:nvSpPr>
+          <p:cNvPr id="10" name="Text 6"/>
           <p:cNvSpPr txBox="1"/>
           <p:nvPr/>
         </p:nvSpPr>
         <p:spPr>
           <a:xfrm>
-            <a:off x="3246120" y="3749040"/>
-            <a:ext cx="2651760" cy="411480"/>
+            <a:off x="3246120" y="3794760"/>
+            <a:ext cx="2651760" cy="384048"/>
           </a:xfrm>
           <a:prstGeom prst="rect">
             <a:avLst/>
@@ -7150,7 +7230,7 @@
               <a:buNone/>
             </a:pPr>
             <a:r>
-              <a:rPr lang="en-US" sz="2200" b="1" dirty="0">
+              <a:rPr lang="en-US" sz="2000" b="1" dirty="0">
                 <a:solidFill>
                   <a:srgbClr val="E23636"/>
                 </a:solidFill>
@@ -7160,19 +7240,19 @@
               </a:rPr>
               <a:t>2 mois</a:t>
             </a:r>
-            <a:endParaRPr lang="en-US" sz="2200" dirty="0"/>
-          </a:p>
-        </p:txBody>
-      </p:sp>
-      <p:sp>
-        <p:nvSpPr>
-          <p:cNvPr id="9" name="Text 5"/>
+            <a:endParaRPr lang="en-US" sz="2000" dirty="0"/>
+          </a:p>
+        </p:txBody>
+      </p:sp>
+      <p:sp>
+        <p:nvSpPr>
+          <p:cNvPr id="11" name="Text 7"/>
           <p:cNvSpPr txBox="1"/>
           <p:nvPr/>
         </p:nvSpPr>
         <p:spPr>
           <a:xfrm>
-            <a:off x="3246120" y="4160520"/>
+            <a:off x="3246120" y="4178808"/>
             <a:ext cx="2651760" cy="548640"/>
           </a:xfrm>
           <a:prstGeom prst="rect">
@@ -7189,7 +7269,7 @@
               <a:buNone/>
             </a:pPr>
             <a:r>
-              <a:rPr lang="en-US" sz="1000" dirty="0">
+              <a:rPr lang="en-US" sz="950" dirty="0">
                 <a:solidFill>
                   <a:srgbClr val="1F2233"/>
                 </a:solidFill>
@@ -7199,20 +7279,20 @@
               </a:rPr>
               <a:t>pour perdre les joueurs ramenés par une saison (+18 % en janv. 2026, +21 % en juil.)</a:t>
             </a:r>
-            <a:endParaRPr lang="en-US" sz="1000" dirty="0"/>
-          </a:p>
-        </p:txBody>
-      </p:sp>
-      <p:sp>
-        <p:nvSpPr>
-          <p:cNvPr id="10" name="Text 6"/>
+            <a:endParaRPr lang="en-US" sz="950" dirty="0"/>
+          </a:p>
+        </p:txBody>
+      </p:sp>
+      <p:sp>
+        <p:nvSpPr>
+          <p:cNvPr id="12" name="Text 8"/>
           <p:cNvSpPr txBox="1"/>
           <p:nvPr/>
         </p:nvSpPr>
         <p:spPr>
           <a:xfrm>
-            <a:off x="6035040" y="3749040"/>
-            <a:ext cx="2651760" cy="411480"/>
+            <a:off x="6035040" y="3794760"/>
+            <a:ext cx="2651760" cy="384048"/>
           </a:xfrm>
           <a:prstGeom prst="rect">
             <a:avLst/>
@@ -7228,7 +7308,7 @@
               <a:buNone/>
             </a:pPr>
             <a:r>
-              <a:rPr lang="en-US" sz="2200" b="1" dirty="0">
+              <a:rPr lang="en-US" sz="2000" b="1" dirty="0">
                 <a:solidFill>
                   <a:srgbClr val="161A33"/>
                 </a:solidFill>
@@ -7238,19 +7318,19 @@
               </a:rPr>
               <a:t>7 → 41 %</a:t>
             </a:r>
-            <a:endParaRPr lang="en-US" sz="2200" dirty="0"/>
-          </a:p>
-        </p:txBody>
-      </p:sp>
-      <p:sp>
-        <p:nvSpPr>
-          <p:cNvPr id="11" name="Text 7"/>
+            <a:endParaRPr lang="en-US" sz="2000" dirty="0"/>
+          </a:p>
+        </p:txBody>
+      </p:sp>
+      <p:sp>
+        <p:nvSpPr>
+          <p:cNvPr id="13" name="Text 9"/>
           <p:cNvSpPr txBox="1"/>
           <p:nvPr/>
         </p:nvSpPr>
         <p:spPr>
           <a:xfrm>
-            <a:off x="6035040" y="4160520"/>
+            <a:off x="6035040" y="4178808"/>
             <a:ext cx="2651760" cy="548640"/>
           </a:xfrm>
           <a:prstGeom prst="rect">
@@ -7267,7 +7347,7 @@
               <a:buNone/>
             </a:pPr>
             <a:r>
-              <a:rPr lang="en-US" sz="1000" dirty="0">
+              <a:rPr lang="en-US" sz="950" dirty="0">
                 <a:solidFill>
                   <a:srgbClr val="1F2233"/>
                 </a:solidFill>
@@ -7277,13 +7357,13 @@
               </a:rPr>
               <a:t>des avis négatifs accusent le matchmaking ; NetEase a dû démentir un matchmaking truqué</a:t>
             </a:r>
-            <a:endParaRPr lang="en-US" sz="1000" dirty="0"/>
-          </a:p>
-        </p:txBody>
-      </p:sp>
-      <p:sp>
-        <p:nvSpPr>
-          <p:cNvPr id="12" name="Text 8"/>
+            <a:endParaRPr lang="en-US" sz="950" dirty="0"/>
+          </a:p>
+        </p:txBody>
+      </p:sp>
+      <p:sp>
+        <p:nvSpPr>
+          <p:cNvPr id="14" name="Text 10"/>
           <p:cNvSpPr txBox="1"/>
           <p:nvPr/>
         </p:nvSpPr>
@@ -7448,7 +7528,7 @@
       </p:sp>
       <p:sp>
         <p:nvSpPr>
-          <p:cNvPr id="13" name="Text 9"/>
+          <p:cNvPr id="15" name="Text 11"/>
           <p:cNvSpPr txBox="1"/>
           <p:nvPr/>
         </p:nvSpPr>

</xml_diff>

<commit_message>
Pitch : 1,2 décide s'il faut agir, les causes A, B et C peuvent se cumuler
Co-Authored-By: Claude Opus 5.5 <noreply@anthropic.com>
Claude-Session: https://claude.ai/code/session_012kyLDzFB57v6JCyVf6ygKi
</commit_message>
<xml_diff>
--- a/docs/presentation/pitch_marvel_rivals_netease.pptx
+++ b/docs/presentation/pitch_marvel_rivals_netease.pptx
@@ -1939,7 +1939,7 @@
           <a:p>
             <a:r>
               <a:rPr lang="en-US" dirty="0"/>
-              <a:t>[35 s] On ne teste que si l'audit confirme le problème, et seulement le levier de la cause trouvée. Démarrage à froid : niveau de départ plus prudent. Manque de joueurs : écart resserré aux heures creuses, arrêté si l'attente dépasse 3 minutes. Rang périmé : matchs de recalibrage au retour. Toujours avec un groupe témoin.</a:t>
+              <a:t>[35 s] On ne teste que si le ratio dépasse 1,2, et seulement les causes que l'audit confirme : une, deux ou les trois, chacune avec son levier. Démarrage à froid : niveau de départ plus prudent. Manque de joueurs : écart resserré aux heures creuses, arrêté si l'attente dépasse 3 minutes. Rang périmé : matchs de recalibrage au retour. Toujours avec un groupe témoin.</a:t>
             </a:r>
             <a:endParaRPr lang="en-US" dirty="0"/>
           </a:p>
@@ -3750,7 +3750,7 @@
                 <a:ea typeface="Calibri" pitchFamily="34" charset="-122"/>
                 <a:cs typeface="Calibri" pitchFamily="34" charset="-120"/>
               </a:rPr>
-              <a:t>Score ICE le plus haut, et elle tranche directement l'hypothèse (départ à 7 jours, cause A, B ou C).</a:t>
+              <a:t>Score ICE le plus haut, et elle tranche directement l'hypothèse (départ à 7 jours, causes A, B et C).</a:t>
             </a:r>
             <a:endParaRPr lang="en-US" sz="1000" dirty="0"/>
           </a:p>
@@ -13297,7 +13297,7 @@
                 <a:ea typeface="Arial" pitchFamily="34" charset="-122"/>
                 <a:cs typeface="Arial" pitchFamily="34" charset="-120"/>
               </a:rPr>
-              <a:t>Puis tester le levier qui correspond à la cause</a:t>
+              <a:t>Puis tester le levier de chaque cause confirmée</a:t>
             </a:r>
             <a:endParaRPr lang="en-US" sz="2600" dirty="0"/>
           </a:p>
@@ -13336,7 +13336,7 @@
                 <a:ea typeface="Calibri" pitchFamily="34" charset="-122"/>
                 <a:cs typeface="Calibri" pitchFamily="34" charset="-120"/>
               </a:rPr>
-              <a:t>Recommandation · tests A/B de 60 jours, seulement si l'audit confirme le problème</a:t>
+              <a:t>Recommandation · tests A/B de 60 jours si le ratio dépasse 1,2 ; les causes peuvent se cumuler</a:t>
             </a:r>
             <a:endParaRPr lang="en-US" sz="1200" dirty="0"/>
           </a:p>
@@ -13543,7 +13543,7 @@
                 <a:ea typeface="Calibri" pitchFamily="34" charset="-122"/>
                 <a:cs typeface="Calibri" pitchFamily="34" charset="-120"/>
               </a:rPr>
-              <a:t>Écart fort sur les premiers matchs, à toute heure.</a:t>
+              <a:t>Écart déjà fort aux heures pleines, quand la file est remplie.</a:t>
             </a:r>
             <a:endParaRPr lang="en-US" sz="950" dirty="0"/>
           </a:p>
@@ -13825,7 +13825,7 @@
                 <a:ea typeface="Calibri" pitchFamily="34" charset="-122"/>
                 <a:cs typeface="Calibri" pitchFamily="34" charset="-120"/>
               </a:rPr>
-              <a:t>L'écart grandit quand la file se vide.</a:t>
+              <a:t>Écart en plus aux heures creuses, quand la file se vide.</a:t>
             </a:r>
             <a:endParaRPr lang="en-US" sz="950" dirty="0"/>
           </a:p>
@@ -15651,7 +15651,7 @@
                 <a:ea typeface="Calibri" pitchFamily="34" charset="-122"/>
                 <a:cs typeface="Calibri" pitchFamily="34" charset="-120"/>
               </a:rPr>
-              <a:t>Ratio ≤ 1,2 sur les deux cohortes → plan B</a:t>
+              <a:t>Cohorte &gt; 1,2 → tests de ses causes ; les deux ≤ 1,2 → plan B</a:t>
             </a:r>
             <a:endParaRPr lang="en-US" sz="950" dirty="0"/>
           </a:p>
@@ -17277,7 +17277,7 @@
                           <a:ea typeface="Calibri" pitchFamily="34" charset="-122"/>
                           <a:cs typeface="Calibri" pitchFamily="34" charset="-120"/>
                         </a:rPr>
-                        <a:t>H5 tient : tests A/B des causes A ou B</a:t>
+                        <a:t>H5 tient : tests des causes confirmées (A, B ou les deux)</a:t>
                       </a:r>
                       <a:endParaRPr lang="en-US" sz="850" dirty="0">
                         <a:latin typeface="Calibri" charset="0"/>

</xml_diff>

<commit_message>
Pitch : données des joueurs de retour détaillées, en classé et en partie rapide
Co-Authored-By: Claude Opus 5.5 <noreply@anthropic.com>
Claude-Session: https://claude.ai/code/session_012kyLDzFB57v6JCyVf6ygKi
</commit_message>
<xml_diff>
--- a/docs/presentation/pitch_marvel_rivals_netease.pptx
+++ b/docs/presentation/pitch_marvel_rivals_netease.pptx
@@ -1852,7 +1852,7 @@
           <a:p>
             <a:r>
               <a:rPr lang="en-US" dirty="0"/>
-              <a:t>[45 s] D'abord mesurer. L'objectif : d'ici fin mars 2027, un joueur qui perd au début ne doit pas partir plus de 1,2 fois plus souvent que les autres, nouveau ou de retour. Six données d'abord : la première mesure l'objectif, la deuxième dit où jouent les nouveaux, trois testent chacune une cause, la dernière exploite une expérience déjà faite en saison 5.</a:t>
+              <a:t>[45 s] D'abord mesurer. L'objectif : d'ici fin mars 2027, un joueur qui perd au début ne doit pas partir plus de 1,2 fois plus souvent que les autres, nouveau ou de retour. Sept données d'abord : la première mesure l'objectif, la deuxième dit où jouent les nouveaux, quatre testent les causes, dont deux pour les joueurs de retour, en classé et hors classé, car un revenant ne rejoue pas forcément en classé. La dernière exploite une expérience déjà faite en saison 5.</a:t>
             </a:r>
             <a:endParaRPr lang="en-US" dirty="0"/>
           </a:p>
@@ -1940,7 +1940,7 @@
           <a:p>
             <a:r>
               <a:rPr lang="en-US" dirty="0"/>
-              <a:t>[15 s] Chaque donnée est notée sur l'impact, la confiance et la facilité ; le score est leur produit. Treize dépassent 80, toutes déjà dans votre télémétrie. Le chat ou le téléphone tombent sous 30 : risque RGPD sans décision.</a:t>
+              <a:t>[15 s] Chaque donnée est notée sur l'impact, la confiance et la facilité ; le score est leur produit. Quinze dépassent 80, toutes déjà dans votre télémétrie. Le chat ou le téléphone tombent sous 30 : risque RGPD sans décision.</a:t>
             </a:r>
             <a:endParaRPr lang="en-US" dirty="0"/>
           </a:p>
@@ -2028,7 +2028,7 @@
           <a:p>
             <a:r>
               <a:rPr lang="en-US" dirty="0"/>
-              <a:t>[35 s] On ne teste que si le ratio dépasse 1,2, et seulement les causes que l'audit confirme : une, deux ou les trois, chacune avec son levier. Démarrage à froid : niveau de départ plus prudent. Manque de joueurs : écart resserré aux heures creuses, arrêté si l'attente dépasse 3 minutes. Rang périmé : matchs de recalibrage au retour. Toujours avec un groupe témoin.</a:t>
+              <a:t>[35 s] On ne teste que si le ratio dépasse 1,2, et seulement les causes que l'audit confirme : une, deux ou les trois, chacune avec son levier. Démarrage à froid : niveau de départ plus prudent. Manque de joueurs : écart resserré aux heures creuses, arrêté si l'attente dépasse 3 minutes. Niveau périmé : recalibrage au retour, en classé comme en partie rapide. Toujours avec un groupe témoin.</a:t>
             </a:r>
             <a:endParaRPr lang="en-US" dirty="0"/>
           </a:p>
@@ -3864,7 +3864,7 @@
                           <a:ea typeface="Calibri" pitchFamily="34" charset="-122"/>
                           <a:cs typeface="Calibri" pitchFamily="34" charset="-120"/>
                         </a:rPr>
-                        <a:t>Même calcul sur les 10 premiers matchs classés après au moins 60 jours d'absence</a:t>
+                        <a:t>Même calcul sur les 10 premiers matchs après au moins 60 jours d'absence, classé et partie rapide séparés</a:t>
                       </a:r>
                       <a:endParaRPr lang="en-US" sz="850" dirty="0">
                         <a:latin typeface="Calibri" charset="0"/>
@@ -4000,7 +4000,7 @@
                           <a:ea typeface="Calibri" pitchFamily="34" charset="-122"/>
                           <a:cs typeface="Calibri" pitchFamily="34" charset="-120"/>
                         </a:rPr>
-                        <a:t>H5c tient : test des matchs de recalibrage (cause C)</a:t>
+                        <a:t>H5c tient : recalibrage au retour (cause C) dans le mode concerné</a:t>
                       </a:r>
                       <a:endParaRPr lang="en-US" sz="850" dirty="0">
                         <a:latin typeface="Calibri" charset="0"/>
@@ -4068,7 +4068,7 @@
                           <a:ea typeface="Calibri" pitchFamily="34" charset="-122"/>
                           <a:cs typeface="Calibri" pitchFamily="34" charset="-120"/>
                         </a:rPr>
-                        <a:t>Rang au retour inchangé</a:t>
+                        <a:t>Niveau au retour inchangé</a:t>
                       </a:r>
                       <a:endParaRPr lang="en-US" sz="850" dirty="0">
                         <a:latin typeface="Calibri" charset="0"/>
@@ -7999,7 +7999,7 @@
                 <a:ea typeface="Arial" pitchFamily="34" charset="-122"/>
                 <a:cs typeface="Arial" pitchFamily="34" charset="-120"/>
               </a:rPr>
-              <a:t>H5c · Les joueurs de retour, en classé</a:t>
+              <a:t>H5c · Les joueurs de retour</a:t>
             </a:r>
             <a:endParaRPr lang="en-US" sz="1300" dirty="0"/>
           </a:p>
@@ -8052,7 +8052,7 @@
                 <a:ea typeface="Calibri" pitchFamily="34" charset="-122"/>
                 <a:cs typeface="Calibri" pitchFamily="34" charset="-120"/>
               </a:rPr>
-              <a:t>À chaque saison, le rang n'est abaissé que de 6 divisions, quelle que soit la durée de l'absence (Dev Talk Vol.10).</a:t>
+              <a:t>En classé, le rang n'est abaissé que de 6 divisions par saison, quelle que soit l'absence (Dev Talk Vol.10). En partie rapide, rien n'indique que le niveau caché baisse (à vérifier).</a:t>
             </a:r>
             <a:endParaRPr lang="en-US" sz="1050" dirty="0"/>
           </a:p>
@@ -8624,11 +8624,11 @@
             <a:tbl>
               <a:tblPr/>
               <a:tblGrid>
-                <a:gridCol w="3200400"/>
-                <a:gridCol w="2377440"/>
-                <a:gridCol w="2651760"/>
+                <a:gridCol w="3611880"/>
+                <a:gridCol w="2194560"/>
+                <a:gridCol w="2423160"/>
               </a:tblGrid>
-              <a:tr h="237744">
+              <a:tr h="228600">
                 <a:tc>
                   <a:txBody>
                     <a:bodyPr/>
@@ -8834,7 +8834,7 @@
                   </a:tcPr>
                 </a:tc>
               </a:tr>
-              <a:tr h="329184">
+              <a:tr h="256032">
                 <a:tc>
                   <a:txBody>
                     <a:bodyPr/>
@@ -8844,7 +8844,7 @@
                         <a:buNone/>
                       </a:pPr>
                       <a:r>
-                        <a:rPr lang="en-US" sz="900" dirty="0">
+                        <a:rPr lang="en-US" sz="850" dirty="0">
                           <a:solidFill>
                             <a:srgbClr val="1F2233"/>
                           </a:solidFill>
@@ -8854,7 +8854,7 @@
                         </a:rPr>
                         <a:t>Résultats des 10 premiers matchs et départ à 7 jours</a:t>
                       </a:r>
-                      <a:endParaRPr lang="en-US" sz="900" dirty="0">
+                      <a:endParaRPr lang="en-US" sz="850" dirty="0">
                         <a:latin typeface="Calibri" charset="0"/>
                         <a:ea typeface="Calibri" charset="0"/>
                         <a:cs typeface="Calibri" charset="0"/>
@@ -8912,7 +8912,7 @@
                         <a:buNone/>
                       </a:pPr>
                       <a:r>
-                        <a:rPr lang="en-US" sz="900" dirty="0">
+                        <a:rPr lang="en-US" sz="850" dirty="0">
                           <a:solidFill>
                             <a:srgbClr val="1F2233"/>
                           </a:solidFill>
@@ -8922,7 +8922,7 @@
                         </a:rPr>
                         <a:t>Si perdre au début fait partir</a:t>
                       </a:r>
-                      <a:endParaRPr lang="en-US" sz="900" dirty="0">
+                      <a:endParaRPr lang="en-US" sz="850" dirty="0">
                         <a:latin typeface="Calibri" charset="0"/>
                         <a:ea typeface="Calibri" charset="0"/>
                         <a:cs typeface="Calibri" charset="0"/>
@@ -8980,7 +8980,7 @@
                         <a:buNone/>
                       </a:pPr>
                       <a:r>
-                        <a:rPr lang="en-US" sz="900" dirty="0">
+                        <a:rPr lang="en-US" sz="850" dirty="0">
                           <a:solidFill>
                             <a:srgbClr val="1F2233"/>
                           </a:solidFill>
@@ -8990,7 +8990,7 @@
                         </a:rPr>
                         <a:t>C'est la mesure de l'objectif</a:t>
                       </a:r>
-                      <a:endParaRPr lang="en-US" sz="900" dirty="0">
+                      <a:endParaRPr lang="en-US" sz="850" dirty="0">
                         <a:latin typeface="Calibri" charset="0"/>
                         <a:ea typeface="Calibri" charset="0"/>
                         <a:cs typeface="Calibri" charset="0"/>
@@ -9040,7 +9040,7 @@
                   </a:tcPr>
                 </a:tc>
               </a:tr>
-              <a:tr h="329184">
+              <a:tr h="256032">
                 <a:tc>
                   <a:txBody>
                     <a:bodyPr/>
@@ -9050,7 +9050,7 @@
                         <a:buNone/>
                       </a:pPr>
                       <a:r>
-                        <a:rPr lang="en-US" sz="900" dirty="0">
+                        <a:rPr lang="en-US" sz="850" dirty="0">
                           <a:solidFill>
                             <a:srgbClr val="1F2233"/>
                           </a:solidFill>
@@ -9060,7 +9060,7 @@
                         </a:rPr>
                         <a:t>Mode et plateforme de ces 10 premiers matchs</a:t>
                       </a:r>
-                      <a:endParaRPr lang="en-US" sz="900" dirty="0">
+                      <a:endParaRPr lang="en-US" sz="850" dirty="0">
                         <a:latin typeface="Calibri" charset="0"/>
                         <a:ea typeface="Calibri" charset="0"/>
                         <a:cs typeface="Calibri" charset="0"/>
@@ -9118,7 +9118,7 @@
                         <a:buNone/>
                       </a:pPr>
                       <a:r>
-                        <a:rPr lang="en-US" sz="900" dirty="0">
+                        <a:rPr lang="en-US" sz="850" dirty="0">
                           <a:solidFill>
                             <a:srgbClr val="1F2233"/>
                           </a:solidFill>
@@ -9128,7 +9128,7 @@
                         </a:rPr>
                         <a:t>Où jouent les nouveaux</a:t>
                       </a:r>
-                      <a:endParaRPr lang="en-US" sz="900" dirty="0">
+                      <a:endParaRPr lang="en-US" sz="850" dirty="0">
                         <a:latin typeface="Calibri" charset="0"/>
                         <a:ea typeface="Calibri" charset="0"/>
                         <a:cs typeface="Calibri" charset="0"/>
@@ -9186,7 +9186,7 @@
                         <a:buNone/>
                       </a:pPr>
                       <a:r>
-                        <a:rPr lang="en-US" sz="900" dirty="0">
+                        <a:rPr lang="en-US" sz="850" dirty="0">
                           <a:solidFill>
                             <a:srgbClr val="1F2233"/>
                           </a:solidFill>
@@ -9196,7 +9196,7 @@
                         </a:rPr>
                         <a:t>Dit quel mode corriger en premier (Steam = PC seul)</a:t>
                       </a:r>
-                      <a:endParaRPr lang="en-US" sz="900" dirty="0">
+                      <a:endParaRPr lang="en-US" sz="850" dirty="0">
                         <a:latin typeface="Calibri" charset="0"/>
                         <a:ea typeface="Calibri" charset="0"/>
                         <a:cs typeface="Calibri" charset="0"/>
@@ -9246,7 +9246,7 @@
                   </a:tcPr>
                 </a:tc>
               </a:tr>
-              <a:tr h="329184">
+              <a:tr h="256032">
                 <a:tc>
                   <a:txBody>
                     <a:bodyPr/>
@@ -9256,7 +9256,7 @@
                         <a:buNone/>
                       </a:pPr>
                       <a:r>
-                        <a:rPr lang="en-US" sz="900" dirty="0">
+                        <a:rPr lang="en-US" sz="850" dirty="0">
                           <a:solidFill>
                             <a:srgbClr val="1F2233"/>
                           </a:solidFill>
@@ -9266,7 +9266,7 @@
                         </a:rPr>
                         <a:t>Niveau de départ attribué / niveau réel après 50 matchs</a:t>
                       </a:r>
-                      <a:endParaRPr lang="en-US" sz="900" dirty="0">
+                      <a:endParaRPr lang="en-US" sz="850" dirty="0">
                         <a:latin typeface="Calibri" charset="0"/>
                         <a:ea typeface="Calibri" charset="0"/>
                         <a:cs typeface="Calibri" charset="0"/>
@@ -9324,7 +9324,7 @@
                         <a:buNone/>
                       </a:pPr>
                       <a:r>
-                        <a:rPr lang="en-US" sz="900" dirty="0">
+                        <a:rPr lang="en-US" sz="850" dirty="0">
                           <a:solidFill>
                             <a:srgbClr val="1F2233"/>
                           </a:solidFill>
@@ -9334,7 +9334,7 @@
                         </a:rPr>
                         <a:t>Si le jeu place mal un nouveau</a:t>
                       </a:r>
-                      <a:endParaRPr lang="en-US" sz="900" dirty="0">
+                      <a:endParaRPr lang="en-US" sz="850" dirty="0">
                         <a:latin typeface="Calibri" charset="0"/>
                         <a:ea typeface="Calibri" charset="0"/>
                         <a:cs typeface="Calibri" charset="0"/>
@@ -9392,7 +9392,7 @@
                         <a:buNone/>
                       </a:pPr>
                       <a:r>
-                        <a:rPr lang="en-US" sz="900" dirty="0">
+                        <a:rPr lang="en-US" sz="850" dirty="0">
                           <a:solidFill>
                             <a:srgbClr val="1F2233"/>
                           </a:solidFill>
@@ -9402,7 +9402,7 @@
                         </a:rPr>
                         <a:t>Teste la cause A (démarrage à froid)</a:t>
                       </a:r>
-                      <a:endParaRPr lang="en-US" sz="900" dirty="0">
+                      <a:endParaRPr lang="en-US" sz="850" dirty="0">
                         <a:latin typeface="Calibri" charset="0"/>
                         <a:ea typeface="Calibri" charset="0"/>
                         <a:cs typeface="Calibri" charset="0"/>
@@ -9452,7 +9452,7 @@
                   </a:tcPr>
                 </a:tc>
               </a:tr>
-              <a:tr h="329184">
+              <a:tr h="256032">
                 <a:tc>
                   <a:txBody>
                     <a:bodyPr/>
@@ -9462,7 +9462,7 @@
                         <a:buNone/>
                       </a:pPr>
                       <a:r>
-                        <a:rPr lang="en-US" sz="900" dirty="0">
+                        <a:rPr lang="en-US" sz="850" dirty="0">
                           <a:solidFill>
                             <a:srgbClr val="1F2233"/>
                           </a:solidFill>
@@ -9472,7 +9472,7 @@
                         </a:rPr>
                         <a:t>Écart de niveau par match, selon les joueurs en file, l'heure, la région</a:t>
                       </a:r>
-                      <a:endParaRPr lang="en-US" sz="900" dirty="0">
+                      <a:endParaRPr lang="en-US" sz="850" dirty="0">
                         <a:latin typeface="Calibri" charset="0"/>
                         <a:ea typeface="Calibri" charset="0"/>
                         <a:cs typeface="Calibri" charset="0"/>
@@ -9530,7 +9530,7 @@
                         <a:buNone/>
                       </a:pPr>
                       <a:r>
-                        <a:rPr lang="en-US" sz="900" dirty="0">
+                        <a:rPr lang="en-US" sz="850" dirty="0">
                           <a:solidFill>
                             <a:srgbClr val="1F2233"/>
                           </a:solidFill>
@@ -9540,7 +9540,7 @@
                         </a:rPr>
                         <a:t>Si l'écart grandit quand la file se vide</a:t>
                       </a:r>
-                      <a:endParaRPr lang="en-US" sz="900" dirty="0">
+                      <a:endParaRPr lang="en-US" sz="850" dirty="0">
                         <a:latin typeface="Calibri" charset="0"/>
                         <a:ea typeface="Calibri" charset="0"/>
                         <a:cs typeface="Calibri" charset="0"/>
@@ -9598,7 +9598,7 @@
                         <a:buNone/>
                       </a:pPr>
                       <a:r>
-                        <a:rPr lang="en-US" sz="900" dirty="0">
+                        <a:rPr lang="en-US" sz="850" dirty="0">
                           <a:solidFill>
                             <a:srgbClr val="1F2233"/>
                           </a:solidFill>
@@ -9608,7 +9608,7 @@
                         </a:rPr>
                         <a:t>Teste la cause B (manque de joueurs)</a:t>
                       </a:r>
-                      <a:endParaRPr lang="en-US" sz="900" dirty="0">
+                      <a:endParaRPr lang="en-US" sz="850" dirty="0">
                         <a:latin typeface="Calibri" charset="0"/>
                         <a:ea typeface="Calibri" charset="0"/>
                         <a:cs typeface="Calibri" charset="0"/>
@@ -9658,7 +9658,7 @@
                   </a:tcPr>
                 </a:tc>
               </a:tr>
-              <a:tr h="329184">
+              <a:tr h="256032">
                 <a:tc>
                   <a:txBody>
                     <a:bodyPr/>
@@ -9668,7 +9668,7 @@
                         <a:buNone/>
                       </a:pPr>
                       <a:r>
-                        <a:rPr lang="en-US" sz="900" dirty="0">
+                        <a:rPr lang="en-US" sz="850" dirty="0">
                           <a:solidFill>
                             <a:srgbClr val="1F2233"/>
                           </a:solidFill>
@@ -9676,9 +9676,9 @@
                           <a:ea typeface="Calibri" pitchFamily="34" charset="-122"/>
                           <a:cs typeface="Calibri" pitchFamily="34" charset="-120"/>
                         </a:rPr>
-                        <a:t>Durée d'absence, rang au retour et bilan des 10 premiers matchs classés</a:t>
+                        <a:t>Revenants en classé : absence, rang avant / après, bilan, départ à 7 jours</a:t>
                       </a:r>
-                      <a:endParaRPr lang="en-US" sz="900" dirty="0">
+                      <a:endParaRPr lang="en-US" sz="850" dirty="0">
                         <a:latin typeface="Calibri" charset="0"/>
                         <a:ea typeface="Calibri" charset="0"/>
                         <a:cs typeface="Calibri" charset="0"/>
@@ -9736,7 +9736,7 @@
                         <a:buNone/>
                       </a:pPr>
                       <a:r>
-                        <a:rPr lang="en-US" sz="900" dirty="0">
+                        <a:rPr lang="en-US" sz="850" dirty="0">
                           <a:solidFill>
                             <a:srgbClr val="1F2233"/>
                           </a:solidFill>
@@ -9746,7 +9746,7 @@
                         </a:rPr>
                         <a:t>Si le rang au retour est périmé</a:t>
                       </a:r>
-                      <a:endParaRPr lang="en-US" sz="900" dirty="0">
+                      <a:endParaRPr lang="en-US" sz="850" dirty="0">
                         <a:latin typeface="Calibri" charset="0"/>
                         <a:ea typeface="Calibri" charset="0"/>
                         <a:cs typeface="Calibri" charset="0"/>
@@ -9804,7 +9804,7 @@
                         <a:buNone/>
                       </a:pPr>
                       <a:r>
-                        <a:rPr lang="en-US" sz="900" dirty="0">
+                        <a:rPr lang="en-US" sz="850" dirty="0">
                           <a:solidFill>
                             <a:srgbClr val="1F2233"/>
                           </a:solidFill>
@@ -9812,9 +9812,9 @@
                           <a:ea typeface="Calibri" pitchFamily="34" charset="-122"/>
                           <a:cs typeface="Calibri" pitchFamily="34" charset="-120"/>
                         </a:rPr>
-                        <a:t>Teste la cause C (joueurs de retour)</a:t>
+                        <a:t>Teste la cause C en classé</a:t>
                       </a:r>
-                      <a:endParaRPr lang="en-US" sz="900" dirty="0">
+                      <a:endParaRPr lang="en-US" sz="850" dirty="0">
                         <a:latin typeface="Calibri" charset="0"/>
                         <a:ea typeface="Calibri" charset="0"/>
                         <a:cs typeface="Calibri" charset="0"/>
@@ -9864,7 +9864,7 @@
                   </a:tcPr>
                 </a:tc>
               </a:tr>
-              <a:tr h="329184">
+              <a:tr h="256032">
                 <a:tc>
                   <a:txBody>
                     <a:bodyPr/>
@@ -9874,7 +9874,7 @@
                         <a:buNone/>
                       </a:pPr>
                       <a:r>
-                        <a:rPr lang="en-US" sz="900" dirty="0">
+                        <a:rPr lang="en-US" sz="850" dirty="0">
                           <a:solidFill>
                             <a:srgbClr val="1F2233"/>
                           </a:solidFill>
@@ -9882,9 +9882,9 @@
                           <a:ea typeface="Calibri" pitchFamily="34" charset="-122"/>
                           <a:cs typeface="Calibri" pitchFamily="34" charset="-120"/>
                         </a:rPr>
-                        <a:t>Départs en classé avant / après les placements de la saison 5</a:t>
+                        <a:t>Revenants hors classé : mode rejoué ; en partie rapide, écart subi, bilan, départ</a:t>
                       </a:r>
-                      <a:endParaRPr lang="en-US" sz="900" dirty="0">
+                      <a:endParaRPr lang="en-US" sz="850" dirty="0">
                         <a:latin typeface="Calibri" charset="0"/>
                         <a:ea typeface="Calibri" charset="0"/>
                         <a:cs typeface="Calibri" charset="0"/>
@@ -9942,7 +9942,7 @@
                         <a:buNone/>
                       </a:pPr>
                       <a:r>
-                        <a:rPr lang="en-US" sz="900" dirty="0">
+                        <a:rPr lang="en-US" sz="850" dirty="0">
                           <a:solidFill>
                             <a:srgbClr val="1F2233"/>
                           </a:solidFill>
@@ -9950,9 +9950,9 @@
                           <a:ea typeface="Calibri" pitchFamily="34" charset="-122"/>
                           <a:cs typeface="Calibri" pitchFamily="34" charset="-120"/>
                         </a:rPr>
-                        <a:t>Si mieux placer les joueurs les a retenus</a:t>
+                        <a:t>Si un revenant est mal placé en partie rapide</a:t>
                       </a:r>
-                      <a:endParaRPr lang="en-US" sz="900" dirty="0">
+                      <a:endParaRPr lang="en-US" sz="850" dirty="0">
                         <a:latin typeface="Calibri" charset="0"/>
                         <a:ea typeface="Calibri" charset="0"/>
                         <a:cs typeface="Calibri" charset="0"/>
@@ -10010,7 +10010,213 @@
                         <a:buNone/>
                       </a:pPr>
                       <a:r>
-                        <a:rPr lang="en-US" sz="900" dirty="0">
+                        <a:rPr lang="en-US" sz="850" dirty="0">
+                          <a:solidFill>
+                            <a:srgbClr val="1F2233"/>
+                          </a:solidFill>
+                          <a:latin typeface="Calibri" pitchFamily="34" charset="0"/>
+                          <a:ea typeface="Calibri" pitchFamily="34" charset="-122"/>
+                          <a:cs typeface="Calibri" pitchFamily="34" charset="-120"/>
+                        </a:rPr>
+                        <a:t>Teste C hors classé (il ne rejoue pas forcément en classé)</a:t>
+                      </a:r>
+                      <a:endParaRPr lang="en-US" sz="850" dirty="0">
+                        <a:latin typeface="Calibri" charset="0"/>
+                        <a:ea typeface="Calibri" charset="0"/>
+                        <a:cs typeface="Calibri" charset="0"/>
+                      </a:endParaRPr>
+                    </a:p>
+                  </a:txBody>
+                  <a:tcPr marL="63500" marR="63500" marT="12700" marB="12700" anchor="ctr">
+                    <a:lnL w="6350" cap="flat" cmpd="sng" algn="ctr">
+                      <a:solidFill>
+                        <a:srgbClr val="D5D8E3"/>
+                      </a:solidFill>
+                      <a:prstDash val="solid"/>
+                      <a:round/>
+                      <a:headEnd type="none" w="med" len="med"/>
+                      <a:tailEnd type="none" w="med" len="med"/>
+                    </a:lnL>
+                    <a:lnR w="6350" cap="flat" cmpd="sng" algn="ctr">
+                      <a:solidFill>
+                        <a:srgbClr val="D5D8E3"/>
+                      </a:solidFill>
+                      <a:prstDash val="solid"/>
+                      <a:round/>
+                      <a:headEnd type="none" w="med" len="med"/>
+                      <a:tailEnd type="none" w="med" len="med"/>
+                    </a:lnR>
+                    <a:lnT w="6350" cap="flat" cmpd="sng" algn="ctr">
+                      <a:solidFill>
+                        <a:srgbClr val="D5D8E3"/>
+                      </a:solidFill>
+                      <a:prstDash val="solid"/>
+                      <a:round/>
+                      <a:headEnd type="none" w="med" len="med"/>
+                      <a:tailEnd type="none" w="med" len="med"/>
+                    </a:lnT>
+                    <a:lnB w="6350" cap="flat" cmpd="sng" algn="ctr">
+                      <a:solidFill>
+                        <a:srgbClr val="D5D8E3"/>
+                      </a:solidFill>
+                      <a:prstDash val="solid"/>
+                      <a:round/>
+                      <a:headEnd type="none" w="med" len="med"/>
+                      <a:tailEnd type="none" w="med" len="med"/>
+                    </a:lnB>
+                    <a:solidFill>
+                      <a:srgbClr val="FFFFFF"/>
+                    </a:solidFill>
+                  </a:tcPr>
+                </a:tc>
+              </a:tr>
+              <a:tr h="256032">
+                <a:tc>
+                  <a:txBody>
+                    <a:bodyPr/>
+                    <a:lstStyle/>
+                    <a:p>
+                      <a:pPr indent="0" marL="0">
+                        <a:buNone/>
+                      </a:pPr>
+                      <a:r>
+                        <a:rPr lang="en-US" sz="850" dirty="0">
+                          <a:solidFill>
+                            <a:srgbClr val="1F2233"/>
+                          </a:solidFill>
+                          <a:latin typeface="Calibri" pitchFamily="34" charset="0"/>
+                          <a:ea typeface="Calibri" pitchFamily="34" charset="-122"/>
+                          <a:cs typeface="Calibri" pitchFamily="34" charset="-120"/>
+                        </a:rPr>
+                        <a:t>Départs en classé avant / après les placements de la saison 5</a:t>
+                      </a:r>
+                      <a:endParaRPr lang="en-US" sz="850" dirty="0">
+                        <a:latin typeface="Calibri" charset="0"/>
+                        <a:ea typeface="Calibri" charset="0"/>
+                        <a:cs typeface="Calibri" charset="0"/>
+                      </a:endParaRPr>
+                    </a:p>
+                  </a:txBody>
+                  <a:tcPr marL="63500" marR="63500" marT="12700" marB="12700" anchor="ctr">
+                    <a:lnL w="6350" cap="flat" cmpd="sng" algn="ctr">
+                      <a:solidFill>
+                        <a:srgbClr val="D5D8E3"/>
+                      </a:solidFill>
+                      <a:prstDash val="solid"/>
+                      <a:round/>
+                      <a:headEnd type="none" w="med" len="med"/>
+                      <a:tailEnd type="none" w="med" len="med"/>
+                    </a:lnL>
+                    <a:lnR w="6350" cap="flat" cmpd="sng" algn="ctr">
+                      <a:solidFill>
+                        <a:srgbClr val="D5D8E3"/>
+                      </a:solidFill>
+                      <a:prstDash val="solid"/>
+                      <a:round/>
+                      <a:headEnd type="none" w="med" len="med"/>
+                      <a:tailEnd type="none" w="med" len="med"/>
+                    </a:lnR>
+                    <a:lnT w="6350" cap="flat" cmpd="sng" algn="ctr">
+                      <a:solidFill>
+                        <a:srgbClr val="D5D8E3"/>
+                      </a:solidFill>
+                      <a:prstDash val="solid"/>
+                      <a:round/>
+                      <a:headEnd type="none" w="med" len="med"/>
+                      <a:tailEnd type="none" w="med" len="med"/>
+                    </a:lnT>
+                    <a:lnB w="6350" cap="flat" cmpd="sng" algn="ctr">
+                      <a:solidFill>
+                        <a:srgbClr val="D5D8E3"/>
+                      </a:solidFill>
+                      <a:prstDash val="solid"/>
+                      <a:round/>
+                      <a:headEnd type="none" w="med" len="med"/>
+                      <a:tailEnd type="none" w="med" len="med"/>
+                    </a:lnB>
+                    <a:solidFill>
+                      <a:srgbClr val="FFFFFF"/>
+                    </a:solidFill>
+                  </a:tcPr>
+                </a:tc>
+                <a:tc>
+                  <a:txBody>
+                    <a:bodyPr/>
+                    <a:lstStyle/>
+                    <a:p>
+                      <a:pPr indent="0" marL="0">
+                        <a:buNone/>
+                      </a:pPr>
+                      <a:r>
+                        <a:rPr lang="en-US" sz="850" dirty="0">
+                          <a:solidFill>
+                            <a:srgbClr val="1F2233"/>
+                          </a:solidFill>
+                          <a:latin typeface="Calibri" pitchFamily="34" charset="0"/>
+                          <a:ea typeface="Calibri" pitchFamily="34" charset="-122"/>
+                          <a:cs typeface="Calibri" pitchFamily="34" charset="-120"/>
+                        </a:rPr>
+                        <a:t>Si mieux placer les joueurs les a retenus</a:t>
+                      </a:r>
+                      <a:endParaRPr lang="en-US" sz="850" dirty="0">
+                        <a:latin typeface="Calibri" charset="0"/>
+                        <a:ea typeface="Calibri" charset="0"/>
+                        <a:cs typeface="Calibri" charset="0"/>
+                      </a:endParaRPr>
+                    </a:p>
+                  </a:txBody>
+                  <a:tcPr marL="63500" marR="63500" marT="12700" marB="12700" anchor="ctr">
+                    <a:lnL w="6350" cap="flat" cmpd="sng" algn="ctr">
+                      <a:solidFill>
+                        <a:srgbClr val="D5D8E3"/>
+                      </a:solidFill>
+                      <a:prstDash val="solid"/>
+                      <a:round/>
+                      <a:headEnd type="none" w="med" len="med"/>
+                      <a:tailEnd type="none" w="med" len="med"/>
+                    </a:lnL>
+                    <a:lnR w="6350" cap="flat" cmpd="sng" algn="ctr">
+                      <a:solidFill>
+                        <a:srgbClr val="D5D8E3"/>
+                      </a:solidFill>
+                      <a:prstDash val="solid"/>
+                      <a:round/>
+                      <a:headEnd type="none" w="med" len="med"/>
+                      <a:tailEnd type="none" w="med" len="med"/>
+                    </a:lnR>
+                    <a:lnT w="6350" cap="flat" cmpd="sng" algn="ctr">
+                      <a:solidFill>
+                        <a:srgbClr val="D5D8E3"/>
+                      </a:solidFill>
+                      <a:prstDash val="solid"/>
+                      <a:round/>
+                      <a:headEnd type="none" w="med" len="med"/>
+                      <a:tailEnd type="none" w="med" len="med"/>
+                    </a:lnT>
+                    <a:lnB w="6350" cap="flat" cmpd="sng" algn="ctr">
+                      <a:solidFill>
+                        <a:srgbClr val="D5D8E3"/>
+                      </a:solidFill>
+                      <a:prstDash val="solid"/>
+                      <a:round/>
+                      <a:headEnd type="none" w="med" len="med"/>
+                      <a:tailEnd type="none" w="med" len="med"/>
+                    </a:lnB>
+                    <a:solidFill>
+                      <a:srgbClr val="FFFFFF"/>
+                    </a:solidFill>
+                  </a:tcPr>
+                </a:tc>
+                <a:tc>
+                  <a:txBody>
+                    <a:bodyPr/>
+                    <a:lstStyle/>
+                    <a:p>
+                      <a:pPr indent="0" marL="0">
+                        <a:buNone/>
+                      </a:pPr>
+                      <a:r>
+                        <a:rPr lang="en-US" sz="850" dirty="0">
                           <a:solidFill>
                             <a:srgbClr val="1F2233"/>
                           </a:solidFill>
@@ -10020,7 +10226,7 @@
                         </a:rPr>
                         <a:t>Expérience déjà faite : la preuve la moins chère</a:t>
                       </a:r>
-                      <a:endParaRPr lang="en-US" sz="900" dirty="0">
+                      <a:endParaRPr lang="en-US" sz="850" dirty="0">
                         <a:latin typeface="Calibri" charset="0"/>
                         <a:ea typeface="Calibri" charset="0"/>
                         <a:cs typeface="Calibri" charset="0"/>
@@ -10082,8 +10288,8 @@
         </p:nvSpPr>
         <p:spPr>
           <a:xfrm>
-            <a:off x="457200" y="4416552"/>
-            <a:ext cx="8229600" cy="320040"/>
+            <a:off x="457200" y="4443984"/>
+            <a:ext cx="8229600" cy="301752"/>
           </a:xfrm>
           <a:prstGeom prst="rect">
             <a:avLst/>
@@ -10099,7 +10305,7 @@
               <a:buNone/>
             </a:pPr>
             <a:r>
-              <a:rPr lang="en-US" sz="950" i="1" dirty="0">
+              <a:rPr lang="en-US" sz="900" i="1" dirty="0">
                 <a:solidFill>
                   <a:srgbClr val="5E6378"/>
                 </a:solidFill>
@@ -10109,7 +10315,7 @@
               </a:rPr>
               <a:t>Ensuite, pour écarter les autres explications : héros joué, parties avec bots, joueurs en groupe, comptes arrivés en 2025. Tout existe déjà dans vos serveurs.</a:t>
             </a:r>
-            <a:endParaRPr lang="en-US" sz="950" dirty="0"/>
+            <a:endParaRPr lang="en-US" sz="900" dirty="0"/>
           </a:p>
         </p:txBody>
       </p:sp>
@@ -10312,7 +10518,7 @@
                 <a:ea typeface="Arial" pitchFamily="34" charset="-122"/>
                 <a:cs typeface="Arial" pitchFamily="34" charset="-120"/>
               </a:rPr>
-              <a:t>Matrice ICE : 13 données indispensables</a:t>
+              <a:t>Matrice ICE : 15 données indispensables</a:t>
             </a:r>
             <a:endParaRPr lang="en-US" sz="2600" dirty="0"/>
           </a:p>
@@ -10387,7 +10593,7 @@
                 <a:gridCol w="685800"/>
                 <a:gridCol w="2331720"/>
               </a:tblGrid>
-              <a:tr h="233172">
+              <a:tr h="214884">
                 <a:tc>
                   <a:txBody>
                     <a:bodyPr/>
@@ -10797,7 +11003,7 @@
                   </a:tcPr>
                 </a:tc>
               </a:tr>
-              <a:tr h="233172">
+              <a:tr h="214884">
                 <a:tc>
                   <a:txBody>
                     <a:bodyPr/>
@@ -11207,7 +11413,7 @@
                   </a:tcPr>
                 </a:tc>
               </a:tr>
-              <a:tr h="233172">
+              <a:tr h="214884">
                 <a:tc>
                   <a:txBody>
                     <a:bodyPr/>
@@ -11617,7 +11823,7 @@
                   </a:tcPr>
                 </a:tc>
               </a:tr>
-              <a:tr h="233172">
+              <a:tr h="214884">
                 <a:tc>
                   <a:txBody>
                     <a:bodyPr/>
@@ -12027,7 +12233,7 @@
                   </a:tcPr>
                 </a:tc>
               </a:tr>
-              <a:tr h="233172">
+              <a:tr h="214884">
                 <a:tc>
                   <a:txBody>
                     <a:bodyPr/>
@@ -12437,7 +12643,7 @@
                   </a:tcPr>
                 </a:tc>
               </a:tr>
-              <a:tr h="233172">
+              <a:tr h="214884">
                 <a:tc>
                   <a:txBody>
                     <a:bodyPr/>
@@ -12455,7 +12661,7 @@
                           <a:ea typeface="Calibri" pitchFamily="34" charset="-122"/>
                           <a:cs typeface="Calibri" pitchFamily="34" charset="-120"/>
                         </a:rPr>
-                        <a:t>Joueurs de retour : absence × rang au retour × bilan</a:t>
+                        <a:t>Revenants en classé : absence × rang au retour × bilan</a:t>
                       </a:r>
                       <a:endParaRPr lang="en-US" sz="900" dirty="0">
                         <a:latin typeface="Calibri" charset="0"/>
@@ -12847,7 +13053,7 @@
                   </a:tcPr>
                 </a:tc>
               </a:tr>
-              <a:tr h="233172">
+              <a:tr h="214884">
                 <a:tc>
                   <a:txBody>
                     <a:bodyPr/>
@@ -12865,7 +13071,417 @@
                           <a:ea typeface="Calibri" pitchFamily="34" charset="-122"/>
                           <a:cs typeface="Calibri" pitchFamily="34" charset="-120"/>
                         </a:rPr>
-                        <a:t>Écart de niveau subi en partie rapide</a:t>
+                        <a:t>Revenants : mode rejoué au retour</a:t>
+                      </a:r>
+                      <a:endParaRPr lang="en-US" sz="900" dirty="0">
+                        <a:latin typeface="Calibri" charset="0"/>
+                        <a:ea typeface="Calibri" charset="0"/>
+                        <a:cs typeface="Calibri" charset="0"/>
+                      </a:endParaRPr>
+                    </a:p>
+                  </a:txBody>
+                  <a:tcPr marL="63500" marR="63500" marT="12700" marB="12700" anchor="ctr">
+                    <a:lnL w="9525" cap="flat" cmpd="sng" algn="ctr">
+                      <a:solidFill>
+                        <a:srgbClr val="FFFFFF"/>
+                      </a:solidFill>
+                      <a:prstDash val="solid"/>
+                      <a:round/>
+                      <a:headEnd type="none" w="med" len="med"/>
+                      <a:tailEnd type="none" w="med" len="med"/>
+                    </a:lnL>
+                    <a:lnR w="9525" cap="flat" cmpd="sng" algn="ctr">
+                      <a:solidFill>
+                        <a:srgbClr val="FFFFFF"/>
+                      </a:solidFill>
+                      <a:prstDash val="solid"/>
+                      <a:round/>
+                      <a:headEnd type="none" w="med" len="med"/>
+                      <a:tailEnd type="none" w="med" len="med"/>
+                    </a:lnR>
+                    <a:lnT w="9525" cap="flat" cmpd="sng" algn="ctr">
+                      <a:solidFill>
+                        <a:srgbClr val="FFFFFF"/>
+                      </a:solidFill>
+                      <a:prstDash val="solid"/>
+                      <a:round/>
+                      <a:headEnd type="none" w="med" len="med"/>
+                      <a:tailEnd type="none" w="med" len="med"/>
+                    </a:lnT>
+                    <a:lnB w="9525" cap="flat" cmpd="sng" algn="ctr">
+                      <a:solidFill>
+                        <a:srgbClr val="FFFFFF"/>
+                      </a:solidFill>
+                      <a:prstDash val="solid"/>
+                      <a:round/>
+                      <a:headEnd type="none" w="med" len="med"/>
+                      <a:tailEnd type="none" w="med" len="med"/>
+                    </a:lnB>
+                    <a:solidFill>
+                      <a:srgbClr val="F4F5F9"/>
+                    </a:solidFill>
+                  </a:tcPr>
+                </a:tc>
+                <a:tc>
+                  <a:txBody>
+                    <a:bodyPr/>
+                    <a:lstStyle/>
+                    <a:p>
+                      <a:pPr algn="ctr" indent="0" marL="0">
+                        <a:buNone/>
+                      </a:pPr>
+                      <a:r>
+                        <a:rPr lang="en-US" sz="900" b="1" dirty="0">
+                          <a:solidFill>
+                            <a:srgbClr val="1E8C93"/>
+                          </a:solidFill>
+                          <a:latin typeface="Arial" pitchFamily="34" charset="0"/>
+                          <a:ea typeface="Arial" pitchFamily="34" charset="-122"/>
+                          <a:cs typeface="Arial" pitchFamily="34" charset="-120"/>
+                        </a:rPr>
+                        <a:t>4</a:t>
+                      </a:r>
+                      <a:endParaRPr lang="en-US" sz="900" dirty="0">
+                        <a:latin typeface="Arial" charset="0"/>
+                        <a:ea typeface="Arial" charset="0"/>
+                        <a:cs typeface="Arial" charset="0"/>
+                      </a:endParaRPr>
+                    </a:p>
+                  </a:txBody>
+                  <a:tcPr marL="63500" marR="63500" marT="12700" marB="12700" anchor="ctr">
+                    <a:lnL w="9525" cap="flat" cmpd="sng" algn="ctr">
+                      <a:solidFill>
+                        <a:srgbClr val="FFFFFF"/>
+                      </a:solidFill>
+                      <a:prstDash val="solid"/>
+                      <a:round/>
+                      <a:headEnd type="none" w="med" len="med"/>
+                      <a:tailEnd type="none" w="med" len="med"/>
+                    </a:lnL>
+                    <a:lnR w="9525" cap="flat" cmpd="sng" algn="ctr">
+                      <a:solidFill>
+                        <a:srgbClr val="FFFFFF"/>
+                      </a:solidFill>
+                      <a:prstDash val="solid"/>
+                      <a:round/>
+                      <a:headEnd type="none" w="med" len="med"/>
+                      <a:tailEnd type="none" w="med" len="med"/>
+                    </a:lnR>
+                    <a:lnT w="9525" cap="flat" cmpd="sng" algn="ctr">
+                      <a:solidFill>
+                        <a:srgbClr val="FFFFFF"/>
+                      </a:solidFill>
+                      <a:prstDash val="solid"/>
+                      <a:round/>
+                      <a:headEnd type="none" w="med" len="med"/>
+                      <a:tailEnd type="none" w="med" len="med"/>
+                    </a:lnT>
+                    <a:lnB w="9525" cap="flat" cmpd="sng" algn="ctr">
+                      <a:solidFill>
+                        <a:srgbClr val="FFFFFF"/>
+                      </a:solidFill>
+                      <a:prstDash val="solid"/>
+                      <a:round/>
+                      <a:headEnd type="none" w="med" len="med"/>
+                      <a:tailEnd type="none" w="med" len="med"/>
+                    </a:lnB>
+                    <a:solidFill>
+                      <a:srgbClr val="F4F5F9"/>
+                    </a:solidFill>
+                  </a:tcPr>
+                </a:tc>
+                <a:tc>
+                  <a:txBody>
+                    <a:bodyPr/>
+                    <a:lstStyle/>
+                    <a:p>
+                      <a:pPr algn="ctr" indent="0" marL="0">
+                        <a:buNone/>
+                      </a:pPr>
+                      <a:r>
+                        <a:rPr lang="en-US" sz="900" b="1" dirty="0">
+                          <a:solidFill>
+                            <a:srgbClr val="C2185B"/>
+                          </a:solidFill>
+                          <a:latin typeface="Arial" pitchFamily="34" charset="0"/>
+                          <a:ea typeface="Arial" pitchFamily="34" charset="-122"/>
+                          <a:cs typeface="Arial" pitchFamily="34" charset="-120"/>
+                        </a:rPr>
+                        <a:t>5</a:t>
+                      </a:r>
+                      <a:endParaRPr lang="en-US" sz="900" dirty="0">
+                        <a:latin typeface="Arial" charset="0"/>
+                        <a:ea typeface="Arial" charset="0"/>
+                        <a:cs typeface="Arial" charset="0"/>
+                      </a:endParaRPr>
+                    </a:p>
+                  </a:txBody>
+                  <a:tcPr marL="63500" marR="63500" marT="12700" marB="12700" anchor="ctr">
+                    <a:lnL w="9525" cap="flat" cmpd="sng" algn="ctr">
+                      <a:solidFill>
+                        <a:srgbClr val="FFFFFF"/>
+                      </a:solidFill>
+                      <a:prstDash val="solid"/>
+                      <a:round/>
+                      <a:headEnd type="none" w="med" len="med"/>
+                      <a:tailEnd type="none" w="med" len="med"/>
+                    </a:lnL>
+                    <a:lnR w="9525" cap="flat" cmpd="sng" algn="ctr">
+                      <a:solidFill>
+                        <a:srgbClr val="FFFFFF"/>
+                      </a:solidFill>
+                      <a:prstDash val="solid"/>
+                      <a:round/>
+                      <a:headEnd type="none" w="med" len="med"/>
+                      <a:tailEnd type="none" w="med" len="med"/>
+                    </a:lnR>
+                    <a:lnT w="9525" cap="flat" cmpd="sng" algn="ctr">
+                      <a:solidFill>
+                        <a:srgbClr val="FFFFFF"/>
+                      </a:solidFill>
+                      <a:prstDash val="solid"/>
+                      <a:round/>
+                      <a:headEnd type="none" w="med" len="med"/>
+                      <a:tailEnd type="none" w="med" len="med"/>
+                    </a:lnT>
+                    <a:lnB w="9525" cap="flat" cmpd="sng" algn="ctr">
+                      <a:solidFill>
+                        <a:srgbClr val="FFFFFF"/>
+                      </a:solidFill>
+                      <a:prstDash val="solid"/>
+                      <a:round/>
+                      <a:headEnd type="none" w="med" len="med"/>
+                      <a:tailEnd type="none" w="med" len="med"/>
+                    </a:lnB>
+                    <a:solidFill>
+                      <a:srgbClr val="F4F5F9"/>
+                    </a:solidFill>
+                  </a:tcPr>
+                </a:tc>
+                <a:tc>
+                  <a:txBody>
+                    <a:bodyPr/>
+                    <a:lstStyle/>
+                    <a:p>
+                      <a:pPr algn="ctr" indent="0" marL="0">
+                        <a:buNone/>
+                      </a:pPr>
+                      <a:r>
+                        <a:rPr lang="en-US" sz="900" b="1" dirty="0">
+                          <a:solidFill>
+                            <a:srgbClr val="C98A00"/>
+                          </a:solidFill>
+                          <a:latin typeface="Arial" pitchFamily="34" charset="0"/>
+                          <a:ea typeface="Arial" pitchFamily="34" charset="-122"/>
+                          <a:cs typeface="Arial" pitchFamily="34" charset="-120"/>
+                        </a:rPr>
+                        <a:t>5</a:t>
+                      </a:r>
+                      <a:endParaRPr lang="en-US" sz="900" dirty="0">
+                        <a:latin typeface="Arial" charset="0"/>
+                        <a:ea typeface="Arial" charset="0"/>
+                        <a:cs typeface="Arial" charset="0"/>
+                      </a:endParaRPr>
+                    </a:p>
+                  </a:txBody>
+                  <a:tcPr marL="63500" marR="63500" marT="12700" marB="12700" anchor="ctr">
+                    <a:lnL w="9525" cap="flat" cmpd="sng" algn="ctr">
+                      <a:solidFill>
+                        <a:srgbClr val="FFFFFF"/>
+                      </a:solidFill>
+                      <a:prstDash val="solid"/>
+                      <a:round/>
+                      <a:headEnd type="none" w="med" len="med"/>
+                      <a:tailEnd type="none" w="med" len="med"/>
+                    </a:lnL>
+                    <a:lnR w="9525" cap="flat" cmpd="sng" algn="ctr">
+                      <a:solidFill>
+                        <a:srgbClr val="FFFFFF"/>
+                      </a:solidFill>
+                      <a:prstDash val="solid"/>
+                      <a:round/>
+                      <a:headEnd type="none" w="med" len="med"/>
+                      <a:tailEnd type="none" w="med" len="med"/>
+                    </a:lnR>
+                    <a:lnT w="9525" cap="flat" cmpd="sng" algn="ctr">
+                      <a:solidFill>
+                        <a:srgbClr val="FFFFFF"/>
+                      </a:solidFill>
+                      <a:prstDash val="solid"/>
+                      <a:round/>
+                      <a:headEnd type="none" w="med" len="med"/>
+                      <a:tailEnd type="none" w="med" len="med"/>
+                    </a:lnT>
+                    <a:lnB w="9525" cap="flat" cmpd="sng" algn="ctr">
+                      <a:solidFill>
+                        <a:srgbClr val="FFFFFF"/>
+                      </a:solidFill>
+                      <a:prstDash val="solid"/>
+                      <a:round/>
+                      <a:headEnd type="none" w="med" len="med"/>
+                      <a:tailEnd type="none" w="med" len="med"/>
+                    </a:lnB>
+                    <a:solidFill>
+                      <a:srgbClr val="F4F5F9"/>
+                    </a:solidFill>
+                  </a:tcPr>
+                </a:tc>
+                <a:tc>
+                  <a:txBody>
+                    <a:bodyPr/>
+                    <a:lstStyle/>
+                    <a:p>
+                      <a:pPr algn="ctr" indent="0" marL="0">
+                        <a:buNone/>
+                      </a:pPr>
+                      <a:r>
+                        <a:rPr lang="en-US" sz="1050" b="1" dirty="0">
+                          <a:solidFill>
+                            <a:srgbClr val="1F2233"/>
+                          </a:solidFill>
+                          <a:latin typeface="Arial" pitchFamily="34" charset="0"/>
+                          <a:ea typeface="Arial" pitchFamily="34" charset="-122"/>
+                          <a:cs typeface="Arial" pitchFamily="34" charset="-120"/>
+                        </a:rPr>
+                        <a:t>100</a:t>
+                      </a:r>
+                      <a:endParaRPr lang="en-US" sz="1050" dirty="0">
+                        <a:latin typeface="Arial" charset="0"/>
+                        <a:ea typeface="Arial" charset="0"/>
+                        <a:cs typeface="Arial" charset="0"/>
+                      </a:endParaRPr>
+                    </a:p>
+                  </a:txBody>
+                  <a:tcPr marL="63500" marR="63500" marT="12700" marB="12700" anchor="ctr">
+                    <a:lnL w="9525" cap="flat" cmpd="sng" algn="ctr">
+                      <a:solidFill>
+                        <a:srgbClr val="FFFFFF"/>
+                      </a:solidFill>
+                      <a:prstDash val="solid"/>
+                      <a:round/>
+                      <a:headEnd type="none" w="med" len="med"/>
+                      <a:tailEnd type="none" w="med" len="med"/>
+                    </a:lnL>
+                    <a:lnR w="9525" cap="flat" cmpd="sng" algn="ctr">
+                      <a:solidFill>
+                        <a:srgbClr val="FFFFFF"/>
+                      </a:solidFill>
+                      <a:prstDash val="solid"/>
+                      <a:round/>
+                      <a:headEnd type="none" w="med" len="med"/>
+                      <a:tailEnd type="none" w="med" len="med"/>
+                    </a:lnR>
+                    <a:lnT w="9525" cap="flat" cmpd="sng" algn="ctr">
+                      <a:solidFill>
+                        <a:srgbClr val="FFFFFF"/>
+                      </a:solidFill>
+                      <a:prstDash val="solid"/>
+                      <a:round/>
+                      <a:headEnd type="none" w="med" len="med"/>
+                      <a:tailEnd type="none" w="med" len="med"/>
+                    </a:lnT>
+                    <a:lnB w="9525" cap="flat" cmpd="sng" algn="ctr">
+                      <a:solidFill>
+                        <a:srgbClr val="FFFFFF"/>
+                      </a:solidFill>
+                      <a:prstDash val="solid"/>
+                      <a:round/>
+                      <a:headEnd type="none" w="med" len="med"/>
+                      <a:tailEnd type="none" w="med" len="med"/>
+                    </a:lnB>
+                    <a:solidFill>
+                      <a:srgbClr val="F4F5F9"/>
+                    </a:solidFill>
+                  </a:tcPr>
+                </a:tc>
+                <a:tc>
+                  <a:txBody>
+                    <a:bodyPr/>
+                    <a:lstStyle/>
+                    <a:p>
+                      <a:pPr algn="ctr" indent="0" marL="0">
+                        <a:buNone/>
+                      </a:pPr>
+                      <a:r>
+                        <a:rPr lang="en-US" sz="850" b="1" dirty="0">
+                          <a:solidFill>
+                            <a:srgbClr val="FFFFFF"/>
+                          </a:solidFill>
+                          <a:latin typeface="Calibri" pitchFamily="34" charset="0"/>
+                          <a:ea typeface="Calibri" pitchFamily="34" charset="-122"/>
+                          <a:cs typeface="Calibri" pitchFamily="34" charset="-120"/>
+                        </a:rPr>
+                        <a:t>Indispensable · où agir pour C</a:t>
+                      </a:r>
+                      <a:endParaRPr lang="en-US" sz="850" dirty="0">
+                        <a:latin typeface="Calibri" charset="0"/>
+                        <a:ea typeface="Calibri" charset="0"/>
+                        <a:cs typeface="Calibri" charset="0"/>
+                      </a:endParaRPr>
+                    </a:p>
+                  </a:txBody>
+                  <a:tcPr marL="63500" marR="63500" marT="12700" marB="12700" anchor="ctr">
+                    <a:lnL w="9525" cap="flat" cmpd="sng" algn="ctr">
+                      <a:solidFill>
+                        <a:srgbClr val="FFFFFF"/>
+                      </a:solidFill>
+                      <a:prstDash val="solid"/>
+                      <a:round/>
+                      <a:headEnd type="none" w="med" len="med"/>
+                      <a:tailEnd type="none" w="med" len="med"/>
+                    </a:lnL>
+                    <a:lnR w="9525" cap="flat" cmpd="sng" algn="ctr">
+                      <a:solidFill>
+                        <a:srgbClr val="FFFFFF"/>
+                      </a:solidFill>
+                      <a:prstDash val="solid"/>
+                      <a:round/>
+                      <a:headEnd type="none" w="med" len="med"/>
+                      <a:tailEnd type="none" w="med" len="med"/>
+                    </a:lnR>
+                    <a:lnT w="9525" cap="flat" cmpd="sng" algn="ctr">
+                      <a:solidFill>
+                        <a:srgbClr val="FFFFFF"/>
+                      </a:solidFill>
+                      <a:prstDash val="solid"/>
+                      <a:round/>
+                      <a:headEnd type="none" w="med" len="med"/>
+                      <a:tailEnd type="none" w="med" len="med"/>
+                    </a:lnT>
+                    <a:lnB w="9525" cap="flat" cmpd="sng" algn="ctr">
+                      <a:solidFill>
+                        <a:srgbClr val="FFFFFF"/>
+                      </a:solidFill>
+                      <a:prstDash val="solid"/>
+                      <a:round/>
+                      <a:headEnd type="none" w="med" len="med"/>
+                      <a:tailEnd type="none" w="med" len="med"/>
+                    </a:lnB>
+                    <a:solidFill>
+                      <a:srgbClr val="2E7D5B"/>
+                    </a:solidFill>
+                  </a:tcPr>
+                </a:tc>
+              </a:tr>
+              <a:tr h="214884">
+                <a:tc>
+                  <a:txBody>
+                    <a:bodyPr/>
+                    <a:lstStyle/>
+                    <a:p>
+                      <a:pPr indent="0" marL="0">
+                        <a:buNone/>
+                      </a:pPr>
+                      <a:r>
+                        <a:rPr lang="en-US" sz="900" dirty="0">
+                          <a:solidFill>
+                            <a:srgbClr val="1F2233"/>
+                          </a:solidFill>
+                          <a:latin typeface="Calibri" pitchFamily="34" charset="0"/>
+                          <a:ea typeface="Calibri" pitchFamily="34" charset="-122"/>
+                          <a:cs typeface="Calibri" pitchFamily="34" charset="-120"/>
+                        </a:rPr>
+                        <a:t>Revenants en partie rapide : écart subi × bilan</a:t>
                       </a:r>
                       <a:endParaRPr lang="en-US" sz="900" dirty="0">
                         <a:latin typeface="Calibri" charset="0"/>
@@ -13069,7 +13685,7 @@
                           <a:ea typeface="Arial" pitchFamily="34" charset="-122"/>
                           <a:cs typeface="Arial" pitchFamily="34" charset="-120"/>
                         </a:rPr>
-                        <a:t>4</a:t>
+                        <a:t>5</a:t>
                       </a:r>
                       <a:endParaRPr lang="en-US" sz="900" dirty="0">
                         <a:latin typeface="Arial" charset="0"/>
@@ -13137,7 +13753,7 @@
                           <a:ea typeface="Arial" pitchFamily="34" charset="-122"/>
                           <a:cs typeface="Arial" pitchFamily="34" charset="-120"/>
                         </a:rPr>
-                        <a:t>80</a:t>
+                        <a:t>100</a:t>
                       </a:r>
                       <a:endParaRPr lang="en-US" sz="1050" dirty="0">
                         <a:latin typeface="Arial" charset="0"/>
@@ -13205,7 +13821,7 @@
                           <a:ea typeface="Calibri" pitchFamily="34" charset="-122"/>
                           <a:cs typeface="Calibri" pitchFamily="34" charset="-120"/>
                         </a:rPr>
-                        <a:t>Indispensable</a:t>
+                        <a:t>Indispensable · cause C hors classé</a:t>
                       </a:r>
                       <a:endParaRPr lang="en-US" sz="850" dirty="0">
                         <a:latin typeface="Calibri" charset="0"/>
@@ -13257,7 +13873,7 @@
                   </a:tcPr>
                 </a:tc>
               </a:tr>
-              <a:tr h="233172">
+              <a:tr h="214884">
                 <a:tc>
                   <a:txBody>
                     <a:bodyPr/>
@@ -13667,7 +14283,7 @@
                   </a:tcPr>
                 </a:tc>
               </a:tr>
-              <a:tr h="233172">
+              <a:tr h="214884">
                 <a:tc>
                   <a:txBody>
                     <a:bodyPr/>
@@ -14077,7 +14693,7 @@
                   </a:tcPr>
                 </a:tc>
               </a:tr>
-              <a:tr h="233172">
+              <a:tr h="214884">
                 <a:tc>
                   <a:txBody>
                     <a:bodyPr/>
@@ -14487,7 +15103,7 @@
                   </a:tcPr>
                 </a:tc>
               </a:tr>
-              <a:tr h="233172">
+              <a:tr h="214884">
                 <a:tc>
                   <a:txBody>
                     <a:bodyPr/>
@@ -14897,7 +15513,7 @@
                   </a:tcPr>
                 </a:tc>
               </a:tr>
-              <a:tr h="233172">
+              <a:tr h="214884">
                 <a:tc>
                   <a:txBody>
                     <a:bodyPr/>
@@ -15307,7 +15923,7 @@
                   </a:tcPr>
                 </a:tc>
               </a:tr>
-              <a:tr h="233172">
+              <a:tr h="214884">
                 <a:tc>
                   <a:txBody>
                     <a:bodyPr/>
@@ -15754,7 +16370,7 @@
                 <a:ea typeface="Calibri" pitchFamily="34" charset="-122"/>
                 <a:cs typeface="Calibri" pitchFamily="34" charset="-120"/>
               </a:rPr>
-              <a:t>Les 13 indispensables existent déjà dans votre télémétrie : </a:t>
+              <a:t>Les 15 indispensables existent déjà dans votre télémétrie : </a:t>
             </a:r>
             <a:pPr indent="0" marL="0">
               <a:buNone/>
@@ -15768,7 +16384,7 @@
                 <a:ea typeface="Calibri" pitchFamily="34" charset="-122"/>
                 <a:cs typeface="Calibri" pitchFamily="34" charset="-120"/>
               </a:rPr>
-              <a:t>aucune nouvelle collecte pour l'audit. Extrait de la matrice : 7 autres indispensables (ICE 80 à 100) et 5 autres utiles sont notés dans le plan de collecte.</a:t>
+              <a:t>aucune nouvelle collecte pour l'audit. Extrait de la matrice : 8 autres indispensables (ICE 80 à 100) et 5 autres utiles sont notés dans le plan de collecte.</a:t>
             </a:r>
             <a:endParaRPr lang="en-US" sz="950" dirty="0"/>
           </a:p>
@@ -16656,7 +17272,7 @@
                 <a:ea typeface="Arial" pitchFamily="34" charset="-122"/>
                 <a:cs typeface="Arial" pitchFamily="34" charset="-120"/>
               </a:rPr>
-              <a:t>C · Rang périmé au retour</a:t>
+              <a:t>C · Niveau périmé au retour</a:t>
             </a:r>
             <a:endParaRPr lang="en-US" sz="1200" dirty="0"/>
           </a:p>
@@ -16695,7 +17311,7 @@
                 <a:ea typeface="Calibri" pitchFamily="34" charset="-122"/>
                 <a:cs typeface="Calibri" pitchFamily="34" charset="-120"/>
               </a:rPr>
-              <a:t>Le rang ne tient pas compte de la durée d'absence.</a:t>
+              <a:t>Le rang (classé) et le niveau caché (partie rapide) ignorent la durée d'absence.</a:t>
             </a:r>
             <a:endParaRPr lang="en-US" sz="1000" dirty="0"/>
           </a:p>
@@ -16823,7 +17439,7 @@
                 <a:ea typeface="Calibri" pitchFamily="34" charset="-122"/>
                 <a:cs typeface="Calibri" pitchFamily="34" charset="-120"/>
               </a:rPr>
-              <a:t>Baisse de rang selon l'absence</a:t>
+              <a:t>Niveau ajusté selon l'absence, dans les deux modes</a:t>
             </a:r>
             <a:endParaRPr lang="en-US" sz="1000" dirty="0"/>
           </a:p>

</xml_diff>

<commit_message>
Pitch : graphiques de la slide 2 rendus en image pour tous les lecteurs
Co-Authored-By: Claude Opus 5.5 <noreply@anthropic.com>
Claude-Session: https://claude.ai/code/session_012kyLDzFB57v6JCyVf6ygKi
</commit_message>
<xml_diff>
--- a/docs/presentation/pitch_marvel_rivals_netease.pptx
+++ b/docs/presentation/pitch_marvel_rivals_netease.pptx
@@ -116,771 +116,6 @@
     </a:lvl9pPr>
   </p:defaultTextStyle>
 </p:presentation>
-</file>
-
-<file path=ppt/charts/chart1.xml><?xml version="1.0" encoding="utf-8"?>
-<c:chartSpace xmlns:c="http://schemas.openxmlformats.org/drawingml/2006/chart" xmlns:a="http://schemas.openxmlformats.org/drawingml/2006/main" xmlns:r="http://schemas.openxmlformats.org/officeDocument/2006/relationships">
-  <c:date1904 val="0"/>
-  <c:roundedCorners val="1"/>
-  <c:chart>
-    <c:title>
-      <c:tx>
-        <c:rich>
-          <a:bodyPr/>
-          <a:lstStyle/>
-          <a:p>
-            <a:pPr>
-              <a:defRPr sz="1100" b="0" i="0" u="none" strike="noStrike">
-                <a:solidFill>
-                  <a:srgbClr val="1F2233"/>
-                </a:solidFill>
-                <a:latin typeface="Calibri"/>
-              </a:defRPr>
-            </a:pPr>
-            <a:r>
-              <a:rPr sz="1100" b="0" i="0" u="none" strike="noStrike">
-                <a:solidFill>
-                  <a:srgbClr val="1F2233"/>
-                </a:solidFill>
-                <a:latin typeface="Calibri"/>
-              </a:rPr>
-              <a:t>Joueurs simultanés, moyenne mensuelle (milliers)</a:t>
-            </a:r>
-          </a:p>
-        </c:rich>
-      </c:tx>
-      <c:layout/>
-      <c:overlay val="0"/>
-    </c:title>
-    <c:autoTitleDeleted val="0"/>
-    <c:plotArea>
-      <c:layout/>
-      <c:areaChart>
-        <c:varyColors val="0"/>
-        <c:ser>
-          <c:idx val="0"/>
-          <c:order val="0"/>
-          <c:tx>
-            <c:strRef>
-              <c:f>Sheet1!$B$1</c:f>
-              <c:strCache>
-                <c:ptCount val="1"/>
-                <c:pt idx="0">
-                  <c:v>Joueurs simultanés (milliers)</c:v>
-                </c:pt>
-              </c:strCache>
-            </c:strRef>
-          </c:tx>
-          <c:spPr>
-            <a:solidFill>
-              <a:srgbClr val="E62429">
-                <a:alpha val="55000"/>
-              </a:srgbClr>
-            </a:solidFill>
-            <a:effectLst/>
-          </c:spPr>
-          <c:invertIfNegative val="0"/>
-          <c:dLbls>
-            <c:numFmt formatCode="#,##0" sourceLinked="0"/>
-            <c:txPr>
-              <a:bodyPr/>
-              <a:lstStyle/>
-              <a:p>
-                <a:pPr>
-                  <a:defRPr b="0" i="0" strike="noStrike" sz="1200" u="none">
-                    <a:solidFill>
-                      <a:srgbClr val="000000"/>
-                    </a:solidFill>
-                    <a:latin typeface="Arial"/>
-                  </a:defRPr>
-                </a:pPr>
-              </a:p>
-            </c:txPr>
-            <c:showLegendKey val="0"/>
-            <c:showVal val="0"/>
-            <c:showCatName val="0"/>
-            <c:showSerName val="0"/>
-            <c:showPercent val="0"/>
-            <c:showBubbleSize val="0"/>
-            <c:showLeaderLines val="0"/>
-          </c:dLbls>
-          <c:cat>
-            <c:multiLvlStrRef>
-              <c:f>Sheet1!$A$2:$A$23</c:f>
-              <c:multiLvlStrCache>
-                <c:ptCount val="22"/>
-                <c:lvl>
-                  <c:pt idx="0">
-                    <c:v>Déc. 24</c:v>
-                  </c:pt>
-                  <c:pt idx="1">
-                    <c:v>Janv.</c:v>
-                  </c:pt>
-                  <c:pt idx="2">
-                    <c:v>Févr.</c:v>
-                  </c:pt>
-                  <c:pt idx="3">
-                    <c:v>Mars</c:v>
-                  </c:pt>
-                  <c:pt idx="4">
-                    <c:v>Avr.</c:v>
-                  </c:pt>
-                  <c:pt idx="5">
-                    <c:v>Mai</c:v>
-                  </c:pt>
-                  <c:pt idx="6">
-                    <c:v>Juin</c:v>
-                  </c:pt>
-                  <c:pt idx="7">
-                    <c:v>Juil.</c:v>
-                  </c:pt>
-                  <c:pt idx="8">
-                    <c:v>Août</c:v>
-                  </c:pt>
-                  <c:pt idx="9">
-                    <c:v>Sept.</c:v>
-                  </c:pt>
-                  <c:pt idx="10">
-                    <c:v>Oct.</c:v>
-                  </c:pt>
-                  <c:pt idx="11">
-                    <c:v>Nov.</c:v>
-                  </c:pt>
-                  <c:pt idx="12">
-                    <c:v>Déc.</c:v>
-                  </c:pt>
-                  <c:pt idx="13">
-                    <c:v>Janv. 26</c:v>
-                  </c:pt>
-                  <c:pt idx="14">
-                    <c:v>Févr.</c:v>
-                  </c:pt>
-                  <c:pt idx="15">
-                    <c:v>Mars</c:v>
-                  </c:pt>
-                  <c:pt idx="16">
-                    <c:v>Avr.</c:v>
-                  </c:pt>
-                  <c:pt idx="17">
-                    <c:v>Mai</c:v>
-                  </c:pt>
-                  <c:pt idx="18">
-                    <c:v>Juin</c:v>
-                  </c:pt>
-                  <c:pt idx="19">
-                    <c:v>Juil.</c:v>
-                  </c:pt>
-                  <c:pt idx="20">
-                    <c:v>Août</c:v>
-                  </c:pt>
-                  <c:pt idx="21">
-                    <c:v>Sept.*</c:v>
-                  </c:pt>
-                </c:lvl>
-              </c:multiLvlStrCache>
-            </c:multiLvlStrRef>
-          </c:cat>
-          <c:val>
-            <c:numRef>
-              <c:f>Sheet1!$B$2:$B$23</c:f>
-              <c:numCache>
-                <c:formatCode>General</c:formatCode>
-                <c:ptCount val="22"/>
-                <c:pt idx="0">
-                  <c:v>279</c:v>
-                </c:pt>
-                <c:pt idx="1">
-                  <c:v>306</c:v>
-                </c:pt>
-                <c:pt idx="2">
-                  <c:v>228</c:v>
-                </c:pt>
-                <c:pt idx="3">
-                  <c:v>144</c:v>
-                </c:pt>
-                <c:pt idx="4">
-                  <c:v>134</c:v>
-                </c:pt>
-                <c:pt idx="5">
-                  <c:v>102</c:v>
-                </c:pt>
-                <c:pt idx="6">
-                  <c:v>80</c:v>
-                </c:pt>
-                <c:pt idx="7">
-                  <c:v>83</c:v>
-                </c:pt>
-                <c:pt idx="8">
-                  <c:v>78</c:v>
-                </c:pt>
-                <c:pt idx="9">
-                  <c:v>64</c:v>
-                </c:pt>
-                <c:pt idx="10">
-                  <c:v>64</c:v>
-                </c:pt>
-                <c:pt idx="11">
-                  <c:v>65</c:v>
-                </c:pt>
-                <c:pt idx="12">
-                  <c:v>75</c:v>
-                </c:pt>
-                <c:pt idx="13">
-                  <c:v>89</c:v>
-                </c:pt>
-                <c:pt idx="14">
-                  <c:v>81</c:v>
-                </c:pt>
-                <c:pt idx="15">
-                  <c:v>65</c:v>
-                </c:pt>
-                <c:pt idx="16">
-                  <c:v>70</c:v>
-                </c:pt>
-                <c:pt idx="17">
-                  <c:v>68</c:v>
-                </c:pt>
-                <c:pt idx="18">
-                  <c:v>70</c:v>
-                </c:pt>
-                <c:pt idx="19">
-                  <c:v>84</c:v>
-                </c:pt>
-                <c:pt idx="20">
-                  <c:v>80</c:v>
-                </c:pt>
-                <c:pt idx="21">
-                  <c:v>68</c:v>
-                </c:pt>
-              </c:numCache>
-            </c:numRef>
-          </c:val>
-        </c:ser>
-        <c:dLbls>
-          <c:numFmt formatCode="#,##0" sourceLinked="0"/>
-          <c:txPr>
-            <a:bodyPr/>
-            <a:lstStyle/>
-            <a:p>
-              <a:pPr>
-                <a:defRPr b="0" i="0" strike="noStrike" sz="1200" u="none">
-                  <a:solidFill>
-                    <a:srgbClr val="000000"/>
-                  </a:solidFill>
-                  <a:latin typeface="Arial"/>
-                </a:defRPr>
-              </a:pPr>
-            </a:p>
-          </c:txPr>
-          <c:showLegendKey val="0"/>
-          <c:showVal val="0"/>
-          <c:showCatName val="0"/>
-          <c:showSerName val="0"/>
-          <c:showPercent val="0"/>
-          <c:showBubbleSize val="0"/>
-          <c:showLeaderLines val="0"/>
-        </c:dLbls>
-        <c:axId val="2094734554"/>
-        <c:axId val="2094734552"/>
-        <c:axId val="2094734556"/>
-      </c:areaChart>
-      <c:catAx>
-        <c:axId val="2094734554"/>
-        <c:scaling>
-          <c:orientation val="minMax"/>
-        </c:scaling>
-        <c:delete val="0"/>
-        <c:axPos val="b"/>
-        <c:numFmt formatCode="General" sourceLinked="1"/>
-        <c:majorTickMark val="out"/>
-        <c:minorTickMark val="none"/>
-        <c:tickLblPos val="low"/>
-        <c:spPr>
-          <a:ln w="12700" cap="flat">
-            <a:solidFill>
-              <a:srgbClr val="888888"/>
-            </a:solidFill>
-            <a:prstDash val="solid"/>
-            <a:round/>
-          </a:ln>
-        </c:spPr>
-        <c:txPr>
-          <a:bodyPr/>
-          <a:lstStyle/>
-          <a:p>
-            <a:pPr>
-              <a:defRPr sz="700" b="0" i="0" u="none" strike="noStrike">
-                <a:solidFill>
-                  <a:srgbClr val="5E6378"/>
-                </a:solidFill>
-                <a:latin typeface="Arial"/>
-              </a:defRPr>
-            </a:pPr>
-            <a:endParaRPr lang="en-US"/>
-          </a:p>
-        </c:txPr>
-        <c:crossAx val="2094734552"/>
-        <c:crosses val="autoZero"/>
-        <c:auto val="1"/>
-        <c:lblAlgn val="ctr"/>
-        <c:noMultiLvlLbl val="1"/>
-      </c:catAx>
-      <c:valAx>
-        <c:axId val="2094734552"/>
-        <c:scaling>
-          <c:orientation val="minMax"/>
-        </c:scaling>
-        <c:delete val="0"/>
-        <c:axPos val="l"/>
-        <c:majorGridlines>
-          <c:spPr>
-            <a:ln w="6350" cap="flat">
-              <a:solidFill>
-                <a:srgbClr val="E3E5EE"/>
-              </a:solidFill>
-              <a:prstDash val="solid"/>
-              <a:round/>
-            </a:ln>
-          </c:spPr>
-        </c:majorGridlines>
-        <c:numFmt formatCode="General" sourceLinked="0"/>
-        <c:majorTickMark val="out"/>
-        <c:minorTickMark val="none"/>
-        <c:tickLblPos val="nextTo"/>
-        <c:spPr>
-          <a:ln w="12700" cap="flat">
-            <a:solidFill>
-              <a:srgbClr val="888888"/>
-            </a:solidFill>
-            <a:prstDash val="solid"/>
-            <a:round/>
-          </a:ln>
-        </c:spPr>
-        <c:txPr>
-          <a:bodyPr/>
-          <a:lstStyle/>
-          <a:p>
-            <a:pPr>
-              <a:defRPr sz="800" b="0" i="0" u="none" strike="noStrike">
-                <a:solidFill>
-                  <a:srgbClr val="5E6378"/>
-                </a:solidFill>
-                <a:latin typeface="Arial"/>
-              </a:defRPr>
-            </a:pPr>
-            <a:endParaRPr lang="en-US"/>
-          </a:p>
-        </c:txPr>
-        <c:crossAx val="2094734554"/>
-        <c:crosses val="autoZero"/>
-        <c:crossBetween val="between"/>
-      </c:valAx>
-      <c:spPr>
-        <a:noFill/>
-        <a:ln>
-          <a:noFill/>
-        </a:ln>
-        <a:effectLst/>
-      </c:spPr>
-    </c:plotArea>
-    <c:plotVisOnly val="1"/>
-    <c:dispBlanksAs val="span"/>
-  </c:chart>
-  <c:spPr>
-    <a:noFill/>
-    <a:ln>
-      <a:noFill/>
-    </a:ln>
-    <a:effectLst/>
-  </c:spPr>
-  <c:externalData r:id="rId1">
-    <c:autoUpdate val="0"/>
-  </c:externalData>
-</c:chartSpace>
-</file>
-
-<file path=ppt/charts/chart2.xml><?xml version="1.0" encoding="utf-8"?>
-<c:chartSpace xmlns:c="http://schemas.openxmlformats.org/drawingml/2006/chart" xmlns:a="http://schemas.openxmlformats.org/drawingml/2006/main" xmlns:r="http://schemas.openxmlformats.org/officeDocument/2006/relationships">
-  <c:date1904 val="0"/>
-  <c:roundedCorners val="1"/>
-  <c:chart>
-    <c:title>
-      <c:tx>
-        <c:rich>
-          <a:bodyPr/>
-          <a:lstStyle/>
-          <a:p>
-            <a:pPr>
-              <a:defRPr sz="1100" b="0" i="0" u="none" strike="noStrike">
-                <a:solidFill>
-                  <a:srgbClr val="1F2233"/>
-                </a:solidFill>
-                <a:latin typeface="Calibri"/>
-              </a:defRPr>
-            </a:pPr>
-            <a:r>
-              <a:rPr sz="1100" b="0" i="0" u="none" strike="noStrike">
-                <a:solidFill>
-                  <a:srgbClr val="1F2233"/>
-                </a:solidFill>
-                <a:latin typeface="Calibri"/>
-              </a:rPr>
-              <a:t>% des avis Steam négatifs qui citent le matchmaking</a:t>
-            </a:r>
-          </a:p>
-        </c:rich>
-      </c:tx>
-      <c:layout/>
-      <c:overlay val="0"/>
-    </c:title>
-    <c:autoTitleDeleted val="0"/>
-    <c:plotArea>
-      <c:layout/>
-      <c:barChart>
-        <c:barDir val="col"/>
-        <c:grouping val="clustered"/>
-        <c:varyColors val="0"/>
-        <c:ser>
-          <c:idx val="0"/>
-          <c:order val="0"/>
-          <c:tx>
-            <c:strRef>
-              <c:f>Sheet1!$B$1</c:f>
-              <c:strCache>
-                <c:ptCount val="1"/>
-                <c:pt idx="0">
-                  <c:v>% des avis négatifs citant le matchmaking</c:v>
-                </c:pt>
-              </c:strCache>
-            </c:strRef>
-          </c:tx>
-          <c:spPr>
-            <a:solidFill>
-              <a:srgbClr val="FFC72C"/>
-            </a:solidFill>
-            <a:effectLst/>
-          </c:spPr>
-          <c:invertIfNegative val="0"/>
-          <c:dLbls>
-            <c:numFmt formatCode="#,##0" sourceLinked="0"/>
-            <c:txPr>
-              <a:bodyPr/>
-              <a:lstStyle/>
-              <a:p>
-                <a:pPr>
-                  <a:defRPr b="0" i="0" strike="noStrike" sz="1200" u="none">
-                    <a:solidFill>
-                      <a:srgbClr val="000000"/>
-                    </a:solidFill>
-                    <a:latin typeface="Arial"/>
-                  </a:defRPr>
-                </a:pPr>
-              </a:p>
-            </c:txPr>
-            <c:showLegendKey val="0"/>
-            <c:showVal val="0"/>
-            <c:showCatName val="0"/>
-            <c:showSerName val="0"/>
-            <c:showPercent val="0"/>
-            <c:showBubbleSize val="0"/>
-            <c:showLeaderLines val="0"/>
-          </c:dLbls>
-          <c:cat>
-            <c:multiLvlStrRef>
-              <c:f>Sheet1!$A$2:$A$23</c:f>
-              <c:multiLvlStrCache>
-                <c:ptCount val="22"/>
-                <c:lvl>
-                  <c:pt idx="0">
-                    <c:v>Déc. 24</c:v>
-                  </c:pt>
-                  <c:pt idx="1">
-                    <c:v>Janv.</c:v>
-                  </c:pt>
-                  <c:pt idx="2">
-                    <c:v>Févr.</c:v>
-                  </c:pt>
-                  <c:pt idx="3">
-                    <c:v>Mars</c:v>
-                  </c:pt>
-                  <c:pt idx="4">
-                    <c:v>Avr.</c:v>
-                  </c:pt>
-                  <c:pt idx="5">
-                    <c:v>Mai</c:v>
-                  </c:pt>
-                  <c:pt idx="6">
-                    <c:v>Juin</c:v>
-                  </c:pt>
-                  <c:pt idx="7">
-                    <c:v>Juil.</c:v>
-                  </c:pt>
-                  <c:pt idx="8">
-                    <c:v>Août</c:v>
-                  </c:pt>
-                  <c:pt idx="9">
-                    <c:v>Sept.</c:v>
-                  </c:pt>
-                  <c:pt idx="10">
-                    <c:v>Oct.</c:v>
-                  </c:pt>
-                  <c:pt idx="11">
-                    <c:v>Nov.</c:v>
-                  </c:pt>
-                  <c:pt idx="12">
-                    <c:v>Déc.</c:v>
-                  </c:pt>
-                  <c:pt idx="13">
-                    <c:v>Janv. 26</c:v>
-                  </c:pt>
-                  <c:pt idx="14">
-                    <c:v>Févr.</c:v>
-                  </c:pt>
-                  <c:pt idx="15">
-                    <c:v>Mars</c:v>
-                  </c:pt>
-                  <c:pt idx="16">
-                    <c:v>Avr.</c:v>
-                  </c:pt>
-                  <c:pt idx="17">
-                    <c:v>Mai</c:v>
-                  </c:pt>
-                  <c:pt idx="18">
-                    <c:v>Juin</c:v>
-                  </c:pt>
-                  <c:pt idx="19">
-                    <c:v>Juil.</c:v>
-                  </c:pt>
-                  <c:pt idx="20">
-                    <c:v>Août</c:v>
-                  </c:pt>
-                  <c:pt idx="21">
-                    <c:v>Sept.*</c:v>
-                  </c:pt>
-                </c:lvl>
-              </c:multiLvlStrCache>
-            </c:multiLvlStrRef>
-          </c:cat>
-          <c:val>
-            <c:numRef>
-              <c:f>Sheet1!$B$2:$B$23</c:f>
-              <c:numCache>
-                <c:formatCode>General</c:formatCode>
-                <c:ptCount val="22"/>
-                <c:pt idx="0">
-                  <c:v>7.4</c:v>
-                </c:pt>
-                <c:pt idx="1">
-                  <c:v>10.9</c:v>
-                </c:pt>
-                <c:pt idx="2">
-                  <c:v>12.1</c:v>
-                </c:pt>
-                <c:pt idx="3">
-                  <c:v>20.3</c:v>
-                </c:pt>
-                <c:pt idx="4">
-                  <c:v>21.1</c:v>
-                </c:pt>
-                <c:pt idx="5">
-                  <c:v>29.1</c:v>
-                </c:pt>
-                <c:pt idx="6">
-                  <c:v>27.6</c:v>
-                </c:pt>
-                <c:pt idx="7">
-                  <c:v>37</c:v>
-                </c:pt>
-                <c:pt idx="8">
-                  <c:v>41</c:v>
-                </c:pt>
-                <c:pt idx="9">
-                  <c:v>33.9</c:v>
-                </c:pt>
-                <c:pt idx="10">
-                  <c:v>25.9</c:v>
-                </c:pt>
-                <c:pt idx="11">
-                  <c:v>17.3</c:v>
-                </c:pt>
-                <c:pt idx="12">
-                  <c:v>18.2</c:v>
-                </c:pt>
-                <c:pt idx="13">
-                  <c:v>15.4</c:v>
-                </c:pt>
-                <c:pt idx="14">
-                  <c:v>15.6</c:v>
-                </c:pt>
-                <c:pt idx="15">
-                  <c:v>13.4</c:v>
-                </c:pt>
-                <c:pt idx="16">
-                  <c:v>14.4</c:v>
-                </c:pt>
-                <c:pt idx="17">
-                  <c:v>14.7</c:v>
-                </c:pt>
-                <c:pt idx="18">
-                  <c:v>14.2</c:v>
-                </c:pt>
-                <c:pt idx="19">
-                  <c:v>8.8</c:v>
-                </c:pt>
-                <c:pt idx="20">
-                  <c:v>13.4</c:v>
-                </c:pt>
-                <c:pt idx="21">
-                  <c:v>10.5</c:v>
-                </c:pt>
-              </c:numCache>
-            </c:numRef>
-          </c:val>
-        </c:ser>
-        <c:dLbls>
-          <c:numFmt formatCode="#,##0" sourceLinked="0"/>
-          <c:txPr>
-            <a:bodyPr/>
-            <a:lstStyle/>
-            <a:p>
-              <a:pPr>
-                <a:defRPr b="0" i="0" strike="noStrike" sz="1200" u="none">
-                  <a:solidFill>
-                    <a:srgbClr val="000000"/>
-                  </a:solidFill>
-                  <a:latin typeface="Arial"/>
-                </a:defRPr>
-              </a:pPr>
-            </a:p>
-          </c:txPr>
-          <c:showLegendKey val="0"/>
-          <c:showVal val="0"/>
-          <c:showCatName val="0"/>
-          <c:showSerName val="0"/>
-          <c:showPercent val="0"/>
-          <c:showBubbleSize val="0"/>
-          <c:showLeaderLines val="0"/>
-        </c:dLbls>
-        <c:gapWidth val="35"/>
-        <c:overlap val="0"/>
-        <c:axId val="2094734554"/>
-        <c:axId val="2094734552"/>
-        <c:axId val="2094734556"/>
-      </c:barChart>
-      <c:catAx>
-        <c:axId val="2094734554"/>
-        <c:scaling>
-          <c:orientation val="minMax"/>
-        </c:scaling>
-        <c:delete val="0"/>
-        <c:axPos val="b"/>
-        <c:numFmt formatCode="General" sourceLinked="1"/>
-        <c:majorTickMark val="out"/>
-        <c:minorTickMark val="none"/>
-        <c:tickLblPos val="low"/>
-        <c:spPr>
-          <a:ln w="12700" cap="flat">
-            <a:solidFill>
-              <a:srgbClr val="888888"/>
-            </a:solidFill>
-            <a:prstDash val="solid"/>
-            <a:round/>
-          </a:ln>
-        </c:spPr>
-        <c:txPr>
-          <a:bodyPr/>
-          <a:lstStyle/>
-          <a:p>
-            <a:pPr>
-              <a:defRPr sz="700" b="0" i="0" u="none" strike="noStrike">
-                <a:solidFill>
-                  <a:srgbClr val="5E6378"/>
-                </a:solidFill>
-                <a:latin typeface="Arial"/>
-              </a:defRPr>
-            </a:pPr>
-            <a:endParaRPr lang="en-US"/>
-          </a:p>
-        </c:txPr>
-        <c:crossAx val="2094734552"/>
-        <c:crosses val="autoZero"/>
-        <c:auto val="1"/>
-        <c:lblAlgn val="ctr"/>
-        <c:noMultiLvlLbl val="1"/>
-      </c:catAx>
-      <c:valAx>
-        <c:axId val="2094734552"/>
-        <c:scaling>
-          <c:orientation val="minMax"/>
-          <c:max val="45"/>
-        </c:scaling>
-        <c:delete val="0"/>
-        <c:axPos val="l"/>
-        <c:majorGridlines>
-          <c:spPr>
-            <a:ln w="6350" cap="flat">
-              <a:solidFill>
-                <a:srgbClr val="E3E5EE"/>
-              </a:solidFill>
-              <a:prstDash val="solid"/>
-              <a:round/>
-            </a:ln>
-          </c:spPr>
-        </c:majorGridlines>
-        <c:numFmt formatCode="0&quot;%&quot;" sourceLinked="0"/>
-        <c:majorTickMark val="out"/>
-        <c:minorTickMark val="none"/>
-        <c:tickLblPos val="nextTo"/>
-        <c:spPr>
-          <a:ln w="12700" cap="flat">
-            <a:solidFill>
-              <a:srgbClr val="888888"/>
-            </a:solidFill>
-            <a:prstDash val="solid"/>
-            <a:round/>
-          </a:ln>
-        </c:spPr>
-        <c:txPr>
-          <a:bodyPr/>
-          <a:lstStyle/>
-          <a:p>
-            <a:pPr>
-              <a:defRPr sz="800" b="0" i="0" u="none" strike="noStrike">
-                <a:solidFill>
-                  <a:srgbClr val="5E6378"/>
-                </a:solidFill>
-                <a:latin typeface="Arial"/>
-              </a:defRPr>
-            </a:pPr>
-            <a:endParaRPr lang="en-US"/>
-          </a:p>
-        </c:txPr>
-        <c:crossAx val="2094734554"/>
-        <c:crosses val="autoZero"/>
-        <c:crossBetween val="between"/>
-      </c:valAx>
-      <c:spPr>
-        <a:noFill/>
-        <a:ln>
-          <a:noFill/>
-        </a:ln>
-        <a:effectLst/>
-      </c:spPr>
-    </c:plotArea>
-    <c:plotVisOnly val="1"/>
-    <c:dispBlanksAs val="span"/>
-  </c:chart>
-  <c:spPr>
-    <a:noFill/>
-    <a:ln>
-      <a:noFill/>
-    </a:ln>
-    <a:effectLst/>
-  </c:spPr>
-  <c:externalData r:id="rId1">
-    <c:autoUpdate val="0"/>
-  </c:externalData>
-</c:chartSpace>
 </file>
 
 <file path=ppt/notesMasters/notesMaster1.xml><?xml version="1.0" encoding="utf-8"?>
@@ -7946,38 +7181,54 @@
           </a:p>
         </p:txBody>
       </p:sp>
-      <p:graphicFrame>
-        <p:nvGraphicFramePr>
-          <p:cNvPr id="13" name="Chart 0" descr=""/>
-          <p:cNvGraphicFramePr/>
+      <p:pic>
+        <p:nvPicPr>
+          <p:cNvPr id="13" name="Image 1" descr="preencoded.png">    </p:cNvPr>
+          <p:cNvPicPr>
+            <a:picLocks noChangeAspect="1"/>
+          </p:cNvPicPr>
           <p:nvPr/>
-        </p:nvGraphicFramePr>
-        <p:xfrm>
-          <a:off x="320040" y="1783080"/>
-          <a:ext cx="4251960" cy="1965960"/>
-        </p:xfrm>
-        <a:graphic xmlns:a="http://schemas.openxmlformats.org/drawingml/2006/main">
-          <a:graphicData uri="http://schemas.openxmlformats.org/drawingml/2006/chart">
-            <c:chart xmlns:c="http://schemas.openxmlformats.org/drawingml/2006/chart" r:id="rId2"/>
-          </a:graphicData>
-        </a:graphic>
-      </p:graphicFrame>
-      <p:graphicFrame>
-        <p:nvGraphicFramePr>
-          <p:cNvPr id="14" name="Chart 1" descr=""/>
-          <p:cNvGraphicFramePr/>
+        </p:nvPicPr>
+        <p:blipFill>
+          <a:blip r:embed="rId2"/>
+          <a:stretch>
+            <a:fillRect/>
+          </a:stretch>
+        </p:blipFill>
+        <p:spPr>
+          <a:xfrm>
+            <a:off x="320040" y="1801368"/>
+            <a:ext cx="4251960" cy="1965960"/>
+          </a:xfrm>
+          <a:prstGeom prst="rect">
+            <a:avLst/>
+          </a:prstGeom>
+        </p:spPr>
+      </p:pic>
+      <p:pic>
+        <p:nvPicPr>
+          <p:cNvPr id="14" name="Image 2" descr="preencoded.png">    </p:cNvPr>
+          <p:cNvPicPr>
+            <a:picLocks noChangeAspect="1"/>
+          </p:cNvPicPr>
           <p:nvPr/>
-        </p:nvGraphicFramePr>
-        <p:xfrm>
-          <a:off x="4572000" y="1783080"/>
-          <a:ext cx="4251960" cy="1965960"/>
-        </p:xfrm>
-        <a:graphic xmlns:a="http://schemas.openxmlformats.org/drawingml/2006/main">
-          <a:graphicData uri="http://schemas.openxmlformats.org/drawingml/2006/chart">
-            <c:chart xmlns:c="http://schemas.openxmlformats.org/drawingml/2006/chart" r:id="rId3"/>
-          </a:graphicData>
-        </a:graphic>
-      </p:graphicFrame>
+        </p:nvPicPr>
+        <p:blipFill>
+          <a:blip r:embed="rId3"/>
+          <a:stretch>
+            <a:fillRect/>
+          </a:stretch>
+        </p:blipFill>
+        <p:spPr>
+          <a:xfrm>
+            <a:off x="4572000" y="1801368"/>
+            <a:ext cx="4251960" cy="1965960"/>
+          </a:xfrm>
+          <a:prstGeom prst="rect">
+            <a:avLst/>
+          </a:prstGeom>
+        </p:spPr>
+      </p:pic>
       <p:sp>
         <p:nvSpPr>
           <p:cNvPr id="15" name="Text 10"/>

</xml_diff>

<commit_message>
Pitch : liens vers le PDF du plan de collecte au lieu du Google Doc
Co-Authored-By: Claude Opus 5.5 <noreply@anthropic.com>
Claude-Session: https://claude.ai/code/session_012kyLDzFB57v6JCyVf6ygKi
</commit_message>
<xml_diff>
--- a/docs/presentation/pitch_marvel_rivals_netease.pptx
+++ b/docs/presentation/pitch_marvel_rivals_netease.pptx
@@ -4932,7 +4932,7 @@
                   </a:extLst>
                 </a:hlinkClick>
               </a:rPr>
-              <a:t>plan de collecte complet (§3)</a:t>
+              <a:t>plan de collecte, partie 3 (PDF, p. 10)</a:t>
             </a:r>
             <a:endParaRPr lang="en-US" sz="850" dirty="0"/>
           </a:p>
@@ -5848,7 +5848,7 @@
                   </a:extLst>
                 </a:hlinkClick>
               </a:rPr>
-              <a:t>Plan de collecte complet (Google Docs)</a:t>
+              <a:t>Plan de collecte complet (PDF joint : Marvel_Rivals_plan_de_collecte_NetEase.pdf)</a:t>
             </a:r>
             <a:endParaRPr lang="en-US" sz="1000" dirty="0"/>
           </a:p>
@@ -10950,7 +10950,7 @@
                   </a:extLst>
                 </a:hlinkClick>
               </a:rPr>
-              <a:t>plan de collecte complet (matrice ICE)</a:t>
+              <a:t>plan de collecte, partie 4 : matrice ICE (PDF, p. 12)</a:t>
             </a:r>
             <a:pPr indent="0" marL="0">
               <a:buNone/>
@@ -17234,7 +17234,7 @@
                   </a:extLst>
                 </a:hlinkClick>
               </a:rPr>
-              <a:t>plan de collecte complet (justification de chaque note)</a:t>
+              <a:t>plan de collecte, partie 4 : justification de chaque note (PDF, p. 12)</a:t>
             </a:r>
             <a:endParaRPr lang="en-US" sz="850" dirty="0"/>
           </a:p>
@@ -19682,7 +19682,7 @@
                   </a:extLst>
                 </a:hlinkClick>
               </a:rPr>
-              <a:t>plan de collecte complet</a:t>
+              <a:t>plan de collecte, partie 6 (PDF, p. 18)</a:t>
             </a:r>
             <a:endParaRPr lang="en-US" sz="850" dirty="0"/>
           </a:p>
@@ -21627,7 +21627,7 @@
                   </a:extLst>
                 </a:hlinkClick>
               </a:rPr>
-              <a:t>plan de collecte complet (§7)</a:t>
+              <a:t>plan de collecte, partie 7 (PDF, p. 20)</a:t>
             </a:r>
             <a:endParaRPr lang="en-US" sz="850" dirty="0"/>
           </a:p>
@@ -24503,7 +24503,7 @@
                   </a:extLst>
                 </a:hlinkClick>
               </a:rPr>
-              <a:t>plan de collecte (§5)</a:t>
+              <a:t>plan de collecte, partie 5 (PDF, p. 15)</a:t>
             </a:r>
             <a:endParaRPr lang="en-US" sz="850" dirty="0"/>
           </a:p>

</xml_diff>

<commit_message>
PDF : logo recentré dans les bandeaux, colonnes alignées sur les tableaux coupés ; pptx : numéros de page mis à jour
Co-Authored-By: Claude Opus 5.5 <noreply@anthropic.com>
Claude-Session: https://claude.ai/code/session_012kyLDzFB57v6JCyVf6ygKi
</commit_message>
<xml_diff>
--- a/docs/presentation/pitch_marvel_rivals_netease.pptx
+++ b/docs/presentation/pitch_marvel_rivals_netease.pptx
@@ -19682,7 +19682,7 @@
                   </a:extLst>
                 </a:hlinkClick>
               </a:rPr>
-              <a:t>plan de collecte, partie 6 (PDF, p. 18)</a:t>
+              <a:t>plan de collecte, partie 6 (PDF, p. 20)</a:t>
             </a:r>
             <a:endParaRPr lang="en-US" sz="850" dirty="0"/>
           </a:p>
@@ -21627,7 +21627,7 @@
                   </a:extLst>
                 </a:hlinkClick>
               </a:rPr>
-              <a:t>plan de collecte, partie 7 (PDF, p. 20)</a:t>
+              <a:t>plan de collecte, partie 7 (PDF, p. 22)</a:t>
             </a:r>
             <a:endParaRPr lang="en-US" sz="850" dirty="0"/>
           </a:p>
@@ -24503,7 +24503,7 @@
                   </a:extLst>
                 </a:hlinkClick>
               </a:rPr>
-              <a:t>plan de collecte, partie 5 (PDF, p. 15)</a:t>
+              <a:t>plan de collecte, partie 5 (PDF, p. 16)</a:t>
             </a:r>
             <a:endParaRPr lang="en-US" sz="850" dirty="0"/>
           </a:p>

</xml_diff>